<commit_message>
11/8/2023 11:20 AM commit
</commit_message>
<xml_diff>
--- a/SFN/2023_SFN_trust.pptx
+++ b/SFN/2023_SFN_trust.pptx
@@ -4390,42 +4390,6 @@
           <a:chExt cx="0" cy="0"/>
         </a:xfrm>
       </p:grpSpPr>
-      <p:pic>
-        <p:nvPicPr>
-          <p:cNvPr id="15424" name="Picture 15423" descr="A close-up of a brain&#10;&#10;Description automatically generated">
-            <a:extLst>
-              <a:ext uri="{FF2B5EF4-FFF2-40B4-BE49-F238E27FC236}">
-                <a16:creationId xmlns:a16="http://schemas.microsoft.com/office/drawing/2014/main" id="{CC6419D2-DC29-B910-B6FA-A6DAC7775AD7}"/>
-              </a:ext>
-            </a:extLst>
-          </p:cNvPr>
-          <p:cNvPicPr>
-            <a:picLocks noChangeAspect="1"/>
-          </p:cNvPicPr>
-          <p:nvPr/>
-        </p:nvPicPr>
-        <p:blipFill>
-          <a:blip r:embed="rId3">
-            <a:extLst>
-              <a:ext uri="{28A0092B-C50C-407E-A947-70E740481C1C}">
-                <a14:useLocalDpi xmlns:a14="http://schemas.microsoft.com/office/drawing/2010/main" val="0"/>
-              </a:ext>
-            </a:extLst>
-          </a:blip>
-          <a:stretch>
-            <a:fillRect/>
-          </a:stretch>
-        </p:blipFill>
-        <p:spPr>
-          <a:xfrm>
-            <a:off x="23357979" y="25006432"/>
-            <a:ext cx="6457795" cy="5596080"/>
-          </a:xfrm>
-          <a:prstGeom prst="rect">
-            <a:avLst/>
-          </a:prstGeom>
-        </p:spPr>
-      </p:pic>
       <p:sp>
         <p:nvSpPr>
           <p:cNvPr id="15399" name="Rectangle 15398">
@@ -4502,315 +4466,6 @@
       </p:sp>
       <p:sp>
         <p:nvSpPr>
-          <p:cNvPr id="15362" name="TextBox 189"/>
-          <p:cNvSpPr txBox="1">
-            <a:spLocks noChangeArrowheads="1"/>
-          </p:cNvSpPr>
-          <p:nvPr/>
-        </p:nvSpPr>
-        <p:spPr bwMode="auto">
-          <a:xfrm>
-            <a:off x="515553" y="4761579"/>
-            <a:ext cx="14526988" cy="5016758"/>
-          </a:xfrm>
-          <a:prstGeom prst="rect">
-            <a:avLst/>
-          </a:prstGeom>
-          <a:noFill/>
-          <a:ln>
-            <a:noFill/>
-          </a:ln>
-          <a:extLst>
-            <a:ext uri="{909E8E84-426E-40DD-AFC4-6F175D3DCCD1}">
-              <a14:hiddenFill xmlns:a14="http://schemas.microsoft.com/office/drawing/2010/main">
-                <a:solidFill>
-                  <a:srgbClr val="FFFFFF"/>
-                </a:solidFill>
-              </a14:hiddenFill>
-            </a:ext>
-            <a:ext uri="{91240B29-F687-4F45-9708-019B960494DF}">
-              <a14:hiddenLine xmlns:a14="http://schemas.microsoft.com/office/drawing/2010/main" w="9525">
-                <a:solidFill>
-                  <a:srgbClr val="000000"/>
-                </a:solidFill>
-                <a:miter lim="800000"/>
-                <a:headEnd/>
-                <a:tailEnd/>
-              </a14:hiddenLine>
-            </a:ext>
-          </a:extLst>
-        </p:spPr>
-        <p:txBody>
-          <a:bodyPr wrap="square" lIns="91440" tIns="45720" rIns="91440" bIns="45720" anchor="t">
-            <a:spAutoFit/>
-          </a:bodyPr>
-          <a:lstStyle>
-            <a:lvl1pPr>
-              <a:defRPr sz="2400">
-                <a:solidFill>
-                  <a:schemeClr val="tx1"/>
-                </a:solidFill>
-                <a:latin typeface="Helvetica" panose="020B0604020202020204" pitchFamily="34" charset="0"/>
-                <a:ea typeface="MS PGothic" panose="020B0600070205080204" pitchFamily="34" charset="-128"/>
-              </a:defRPr>
-            </a:lvl1pPr>
-            <a:lvl2pPr marL="742950" indent="-285750">
-              <a:defRPr sz="2400">
-                <a:solidFill>
-                  <a:schemeClr val="tx1"/>
-                </a:solidFill>
-                <a:latin typeface="Helvetica" panose="020B0604020202020204" pitchFamily="34" charset="0"/>
-                <a:ea typeface="MS PGothic" panose="020B0600070205080204" pitchFamily="34" charset="-128"/>
-              </a:defRPr>
-            </a:lvl2pPr>
-            <a:lvl3pPr marL="1143000" indent="-228600">
-              <a:defRPr sz="2400">
-                <a:solidFill>
-                  <a:schemeClr val="tx1"/>
-                </a:solidFill>
-                <a:latin typeface="Helvetica" panose="020B0604020202020204" pitchFamily="34" charset="0"/>
-                <a:ea typeface="MS PGothic" panose="020B0600070205080204" pitchFamily="34" charset="-128"/>
-              </a:defRPr>
-            </a:lvl3pPr>
-            <a:lvl4pPr marL="1600200" indent="-228600">
-              <a:defRPr sz="2400">
-                <a:solidFill>
-                  <a:schemeClr val="tx1"/>
-                </a:solidFill>
-                <a:latin typeface="Helvetica" panose="020B0604020202020204" pitchFamily="34" charset="0"/>
-                <a:ea typeface="MS PGothic" panose="020B0600070205080204" pitchFamily="34" charset="-128"/>
-              </a:defRPr>
-            </a:lvl4pPr>
-            <a:lvl5pPr marL="2057400" indent="-228600">
-              <a:defRPr sz="2400">
-                <a:solidFill>
-                  <a:schemeClr val="tx1"/>
-                </a:solidFill>
-                <a:latin typeface="Helvetica" panose="020B0604020202020204" pitchFamily="34" charset="0"/>
-                <a:ea typeface="MS PGothic" panose="020B0600070205080204" pitchFamily="34" charset="-128"/>
-              </a:defRPr>
-            </a:lvl5pPr>
-            <a:lvl6pPr marL="2514600" indent="-228600" eaLnBrk="0" fontAlgn="base" hangingPunct="0">
-              <a:spcBef>
-                <a:spcPct val="0"/>
-              </a:spcBef>
-              <a:spcAft>
-                <a:spcPct val="0"/>
-              </a:spcAft>
-              <a:defRPr sz="2400">
-                <a:solidFill>
-                  <a:schemeClr val="tx1"/>
-                </a:solidFill>
-                <a:latin typeface="Helvetica" panose="020B0604020202020204" pitchFamily="34" charset="0"/>
-                <a:ea typeface="MS PGothic" panose="020B0600070205080204" pitchFamily="34" charset="-128"/>
-              </a:defRPr>
-            </a:lvl6pPr>
-            <a:lvl7pPr marL="2971800" indent="-228600" eaLnBrk="0" fontAlgn="base" hangingPunct="0">
-              <a:spcBef>
-                <a:spcPct val="0"/>
-              </a:spcBef>
-              <a:spcAft>
-                <a:spcPct val="0"/>
-              </a:spcAft>
-              <a:defRPr sz="2400">
-                <a:solidFill>
-                  <a:schemeClr val="tx1"/>
-                </a:solidFill>
-                <a:latin typeface="Helvetica" panose="020B0604020202020204" pitchFamily="34" charset="0"/>
-                <a:ea typeface="MS PGothic" panose="020B0600070205080204" pitchFamily="34" charset="-128"/>
-              </a:defRPr>
-            </a:lvl7pPr>
-            <a:lvl8pPr marL="3429000" indent="-228600" eaLnBrk="0" fontAlgn="base" hangingPunct="0">
-              <a:spcBef>
-                <a:spcPct val="0"/>
-              </a:spcBef>
-              <a:spcAft>
-                <a:spcPct val="0"/>
-              </a:spcAft>
-              <a:defRPr sz="2400">
-                <a:solidFill>
-                  <a:schemeClr val="tx1"/>
-                </a:solidFill>
-                <a:latin typeface="Helvetica" panose="020B0604020202020204" pitchFamily="34" charset="0"/>
-                <a:ea typeface="MS PGothic" panose="020B0600070205080204" pitchFamily="34" charset="-128"/>
-              </a:defRPr>
-            </a:lvl8pPr>
-            <a:lvl9pPr marL="3886200" indent="-228600" eaLnBrk="0" fontAlgn="base" hangingPunct="0">
-              <a:spcBef>
-                <a:spcPct val="0"/>
-              </a:spcBef>
-              <a:spcAft>
-                <a:spcPct val="0"/>
-              </a:spcAft>
-              <a:defRPr sz="2400">
-                <a:solidFill>
-                  <a:schemeClr val="tx1"/>
-                </a:solidFill>
-                <a:latin typeface="Helvetica" panose="020B0604020202020204" pitchFamily="34" charset="0"/>
-                <a:ea typeface="MS PGothic" panose="020B0600070205080204" pitchFamily="34" charset="-128"/>
-              </a:defRPr>
-            </a:lvl9pPr>
-          </a:lstStyle>
-          <a:p>
-            <a:pPr>
-              <a:spcBef>
-                <a:spcPts val="0"/>
-              </a:spcBef>
-              <a:spcAft>
-                <a:spcPts val="0"/>
-              </a:spcAft>
-              <a:buFont typeface="Arial" panose="020B0604020202020204" pitchFamily="34" charset="0"/>
-              <a:buChar char="•"/>
-            </a:pPr>
-            <a:r>
-              <a:rPr lang="en-US" sz="4000" dirty="0">
-                <a:latin typeface="Helvetica"/>
-                <a:ea typeface="MS PGothic"/>
-                <a:cs typeface="Helvetica"/>
-              </a:rPr>
-              <a:t> </a:t>
-            </a:r>
-            <a:r>
-              <a:rPr lang="en-US" sz="4000" b="0" i="0" dirty="0">
-                <a:solidFill>
-                  <a:srgbClr val="000000"/>
-                </a:solidFill>
-                <a:effectLst/>
-                <a:latin typeface="Helvetica" pitchFamily="2" charset="0"/>
-              </a:rPr>
-              <a:t>Social relationships influence our behaviors and may modulate our neural responses to reward. (</a:t>
-            </a:r>
-            <a:r>
-              <a:rPr lang="en-US" sz="4000" b="0" i="0" dirty="0" err="1">
-                <a:solidFill>
-                  <a:srgbClr val="000000"/>
-                </a:solidFill>
-                <a:effectLst/>
-                <a:latin typeface="Helvetica" pitchFamily="2" charset="0"/>
-              </a:rPr>
-              <a:t>Fareri</a:t>
-            </a:r>
-            <a:r>
-              <a:rPr lang="en-US" sz="4000" b="0" i="0" dirty="0">
-                <a:solidFill>
-                  <a:srgbClr val="000000"/>
-                </a:solidFill>
-                <a:effectLst/>
-                <a:latin typeface="Helvetica" pitchFamily="2" charset="0"/>
-              </a:rPr>
-              <a:t> et al., 2015)</a:t>
-            </a:r>
-            <a:endParaRPr lang="en-US" sz="4000" dirty="0">
-              <a:latin typeface="Helvetica" pitchFamily="2" charset="0"/>
-              <a:ea typeface="MS PGothic"/>
-              <a:cs typeface="Helvetica"/>
-            </a:endParaRPr>
-          </a:p>
-          <a:p>
-            <a:pPr>
-              <a:spcBef>
-                <a:spcPts val="0"/>
-              </a:spcBef>
-              <a:spcAft>
-                <a:spcPts val="0"/>
-              </a:spcAft>
-              <a:buFont typeface="Arial" panose="020B0604020202020204" pitchFamily="34" charset="0"/>
-              <a:buChar char="•"/>
-            </a:pPr>
-            <a:r>
-              <a:rPr lang="en-US" sz="4000" dirty="0">
-                <a:latin typeface="Helvetica"/>
-                <a:ea typeface="MS PGothic"/>
-                <a:cs typeface="Helvetica"/>
-              </a:rPr>
-              <a:t> </a:t>
-            </a:r>
-            <a:r>
-              <a:rPr lang="en-US" sz="4000" dirty="0">
-                <a:solidFill>
-                  <a:srgbClr val="000000"/>
-                </a:solidFill>
-                <a:latin typeface="Helvetica" pitchFamily="2" charset="0"/>
-                <a:ea typeface="MS PGothic"/>
-                <a:cs typeface="Helvetica"/>
-              </a:rPr>
-              <a:t>Th</a:t>
-            </a:r>
-            <a:r>
-              <a:rPr lang="en-US" sz="4000" b="0" i="0" dirty="0">
-                <a:solidFill>
-                  <a:srgbClr val="000000"/>
-                </a:solidFill>
-                <a:effectLst/>
-                <a:latin typeface="Helvetica" pitchFamily="2" charset="0"/>
-              </a:rPr>
-              <a:t>e effect of relationships on behavior and reward activation may change as we age. (</a:t>
-            </a:r>
-            <a:r>
-              <a:rPr lang="en-US" sz="4000" b="0" i="0" dirty="0" err="1">
-                <a:solidFill>
-                  <a:srgbClr val="000000"/>
-                </a:solidFill>
-                <a:effectLst/>
-                <a:latin typeface="Helvetica" pitchFamily="2" charset="0"/>
-              </a:rPr>
-              <a:t>Fareri</a:t>
-            </a:r>
-            <a:r>
-              <a:rPr lang="en-US" sz="4000" b="0" i="0" dirty="0">
-                <a:solidFill>
-                  <a:srgbClr val="000000"/>
-                </a:solidFill>
-                <a:effectLst/>
-                <a:latin typeface="Helvetica" pitchFamily="2" charset="0"/>
-              </a:rPr>
-              <a:t> et al., 2022)</a:t>
-            </a:r>
-          </a:p>
-          <a:p>
-            <a:pPr>
-              <a:spcBef>
-                <a:spcPts val="0"/>
-              </a:spcBef>
-              <a:spcAft>
-                <a:spcPts val="0"/>
-              </a:spcAft>
-            </a:pPr>
-            <a:endParaRPr lang="en-US" sz="4000" dirty="0">
-              <a:latin typeface="Helvetica" pitchFamily="2" charset="0"/>
-              <a:ea typeface="MS PGothic"/>
-              <a:cs typeface="Helvetica"/>
-            </a:endParaRPr>
-          </a:p>
-          <a:p>
-            <a:pPr>
-              <a:spcBef>
-                <a:spcPts val="0"/>
-              </a:spcBef>
-              <a:spcAft>
-                <a:spcPts val="0"/>
-              </a:spcAft>
-            </a:pPr>
-            <a:r>
-              <a:rPr lang="en-US" sz="4000" b="0" i="1" dirty="0">
-                <a:solidFill>
-                  <a:srgbClr val="000000"/>
-                </a:solidFill>
-                <a:effectLst/>
-                <a:latin typeface="Helvetica" pitchFamily="2" charset="0"/>
-              </a:rPr>
-              <a:t>It remains unclear whether age-related differences in responses to trust are associated with maladaptive outcomes such as financial exploitation.</a:t>
-            </a:r>
-            <a:endParaRPr lang="en-US" sz="4000" i="1" dirty="0">
-              <a:latin typeface="Helvetica" pitchFamily="2" charset="0"/>
-              <a:ea typeface="MS PGothic"/>
-              <a:cs typeface="Helvetica"/>
-            </a:endParaRPr>
-          </a:p>
-        </p:txBody>
-      </p:sp>
-      <p:sp>
-        <p:nvSpPr>
           <p:cNvPr id="15365" name="Rectangle 162"/>
           <p:cNvSpPr>
             <a:spLocks noChangeArrowheads="1"/>
@@ -4819,8 +4474,8 @@
         </p:nvSpPr>
         <p:spPr bwMode="auto">
           <a:xfrm>
-            <a:off x="338498" y="12420397"/>
-            <a:ext cx="14710114" cy="20245086"/>
+            <a:off x="162957" y="12488003"/>
+            <a:ext cx="14710114" cy="18312188"/>
           </a:xfrm>
           <a:prstGeom prst="rect">
             <a:avLst/>
@@ -5115,158 +4770,6 @@
       </p:sp>
       <p:sp>
         <p:nvSpPr>
-          <p:cNvPr id="15369" name="Rectangle 162"/>
-          <p:cNvSpPr>
-            <a:spLocks noChangeArrowheads="1"/>
-          </p:cNvSpPr>
-          <p:nvPr/>
-        </p:nvSpPr>
-        <p:spPr bwMode="auto">
-          <a:xfrm>
-            <a:off x="338497" y="4246055"/>
-            <a:ext cx="14720168" cy="7760911"/>
-          </a:xfrm>
-          <a:prstGeom prst="rect">
-            <a:avLst/>
-          </a:prstGeom>
-          <a:noFill/>
-          <a:ln w="76200">
-            <a:solidFill>
-              <a:srgbClr val="C00000"/>
-            </a:solidFill>
-            <a:miter lim="800000"/>
-            <a:headEnd/>
-            <a:tailEnd/>
-          </a:ln>
-          <a:extLst>
-            <a:ext uri="{909E8E84-426E-40DD-AFC4-6F175D3DCCD1}">
-              <a14:hiddenFill xmlns:a14="http://schemas.microsoft.com/office/drawing/2010/main">
-                <a:solidFill>
-                  <a:srgbClr val="FFFFFF"/>
-                </a:solidFill>
-              </a14:hiddenFill>
-            </a:ext>
-          </a:extLst>
-        </p:spPr>
-        <p:txBody>
-          <a:bodyPr wrap="none" lIns="81274" tIns="40638" rIns="81274" bIns="40638" anchor="ctr"/>
-          <a:lstStyle>
-            <a:lvl1pPr>
-              <a:defRPr sz="2400">
-                <a:solidFill>
-                  <a:schemeClr val="tx1"/>
-                </a:solidFill>
-                <a:latin typeface="Helvetica" panose="020B0604020202020204" pitchFamily="34" charset="0"/>
-                <a:ea typeface="MS PGothic" panose="020B0600070205080204" pitchFamily="34" charset="-128"/>
-              </a:defRPr>
-            </a:lvl1pPr>
-            <a:lvl2pPr marL="742950" indent="-285750">
-              <a:defRPr sz="2400">
-                <a:solidFill>
-                  <a:schemeClr val="tx1"/>
-                </a:solidFill>
-                <a:latin typeface="Helvetica" panose="020B0604020202020204" pitchFamily="34" charset="0"/>
-                <a:ea typeface="MS PGothic" panose="020B0600070205080204" pitchFamily="34" charset="-128"/>
-              </a:defRPr>
-            </a:lvl2pPr>
-            <a:lvl3pPr marL="1143000" indent="-228600">
-              <a:defRPr sz="2400">
-                <a:solidFill>
-                  <a:schemeClr val="tx1"/>
-                </a:solidFill>
-                <a:latin typeface="Helvetica" panose="020B0604020202020204" pitchFamily="34" charset="0"/>
-                <a:ea typeface="MS PGothic" panose="020B0600070205080204" pitchFamily="34" charset="-128"/>
-              </a:defRPr>
-            </a:lvl3pPr>
-            <a:lvl4pPr marL="1600200" indent="-228600">
-              <a:defRPr sz="2400">
-                <a:solidFill>
-                  <a:schemeClr val="tx1"/>
-                </a:solidFill>
-                <a:latin typeface="Helvetica" panose="020B0604020202020204" pitchFamily="34" charset="0"/>
-                <a:ea typeface="MS PGothic" panose="020B0600070205080204" pitchFamily="34" charset="-128"/>
-              </a:defRPr>
-            </a:lvl4pPr>
-            <a:lvl5pPr marL="2057400" indent="-228600">
-              <a:defRPr sz="2400">
-                <a:solidFill>
-                  <a:schemeClr val="tx1"/>
-                </a:solidFill>
-                <a:latin typeface="Helvetica" panose="020B0604020202020204" pitchFamily="34" charset="0"/>
-                <a:ea typeface="MS PGothic" panose="020B0600070205080204" pitchFamily="34" charset="-128"/>
-              </a:defRPr>
-            </a:lvl5pPr>
-            <a:lvl6pPr marL="2514600" indent="-228600" eaLnBrk="0" fontAlgn="base" hangingPunct="0">
-              <a:spcBef>
-                <a:spcPct val="0"/>
-              </a:spcBef>
-              <a:spcAft>
-                <a:spcPct val="0"/>
-              </a:spcAft>
-              <a:defRPr sz="2400">
-                <a:solidFill>
-                  <a:schemeClr val="tx1"/>
-                </a:solidFill>
-                <a:latin typeface="Helvetica" panose="020B0604020202020204" pitchFamily="34" charset="0"/>
-                <a:ea typeface="MS PGothic" panose="020B0600070205080204" pitchFamily="34" charset="-128"/>
-              </a:defRPr>
-            </a:lvl6pPr>
-            <a:lvl7pPr marL="2971800" indent="-228600" eaLnBrk="0" fontAlgn="base" hangingPunct="0">
-              <a:spcBef>
-                <a:spcPct val="0"/>
-              </a:spcBef>
-              <a:spcAft>
-                <a:spcPct val="0"/>
-              </a:spcAft>
-              <a:defRPr sz="2400">
-                <a:solidFill>
-                  <a:schemeClr val="tx1"/>
-                </a:solidFill>
-                <a:latin typeface="Helvetica" panose="020B0604020202020204" pitchFamily="34" charset="0"/>
-                <a:ea typeface="MS PGothic" panose="020B0600070205080204" pitchFamily="34" charset="-128"/>
-              </a:defRPr>
-            </a:lvl7pPr>
-            <a:lvl8pPr marL="3429000" indent="-228600" eaLnBrk="0" fontAlgn="base" hangingPunct="0">
-              <a:spcBef>
-                <a:spcPct val="0"/>
-              </a:spcBef>
-              <a:spcAft>
-                <a:spcPct val="0"/>
-              </a:spcAft>
-              <a:defRPr sz="2400">
-                <a:solidFill>
-                  <a:schemeClr val="tx1"/>
-                </a:solidFill>
-                <a:latin typeface="Helvetica" panose="020B0604020202020204" pitchFamily="34" charset="0"/>
-                <a:ea typeface="MS PGothic" panose="020B0600070205080204" pitchFamily="34" charset="-128"/>
-              </a:defRPr>
-            </a:lvl8pPr>
-            <a:lvl9pPr marL="3886200" indent="-228600" eaLnBrk="0" fontAlgn="base" hangingPunct="0">
-              <a:spcBef>
-                <a:spcPct val="0"/>
-              </a:spcBef>
-              <a:spcAft>
-                <a:spcPct val="0"/>
-              </a:spcAft>
-              <a:defRPr sz="2400">
-                <a:solidFill>
-                  <a:schemeClr val="tx1"/>
-                </a:solidFill>
-                <a:latin typeface="Helvetica" panose="020B0604020202020204" pitchFamily="34" charset="0"/>
-                <a:ea typeface="MS PGothic" panose="020B0600070205080204" pitchFamily="34" charset="-128"/>
-              </a:defRPr>
-            </a:lvl9pPr>
-          </a:lstStyle>
-          <a:p>
-            <a:pPr eaLnBrk="1" hangingPunct="1"/>
-            <a:endParaRPr lang="en-US" altLang="en-US" sz="1245">
-              <a:latin typeface="Trebuchet MS" panose="020B0603020202020204" pitchFamily="34" charset="0"/>
-            </a:endParaRPr>
-          </a:p>
-        </p:txBody>
-      </p:sp>
-      <p:sp>
-        <p:nvSpPr>
           <p:cNvPr id="15388" name="TextBox 2"/>
           <p:cNvSpPr txBox="1">
             <a:spLocks noChangeArrowheads="1"/>
@@ -5275,7 +4778,7 @@
         </p:nvSpPr>
         <p:spPr bwMode="auto">
           <a:xfrm>
-            <a:off x="4842671" y="1958662"/>
+            <a:off x="4842671" y="1755462"/>
             <a:ext cx="33932768" cy="1938992"/>
           </a:xfrm>
           <a:prstGeom prst="rect">
@@ -5686,8 +5189,8 @@
         </p:nvSpPr>
         <p:spPr>
           <a:xfrm>
-            <a:off x="4838490" y="925150"/>
-            <a:ext cx="33151930" cy="1353960"/>
+            <a:off x="3880763" y="50008"/>
+            <a:ext cx="36129673" cy="1669368"/>
           </a:xfrm>
           <a:prstGeom prst="rect">
             <a:avLst/>
@@ -5712,7 +5215,7 @@
               </a:spcAft>
             </a:pPr>
             <a:r>
-              <a:rPr lang="en-US" sz="8000" b="1" i="0" dirty="0">
+              <a:rPr lang="en-US" sz="10000" b="1" i="0" dirty="0">
                 <a:solidFill>
                   <a:srgbClr val="000000"/>
                 </a:solidFill>
@@ -5721,164 +5224,12 @@
               </a:rPr>
               <a:t>Examining Age-Related Differences in Neural Responses to Trust</a:t>
             </a:r>
-            <a:endParaRPr lang="en-US" sz="8000" dirty="0">
+            <a:endParaRPr lang="en-US" sz="10000" dirty="0">
               <a:effectLst/>
               <a:latin typeface="Helvetica"/>
               <a:ea typeface="Calibri" panose="020F0502020204030204" pitchFamily="34" charset="0"/>
               <a:cs typeface="Helvetica"/>
             </a:endParaRPr>
-          </a:p>
-        </p:txBody>
-      </p:sp>
-      <p:sp>
-        <p:nvSpPr>
-          <p:cNvPr id="15361" name="Rectangle 200"/>
-          <p:cNvSpPr>
-            <a:spLocks noChangeArrowheads="1"/>
-          </p:cNvSpPr>
-          <p:nvPr/>
-        </p:nvSpPr>
-        <p:spPr bwMode="auto">
-          <a:xfrm>
-            <a:off x="4858205" y="3968278"/>
-            <a:ext cx="4805795" cy="738724"/>
-          </a:xfrm>
-          <a:prstGeom prst="rect">
-            <a:avLst/>
-          </a:prstGeom>
-          <a:solidFill>
-            <a:schemeClr val="bg1"/>
-          </a:solidFill>
-          <a:ln>
-            <a:noFill/>
-          </a:ln>
-        </p:spPr>
-        <p:txBody>
-          <a:bodyPr wrap="square" lIns="81274" tIns="40638" rIns="81274" bIns="40638">
-            <a:spAutoFit/>
-          </a:bodyPr>
-          <a:lstStyle>
-            <a:lvl1pPr defTabSz="5119688">
-              <a:defRPr sz="2400">
-                <a:solidFill>
-                  <a:schemeClr val="tx1"/>
-                </a:solidFill>
-                <a:latin typeface="Helvetica" panose="020B0604020202020204" pitchFamily="34" charset="0"/>
-                <a:ea typeface="MS PGothic" panose="020B0600070205080204" pitchFamily="34" charset="-128"/>
-              </a:defRPr>
-            </a:lvl1pPr>
-            <a:lvl2pPr marL="742950" indent="-285750" defTabSz="5119688">
-              <a:defRPr sz="2400">
-                <a:solidFill>
-                  <a:schemeClr val="tx1"/>
-                </a:solidFill>
-                <a:latin typeface="Helvetica" panose="020B0604020202020204" pitchFamily="34" charset="0"/>
-                <a:ea typeface="MS PGothic" panose="020B0600070205080204" pitchFamily="34" charset="-128"/>
-              </a:defRPr>
-            </a:lvl2pPr>
-            <a:lvl3pPr marL="1143000" indent="-228600" defTabSz="5119688">
-              <a:defRPr sz="2400">
-                <a:solidFill>
-                  <a:schemeClr val="tx1"/>
-                </a:solidFill>
-                <a:latin typeface="Helvetica" panose="020B0604020202020204" pitchFamily="34" charset="0"/>
-                <a:ea typeface="MS PGothic" panose="020B0600070205080204" pitchFamily="34" charset="-128"/>
-              </a:defRPr>
-            </a:lvl3pPr>
-            <a:lvl4pPr marL="1600200" indent="-228600" defTabSz="5119688">
-              <a:defRPr sz="2400">
-                <a:solidFill>
-                  <a:schemeClr val="tx1"/>
-                </a:solidFill>
-                <a:latin typeface="Helvetica" panose="020B0604020202020204" pitchFamily="34" charset="0"/>
-                <a:ea typeface="MS PGothic" panose="020B0600070205080204" pitchFamily="34" charset="-128"/>
-              </a:defRPr>
-            </a:lvl4pPr>
-            <a:lvl5pPr marL="2057400" indent="-228600" defTabSz="5119688">
-              <a:defRPr sz="2400">
-                <a:solidFill>
-                  <a:schemeClr val="tx1"/>
-                </a:solidFill>
-                <a:latin typeface="Helvetica" panose="020B0604020202020204" pitchFamily="34" charset="0"/>
-                <a:ea typeface="MS PGothic" panose="020B0600070205080204" pitchFamily="34" charset="-128"/>
-              </a:defRPr>
-            </a:lvl5pPr>
-            <a:lvl6pPr marL="2514600" indent="-228600" defTabSz="5119688" eaLnBrk="0" fontAlgn="base" hangingPunct="0">
-              <a:spcBef>
-                <a:spcPct val="0"/>
-              </a:spcBef>
-              <a:spcAft>
-                <a:spcPct val="0"/>
-              </a:spcAft>
-              <a:defRPr sz="2400">
-                <a:solidFill>
-                  <a:schemeClr val="tx1"/>
-                </a:solidFill>
-                <a:latin typeface="Helvetica" panose="020B0604020202020204" pitchFamily="34" charset="0"/>
-                <a:ea typeface="MS PGothic" panose="020B0600070205080204" pitchFamily="34" charset="-128"/>
-              </a:defRPr>
-            </a:lvl6pPr>
-            <a:lvl7pPr marL="2971800" indent="-228600" defTabSz="5119688" eaLnBrk="0" fontAlgn="base" hangingPunct="0">
-              <a:spcBef>
-                <a:spcPct val="0"/>
-              </a:spcBef>
-              <a:spcAft>
-                <a:spcPct val="0"/>
-              </a:spcAft>
-              <a:defRPr sz="2400">
-                <a:solidFill>
-                  <a:schemeClr val="tx1"/>
-                </a:solidFill>
-                <a:latin typeface="Helvetica" panose="020B0604020202020204" pitchFamily="34" charset="0"/>
-                <a:ea typeface="MS PGothic" panose="020B0600070205080204" pitchFamily="34" charset="-128"/>
-              </a:defRPr>
-            </a:lvl7pPr>
-            <a:lvl8pPr marL="3429000" indent="-228600" defTabSz="5119688" eaLnBrk="0" fontAlgn="base" hangingPunct="0">
-              <a:spcBef>
-                <a:spcPct val="0"/>
-              </a:spcBef>
-              <a:spcAft>
-                <a:spcPct val="0"/>
-              </a:spcAft>
-              <a:defRPr sz="2400">
-                <a:solidFill>
-                  <a:schemeClr val="tx1"/>
-                </a:solidFill>
-                <a:latin typeface="Helvetica" panose="020B0604020202020204" pitchFamily="34" charset="0"/>
-                <a:ea typeface="MS PGothic" panose="020B0600070205080204" pitchFamily="34" charset="-128"/>
-              </a:defRPr>
-            </a:lvl8pPr>
-            <a:lvl9pPr marL="3886200" indent="-228600" defTabSz="5119688" eaLnBrk="0" fontAlgn="base" hangingPunct="0">
-              <a:spcBef>
-                <a:spcPct val="0"/>
-              </a:spcBef>
-              <a:spcAft>
-                <a:spcPct val="0"/>
-              </a:spcAft>
-              <a:defRPr sz="2400">
-                <a:solidFill>
-                  <a:schemeClr val="tx1"/>
-                </a:solidFill>
-                <a:latin typeface="Helvetica" panose="020B0604020202020204" pitchFamily="34" charset="0"/>
-                <a:ea typeface="MS PGothic" panose="020B0600070205080204" pitchFamily="34" charset="-128"/>
-              </a:defRPr>
-            </a:lvl9pPr>
-          </a:lstStyle>
-          <a:p>
-            <a:pPr algn="ctr">
-              <a:spcBef>
-                <a:spcPct val="50000"/>
-              </a:spcBef>
-            </a:pPr>
-            <a:r>
-              <a:rPr lang="en-US" altLang="en-US" sz="4267" b="1">
-                <a:solidFill>
-                  <a:srgbClr val="C00000"/>
-                </a:solidFill>
-                <a:latin typeface="Trebuchet MS" panose="020B0603020202020204" pitchFamily="34" charset="0"/>
-              </a:rPr>
-              <a:t>1. Introduction</a:t>
-            </a:r>
           </a:p>
         </p:txBody>
       </p:sp>
@@ -6193,7 +5544,7 @@
         <p:spPr>
           <a:xfrm>
             <a:off x="15599737" y="31508836"/>
-            <a:ext cx="14699076" cy="584775"/>
+            <a:ext cx="14699076" cy="1077218"/>
           </a:xfrm>
           <a:prstGeom prst="rect">
             <a:avLst/>
@@ -6207,17 +5558,12 @@
           <a:p>
             <a:pPr algn="ctr"/>
             <a:r>
-              <a:rPr lang="en-US" sz="3200" spc="15" dirty="0">
-                <a:latin typeface="Helvetica"/>
+              <a:rPr lang="en-US" sz="3200" dirty="0">
                 <a:ea typeface="MS PGothic"/>
                 <a:cs typeface="Helvetica"/>
               </a:rPr>
-              <a:t>…</a:t>
+              <a:t>We found that a higher difference in closeness ratings between friends and strangers was associated with an increase in ACC activation</a:t>
             </a:r>
-            <a:endParaRPr lang="en-US" sz="3200" dirty="0">
-              <a:ea typeface="MS PGothic"/>
-              <a:cs typeface="Helvetica"/>
-            </a:endParaRPr>
           </a:p>
         </p:txBody>
       </p:sp>
@@ -6523,7 +5869,7 @@
                 <a:latin typeface="Trebuchet MS"/>
                 <a:ea typeface="MS PGothic"/>
               </a:rPr>
-              <a:t>5. Neural Activation in the ACC is Associated with IOS Scores</a:t>
+              <a:t>5. Neural Activation in the Anterior Cingulate Cortex (ACC) is Associated with IOS Scores</a:t>
             </a:r>
           </a:p>
         </p:txBody>
@@ -7204,49 +6550,6 @@
       </p:sp>
       <p:sp>
         <p:nvSpPr>
-          <p:cNvPr id="25" name="Rectangle 24">
-            <a:extLst>
-              <a:ext uri="{FF2B5EF4-FFF2-40B4-BE49-F238E27FC236}">
-                <a16:creationId xmlns:a16="http://schemas.microsoft.com/office/drawing/2014/main" id="{5AEA1BD0-929B-B248-91B7-4A1AD3CCB35E}"/>
-              </a:ext>
-            </a:extLst>
-          </p:cNvPr>
-          <p:cNvSpPr/>
-          <p:nvPr/>
-        </p:nvSpPr>
-        <p:spPr>
-          <a:xfrm>
-            <a:off x="15426443" y="24805358"/>
-            <a:ext cx="14625853" cy="584775"/>
-          </a:xfrm>
-          <a:prstGeom prst="rect">
-            <a:avLst/>
-          </a:prstGeom>
-        </p:spPr>
-        <p:txBody>
-          <a:bodyPr wrap="square" lIns="91440" tIns="45720" rIns="91440" bIns="45720" anchor="t">
-            <a:spAutoFit/>
-          </a:bodyPr>
-          <a:lstStyle/>
-          <a:p>
-            <a:pPr algn="ctr"/>
-            <a:r>
-              <a:rPr lang="en-US" sz="3200" i="1" dirty="0">
-                <a:latin typeface="Helvetica"/>
-                <a:ea typeface="MS PGothic"/>
-                <a:cs typeface="Helvetica"/>
-              </a:rPr>
-              <a:t>…</a:t>
-            </a:r>
-            <a:endParaRPr lang="en-US" sz="3200" i="1" dirty="0">
-              <a:latin typeface="Helvetica"/>
-              <a:cs typeface="Helvetica"/>
-            </a:endParaRPr>
-          </a:p>
-        </p:txBody>
-      </p:sp>
-      <p:sp>
-        <p:nvSpPr>
           <p:cNvPr id="26" name="Rectangle 25">
             <a:extLst>
               <a:ext uri="{FF2B5EF4-FFF2-40B4-BE49-F238E27FC236}">
@@ -7286,7 +6589,7 @@
                 <a:ea typeface="MS PGothic"/>
                 <a:cs typeface="Helvetica"/>
               </a:rPr>
-              <a:t>We found VS activation for Reciprocate &gt; Defect outcomes</a:t>
+              <a:t>We found Ventral Striatum (VS) activation for Reciprocate &gt; Defect outcomes</a:t>
             </a:r>
             <a:endParaRPr lang="en-US" sz="3200" i="1" dirty="0">
               <a:cs typeface="Helvetica" panose="020B0604020202020204" pitchFamily="34" charset="0"/>
@@ -7328,7 +6631,7 @@
                 <a:latin typeface="Helvetica"/>
                 <a:ea typeface="MS PGothic"/>
               </a:rPr>
-              <a:t>We found increasing activation in the Ventral Stratum (VS) when participants were presented with a reciprocate outcome as opposed to a defect outcome.</a:t>
+              <a:t>We found increasing activation in the VS when participants were presented with a reciprocate outcome as opposed to a defect outcome.</a:t>
             </a:r>
           </a:p>
         </p:txBody>
@@ -7378,281 +6681,803 @@
           </a:p>
         </p:txBody>
       </p:sp>
-      <p:sp>
-        <p:nvSpPr>
-          <p:cNvPr id="66" name="TextBox 65">
+      <p:grpSp>
+        <p:nvGrpSpPr>
+          <p:cNvPr id="15525" name="Group 15524">
             <a:extLst>
               <a:ext uri="{FF2B5EF4-FFF2-40B4-BE49-F238E27FC236}">
-                <a16:creationId xmlns:a16="http://schemas.microsoft.com/office/drawing/2014/main" id="{828EF0BF-392F-46C6-BF23-BF99B2CEA917}"/>
+                <a16:creationId xmlns:a16="http://schemas.microsoft.com/office/drawing/2014/main" id="{495044C5-5185-1E74-1C51-F36E8CA64CBA}"/>
               </a:ext>
             </a:extLst>
           </p:cNvPr>
-          <p:cNvSpPr txBox="1"/>
+          <p:cNvGrpSpPr/>
           <p:nvPr/>
-        </p:nvSpPr>
-        <p:spPr>
+        </p:nvGrpSpPr>
+        <p:grpSpPr>
           <a:xfrm>
-            <a:off x="333765" y="9945451"/>
-            <a:ext cx="14639262" cy="2031325"/>
+            <a:off x="169367" y="3967558"/>
+            <a:ext cx="14831195" cy="8123743"/>
+            <a:chOff x="211346" y="3968278"/>
+            <a:chExt cx="14831195" cy="8123743"/>
           </a:xfrm>
-          <a:prstGeom prst="rect">
-            <a:avLst/>
-          </a:prstGeom>
-          <a:noFill/>
-        </p:spPr>
-        <p:txBody>
-          <a:bodyPr wrap="square" lIns="91440" tIns="45720" rIns="91440" bIns="45720" anchor="t">
-            <a:spAutoFit/>
-          </a:bodyPr>
-          <a:lstStyle/>
-          <a:p>
-            <a:pPr algn="ctr">
-              <a:spcBef>
-                <a:spcPts val="360"/>
-              </a:spcBef>
-              <a:spcAft>
-                <a:spcPts val="0"/>
-              </a:spcAft>
-            </a:pPr>
-            <a:r>
-              <a:rPr lang="en-US" sz="4200" b="1" dirty="0">
-                <a:latin typeface="Helvetica"/>
+        </p:grpSpPr>
+        <p:sp>
+          <p:nvSpPr>
+            <p:cNvPr id="15362" name="TextBox 189"/>
+            <p:cNvSpPr txBox="1">
+              <a:spLocks noChangeArrowheads="1"/>
+            </p:cNvSpPr>
+            <p:nvPr/>
+          </p:nvSpPr>
+          <p:spPr bwMode="auto">
+            <a:xfrm>
+              <a:off x="515553" y="4761579"/>
+              <a:ext cx="14526988" cy="5016758"/>
+            </a:xfrm>
+            <a:prstGeom prst="rect">
+              <a:avLst/>
+            </a:prstGeom>
+            <a:noFill/>
+            <a:ln>
+              <a:noFill/>
+            </a:ln>
+            <a:extLst>
+              <a:ext uri="{909E8E84-426E-40DD-AFC4-6F175D3DCCD1}">
+                <a14:hiddenFill xmlns:a14="http://schemas.microsoft.com/office/drawing/2010/main">
+                  <a:solidFill>
+                    <a:srgbClr val="FFFFFF"/>
+                  </a:solidFill>
+                </a14:hiddenFill>
+              </a:ext>
+              <a:ext uri="{91240B29-F687-4F45-9708-019B960494DF}">
+                <a14:hiddenLine xmlns:a14="http://schemas.microsoft.com/office/drawing/2010/main" w="9525">
+                  <a:solidFill>
+                    <a:srgbClr val="000000"/>
+                  </a:solidFill>
+                  <a:miter lim="800000"/>
+                  <a:headEnd/>
+                  <a:tailEnd/>
+                </a14:hiddenLine>
+              </a:ext>
+            </a:extLst>
+          </p:spPr>
+          <p:txBody>
+            <a:bodyPr wrap="square" lIns="91440" tIns="45720" rIns="91440" bIns="45720" anchor="t">
+              <a:spAutoFit/>
+            </a:bodyPr>
+            <a:lstStyle>
+              <a:lvl1pPr>
+                <a:defRPr sz="2400">
+                  <a:solidFill>
+                    <a:schemeClr val="tx1"/>
+                  </a:solidFill>
+                  <a:latin typeface="Helvetica" panose="020B0604020202020204" pitchFamily="34" charset="0"/>
+                  <a:ea typeface="MS PGothic" panose="020B0600070205080204" pitchFamily="34" charset="-128"/>
+                </a:defRPr>
+              </a:lvl1pPr>
+              <a:lvl2pPr marL="742950" indent="-285750">
+                <a:defRPr sz="2400">
+                  <a:solidFill>
+                    <a:schemeClr val="tx1"/>
+                  </a:solidFill>
+                  <a:latin typeface="Helvetica" panose="020B0604020202020204" pitchFamily="34" charset="0"/>
+                  <a:ea typeface="MS PGothic" panose="020B0600070205080204" pitchFamily="34" charset="-128"/>
+                </a:defRPr>
+              </a:lvl2pPr>
+              <a:lvl3pPr marL="1143000" indent="-228600">
+                <a:defRPr sz="2400">
+                  <a:solidFill>
+                    <a:schemeClr val="tx1"/>
+                  </a:solidFill>
+                  <a:latin typeface="Helvetica" panose="020B0604020202020204" pitchFamily="34" charset="0"/>
+                  <a:ea typeface="MS PGothic" panose="020B0600070205080204" pitchFamily="34" charset="-128"/>
+                </a:defRPr>
+              </a:lvl3pPr>
+              <a:lvl4pPr marL="1600200" indent="-228600">
+                <a:defRPr sz="2400">
+                  <a:solidFill>
+                    <a:schemeClr val="tx1"/>
+                  </a:solidFill>
+                  <a:latin typeface="Helvetica" panose="020B0604020202020204" pitchFamily="34" charset="0"/>
+                  <a:ea typeface="MS PGothic" panose="020B0600070205080204" pitchFamily="34" charset="-128"/>
+                </a:defRPr>
+              </a:lvl4pPr>
+              <a:lvl5pPr marL="2057400" indent="-228600">
+                <a:defRPr sz="2400">
+                  <a:solidFill>
+                    <a:schemeClr val="tx1"/>
+                  </a:solidFill>
+                  <a:latin typeface="Helvetica" panose="020B0604020202020204" pitchFamily="34" charset="0"/>
+                  <a:ea typeface="MS PGothic" panose="020B0600070205080204" pitchFamily="34" charset="-128"/>
+                </a:defRPr>
+              </a:lvl5pPr>
+              <a:lvl6pPr marL="2514600" indent="-228600" eaLnBrk="0" fontAlgn="base" hangingPunct="0">
+                <a:spcBef>
+                  <a:spcPct val="0"/>
+                </a:spcBef>
+                <a:spcAft>
+                  <a:spcPct val="0"/>
+                </a:spcAft>
+                <a:defRPr sz="2400">
+                  <a:solidFill>
+                    <a:schemeClr val="tx1"/>
+                  </a:solidFill>
+                  <a:latin typeface="Helvetica" panose="020B0604020202020204" pitchFamily="34" charset="0"/>
+                  <a:ea typeface="MS PGothic" panose="020B0600070205080204" pitchFamily="34" charset="-128"/>
+                </a:defRPr>
+              </a:lvl6pPr>
+              <a:lvl7pPr marL="2971800" indent="-228600" eaLnBrk="0" fontAlgn="base" hangingPunct="0">
+                <a:spcBef>
+                  <a:spcPct val="0"/>
+                </a:spcBef>
+                <a:spcAft>
+                  <a:spcPct val="0"/>
+                </a:spcAft>
+                <a:defRPr sz="2400">
+                  <a:solidFill>
+                    <a:schemeClr val="tx1"/>
+                  </a:solidFill>
+                  <a:latin typeface="Helvetica" panose="020B0604020202020204" pitchFamily="34" charset="0"/>
+                  <a:ea typeface="MS PGothic" panose="020B0600070205080204" pitchFamily="34" charset="-128"/>
+                </a:defRPr>
+              </a:lvl7pPr>
+              <a:lvl8pPr marL="3429000" indent="-228600" eaLnBrk="0" fontAlgn="base" hangingPunct="0">
+                <a:spcBef>
+                  <a:spcPct val="0"/>
+                </a:spcBef>
+                <a:spcAft>
+                  <a:spcPct val="0"/>
+                </a:spcAft>
+                <a:defRPr sz="2400">
+                  <a:solidFill>
+                    <a:schemeClr val="tx1"/>
+                  </a:solidFill>
+                  <a:latin typeface="Helvetica" panose="020B0604020202020204" pitchFamily="34" charset="0"/>
+                  <a:ea typeface="MS PGothic" panose="020B0600070205080204" pitchFamily="34" charset="-128"/>
+                </a:defRPr>
+              </a:lvl8pPr>
+              <a:lvl9pPr marL="3886200" indent="-228600" eaLnBrk="0" fontAlgn="base" hangingPunct="0">
+                <a:spcBef>
+                  <a:spcPct val="0"/>
+                </a:spcBef>
+                <a:spcAft>
+                  <a:spcPct val="0"/>
+                </a:spcAft>
+                <a:defRPr sz="2400">
+                  <a:solidFill>
+                    <a:schemeClr val="tx1"/>
+                  </a:solidFill>
+                  <a:latin typeface="Helvetica" panose="020B0604020202020204" pitchFamily="34" charset="0"/>
+                  <a:ea typeface="MS PGothic" panose="020B0600070205080204" pitchFamily="34" charset="-128"/>
+                </a:defRPr>
+              </a:lvl9pPr>
+            </a:lstStyle>
+            <a:p>
+              <a:pPr>
+                <a:spcBef>
+                  <a:spcPts val="0"/>
+                </a:spcBef>
+                <a:spcAft>
+                  <a:spcPts val="0"/>
+                </a:spcAft>
+                <a:buFont typeface="Arial" panose="020B0604020202020204" pitchFamily="34" charset="0"/>
+                <a:buChar char="•"/>
+              </a:pPr>
+              <a:r>
+                <a:rPr lang="en-US" sz="4000" dirty="0">
+                  <a:latin typeface="Helvetica"/>
+                  <a:ea typeface="MS PGothic"/>
+                  <a:cs typeface="Helvetica"/>
+                </a:rPr>
+                <a:t> </a:t>
+              </a:r>
+              <a:r>
+                <a:rPr lang="en-US" sz="4000" b="0" i="0" dirty="0">
+                  <a:solidFill>
+                    <a:srgbClr val="000000"/>
+                  </a:solidFill>
+                  <a:effectLst/>
+                  <a:latin typeface="Helvetica" pitchFamily="2" charset="0"/>
+                </a:rPr>
+                <a:t>Social relationships influence our behaviors and may modulate our neural responses to reward. (</a:t>
+              </a:r>
+              <a:r>
+                <a:rPr lang="en-US" sz="4000" b="0" i="0" dirty="0" err="1">
+                  <a:solidFill>
+                    <a:srgbClr val="000000"/>
+                  </a:solidFill>
+                  <a:effectLst/>
+                  <a:latin typeface="Helvetica" pitchFamily="2" charset="0"/>
+                </a:rPr>
+                <a:t>Fareri</a:t>
+              </a:r>
+              <a:r>
+                <a:rPr lang="en-US" sz="4000" b="0" i="0" dirty="0">
+                  <a:solidFill>
+                    <a:srgbClr val="000000"/>
+                  </a:solidFill>
+                  <a:effectLst/>
+                  <a:latin typeface="Helvetica" pitchFamily="2" charset="0"/>
+                </a:rPr>
+                <a:t> et al., 2015)</a:t>
+              </a:r>
+              <a:endParaRPr lang="en-US" sz="4000" dirty="0">
+                <a:latin typeface="Helvetica" pitchFamily="2" charset="0"/>
                 <a:ea typeface="MS PGothic"/>
                 <a:cs typeface="Helvetica"/>
-              </a:rPr>
-              <a:t>We</a:t>
-            </a:r>
-            <a:r>
-              <a:rPr lang="en-US" sz="4200" b="1" i="0" u="none" strike="noStrike" dirty="0">
-                <a:effectLst/>
-                <a:latin typeface="Helvetica"/>
+              </a:endParaRPr>
+            </a:p>
+            <a:p>
+              <a:pPr>
+                <a:spcBef>
+                  <a:spcPts val="0"/>
+                </a:spcBef>
+                <a:spcAft>
+                  <a:spcPts val="0"/>
+                </a:spcAft>
+                <a:buFont typeface="Arial" panose="020B0604020202020204" pitchFamily="34" charset="0"/>
+                <a:buChar char="•"/>
+              </a:pPr>
+              <a:r>
+                <a:rPr lang="en-US" sz="4000" dirty="0">
+                  <a:latin typeface="Helvetica"/>
+                  <a:ea typeface="MS PGothic"/>
+                  <a:cs typeface="Helvetica"/>
+                </a:rPr>
+                <a:t> </a:t>
+              </a:r>
+              <a:r>
+                <a:rPr lang="en-US" sz="4000" dirty="0">
+                  <a:solidFill>
+                    <a:srgbClr val="000000"/>
+                  </a:solidFill>
+                  <a:latin typeface="Helvetica" pitchFamily="2" charset="0"/>
+                  <a:ea typeface="MS PGothic"/>
+                  <a:cs typeface="Helvetica"/>
+                </a:rPr>
+                <a:t>Th</a:t>
+              </a:r>
+              <a:r>
+                <a:rPr lang="en-US" sz="4000" b="0" i="0" dirty="0">
+                  <a:solidFill>
+                    <a:srgbClr val="000000"/>
+                  </a:solidFill>
+                  <a:effectLst/>
+                  <a:latin typeface="Helvetica" pitchFamily="2" charset="0"/>
+                </a:rPr>
+                <a:t>e effect of relationships on behavior and reward activation may change as we age. (</a:t>
+              </a:r>
+              <a:r>
+                <a:rPr lang="en-US" sz="4000" b="0" i="0" dirty="0" err="1">
+                  <a:solidFill>
+                    <a:srgbClr val="000000"/>
+                  </a:solidFill>
+                  <a:effectLst/>
+                  <a:latin typeface="Helvetica" pitchFamily="2" charset="0"/>
+                </a:rPr>
+                <a:t>Fareri</a:t>
+              </a:r>
+              <a:r>
+                <a:rPr lang="en-US" sz="4000" b="0" i="0" dirty="0">
+                  <a:solidFill>
+                    <a:srgbClr val="000000"/>
+                  </a:solidFill>
+                  <a:effectLst/>
+                  <a:latin typeface="Helvetica" pitchFamily="2" charset="0"/>
+                </a:rPr>
+                <a:t> et al., 2022)</a:t>
+              </a:r>
+            </a:p>
+            <a:p>
+              <a:pPr>
+                <a:spcBef>
+                  <a:spcPts val="0"/>
+                </a:spcBef>
+                <a:spcAft>
+                  <a:spcPts val="0"/>
+                </a:spcAft>
+              </a:pPr>
+              <a:endParaRPr lang="en-US" sz="4000" dirty="0">
+                <a:latin typeface="Helvetica" pitchFamily="2" charset="0"/>
                 <a:ea typeface="MS PGothic"/>
                 <a:cs typeface="Helvetica"/>
-              </a:rPr>
-              <a:t> investigated </a:t>
-            </a:r>
-            <a:r>
-              <a:rPr lang="en-US" sz="4200" b="1" dirty="0">
-                <a:latin typeface="Helvetica"/>
+              </a:endParaRPr>
+            </a:p>
+            <a:p>
+              <a:pPr>
+                <a:spcBef>
+                  <a:spcPts val="0"/>
+                </a:spcBef>
+                <a:spcAft>
+                  <a:spcPts val="0"/>
+                </a:spcAft>
+              </a:pPr>
+              <a:r>
+                <a:rPr lang="en-US" sz="4000" b="0" i="1" dirty="0">
+                  <a:solidFill>
+                    <a:srgbClr val="000000"/>
+                  </a:solidFill>
+                  <a:effectLst/>
+                  <a:latin typeface="Helvetica" pitchFamily="2" charset="0"/>
+                </a:rPr>
+                <a:t>It remains unclear whether age-related differences in responses to trust are associated with maladaptive outcomes such as financial exploitation.</a:t>
+              </a:r>
+              <a:endParaRPr lang="en-US" sz="4000" i="1" dirty="0">
+                <a:latin typeface="Helvetica" pitchFamily="2" charset="0"/>
                 <a:ea typeface="MS PGothic"/>
                 <a:cs typeface="Helvetica"/>
-              </a:rPr>
-              <a:t>whether social trust decisions change as we age, and how those changes could be related to financial exploitation.</a:t>
-            </a:r>
-            <a:endParaRPr lang="en-US" sz="4200" b="1" dirty="0">
-              <a:cs typeface="Helvetica"/>
-            </a:endParaRPr>
-          </a:p>
-        </p:txBody>
-      </p:sp>
-      <p:sp>
-        <p:nvSpPr>
-          <p:cNvPr id="35" name="TextBox 34">
+              </a:endParaRPr>
+            </a:p>
+          </p:txBody>
+        </p:sp>
+        <p:sp>
+          <p:nvSpPr>
+            <p:cNvPr id="15369" name="Rectangle 162"/>
+            <p:cNvSpPr>
+              <a:spLocks noChangeArrowheads="1"/>
+            </p:cNvSpPr>
+            <p:nvPr/>
+          </p:nvSpPr>
+          <p:spPr bwMode="auto">
+            <a:xfrm>
+              <a:off x="211346" y="4331110"/>
+              <a:ext cx="14720168" cy="7760911"/>
+            </a:xfrm>
+            <a:prstGeom prst="rect">
+              <a:avLst/>
+            </a:prstGeom>
+            <a:noFill/>
+            <a:ln w="76200">
+              <a:solidFill>
+                <a:srgbClr val="C00000"/>
+              </a:solidFill>
+              <a:miter lim="800000"/>
+              <a:headEnd/>
+              <a:tailEnd/>
+            </a:ln>
+            <a:extLst>
+              <a:ext uri="{909E8E84-426E-40DD-AFC4-6F175D3DCCD1}">
+                <a14:hiddenFill xmlns:a14="http://schemas.microsoft.com/office/drawing/2010/main">
+                  <a:solidFill>
+                    <a:srgbClr val="FFFFFF"/>
+                  </a:solidFill>
+                </a14:hiddenFill>
+              </a:ext>
+            </a:extLst>
+          </p:spPr>
+          <p:txBody>
+            <a:bodyPr wrap="none" lIns="81274" tIns="40638" rIns="81274" bIns="40638" anchor="ctr"/>
+            <a:lstStyle>
+              <a:lvl1pPr>
+                <a:defRPr sz="2400">
+                  <a:solidFill>
+                    <a:schemeClr val="tx1"/>
+                  </a:solidFill>
+                  <a:latin typeface="Helvetica" panose="020B0604020202020204" pitchFamily="34" charset="0"/>
+                  <a:ea typeface="MS PGothic" panose="020B0600070205080204" pitchFamily="34" charset="-128"/>
+                </a:defRPr>
+              </a:lvl1pPr>
+              <a:lvl2pPr marL="742950" indent="-285750">
+                <a:defRPr sz="2400">
+                  <a:solidFill>
+                    <a:schemeClr val="tx1"/>
+                  </a:solidFill>
+                  <a:latin typeface="Helvetica" panose="020B0604020202020204" pitchFamily="34" charset="0"/>
+                  <a:ea typeface="MS PGothic" panose="020B0600070205080204" pitchFamily="34" charset="-128"/>
+                </a:defRPr>
+              </a:lvl2pPr>
+              <a:lvl3pPr marL="1143000" indent="-228600">
+                <a:defRPr sz="2400">
+                  <a:solidFill>
+                    <a:schemeClr val="tx1"/>
+                  </a:solidFill>
+                  <a:latin typeface="Helvetica" panose="020B0604020202020204" pitchFamily="34" charset="0"/>
+                  <a:ea typeface="MS PGothic" panose="020B0600070205080204" pitchFamily="34" charset="-128"/>
+                </a:defRPr>
+              </a:lvl3pPr>
+              <a:lvl4pPr marL="1600200" indent="-228600">
+                <a:defRPr sz="2400">
+                  <a:solidFill>
+                    <a:schemeClr val="tx1"/>
+                  </a:solidFill>
+                  <a:latin typeface="Helvetica" panose="020B0604020202020204" pitchFamily="34" charset="0"/>
+                  <a:ea typeface="MS PGothic" panose="020B0600070205080204" pitchFamily="34" charset="-128"/>
+                </a:defRPr>
+              </a:lvl4pPr>
+              <a:lvl5pPr marL="2057400" indent="-228600">
+                <a:defRPr sz="2400">
+                  <a:solidFill>
+                    <a:schemeClr val="tx1"/>
+                  </a:solidFill>
+                  <a:latin typeface="Helvetica" panose="020B0604020202020204" pitchFamily="34" charset="0"/>
+                  <a:ea typeface="MS PGothic" panose="020B0600070205080204" pitchFamily="34" charset="-128"/>
+                </a:defRPr>
+              </a:lvl5pPr>
+              <a:lvl6pPr marL="2514600" indent="-228600" eaLnBrk="0" fontAlgn="base" hangingPunct="0">
+                <a:spcBef>
+                  <a:spcPct val="0"/>
+                </a:spcBef>
+                <a:spcAft>
+                  <a:spcPct val="0"/>
+                </a:spcAft>
+                <a:defRPr sz="2400">
+                  <a:solidFill>
+                    <a:schemeClr val="tx1"/>
+                  </a:solidFill>
+                  <a:latin typeface="Helvetica" panose="020B0604020202020204" pitchFamily="34" charset="0"/>
+                  <a:ea typeface="MS PGothic" panose="020B0600070205080204" pitchFamily="34" charset="-128"/>
+                </a:defRPr>
+              </a:lvl6pPr>
+              <a:lvl7pPr marL="2971800" indent="-228600" eaLnBrk="0" fontAlgn="base" hangingPunct="0">
+                <a:spcBef>
+                  <a:spcPct val="0"/>
+                </a:spcBef>
+                <a:spcAft>
+                  <a:spcPct val="0"/>
+                </a:spcAft>
+                <a:defRPr sz="2400">
+                  <a:solidFill>
+                    <a:schemeClr val="tx1"/>
+                  </a:solidFill>
+                  <a:latin typeface="Helvetica" panose="020B0604020202020204" pitchFamily="34" charset="0"/>
+                  <a:ea typeface="MS PGothic" panose="020B0600070205080204" pitchFamily="34" charset="-128"/>
+                </a:defRPr>
+              </a:lvl7pPr>
+              <a:lvl8pPr marL="3429000" indent="-228600" eaLnBrk="0" fontAlgn="base" hangingPunct="0">
+                <a:spcBef>
+                  <a:spcPct val="0"/>
+                </a:spcBef>
+                <a:spcAft>
+                  <a:spcPct val="0"/>
+                </a:spcAft>
+                <a:defRPr sz="2400">
+                  <a:solidFill>
+                    <a:schemeClr val="tx1"/>
+                  </a:solidFill>
+                  <a:latin typeface="Helvetica" panose="020B0604020202020204" pitchFamily="34" charset="0"/>
+                  <a:ea typeface="MS PGothic" panose="020B0600070205080204" pitchFamily="34" charset="-128"/>
+                </a:defRPr>
+              </a:lvl8pPr>
+              <a:lvl9pPr marL="3886200" indent="-228600" eaLnBrk="0" fontAlgn="base" hangingPunct="0">
+                <a:spcBef>
+                  <a:spcPct val="0"/>
+                </a:spcBef>
+                <a:spcAft>
+                  <a:spcPct val="0"/>
+                </a:spcAft>
+                <a:defRPr sz="2400">
+                  <a:solidFill>
+                    <a:schemeClr val="tx1"/>
+                  </a:solidFill>
+                  <a:latin typeface="Helvetica" panose="020B0604020202020204" pitchFamily="34" charset="0"/>
+                  <a:ea typeface="MS PGothic" panose="020B0600070205080204" pitchFamily="34" charset="-128"/>
+                </a:defRPr>
+              </a:lvl9pPr>
+            </a:lstStyle>
+            <a:p>
+              <a:pPr eaLnBrk="1" hangingPunct="1"/>
+              <a:endParaRPr lang="en-US" altLang="en-US" sz="1245" dirty="0">
+                <a:latin typeface="Trebuchet MS" panose="020B0603020202020204" pitchFamily="34" charset="0"/>
+              </a:endParaRPr>
+            </a:p>
+          </p:txBody>
+        </p:sp>
+        <p:sp>
+          <p:nvSpPr>
+            <p:cNvPr id="15361" name="Rectangle 200"/>
+            <p:cNvSpPr>
+              <a:spLocks noChangeArrowheads="1"/>
+            </p:cNvSpPr>
+            <p:nvPr/>
+          </p:nvSpPr>
+          <p:spPr bwMode="auto">
+            <a:xfrm>
+              <a:off x="4858205" y="3968278"/>
+              <a:ext cx="4805795" cy="738724"/>
+            </a:xfrm>
+            <a:prstGeom prst="rect">
+              <a:avLst/>
+            </a:prstGeom>
+            <a:solidFill>
+              <a:schemeClr val="bg1"/>
+            </a:solidFill>
+            <a:ln>
+              <a:noFill/>
+            </a:ln>
+          </p:spPr>
+          <p:txBody>
+            <a:bodyPr wrap="square" lIns="81274" tIns="40638" rIns="81274" bIns="40638">
+              <a:spAutoFit/>
+            </a:bodyPr>
+            <a:lstStyle>
+              <a:lvl1pPr defTabSz="5119688">
+                <a:defRPr sz="2400">
+                  <a:solidFill>
+                    <a:schemeClr val="tx1"/>
+                  </a:solidFill>
+                  <a:latin typeface="Helvetica" panose="020B0604020202020204" pitchFamily="34" charset="0"/>
+                  <a:ea typeface="MS PGothic" panose="020B0600070205080204" pitchFamily="34" charset="-128"/>
+                </a:defRPr>
+              </a:lvl1pPr>
+              <a:lvl2pPr marL="742950" indent="-285750" defTabSz="5119688">
+                <a:defRPr sz="2400">
+                  <a:solidFill>
+                    <a:schemeClr val="tx1"/>
+                  </a:solidFill>
+                  <a:latin typeface="Helvetica" panose="020B0604020202020204" pitchFamily="34" charset="0"/>
+                  <a:ea typeface="MS PGothic" panose="020B0600070205080204" pitchFamily="34" charset="-128"/>
+                </a:defRPr>
+              </a:lvl2pPr>
+              <a:lvl3pPr marL="1143000" indent="-228600" defTabSz="5119688">
+                <a:defRPr sz="2400">
+                  <a:solidFill>
+                    <a:schemeClr val="tx1"/>
+                  </a:solidFill>
+                  <a:latin typeface="Helvetica" panose="020B0604020202020204" pitchFamily="34" charset="0"/>
+                  <a:ea typeface="MS PGothic" panose="020B0600070205080204" pitchFamily="34" charset="-128"/>
+                </a:defRPr>
+              </a:lvl3pPr>
+              <a:lvl4pPr marL="1600200" indent="-228600" defTabSz="5119688">
+                <a:defRPr sz="2400">
+                  <a:solidFill>
+                    <a:schemeClr val="tx1"/>
+                  </a:solidFill>
+                  <a:latin typeface="Helvetica" panose="020B0604020202020204" pitchFamily="34" charset="0"/>
+                  <a:ea typeface="MS PGothic" panose="020B0600070205080204" pitchFamily="34" charset="-128"/>
+                </a:defRPr>
+              </a:lvl4pPr>
+              <a:lvl5pPr marL="2057400" indent="-228600" defTabSz="5119688">
+                <a:defRPr sz="2400">
+                  <a:solidFill>
+                    <a:schemeClr val="tx1"/>
+                  </a:solidFill>
+                  <a:latin typeface="Helvetica" panose="020B0604020202020204" pitchFamily="34" charset="0"/>
+                  <a:ea typeface="MS PGothic" panose="020B0600070205080204" pitchFamily="34" charset="-128"/>
+                </a:defRPr>
+              </a:lvl5pPr>
+              <a:lvl6pPr marL="2514600" indent="-228600" defTabSz="5119688" eaLnBrk="0" fontAlgn="base" hangingPunct="0">
+                <a:spcBef>
+                  <a:spcPct val="0"/>
+                </a:spcBef>
+                <a:spcAft>
+                  <a:spcPct val="0"/>
+                </a:spcAft>
+                <a:defRPr sz="2400">
+                  <a:solidFill>
+                    <a:schemeClr val="tx1"/>
+                  </a:solidFill>
+                  <a:latin typeface="Helvetica" panose="020B0604020202020204" pitchFamily="34" charset="0"/>
+                  <a:ea typeface="MS PGothic" panose="020B0600070205080204" pitchFamily="34" charset="-128"/>
+                </a:defRPr>
+              </a:lvl6pPr>
+              <a:lvl7pPr marL="2971800" indent="-228600" defTabSz="5119688" eaLnBrk="0" fontAlgn="base" hangingPunct="0">
+                <a:spcBef>
+                  <a:spcPct val="0"/>
+                </a:spcBef>
+                <a:spcAft>
+                  <a:spcPct val="0"/>
+                </a:spcAft>
+                <a:defRPr sz="2400">
+                  <a:solidFill>
+                    <a:schemeClr val="tx1"/>
+                  </a:solidFill>
+                  <a:latin typeface="Helvetica" panose="020B0604020202020204" pitchFamily="34" charset="0"/>
+                  <a:ea typeface="MS PGothic" panose="020B0600070205080204" pitchFamily="34" charset="-128"/>
+                </a:defRPr>
+              </a:lvl7pPr>
+              <a:lvl8pPr marL="3429000" indent="-228600" defTabSz="5119688" eaLnBrk="0" fontAlgn="base" hangingPunct="0">
+                <a:spcBef>
+                  <a:spcPct val="0"/>
+                </a:spcBef>
+                <a:spcAft>
+                  <a:spcPct val="0"/>
+                </a:spcAft>
+                <a:defRPr sz="2400">
+                  <a:solidFill>
+                    <a:schemeClr val="tx1"/>
+                  </a:solidFill>
+                  <a:latin typeface="Helvetica" panose="020B0604020202020204" pitchFamily="34" charset="0"/>
+                  <a:ea typeface="MS PGothic" panose="020B0600070205080204" pitchFamily="34" charset="-128"/>
+                </a:defRPr>
+              </a:lvl8pPr>
+              <a:lvl9pPr marL="3886200" indent="-228600" defTabSz="5119688" eaLnBrk="0" fontAlgn="base" hangingPunct="0">
+                <a:spcBef>
+                  <a:spcPct val="0"/>
+                </a:spcBef>
+                <a:spcAft>
+                  <a:spcPct val="0"/>
+                </a:spcAft>
+                <a:defRPr sz="2400">
+                  <a:solidFill>
+                    <a:schemeClr val="tx1"/>
+                  </a:solidFill>
+                  <a:latin typeface="Helvetica" panose="020B0604020202020204" pitchFamily="34" charset="0"/>
+                  <a:ea typeface="MS PGothic" panose="020B0600070205080204" pitchFamily="34" charset="-128"/>
+                </a:defRPr>
+              </a:lvl9pPr>
+            </a:lstStyle>
+            <a:p>
+              <a:pPr algn="ctr">
+                <a:spcBef>
+                  <a:spcPct val="50000"/>
+                </a:spcBef>
+              </a:pPr>
+              <a:r>
+                <a:rPr lang="en-US" altLang="en-US" sz="4267" b="1" dirty="0">
+                  <a:solidFill>
+                    <a:srgbClr val="C00000"/>
+                  </a:solidFill>
+                  <a:latin typeface="Trebuchet MS" panose="020B0603020202020204" pitchFamily="34" charset="0"/>
+                </a:rPr>
+                <a:t>1. Introduction</a:t>
+              </a:r>
+            </a:p>
+          </p:txBody>
+        </p:sp>
+        <p:sp>
+          <p:nvSpPr>
+            <p:cNvPr id="66" name="TextBox 65">
+              <a:extLst>
+                <a:ext uri="{FF2B5EF4-FFF2-40B4-BE49-F238E27FC236}">
+                  <a16:creationId xmlns:a16="http://schemas.microsoft.com/office/drawing/2014/main" id="{828EF0BF-392F-46C6-BF23-BF99B2CEA917}"/>
+                </a:ext>
+              </a:extLst>
+            </p:cNvPr>
+            <p:cNvSpPr txBox="1"/>
+            <p:nvPr/>
+          </p:nvSpPr>
+          <p:spPr>
+            <a:xfrm>
+              <a:off x="333765" y="9945451"/>
+              <a:ext cx="14639262" cy="2031325"/>
+            </a:xfrm>
+            <a:prstGeom prst="rect">
+              <a:avLst/>
+            </a:prstGeom>
+            <a:noFill/>
+          </p:spPr>
+          <p:txBody>
+            <a:bodyPr wrap="square" lIns="91440" tIns="45720" rIns="91440" bIns="45720" anchor="t">
+              <a:spAutoFit/>
+            </a:bodyPr>
+            <a:lstStyle/>
+            <a:p>
+              <a:pPr algn="ctr">
+                <a:spcBef>
+                  <a:spcPts val="360"/>
+                </a:spcBef>
+                <a:spcAft>
+                  <a:spcPts val="0"/>
+                </a:spcAft>
+              </a:pPr>
+              <a:r>
+                <a:rPr lang="en-US" sz="4200" b="1" dirty="0">
+                  <a:latin typeface="Helvetica"/>
+                  <a:ea typeface="MS PGothic"/>
+                  <a:cs typeface="Helvetica"/>
+                </a:rPr>
+                <a:t>We</a:t>
+              </a:r>
+              <a:r>
+                <a:rPr lang="en-US" sz="4200" b="1" i="0" u="none" strike="noStrike" dirty="0">
+                  <a:effectLst/>
+                  <a:latin typeface="Helvetica"/>
+                  <a:ea typeface="MS PGothic"/>
+                  <a:cs typeface="Helvetica"/>
+                </a:rPr>
+                <a:t> investigated </a:t>
+              </a:r>
+              <a:r>
+                <a:rPr lang="en-US" sz="4200" b="1" dirty="0">
+                  <a:latin typeface="Helvetica"/>
+                  <a:ea typeface="MS PGothic"/>
+                  <a:cs typeface="Helvetica"/>
+                </a:rPr>
+                <a:t>whether social trust decisions change as we age, and how those changes could be related to financial exploitation.</a:t>
+              </a:r>
+              <a:endParaRPr lang="en-US" sz="4200" b="1" dirty="0">
+                <a:cs typeface="Helvetica"/>
+              </a:endParaRPr>
+            </a:p>
+          </p:txBody>
+        </p:sp>
+      </p:grpSp>
+      <p:grpSp>
+        <p:nvGrpSpPr>
+          <p:cNvPr id="15503" name="Group 15502">
             <a:extLst>
               <a:ext uri="{FF2B5EF4-FFF2-40B4-BE49-F238E27FC236}">
-                <a16:creationId xmlns:a16="http://schemas.microsoft.com/office/drawing/2014/main" id="{D37958DE-5E24-D58C-4A7D-3AB8A936FE13}"/>
+                <a16:creationId xmlns:a16="http://schemas.microsoft.com/office/drawing/2014/main" id="{5FCA49CE-81E7-6F59-66DA-CE0C5F49E6D0}"/>
               </a:ext>
             </a:extLst>
           </p:cNvPr>
-          <p:cNvSpPr txBox="1"/>
+          <p:cNvGrpSpPr/>
           <p:nvPr/>
-        </p:nvSpPr>
-        <p:spPr>
+        </p:nvGrpSpPr>
+        <p:grpSpPr>
           <a:xfrm>
-            <a:off x="21821456" y="15519657"/>
-            <a:ext cx="1133197" cy="584775"/>
+            <a:off x="23573171" y="24842403"/>
+            <a:ext cx="6457795" cy="5596080"/>
+            <a:chOff x="23380200" y="25326205"/>
+            <a:chExt cx="6457795" cy="5596080"/>
           </a:xfrm>
-          <a:prstGeom prst="rect">
-            <a:avLst/>
-          </a:prstGeom>
-          <a:noFill/>
-        </p:spPr>
-        <p:txBody>
-          <a:bodyPr wrap="square">
-            <a:spAutoFit/>
-          </a:bodyPr>
-          <a:lstStyle/>
-          <a:p>
-            <a:r>
-              <a:rPr lang="en-US" sz="3200" b="1" dirty="0">
-                <a:latin typeface="Helvetica"/>
-                <a:ea typeface="MS PGothic"/>
-              </a:rPr>
-              <a:t>VS</a:t>
-            </a:r>
-            <a:endParaRPr lang="en-US" sz="3200" b="1" dirty="0">
-              <a:latin typeface="Helvetica"/>
-            </a:endParaRPr>
-          </a:p>
-        </p:txBody>
-      </p:sp>
-      <p:sp>
-        <p:nvSpPr>
-          <p:cNvPr id="39" name="TextBox 38">
-            <a:extLst>
-              <a:ext uri="{FF2B5EF4-FFF2-40B4-BE49-F238E27FC236}">
-                <a16:creationId xmlns:a16="http://schemas.microsoft.com/office/drawing/2014/main" id="{D99AB7A3-EC66-2E69-D984-AA56725B49BC}"/>
-              </a:ext>
-            </a:extLst>
-          </p:cNvPr>
-          <p:cNvSpPr txBox="1"/>
-          <p:nvPr/>
-        </p:nvSpPr>
-        <p:spPr>
-          <a:xfrm>
-            <a:off x="21094087" y="20438064"/>
-            <a:ext cx="2660825" cy="954107"/>
-          </a:xfrm>
-          <a:prstGeom prst="rect">
-            <a:avLst/>
-          </a:prstGeom>
-          <a:noFill/>
-        </p:spPr>
-        <p:txBody>
-          <a:bodyPr wrap="square" lIns="91440" tIns="45720" rIns="91440" bIns="45720" anchor="t">
-            <a:spAutoFit/>
-          </a:bodyPr>
-          <a:lstStyle/>
-          <a:p>
-            <a:pPr algn="ctr"/>
-            <a:r>
-              <a:rPr lang="en-US" sz="2800" dirty="0">
-                <a:latin typeface="Helvetica"/>
-                <a:ea typeface="MS PGothic"/>
-              </a:rPr>
-              <a:t>Y=9</a:t>
-            </a:r>
-          </a:p>
-          <a:p>
-            <a:pPr algn="ctr"/>
-            <a:endParaRPr lang="en-US" sz="2800" dirty="0">
-              <a:latin typeface="Helvetica"/>
-            </a:endParaRPr>
-          </a:p>
-        </p:txBody>
-      </p:sp>
-      <p:sp>
-        <p:nvSpPr>
-          <p:cNvPr id="50" name="TextBox 49">
-            <a:extLst>
-              <a:ext uri="{FF2B5EF4-FFF2-40B4-BE49-F238E27FC236}">
-                <a16:creationId xmlns:a16="http://schemas.microsoft.com/office/drawing/2014/main" id="{3E5D8420-A794-E6A2-1628-ED1203DBAD11}"/>
-              </a:ext>
-            </a:extLst>
-          </p:cNvPr>
-          <p:cNvSpPr txBox="1"/>
-          <p:nvPr/>
-        </p:nvSpPr>
-        <p:spPr>
-          <a:xfrm>
-            <a:off x="16257885" y="24711152"/>
-            <a:ext cx="1046440" cy="6220601"/>
-          </a:xfrm>
-          <a:prstGeom prst="rect">
-            <a:avLst/>
-          </a:prstGeom>
-          <a:noFill/>
-        </p:spPr>
-        <p:txBody>
-          <a:bodyPr vert="vert270" wrap="square">
-            <a:spAutoFit/>
-          </a:bodyPr>
-          <a:lstStyle/>
-          <a:p>
-            <a:pPr algn="ctr"/>
-            <a:r>
-              <a:rPr lang="en-US" sz="2800" dirty="0">
-                <a:latin typeface="Helvetica"/>
-                <a:ea typeface="MS PGothic"/>
-              </a:rPr>
-              <a:t>VS-</a:t>
-            </a:r>
-            <a:r>
-              <a:rPr lang="en-US" sz="2800" dirty="0" err="1">
-                <a:latin typeface="Helvetica"/>
-                <a:ea typeface="MS PGothic"/>
-              </a:rPr>
-              <a:t>pTPJ</a:t>
-            </a:r>
-            <a:r>
-              <a:rPr lang="en-US" sz="2800" dirty="0">
-                <a:latin typeface="Helvetica"/>
-                <a:ea typeface="MS PGothic"/>
-              </a:rPr>
-              <a:t> Connectivity (</a:t>
-            </a:r>
-            <a:r>
-              <a:rPr lang="el-GR" sz="2800" dirty="0">
-                <a:latin typeface="Helvetica"/>
-                <a:ea typeface="MS PGothic"/>
-              </a:rPr>
-              <a:t>β) </a:t>
-            </a:r>
-            <a:endParaRPr lang="en-US" sz="2800" dirty="0">
-              <a:latin typeface="Helvetica"/>
-              <a:ea typeface="MS PGothic"/>
-            </a:endParaRPr>
-          </a:p>
-          <a:p>
-            <a:pPr algn="ctr"/>
-            <a:r>
-              <a:rPr lang="en-US" sz="2800" dirty="0">
-                <a:latin typeface="Helvetica"/>
-                <a:ea typeface="MS PGothic"/>
-              </a:rPr>
-              <a:t>Parametric Effect of Fairness</a:t>
-            </a:r>
-            <a:endParaRPr lang="en-US" sz="2800" dirty="0">
-              <a:latin typeface="Helvetica"/>
-            </a:endParaRPr>
-          </a:p>
-        </p:txBody>
-      </p:sp>
-      <p:sp>
-        <p:nvSpPr>
-          <p:cNvPr id="80" name="TextBox 79">
-            <a:extLst>
-              <a:ext uri="{FF2B5EF4-FFF2-40B4-BE49-F238E27FC236}">
-                <a16:creationId xmlns:a16="http://schemas.microsoft.com/office/drawing/2014/main" id="{FD72DC14-1E2D-4557-BD08-7DD34FFE9083}"/>
-              </a:ext>
-            </a:extLst>
-          </p:cNvPr>
-          <p:cNvSpPr txBox="1"/>
-          <p:nvPr/>
-        </p:nvSpPr>
-        <p:spPr>
-          <a:xfrm>
-            <a:off x="26561482" y="29968178"/>
-            <a:ext cx="2664868" cy="954107"/>
-          </a:xfrm>
-          <a:prstGeom prst="rect">
-            <a:avLst/>
-          </a:prstGeom>
-          <a:noFill/>
-        </p:spPr>
-        <p:txBody>
-          <a:bodyPr wrap="square" lIns="91440" tIns="45720" rIns="91440" bIns="45720" anchor="t">
-            <a:spAutoFit/>
-          </a:bodyPr>
-          <a:lstStyle/>
-          <a:p>
-            <a:pPr algn="ctr"/>
-            <a:r>
-              <a:rPr lang="en-US" sz="2800" dirty="0">
-                <a:latin typeface="Helvetica"/>
-                <a:ea typeface="MS PGothic"/>
-              </a:rPr>
-              <a:t>X=5</a:t>
-            </a:r>
-          </a:p>
-          <a:p>
-            <a:pPr algn="ctr"/>
-            <a:endParaRPr lang="en-US" sz="2800" dirty="0">
-              <a:latin typeface="Helvetica"/>
-            </a:endParaRPr>
-          </a:p>
-        </p:txBody>
-      </p:sp>
+        </p:grpSpPr>
+        <p:pic>
+          <p:nvPicPr>
+            <p:cNvPr id="15424" name="Picture 15423" descr="A close-up of a brain&#10;&#10;Description automatically generated">
+              <a:extLst>
+                <a:ext uri="{FF2B5EF4-FFF2-40B4-BE49-F238E27FC236}">
+                  <a16:creationId xmlns:a16="http://schemas.microsoft.com/office/drawing/2014/main" id="{CC6419D2-DC29-B910-B6FA-A6DAC7775AD7}"/>
+                </a:ext>
+              </a:extLst>
+            </p:cNvPr>
+            <p:cNvPicPr>
+              <a:picLocks noChangeAspect="1"/>
+            </p:cNvPicPr>
+            <p:nvPr/>
+          </p:nvPicPr>
+          <p:blipFill>
+            <a:blip r:embed="rId3">
+              <a:extLst>
+                <a:ext uri="{28A0092B-C50C-407E-A947-70E740481C1C}">
+                  <a14:useLocalDpi xmlns:a14="http://schemas.microsoft.com/office/drawing/2010/main" val="0"/>
+                </a:ext>
+              </a:extLst>
+            </a:blip>
+            <a:stretch>
+              <a:fillRect/>
+            </a:stretch>
+          </p:blipFill>
+          <p:spPr>
+            <a:xfrm>
+              <a:off x="23380200" y="25326205"/>
+              <a:ext cx="6457795" cy="5596080"/>
+            </a:xfrm>
+            <a:prstGeom prst="rect">
+              <a:avLst/>
+            </a:prstGeom>
+          </p:spPr>
+        </p:pic>
+        <p:sp>
+          <p:nvSpPr>
+            <p:cNvPr id="80" name="TextBox 79">
+              <a:extLst>
+                <a:ext uri="{FF2B5EF4-FFF2-40B4-BE49-F238E27FC236}">
+                  <a16:creationId xmlns:a16="http://schemas.microsoft.com/office/drawing/2014/main" id="{FD72DC14-1E2D-4557-BD08-7DD34FFE9083}"/>
+                </a:ext>
+              </a:extLst>
+            </p:cNvPr>
+            <p:cNvSpPr txBox="1"/>
+            <p:nvPr/>
+          </p:nvSpPr>
+          <p:spPr>
+            <a:xfrm>
+              <a:off x="26561482" y="29968178"/>
+              <a:ext cx="2664868" cy="523220"/>
+            </a:xfrm>
+            <a:prstGeom prst="rect">
+              <a:avLst/>
+            </a:prstGeom>
+            <a:noFill/>
+          </p:spPr>
+          <p:txBody>
+            <a:bodyPr wrap="square" lIns="91440" tIns="45720" rIns="91440" bIns="45720" anchor="t">
+              <a:spAutoFit/>
+            </a:bodyPr>
+            <a:lstStyle/>
+            <a:p>
+              <a:pPr algn="ctr"/>
+              <a:r>
+                <a:rPr lang="en-US" sz="2800" dirty="0">
+                  <a:latin typeface="Helvetica"/>
+                  <a:ea typeface="MS PGothic"/>
+                </a:rPr>
+                <a:t>X=5</a:t>
+              </a:r>
+            </a:p>
+          </p:txBody>
+        </p:sp>
+      </p:grpSp>
       <p:grpSp>
         <p:nvGrpSpPr>
           <p:cNvPr id="15402" name="Group 15401">
@@ -7667,7 +7492,7 @@
         </p:nvGrpSpPr>
         <p:grpSpPr>
           <a:xfrm>
-            <a:off x="724818" y="29192296"/>
+            <a:off x="741991" y="26606768"/>
             <a:ext cx="6854956" cy="2277700"/>
             <a:chOff x="569101" y="26252269"/>
             <a:chExt cx="6854956" cy="2277700"/>
@@ -7811,21 +7636,7 @@
                   <a:effectLst/>
                   <a:latin typeface="Helvetica" pitchFamily="2" charset="0"/>
                 </a:rPr>
-                <a:t>Financial Exploitation Vulnerability Scale</a:t>
-              </a:r>
-              <a:r>
-                <a:rPr lang="en-US" sz="3200" dirty="0">
-                  <a:latin typeface="Calibri" panose="020F0502020204030204" pitchFamily="34" charset="0"/>
-                </a:rPr>
-                <a:t> </a:t>
-              </a:r>
-              <a:r>
-                <a:rPr lang="en-US" sz="3200" dirty="0">
-                  <a:latin typeface="Helvetica"/>
-                  <a:ea typeface="Times New Roman" panose="02020603050405020304" pitchFamily="18" charset="0"/>
-                  <a:cs typeface="Helvetica"/>
-                </a:rPr>
-                <a:t>(Lichtenberg et al., 2020a)</a:t>
+                <a:t>Older Adults Financial Exploitation and Vulnerability Scale.</a:t>
               </a:r>
               <a:endParaRPr lang="en-US" sz="3200" dirty="0">
                 <a:effectLst/>
@@ -7837,45 +7648,6 @@
           </p:txBody>
         </p:sp>
       </p:grpSp>
-      <p:sp>
-        <p:nvSpPr>
-          <p:cNvPr id="15434" name="TextBox 15433">
-            <a:extLst>
-              <a:ext uri="{FF2B5EF4-FFF2-40B4-BE49-F238E27FC236}">
-                <a16:creationId xmlns:a16="http://schemas.microsoft.com/office/drawing/2014/main" id="{F42DD616-45E9-33CA-3CBB-04AC7B550D62}"/>
-              </a:ext>
-            </a:extLst>
-          </p:cNvPr>
-          <p:cNvSpPr txBox="1"/>
-          <p:nvPr/>
-        </p:nvSpPr>
-        <p:spPr>
-          <a:xfrm>
-            <a:off x="37051877" y="6753009"/>
-            <a:ext cx="615553" cy="4368929"/>
-          </a:xfrm>
-          <a:prstGeom prst="rect">
-            <a:avLst/>
-          </a:prstGeom>
-          <a:noFill/>
-        </p:spPr>
-        <p:txBody>
-          <a:bodyPr vert="vert270" wrap="square">
-            <a:spAutoFit/>
-          </a:bodyPr>
-          <a:lstStyle/>
-          <a:p>
-            <a:pPr algn="ctr"/>
-            <a:r>
-              <a:rPr lang="en-US" sz="2800" dirty="0">
-                <a:latin typeface="Helvetica"/>
-                <a:ea typeface="MS PGothic"/>
-              </a:rPr>
-              <a:t>Precuneus Activation</a:t>
-            </a:r>
-          </a:p>
-        </p:txBody>
-      </p:sp>
       <p:grpSp>
         <p:nvGrpSpPr>
           <p:cNvPr id="15426" name="Group 15425">
@@ -7890,7 +7662,7 @@
         </p:nvGrpSpPr>
         <p:grpSpPr>
           <a:xfrm>
-            <a:off x="8164021" y="29079185"/>
+            <a:off x="8030984" y="26218030"/>
             <a:ext cx="6812529" cy="2732092"/>
             <a:chOff x="8015298" y="29141496"/>
             <a:chExt cx="6812529" cy="2732092"/>
@@ -8036,36 +7808,143 @@
           </p:txBody>
         </p:sp>
       </p:grpSp>
-      <p:pic>
-        <p:nvPicPr>
-          <p:cNvPr id="17" name="Picture 16">
+      <p:grpSp>
+        <p:nvGrpSpPr>
+          <p:cNvPr id="15508" name="Group 15507">
             <a:extLst>
               <a:ext uri="{FF2B5EF4-FFF2-40B4-BE49-F238E27FC236}">
-                <a16:creationId xmlns:a16="http://schemas.microsoft.com/office/drawing/2014/main" id="{428FE8E4-EF11-44C2-C242-0D3749E5303B}"/>
+                <a16:creationId xmlns:a16="http://schemas.microsoft.com/office/drawing/2014/main" id="{ACE08C75-5E52-BA85-3BBA-E0BBC55E5D24}"/>
               </a:ext>
             </a:extLst>
           </p:cNvPr>
-          <p:cNvPicPr>
-            <a:picLocks noChangeAspect="1"/>
-          </p:cNvPicPr>
+          <p:cNvGrpSpPr/>
           <p:nvPr/>
-        </p:nvPicPr>
-        <p:blipFill>
-          <a:blip r:embed="rId4"/>
-          <a:stretch>
-            <a:fillRect/>
-          </a:stretch>
-        </p:blipFill>
-        <p:spPr>
+        </p:nvGrpSpPr>
+        <p:grpSpPr>
           <a:xfrm>
-            <a:off x="15705595" y="15406813"/>
-            <a:ext cx="6082076" cy="6071098"/>
+            <a:off x="19981771" y="15435963"/>
+            <a:ext cx="8049317" cy="6071098"/>
+            <a:chOff x="15705595" y="15406813"/>
+            <a:chExt cx="8049317" cy="6071098"/>
           </a:xfrm>
-          <a:prstGeom prst="rect">
-            <a:avLst/>
-          </a:prstGeom>
-        </p:spPr>
-      </p:pic>
+        </p:grpSpPr>
+        <p:sp>
+          <p:nvSpPr>
+            <p:cNvPr id="35" name="TextBox 34">
+              <a:extLst>
+                <a:ext uri="{FF2B5EF4-FFF2-40B4-BE49-F238E27FC236}">
+                  <a16:creationId xmlns:a16="http://schemas.microsoft.com/office/drawing/2014/main" id="{D37958DE-5E24-D58C-4A7D-3AB8A936FE13}"/>
+                </a:ext>
+              </a:extLst>
+            </p:cNvPr>
+            <p:cNvSpPr txBox="1"/>
+            <p:nvPr/>
+          </p:nvSpPr>
+          <p:spPr>
+            <a:xfrm>
+              <a:off x="21821456" y="15519657"/>
+              <a:ext cx="1133197" cy="584775"/>
+            </a:xfrm>
+            <a:prstGeom prst="rect">
+              <a:avLst/>
+            </a:prstGeom>
+            <a:noFill/>
+          </p:spPr>
+          <p:txBody>
+            <a:bodyPr wrap="square">
+              <a:spAutoFit/>
+            </a:bodyPr>
+            <a:lstStyle/>
+            <a:p>
+              <a:r>
+                <a:rPr lang="en-US" sz="3200" b="1" dirty="0">
+                  <a:latin typeface="Helvetica"/>
+                  <a:ea typeface="MS PGothic"/>
+                </a:rPr>
+                <a:t>VS</a:t>
+              </a:r>
+              <a:endParaRPr lang="en-US" sz="3200" b="1" dirty="0">
+                <a:latin typeface="Helvetica"/>
+              </a:endParaRPr>
+            </a:p>
+          </p:txBody>
+        </p:sp>
+        <p:sp>
+          <p:nvSpPr>
+            <p:cNvPr id="39" name="TextBox 38">
+              <a:extLst>
+                <a:ext uri="{FF2B5EF4-FFF2-40B4-BE49-F238E27FC236}">
+                  <a16:creationId xmlns:a16="http://schemas.microsoft.com/office/drawing/2014/main" id="{D99AB7A3-EC66-2E69-D984-AA56725B49BC}"/>
+                </a:ext>
+              </a:extLst>
+            </p:cNvPr>
+            <p:cNvSpPr txBox="1"/>
+            <p:nvPr/>
+          </p:nvSpPr>
+          <p:spPr>
+            <a:xfrm>
+              <a:off x="21094087" y="20438064"/>
+              <a:ext cx="2660825" cy="954107"/>
+            </a:xfrm>
+            <a:prstGeom prst="rect">
+              <a:avLst/>
+            </a:prstGeom>
+            <a:noFill/>
+          </p:spPr>
+          <p:txBody>
+            <a:bodyPr wrap="square" lIns="91440" tIns="45720" rIns="91440" bIns="45720" anchor="t">
+              <a:spAutoFit/>
+            </a:bodyPr>
+            <a:lstStyle/>
+            <a:p>
+              <a:pPr algn="ctr"/>
+              <a:r>
+                <a:rPr lang="en-US" sz="2800" dirty="0">
+                  <a:latin typeface="Helvetica"/>
+                  <a:ea typeface="MS PGothic"/>
+                </a:rPr>
+                <a:t>Y=9</a:t>
+              </a:r>
+            </a:p>
+            <a:p>
+              <a:pPr algn="ctr"/>
+              <a:endParaRPr lang="en-US" sz="2800" dirty="0">
+                <a:latin typeface="Helvetica"/>
+              </a:endParaRPr>
+            </a:p>
+          </p:txBody>
+        </p:sp>
+        <p:pic>
+          <p:nvPicPr>
+            <p:cNvPr id="17" name="Picture 16">
+              <a:extLst>
+                <a:ext uri="{FF2B5EF4-FFF2-40B4-BE49-F238E27FC236}">
+                  <a16:creationId xmlns:a16="http://schemas.microsoft.com/office/drawing/2014/main" id="{428FE8E4-EF11-44C2-C242-0D3749E5303B}"/>
+                </a:ext>
+              </a:extLst>
+            </p:cNvPr>
+            <p:cNvPicPr>
+              <a:picLocks noChangeAspect="1"/>
+            </p:cNvPicPr>
+            <p:nvPr/>
+          </p:nvPicPr>
+          <p:blipFill>
+            <a:blip r:embed="rId4"/>
+            <a:stretch>
+              <a:fillRect/>
+            </a:stretch>
+          </p:blipFill>
+          <p:spPr>
+            <a:xfrm>
+              <a:off x="15705595" y="15406813"/>
+              <a:ext cx="6082076" cy="6071098"/>
+            </a:xfrm>
+            <a:prstGeom prst="rect">
+              <a:avLst/>
+            </a:prstGeom>
+          </p:spPr>
+        </p:pic>
+      </p:grpSp>
       <p:grpSp>
         <p:nvGrpSpPr>
           <p:cNvPr id="84" name="Group 83">
@@ -9564,136 +9443,12 @@
         </p:blipFill>
         <p:spPr>
           <a:xfrm>
-            <a:off x="31495021" y="5969483"/>
+            <a:off x="30965290" y="6030821"/>
             <a:ext cx="4495800" cy="5003800"/>
           </a:xfrm>
           <a:prstGeom prst="rect">
             <a:avLst/>
           </a:prstGeom>
-        </p:spPr>
-      </p:pic>
-      <p:pic>
-        <p:nvPicPr>
-          <p:cNvPr id="15418" name="Picture 15417" descr="A graph with red dots&#10;&#10;Description automatically generated">
-            <a:extLst>
-              <a:ext uri="{FF2B5EF4-FFF2-40B4-BE49-F238E27FC236}">
-                <a16:creationId xmlns:a16="http://schemas.microsoft.com/office/drawing/2014/main" id="{7AE9EF6F-6375-47A1-D536-FAF3F473B789}"/>
-              </a:ext>
-            </a:extLst>
-          </p:cNvPr>
-          <p:cNvPicPr>
-            <a:picLocks noChangeAspect="1"/>
-          </p:cNvPicPr>
-          <p:nvPr/>
-        </p:nvPicPr>
-        <p:blipFill rotWithShape="1">
-          <a:blip r:embed="rId6">
-            <a:extLst>
-              <a:ext uri="{28A0092B-C50C-407E-A947-70E740481C1C}">
-                <a14:useLocalDpi xmlns:a14="http://schemas.microsoft.com/office/drawing/2010/main" val="0"/>
-              </a:ext>
-            </a:extLst>
-          </a:blip>
-          <a:srcRect l="3131"/>
-          <a:stretch/>
-        </p:blipFill>
-        <p:spPr>
-          <a:xfrm>
-            <a:off x="37850303" y="6924524"/>
-            <a:ext cx="5314627" cy="4025900"/>
-          </a:xfrm>
-          <a:prstGeom prst="rect">
-            <a:avLst/>
-          </a:prstGeom>
-        </p:spPr>
-      </p:pic>
-      <p:sp>
-        <p:nvSpPr>
-          <p:cNvPr id="15420" name="TextBox 15419">
-            <a:extLst>
-              <a:ext uri="{FF2B5EF4-FFF2-40B4-BE49-F238E27FC236}">
-                <a16:creationId xmlns:a16="http://schemas.microsoft.com/office/drawing/2014/main" id="{069F462D-BFA5-DA6C-F8A4-6704B438B9AA}"/>
-              </a:ext>
-            </a:extLst>
-          </p:cNvPr>
-          <p:cNvSpPr txBox="1"/>
-          <p:nvPr/>
-        </p:nvSpPr>
-        <p:spPr>
-          <a:xfrm>
-            <a:off x="40013832" y="11300491"/>
-            <a:ext cx="867545" cy="553998"/>
-          </a:xfrm>
-          <a:prstGeom prst="rect">
-            <a:avLst/>
-          </a:prstGeom>
-          <a:noFill/>
-        </p:spPr>
-        <p:txBody>
-          <a:bodyPr wrap="none" rtlCol="0">
-            <a:spAutoFit/>
-          </a:bodyPr>
-          <a:lstStyle/>
-          <a:p>
-            <a:r>
-              <a:rPr lang="en-US" sz="3000" dirty="0"/>
-              <a:t>Age</a:t>
-            </a:r>
-          </a:p>
-        </p:txBody>
-      </p:sp>
-      <p:pic>
-        <p:nvPicPr>
-          <p:cNvPr id="15389" name="Picture 10060"/>
-          <p:cNvPicPr>
-            <a:picLocks noChangeAspect="1" noChangeArrowheads="1"/>
-          </p:cNvPicPr>
-          <p:nvPr/>
-        </p:nvPicPr>
-        <p:blipFill>
-          <a:blip>
-            <a:extLst>
-              <a:ext uri="{28A0092B-C50C-407E-A947-70E740481C1C}">
-                <a14:useLocalDpi xmlns:a14="http://schemas.microsoft.com/office/drawing/2010/main" val="0"/>
-              </a:ext>
-            </a:extLst>
-          </a:blip>
-          <a:srcRect/>
-          <a:stretch>
-            <a:fillRect/>
-          </a:stretch>
-        </p:blipFill>
-        <p:spPr bwMode="auto">
-          <a:xfrm>
-            <a:off x="494755" y="252918"/>
-            <a:ext cx="3037143" cy="3396805"/>
-          </a:xfrm>
-          <a:prstGeom prst="rect">
-            <a:avLst/>
-          </a:prstGeom>
-          <a:noFill/>
-          <a:ln>
-            <a:noFill/>
-          </a:ln>
-          <a:extLst>
-            <a:ext uri="{909E8E84-426E-40DD-AFC4-6F175D3DCCD1}">
-              <a14:hiddenFill xmlns:a14="http://schemas.microsoft.com/office/drawing/2010/main">
-                <a:solidFill>
-                  <a:srgbClr val="FFFFFF"/>
-                </a:solidFill>
-              </a14:hiddenFill>
-            </a:ext>
-            <a:ext uri="{91240B29-F687-4F45-9708-019B960494DF}">
-              <a14:hiddenLine xmlns:a14="http://schemas.microsoft.com/office/drawing/2010/main" w="9525">
-                <a:solidFill>
-                  <a:srgbClr val="000000"/>
-                </a:solidFill>
-                <a:miter lim="800000"/>
-                <a:headEnd/>
-                <a:tailEnd/>
-              </a14:hiddenLine>
-            </a:ext>
-          </a:extLst>
         </p:spPr>
       </p:pic>
       <p:sp>
@@ -9707,7 +9462,7 @@
         <p:spPr bwMode="auto">
           <a:xfrm>
             <a:off x="30676645" y="24531321"/>
-            <a:ext cx="12928282" cy="6994361"/>
+            <a:ext cx="12928282" cy="8153186"/>
           </a:xfrm>
           <a:prstGeom prst="rect">
             <a:avLst/>
@@ -10017,7 +9772,7 @@
         <p:spPr>
           <a:xfrm>
             <a:off x="30912367" y="25351882"/>
-            <a:ext cx="12914399" cy="1374735"/>
+            <a:ext cx="12914399" cy="2708434"/>
           </a:xfrm>
           <a:prstGeom prst="rect">
             <a:avLst/>
@@ -10045,7 +9800,47 @@
                 <a:ea typeface="MS PGothic"/>
                 <a:cs typeface="Helvetica"/>
               </a:rPr>
-              <a:t> .</a:t>
+              <a:t> …</a:t>
+            </a:r>
+          </a:p>
+          <a:p>
+            <a:pPr>
+              <a:spcBef>
+                <a:spcPts val="360"/>
+              </a:spcBef>
+              <a:spcAft>
+                <a:spcPts val="0"/>
+              </a:spcAft>
+              <a:buFont typeface="Arial" panose="020B0604020202020204" pitchFamily="34" charset="0"/>
+              <a:buChar char="•"/>
+            </a:pPr>
+            <a:r>
+              <a:rPr lang="en-US" sz="4000" dirty="0">
+                <a:latin typeface="Helvetica"/>
+                <a:ea typeface="MS PGothic"/>
+                <a:cs typeface="Helvetica"/>
+              </a:rPr>
+              <a:t>…</a:t>
+            </a:r>
+          </a:p>
+          <a:p>
+            <a:pPr>
+              <a:spcBef>
+                <a:spcPts val="360"/>
+              </a:spcBef>
+              <a:spcAft>
+                <a:spcPts val="0"/>
+              </a:spcAft>
+              <a:buFont typeface="Arial" panose="020B0604020202020204" pitchFamily="34" charset="0"/>
+              <a:buChar char="•"/>
+            </a:pPr>
+            <a:r>
+              <a:rPr lang="en-US" sz="4000" dirty="0">
+                <a:latin typeface="Helvetica"/>
+                <a:ea typeface="MS PGothic"/>
+                <a:cs typeface="Helvetica"/>
+              </a:rPr>
+              <a:t>…</a:t>
             </a:r>
           </a:p>
           <a:p>
@@ -10061,211 +9856,6 @@
               <a:latin typeface="Helvetica"/>
               <a:ea typeface="MS PGothic"/>
               <a:cs typeface="Helvetica"/>
-            </a:endParaRPr>
-          </a:p>
-        </p:txBody>
-      </p:sp>
-      <p:pic>
-        <p:nvPicPr>
-          <p:cNvPr id="82" name="Picture 2" descr="Image result for adelphi university">
-            <a:extLst>
-              <a:ext uri="{FF2B5EF4-FFF2-40B4-BE49-F238E27FC236}">
-                <a16:creationId xmlns:a16="http://schemas.microsoft.com/office/drawing/2014/main" id="{28154B0C-9082-4664-BE4E-292BAAFD349C}"/>
-              </a:ext>
-            </a:extLst>
-          </p:cNvPr>
-          <p:cNvPicPr>
-            <a:picLocks noChangeAspect="1" noChangeArrowheads="1"/>
-          </p:cNvPicPr>
-          <p:nvPr/>
-        </p:nvPicPr>
-        <p:blipFill>
-          <a:blip>
-            <a:extLst>
-              <a:ext uri="{28A0092B-C50C-407E-A947-70E740481C1C}">
-                <a14:useLocalDpi xmlns:a14="http://schemas.microsoft.com/office/drawing/2010/main" val="0"/>
-              </a:ext>
-            </a:extLst>
-          </a:blip>
-          <a:srcRect/>
-          <a:stretch>
-            <a:fillRect/>
-          </a:stretch>
-        </p:blipFill>
-        <p:spPr bwMode="auto">
-          <a:xfrm>
-            <a:off x="41331346" y="1633353"/>
-            <a:ext cx="1986759" cy="1986759"/>
-          </a:xfrm>
-          <a:prstGeom prst="rect">
-            <a:avLst/>
-          </a:prstGeom>
-          <a:noFill/>
-          <a:extLst>
-            <a:ext uri="{909E8E84-426E-40DD-AFC4-6F175D3DCCD1}">
-              <a14:hiddenFill xmlns:a14="http://schemas.microsoft.com/office/drawing/2010/main">
-                <a:solidFill>
-                  <a:srgbClr val="FFFFFF"/>
-                </a:solidFill>
-              </a14:hiddenFill>
-            </a:ext>
-          </a:extLst>
-        </p:spPr>
-      </p:pic>
-      <p:sp>
-        <p:nvSpPr>
-          <p:cNvPr id="127" name="Rectangle 54">
-            <a:extLst>
-              <a:ext uri="{FF2B5EF4-FFF2-40B4-BE49-F238E27FC236}">
-                <a16:creationId xmlns:a16="http://schemas.microsoft.com/office/drawing/2014/main" id="{CCC8C574-2C37-4FF8-83CC-02DE2FB92E37}"/>
-              </a:ext>
-            </a:extLst>
-          </p:cNvPr>
-          <p:cNvSpPr>
-            <a:spLocks noChangeArrowheads="1"/>
-          </p:cNvSpPr>
-          <p:nvPr/>
-        </p:nvSpPr>
-        <p:spPr bwMode="auto">
-          <a:xfrm>
-            <a:off x="30667546" y="31846944"/>
-            <a:ext cx="12923262" cy="813380"/>
-          </a:xfrm>
-          <a:prstGeom prst="rect">
-            <a:avLst/>
-          </a:prstGeom>
-          <a:noFill/>
-          <a:ln w="76200">
-            <a:solidFill>
-              <a:srgbClr val="C00000"/>
-            </a:solidFill>
-            <a:miter lim="800000"/>
-            <a:headEnd/>
-            <a:tailEnd/>
-          </a:ln>
-          <a:extLst>
-            <a:ext uri="{909E8E84-426E-40DD-AFC4-6F175D3DCCD1}">
-              <a14:hiddenFill xmlns:a14="http://schemas.microsoft.com/office/drawing/2010/main">
-                <a:solidFill>
-                  <a:srgbClr val="FFFFFF"/>
-                </a:solidFill>
-              </a14:hiddenFill>
-            </a:ext>
-          </a:extLst>
-        </p:spPr>
-        <p:txBody>
-          <a:bodyPr wrap="none" lIns="81274" tIns="40638" rIns="81274" bIns="40638" anchor="ctr"/>
-          <a:lstStyle>
-            <a:lvl1pPr>
-              <a:defRPr sz="2400">
-                <a:solidFill>
-                  <a:schemeClr val="tx1"/>
-                </a:solidFill>
-                <a:latin typeface="Helvetica" panose="020B0604020202020204" pitchFamily="34" charset="0"/>
-                <a:ea typeface="MS PGothic" panose="020B0600070205080204" pitchFamily="34" charset="-128"/>
-              </a:defRPr>
-            </a:lvl1pPr>
-            <a:lvl2pPr marL="742950" indent="-285750">
-              <a:defRPr sz="2400">
-                <a:solidFill>
-                  <a:schemeClr val="tx1"/>
-                </a:solidFill>
-                <a:latin typeface="Helvetica" panose="020B0604020202020204" pitchFamily="34" charset="0"/>
-                <a:ea typeface="MS PGothic" panose="020B0600070205080204" pitchFamily="34" charset="-128"/>
-              </a:defRPr>
-            </a:lvl2pPr>
-            <a:lvl3pPr marL="1143000" indent="-228600">
-              <a:defRPr sz="2400">
-                <a:solidFill>
-                  <a:schemeClr val="tx1"/>
-                </a:solidFill>
-                <a:latin typeface="Helvetica" panose="020B0604020202020204" pitchFamily="34" charset="0"/>
-                <a:ea typeface="MS PGothic" panose="020B0600070205080204" pitchFamily="34" charset="-128"/>
-              </a:defRPr>
-            </a:lvl3pPr>
-            <a:lvl4pPr marL="1600200" indent="-228600">
-              <a:defRPr sz="2400">
-                <a:solidFill>
-                  <a:schemeClr val="tx1"/>
-                </a:solidFill>
-                <a:latin typeface="Helvetica" panose="020B0604020202020204" pitchFamily="34" charset="0"/>
-                <a:ea typeface="MS PGothic" panose="020B0600070205080204" pitchFamily="34" charset="-128"/>
-              </a:defRPr>
-            </a:lvl4pPr>
-            <a:lvl5pPr marL="2057400" indent="-228600">
-              <a:defRPr sz="2400">
-                <a:solidFill>
-                  <a:schemeClr val="tx1"/>
-                </a:solidFill>
-                <a:latin typeface="Helvetica" panose="020B0604020202020204" pitchFamily="34" charset="0"/>
-                <a:ea typeface="MS PGothic" panose="020B0600070205080204" pitchFamily="34" charset="-128"/>
-              </a:defRPr>
-            </a:lvl5pPr>
-            <a:lvl6pPr marL="2514600" indent="-228600" eaLnBrk="0" fontAlgn="base" hangingPunct="0">
-              <a:spcBef>
-                <a:spcPct val="0"/>
-              </a:spcBef>
-              <a:spcAft>
-                <a:spcPct val="0"/>
-              </a:spcAft>
-              <a:defRPr sz="2400">
-                <a:solidFill>
-                  <a:schemeClr val="tx1"/>
-                </a:solidFill>
-                <a:latin typeface="Helvetica" panose="020B0604020202020204" pitchFamily="34" charset="0"/>
-                <a:ea typeface="MS PGothic" panose="020B0600070205080204" pitchFamily="34" charset="-128"/>
-              </a:defRPr>
-            </a:lvl6pPr>
-            <a:lvl7pPr marL="2971800" indent="-228600" eaLnBrk="0" fontAlgn="base" hangingPunct="0">
-              <a:spcBef>
-                <a:spcPct val="0"/>
-              </a:spcBef>
-              <a:spcAft>
-                <a:spcPct val="0"/>
-              </a:spcAft>
-              <a:defRPr sz="2400">
-                <a:solidFill>
-                  <a:schemeClr val="tx1"/>
-                </a:solidFill>
-                <a:latin typeface="Helvetica" panose="020B0604020202020204" pitchFamily="34" charset="0"/>
-                <a:ea typeface="MS PGothic" panose="020B0600070205080204" pitchFamily="34" charset="-128"/>
-              </a:defRPr>
-            </a:lvl7pPr>
-            <a:lvl8pPr marL="3429000" indent="-228600" eaLnBrk="0" fontAlgn="base" hangingPunct="0">
-              <a:spcBef>
-                <a:spcPct val="0"/>
-              </a:spcBef>
-              <a:spcAft>
-                <a:spcPct val="0"/>
-              </a:spcAft>
-              <a:defRPr sz="2400">
-                <a:solidFill>
-                  <a:schemeClr val="tx1"/>
-                </a:solidFill>
-                <a:latin typeface="Helvetica" panose="020B0604020202020204" pitchFamily="34" charset="0"/>
-                <a:ea typeface="MS PGothic" panose="020B0600070205080204" pitchFamily="34" charset="-128"/>
-              </a:defRPr>
-            </a:lvl8pPr>
-            <a:lvl9pPr marL="3886200" indent="-228600" eaLnBrk="0" fontAlgn="base" hangingPunct="0">
-              <a:spcBef>
-                <a:spcPct val="0"/>
-              </a:spcBef>
-              <a:spcAft>
-                <a:spcPct val="0"/>
-              </a:spcAft>
-              <a:defRPr sz="2400">
-                <a:solidFill>
-                  <a:schemeClr val="tx1"/>
-                </a:solidFill>
-                <a:latin typeface="Helvetica" panose="020B0604020202020204" pitchFamily="34" charset="0"/>
-                <a:ea typeface="MS PGothic" panose="020B0600070205080204" pitchFamily="34" charset="-128"/>
-              </a:defRPr>
-            </a:lvl9pPr>
-          </a:lstStyle>
-          <a:p>
-            <a:pPr eaLnBrk="1" hangingPunct="1"/>
-            <a:endParaRPr lang="en-US" altLang="en-US" sz="1245">
-              <a:latin typeface="Trebuchet MS" panose="020B0603020202020204" pitchFamily="34" charset="0"/>
             </a:endParaRPr>
           </a:p>
         </p:txBody>
@@ -10285,7 +9875,7 @@
         <p:spPr>
           <a:xfrm>
             <a:off x="30912367" y="29293095"/>
-            <a:ext cx="12442911" cy="2146231"/>
+            <a:ext cx="12442911" cy="738664"/>
           </a:xfrm>
           <a:prstGeom prst="rect">
             <a:avLst/>
@@ -10312,352 +9902,9 @@
                 <a:ea typeface="MS PGothic"/>
                 <a:cs typeface="Helvetica"/>
               </a:rPr>
-              <a:t>Our findings help to characterize the role of </a:t>
-            </a:r>
-            <a:r>
-              <a:rPr lang="en-US" sz="4200" b="1" dirty="0" err="1">
-                <a:latin typeface="Helvetica"/>
-                <a:ea typeface="MS PGothic"/>
-                <a:cs typeface="Helvetica"/>
-              </a:rPr>
-              <a:t>corticostriatal</a:t>
-            </a:r>
-            <a:r>
-              <a:rPr lang="en-US" sz="4200" b="1" dirty="0">
-                <a:latin typeface="Helvetica"/>
-                <a:ea typeface="MS PGothic"/>
-                <a:cs typeface="Helvetica"/>
-              </a:rPr>
-              <a:t> connectivity in </a:t>
-            </a:r>
-            <a:endParaRPr lang="en-US" sz="4200" dirty="0">
-              <a:cs typeface="Arial"/>
-            </a:endParaRPr>
-          </a:p>
-          <a:p>
-            <a:pPr algn="ctr">
-              <a:spcBef>
-                <a:spcPts val="360"/>
-              </a:spcBef>
-              <a:spcAft>
-                <a:spcPts val="0"/>
-              </a:spcAft>
-            </a:pPr>
-            <a:r>
-              <a:rPr lang="en-US" sz="4200" b="1" dirty="0">
-                <a:latin typeface="Helvetica"/>
-                <a:ea typeface="MS PGothic"/>
-                <a:cs typeface="Helvetica"/>
-              </a:rPr>
-              <a:t>social decision making.</a:t>
+              <a:t>Our findings help to ???</a:t>
             </a:r>
             <a:endParaRPr lang="en-US" sz="4200" dirty="0"/>
-          </a:p>
-        </p:txBody>
-      </p:sp>
-      <p:pic>
-        <p:nvPicPr>
-          <p:cNvPr id="14" name="Picture 13" descr="A logo of a university&#10;&#10;Description automatically generated">
-            <a:extLst>
-              <a:ext uri="{FF2B5EF4-FFF2-40B4-BE49-F238E27FC236}">
-                <a16:creationId xmlns:a16="http://schemas.microsoft.com/office/drawing/2014/main" id="{9F423328-9A02-A5CE-6F48-CAD10A8AF80B}"/>
-              </a:ext>
-            </a:extLst>
-          </p:cNvPr>
-          <p:cNvPicPr>
-            <a:picLocks noChangeAspect="1"/>
-          </p:cNvPicPr>
-          <p:nvPr/>
-        </p:nvPicPr>
-        <p:blipFill>
-          <a:blip>
-            <a:extLst>
-              <a:ext uri="{28A0092B-C50C-407E-A947-70E740481C1C}">
-                <a14:useLocalDpi xmlns:a14="http://schemas.microsoft.com/office/drawing/2010/main" val="0"/>
-              </a:ext>
-            </a:extLst>
-          </a:blip>
-          <a:stretch>
-            <a:fillRect/>
-          </a:stretch>
-        </p:blipFill>
-        <p:spPr>
-          <a:xfrm>
-            <a:off x="39148879" y="321878"/>
-            <a:ext cx="1819284" cy="2067919"/>
-          </a:xfrm>
-          <a:prstGeom prst="rect">
-            <a:avLst/>
-          </a:prstGeom>
-        </p:spPr>
-      </p:pic>
-      <p:sp>
-        <p:nvSpPr>
-          <p:cNvPr id="15415" name="TextBox 86">
-            <a:extLst>
-              <a:ext uri="{FF2B5EF4-FFF2-40B4-BE49-F238E27FC236}">
-                <a16:creationId xmlns:a16="http://schemas.microsoft.com/office/drawing/2014/main" id="{B1E3A897-53DA-649F-39B9-6F4056C35336}"/>
-              </a:ext>
-            </a:extLst>
-          </p:cNvPr>
-          <p:cNvSpPr txBox="1">
-            <a:spLocks noChangeArrowheads="1"/>
-          </p:cNvSpPr>
-          <p:nvPr/>
-        </p:nvSpPr>
-        <p:spPr bwMode="auto">
-          <a:xfrm>
-            <a:off x="31057107" y="14623506"/>
-            <a:ext cx="12355359" cy="749436"/>
-          </a:xfrm>
-          <a:prstGeom prst="rect">
-            <a:avLst/>
-          </a:prstGeom>
-          <a:solidFill>
-            <a:schemeClr val="bg1"/>
-          </a:solidFill>
-          <a:ln>
-            <a:noFill/>
-          </a:ln>
-        </p:spPr>
-        <p:txBody>
-          <a:bodyPr wrap="square" lIns="91440" tIns="45720" rIns="91440" bIns="45720" anchor="t">
-            <a:spAutoFit/>
-          </a:bodyPr>
-          <a:lstStyle>
-            <a:lvl1pPr>
-              <a:defRPr sz="2400">
-                <a:solidFill>
-                  <a:schemeClr val="tx1"/>
-                </a:solidFill>
-                <a:latin typeface="Helvetica" panose="020B0604020202020204" pitchFamily="34" charset="0"/>
-                <a:ea typeface="MS PGothic" panose="020B0600070205080204" pitchFamily="34" charset="-128"/>
-              </a:defRPr>
-            </a:lvl1pPr>
-            <a:lvl2pPr marL="742950" indent="-285750">
-              <a:defRPr sz="2400">
-                <a:solidFill>
-                  <a:schemeClr val="tx1"/>
-                </a:solidFill>
-                <a:latin typeface="Helvetica" panose="020B0604020202020204" pitchFamily="34" charset="0"/>
-                <a:ea typeface="MS PGothic" panose="020B0600070205080204" pitchFamily="34" charset="-128"/>
-              </a:defRPr>
-            </a:lvl2pPr>
-            <a:lvl3pPr marL="1143000" indent="-228600">
-              <a:defRPr sz="2400">
-                <a:solidFill>
-                  <a:schemeClr val="tx1"/>
-                </a:solidFill>
-                <a:latin typeface="Helvetica" panose="020B0604020202020204" pitchFamily="34" charset="0"/>
-                <a:ea typeface="MS PGothic" panose="020B0600070205080204" pitchFamily="34" charset="-128"/>
-              </a:defRPr>
-            </a:lvl3pPr>
-            <a:lvl4pPr marL="1600200" indent="-228600">
-              <a:defRPr sz="2400">
-                <a:solidFill>
-                  <a:schemeClr val="tx1"/>
-                </a:solidFill>
-                <a:latin typeface="Helvetica" panose="020B0604020202020204" pitchFamily="34" charset="0"/>
-                <a:ea typeface="MS PGothic" panose="020B0600070205080204" pitchFamily="34" charset="-128"/>
-              </a:defRPr>
-            </a:lvl4pPr>
-            <a:lvl5pPr marL="2057400" indent="-228600">
-              <a:defRPr sz="2400">
-                <a:solidFill>
-                  <a:schemeClr val="tx1"/>
-                </a:solidFill>
-                <a:latin typeface="Helvetica" panose="020B0604020202020204" pitchFamily="34" charset="0"/>
-                <a:ea typeface="MS PGothic" panose="020B0600070205080204" pitchFamily="34" charset="-128"/>
-              </a:defRPr>
-            </a:lvl5pPr>
-            <a:lvl6pPr marL="2514600" indent="-228600" eaLnBrk="0" fontAlgn="base" hangingPunct="0">
-              <a:spcBef>
-                <a:spcPct val="0"/>
-              </a:spcBef>
-              <a:spcAft>
-                <a:spcPct val="0"/>
-              </a:spcAft>
-              <a:defRPr sz="2400">
-                <a:solidFill>
-                  <a:schemeClr val="tx1"/>
-                </a:solidFill>
-                <a:latin typeface="Helvetica" panose="020B0604020202020204" pitchFamily="34" charset="0"/>
-                <a:ea typeface="MS PGothic" panose="020B0600070205080204" pitchFamily="34" charset="-128"/>
-              </a:defRPr>
-            </a:lvl6pPr>
-            <a:lvl7pPr marL="2971800" indent="-228600" eaLnBrk="0" fontAlgn="base" hangingPunct="0">
-              <a:spcBef>
-                <a:spcPct val="0"/>
-              </a:spcBef>
-              <a:spcAft>
-                <a:spcPct val="0"/>
-              </a:spcAft>
-              <a:defRPr sz="2400">
-                <a:solidFill>
-                  <a:schemeClr val="tx1"/>
-                </a:solidFill>
-                <a:latin typeface="Helvetica" panose="020B0604020202020204" pitchFamily="34" charset="0"/>
-                <a:ea typeface="MS PGothic" panose="020B0600070205080204" pitchFamily="34" charset="-128"/>
-              </a:defRPr>
-            </a:lvl7pPr>
-            <a:lvl8pPr marL="3429000" indent="-228600" eaLnBrk="0" fontAlgn="base" hangingPunct="0">
-              <a:spcBef>
-                <a:spcPct val="0"/>
-              </a:spcBef>
-              <a:spcAft>
-                <a:spcPct val="0"/>
-              </a:spcAft>
-              <a:defRPr sz="2400">
-                <a:solidFill>
-                  <a:schemeClr val="tx1"/>
-                </a:solidFill>
-                <a:latin typeface="Helvetica" panose="020B0604020202020204" pitchFamily="34" charset="0"/>
-                <a:ea typeface="MS PGothic" panose="020B0600070205080204" pitchFamily="34" charset="-128"/>
-              </a:defRPr>
-            </a:lvl8pPr>
-            <a:lvl9pPr marL="3886200" indent="-228600" eaLnBrk="0" fontAlgn="base" hangingPunct="0">
-              <a:spcBef>
-                <a:spcPct val="0"/>
-              </a:spcBef>
-              <a:spcAft>
-                <a:spcPct val="0"/>
-              </a:spcAft>
-              <a:defRPr sz="2400">
-                <a:solidFill>
-                  <a:schemeClr val="tx1"/>
-                </a:solidFill>
-                <a:latin typeface="Helvetica" panose="020B0604020202020204" pitchFamily="34" charset="0"/>
-                <a:ea typeface="MS PGothic" panose="020B0600070205080204" pitchFamily="34" charset="-128"/>
-              </a:defRPr>
-            </a:lvl9pPr>
-          </a:lstStyle>
-          <a:p>
-            <a:pPr algn="ctr"/>
-            <a:r>
-              <a:rPr lang="en-US" altLang="en-US" sz="4270" b="1" dirty="0">
-                <a:solidFill>
-                  <a:srgbClr val="C00000"/>
-                </a:solidFill>
-                <a:latin typeface="Trebuchet MS"/>
-                <a:ea typeface="MS PGothic"/>
-              </a:rPr>
-              <a:t>7. </a:t>
-            </a:r>
-            <a:endParaRPr lang="en-US" altLang="en-US" sz="4270" b="1" dirty="0">
-              <a:solidFill>
-                <a:srgbClr val="C00000"/>
-              </a:solidFill>
-              <a:latin typeface="Trebuchet MS" panose="020B0603020202020204" pitchFamily="34" charset="0"/>
-            </a:endParaRPr>
-          </a:p>
-        </p:txBody>
-      </p:sp>
-      <p:sp>
-        <p:nvSpPr>
-          <p:cNvPr id="15417" name="TextBox 15416">
-            <a:extLst>
-              <a:ext uri="{FF2B5EF4-FFF2-40B4-BE49-F238E27FC236}">
-                <a16:creationId xmlns:a16="http://schemas.microsoft.com/office/drawing/2014/main" id="{67AF8949-755A-E964-685E-DF2A5F35BDE8}"/>
-              </a:ext>
-            </a:extLst>
-          </p:cNvPr>
-          <p:cNvSpPr txBox="1"/>
-          <p:nvPr/>
-        </p:nvSpPr>
-        <p:spPr>
-          <a:xfrm>
-            <a:off x="30805042" y="31928090"/>
-            <a:ext cx="12648270" cy="646331"/>
-          </a:xfrm>
-          <a:prstGeom prst="rect">
-            <a:avLst/>
-          </a:prstGeom>
-          <a:noFill/>
-        </p:spPr>
-        <p:txBody>
-          <a:bodyPr wrap="square">
-            <a:spAutoFit/>
-          </a:bodyPr>
-          <a:lstStyle/>
-          <a:p>
-            <a:r>
-              <a:rPr lang="en-US" sz="1800" i="1"/>
-              <a:t>This study was supported by a grant from the National Institutes of Health (R03-DA046733 (DVS). Contact information for Daniel Sazhin: daniel.sazhin@temple.edu.</a:t>
-            </a:r>
-            <a:r>
-              <a:rPr lang="en-US" sz="1800" b="0" i="0">
-                <a:solidFill>
-                  <a:srgbClr val="000000"/>
-                </a:solidFill>
-                <a:effectLst/>
-                <a:latin typeface="Times New Roman" panose="02020603050405020304" pitchFamily="18" charset="0"/>
-              </a:rPr>
-              <a:t> </a:t>
-            </a:r>
-            <a:endParaRPr lang="en-US" sz="1800" i="1"/>
-          </a:p>
-        </p:txBody>
-      </p:sp>
-      <p:sp>
-        <p:nvSpPr>
-          <p:cNvPr id="15453" name="TextBox 15452">
-            <a:extLst>
-              <a:ext uri="{FF2B5EF4-FFF2-40B4-BE49-F238E27FC236}">
-                <a16:creationId xmlns:a16="http://schemas.microsoft.com/office/drawing/2014/main" id="{54253D06-A27E-D304-5A43-9CE683DD93BC}"/>
-              </a:ext>
-            </a:extLst>
-          </p:cNvPr>
-          <p:cNvSpPr txBox="1"/>
-          <p:nvPr/>
-        </p:nvSpPr>
-        <p:spPr>
-          <a:xfrm>
-            <a:off x="38658757" y="16524759"/>
-            <a:ext cx="1046440" cy="6220601"/>
-          </a:xfrm>
-          <a:prstGeom prst="rect">
-            <a:avLst/>
-          </a:prstGeom>
-          <a:noFill/>
-        </p:spPr>
-        <p:txBody>
-          <a:bodyPr vert="vert270" wrap="square">
-            <a:spAutoFit/>
-          </a:bodyPr>
-          <a:lstStyle/>
-          <a:p>
-            <a:pPr algn="ctr"/>
-            <a:r>
-              <a:rPr lang="en-US" sz="2800" dirty="0">
-                <a:latin typeface="Helvetica"/>
-                <a:ea typeface="MS PGothic"/>
-              </a:rPr>
-              <a:t>VS-ACC Connectivity (</a:t>
-            </a:r>
-            <a:r>
-              <a:rPr lang="el-GR" sz="2800" dirty="0">
-                <a:latin typeface="Helvetica"/>
-                <a:ea typeface="MS PGothic"/>
-              </a:rPr>
-              <a:t>β) </a:t>
-            </a:r>
-            <a:endParaRPr lang="en-US" sz="2800" dirty="0">
-              <a:latin typeface="Helvetica"/>
-              <a:ea typeface="MS PGothic"/>
-            </a:endParaRPr>
-          </a:p>
-          <a:p>
-            <a:pPr algn="ctr"/>
-            <a:r>
-              <a:rPr lang="en-US" sz="2800" dirty="0">
-                <a:latin typeface="Helvetica"/>
-                <a:ea typeface="MS PGothic"/>
-              </a:rPr>
-              <a:t>Parametric Effect of Fairness</a:t>
-            </a:r>
-            <a:endParaRPr lang="en-US" sz="2800" dirty="0">
-              <a:latin typeface="Helvetica"/>
-            </a:endParaRPr>
           </a:p>
         </p:txBody>
       </p:sp>
@@ -10675,7 +9922,7 @@
         </p:nvSpPr>
         <p:spPr>
           <a:xfrm>
-            <a:off x="40013181" y="21477911"/>
+            <a:off x="39306381" y="20682657"/>
             <a:ext cx="3784646" cy="523220"/>
           </a:xfrm>
           <a:prstGeom prst="rect">
@@ -11232,7 +10479,7 @@
         </p:nvGrpSpPr>
         <p:grpSpPr>
           <a:xfrm>
-            <a:off x="741529" y="15748222"/>
+            <a:off x="741529" y="15880810"/>
             <a:ext cx="14307083" cy="10069546"/>
             <a:chOff x="741529" y="15748222"/>
             <a:chExt cx="14307083" cy="10069546"/>
@@ -11273,7 +10520,7 @@
               <p:nvPr/>
             </p:nvPicPr>
             <p:blipFill>
-              <a:blip r:embed="rId7">
+              <a:blip r:embed="rId6">
                 <a:extLst>
                   <a:ext uri="{28A0092B-C50C-407E-A947-70E740481C1C}">
                     <a14:useLocalDpi xmlns:a14="http://schemas.microsoft.com/office/drawing/2010/main" val="0"/>
@@ -11309,9 +10556,9 @@
             <p:grpSpPr>
               <a:xfrm>
                 <a:off x="9652951" y="17772995"/>
-                <a:ext cx="4137746" cy="1716829"/>
+                <a:ext cx="3819225" cy="1953370"/>
                 <a:chOff x="9671298" y="17666601"/>
-                <a:chExt cx="4137746" cy="1716829"/>
+                <a:chExt cx="3819225" cy="1953370"/>
               </a:xfrm>
             </p:grpSpPr>
             <p:cxnSp>
@@ -11330,12 +10577,12 @@
               </p:nvCxnSpPr>
               <p:spPr bwMode="auto">
                 <a:xfrm rot="16200000" flipH="1">
-                  <a:off x="13057930" y="18587512"/>
-                  <a:ext cx="785486" cy="716743"/>
+                  <a:off x="12757996" y="18887445"/>
+                  <a:ext cx="1066831" cy="398222"/>
                 </a:xfrm>
                 <a:prstGeom prst="bentConnector3">
                   <a:avLst>
-                    <a:gd name="adj1" fmla="val -5434"/>
+                    <a:gd name="adj1" fmla="val -750"/>
                   </a:avLst>
                 </a:prstGeom>
                 <a:solidFill>
@@ -11514,14 +10761,14 @@
               <p:nvPr/>
             </p:nvPicPr>
             <p:blipFill>
-              <a:blip r:embed="rId8"/>
+              <a:blip r:embed="rId7"/>
               <a:stretch>
                 <a:fillRect/>
               </a:stretch>
             </p:blipFill>
             <p:spPr>
               <a:xfrm>
-                <a:off x="12485319" y="19632612"/>
+                <a:off x="12246737" y="19903601"/>
                 <a:ext cx="2419305" cy="2411132"/>
               </a:xfrm>
               <a:prstGeom prst="rect">
@@ -11649,6 +10896,1284 @@
           </p:spPr>
         </p:cxnSp>
       </p:grpSp>
+      <p:grpSp>
+        <p:nvGrpSpPr>
+          <p:cNvPr id="15504" name="Group 15503">
+            <a:extLst>
+              <a:ext uri="{FF2B5EF4-FFF2-40B4-BE49-F238E27FC236}">
+                <a16:creationId xmlns:a16="http://schemas.microsoft.com/office/drawing/2014/main" id="{644DC864-CB77-FB1C-CD61-505A98BC9282}"/>
+              </a:ext>
+            </a:extLst>
+          </p:cNvPr>
+          <p:cNvGrpSpPr/>
+          <p:nvPr/>
+        </p:nvGrpSpPr>
+        <p:grpSpPr>
+          <a:xfrm>
+            <a:off x="15451643" y="25162475"/>
+            <a:ext cx="7503010" cy="5479971"/>
+            <a:chOff x="15470883" y="25749188"/>
+            <a:chExt cx="7503010" cy="5479971"/>
+          </a:xfrm>
+        </p:grpSpPr>
+        <p:grpSp>
+          <p:nvGrpSpPr>
+            <p:cNvPr id="15501" name="Group 15500">
+              <a:extLst>
+                <a:ext uri="{FF2B5EF4-FFF2-40B4-BE49-F238E27FC236}">
+                  <a16:creationId xmlns:a16="http://schemas.microsoft.com/office/drawing/2014/main" id="{4EBE445F-826A-9AF7-418D-8850E8E507A0}"/>
+                </a:ext>
+              </a:extLst>
+            </p:cNvPr>
+            <p:cNvGrpSpPr/>
+            <p:nvPr/>
+          </p:nvGrpSpPr>
+          <p:grpSpPr>
+            <a:xfrm>
+              <a:off x="15470883" y="25749188"/>
+              <a:ext cx="7503010" cy="4871119"/>
+              <a:chOff x="15598291" y="25491649"/>
+              <a:chExt cx="7503010" cy="4871119"/>
+            </a:xfrm>
+          </p:grpSpPr>
+          <p:sp>
+            <p:nvSpPr>
+              <p:cNvPr id="15496" name="TextBox 15495">
+                <a:extLst>
+                  <a:ext uri="{FF2B5EF4-FFF2-40B4-BE49-F238E27FC236}">
+                    <a16:creationId xmlns:a16="http://schemas.microsoft.com/office/drawing/2014/main" id="{97F12319-F968-5A70-A870-C2BAE5E8D7F2}"/>
+                  </a:ext>
+                </a:extLst>
+              </p:cNvPr>
+              <p:cNvSpPr txBox="1"/>
+              <p:nvPr/>
+            </p:nvSpPr>
+            <p:spPr>
+              <a:xfrm rot="5400000">
+                <a:off x="16099096" y="29487428"/>
+                <a:ext cx="615553" cy="894559"/>
+              </a:xfrm>
+              <a:prstGeom prst="rect">
+                <a:avLst/>
+              </a:prstGeom>
+              <a:noFill/>
+            </p:spPr>
+            <p:txBody>
+              <a:bodyPr vert="vert270" wrap="square">
+                <a:spAutoFit/>
+              </a:bodyPr>
+              <a:lstStyle/>
+              <a:p>
+                <a:pPr algn="ctr"/>
+                <a:r>
+                  <a:rPr lang="en-US" sz="2000" dirty="0">
+                    <a:latin typeface="Helvetica"/>
+                    <a:ea typeface="MS PGothic"/>
+                  </a:rPr>
+                  <a:t>-500</a:t>
+                </a:r>
+              </a:p>
+            </p:txBody>
+          </p:sp>
+          <p:grpSp>
+            <p:nvGrpSpPr>
+              <p:cNvPr id="15500" name="Group 15499">
+                <a:extLst>
+                  <a:ext uri="{FF2B5EF4-FFF2-40B4-BE49-F238E27FC236}">
+                    <a16:creationId xmlns:a16="http://schemas.microsoft.com/office/drawing/2014/main" id="{5DE2D8B9-CD7D-1452-B68B-1344AA4FF437}"/>
+                  </a:ext>
+                </a:extLst>
+              </p:cNvPr>
+              <p:cNvGrpSpPr/>
+              <p:nvPr/>
+            </p:nvGrpSpPr>
+            <p:grpSpPr>
+              <a:xfrm>
+                <a:off x="15598291" y="25491649"/>
+                <a:ext cx="7503010" cy="4871119"/>
+                <a:chOff x="15598291" y="25491649"/>
+                <a:chExt cx="7503010" cy="4871119"/>
+              </a:xfrm>
+            </p:grpSpPr>
+            <p:sp>
+              <p:nvSpPr>
+                <p:cNvPr id="50" name="TextBox 49">
+                  <a:extLst>
+                    <a:ext uri="{FF2B5EF4-FFF2-40B4-BE49-F238E27FC236}">
+                      <a16:creationId xmlns:a16="http://schemas.microsoft.com/office/drawing/2014/main" id="{3E5D8420-A794-E6A2-1628-ED1203DBAD11}"/>
+                    </a:ext>
+                  </a:extLst>
+                </p:cNvPr>
+                <p:cNvSpPr txBox="1"/>
+                <p:nvPr/>
+              </p:nvSpPr>
+              <p:spPr>
+                <a:xfrm>
+                  <a:off x="15598291" y="25950356"/>
+                  <a:ext cx="615553" cy="3833392"/>
+                </a:xfrm>
+                <a:prstGeom prst="rect">
+                  <a:avLst/>
+                </a:prstGeom>
+                <a:noFill/>
+              </p:spPr>
+              <p:txBody>
+                <a:bodyPr vert="vert270" wrap="square">
+                  <a:spAutoFit/>
+                </a:bodyPr>
+                <a:lstStyle/>
+                <a:p>
+                  <a:pPr algn="ctr"/>
+                  <a:r>
+                    <a:rPr lang="en-US" sz="2800" dirty="0">
+                      <a:latin typeface="Helvetica"/>
+                    </a:rPr>
+                    <a:t>ACC Activation</a:t>
+                  </a:r>
+                </a:p>
+              </p:txBody>
+            </p:sp>
+            <p:grpSp>
+              <p:nvGrpSpPr>
+                <p:cNvPr id="15499" name="Group 15498">
+                  <a:extLst>
+                    <a:ext uri="{FF2B5EF4-FFF2-40B4-BE49-F238E27FC236}">
+                      <a16:creationId xmlns:a16="http://schemas.microsoft.com/office/drawing/2014/main" id="{96FE859C-4C1F-A2C4-A1D3-E89307BFE71C}"/>
+                    </a:ext>
+                  </a:extLst>
+                </p:cNvPr>
+                <p:cNvGrpSpPr/>
+                <p:nvPr/>
+              </p:nvGrpSpPr>
+              <p:grpSpPr>
+                <a:xfrm>
+                  <a:off x="16012786" y="25491649"/>
+                  <a:ext cx="7088515" cy="4871119"/>
+                  <a:chOff x="16012786" y="25491649"/>
+                  <a:chExt cx="7088515" cy="4871119"/>
+                </a:xfrm>
+              </p:grpSpPr>
+              <p:pic>
+                <p:nvPicPr>
+                  <p:cNvPr id="15495" name="Picture 15494" descr="A white background with red dots&#10;&#10;Description automatically generated">
+                    <a:extLst>
+                      <a:ext uri="{FF2B5EF4-FFF2-40B4-BE49-F238E27FC236}">
+                        <a16:creationId xmlns:a16="http://schemas.microsoft.com/office/drawing/2014/main" id="{F821A0E6-FCAD-A479-2153-337980B9048C}"/>
+                      </a:ext>
+                    </a:extLst>
+                  </p:cNvPr>
+                  <p:cNvPicPr>
+                    <a:picLocks noChangeAspect="1"/>
+                  </p:cNvPicPr>
+                  <p:nvPr/>
+                </p:nvPicPr>
+                <p:blipFill rotWithShape="1">
+                  <a:blip r:embed="rId8">
+                    <a:duotone>
+                      <a:prstClr val="black"/>
+                      <a:srgbClr val="D9C3A5">
+                        <a:tint val="50000"/>
+                        <a:satMod val="180000"/>
+                      </a:srgbClr>
+                    </a:duotone>
+                    <a:extLst>
+                      <a:ext uri="{BEBA8EAE-BF5A-486C-A8C5-ECC9F3942E4B}">
+                        <a14:imgProps xmlns:a14="http://schemas.microsoft.com/office/drawing/2010/main">
+                          <a14:imgLayer r:embed="rId9">
+                            <a14:imgEffect>
+                              <a14:colorTemperature colorTemp="9463"/>
+                            </a14:imgEffect>
+                            <a14:imgEffect>
+                              <a14:saturation sat="377000"/>
+                            </a14:imgEffect>
+                          </a14:imgLayer>
+                        </a14:imgProps>
+                      </a:ext>
+                      <a:ext uri="{28A0092B-C50C-407E-A947-70E740481C1C}">
+                        <a14:useLocalDpi xmlns:a14="http://schemas.microsoft.com/office/drawing/2010/main" val="0"/>
+                      </a:ext>
+                    </a:extLst>
+                  </a:blip>
+                  <a:srcRect l="6725" r="12309" b="12526"/>
+                  <a:stretch/>
+                </p:blipFill>
+                <p:spPr>
+                  <a:xfrm>
+                    <a:off x="16872273" y="25491649"/>
+                    <a:ext cx="6229028" cy="4871119"/>
+                  </a:xfrm>
+                  <a:prstGeom prst="rect">
+                    <a:avLst/>
+                  </a:prstGeom>
+                  <a:ln w="50800">
+                    <a:solidFill>
+                      <a:schemeClr val="tx1"/>
+                    </a:solidFill>
+                  </a:ln>
+                </p:spPr>
+              </p:pic>
+              <p:sp>
+                <p:nvSpPr>
+                  <p:cNvPr id="15497" name="TextBox 15496">
+                    <a:extLst>
+                      <a:ext uri="{FF2B5EF4-FFF2-40B4-BE49-F238E27FC236}">
+                        <a16:creationId xmlns:a16="http://schemas.microsoft.com/office/drawing/2014/main" id="{E8D4CB9D-FFD4-3493-3F54-665739D04D07}"/>
+                      </a:ext>
+                    </a:extLst>
+                  </p:cNvPr>
+                  <p:cNvSpPr txBox="1"/>
+                  <p:nvPr/>
+                </p:nvSpPr>
+                <p:spPr>
+                  <a:xfrm rot="5400000">
+                    <a:off x="16213844" y="25459501"/>
+                    <a:ext cx="492443" cy="894559"/>
+                  </a:xfrm>
+                  <a:prstGeom prst="rect">
+                    <a:avLst/>
+                  </a:prstGeom>
+                  <a:noFill/>
+                </p:spPr>
+                <p:txBody>
+                  <a:bodyPr vert="vert270" wrap="square">
+                    <a:spAutoFit/>
+                  </a:bodyPr>
+                  <a:lstStyle/>
+                  <a:p>
+                    <a:pPr algn="ctr"/>
+                    <a:r>
+                      <a:rPr lang="en-US" sz="2000" dirty="0">
+                        <a:latin typeface="Helvetica"/>
+                        <a:ea typeface="MS PGothic"/>
+                      </a:rPr>
+                      <a:t>500</a:t>
+                    </a:r>
+                  </a:p>
+                </p:txBody>
+              </p:sp>
+            </p:grpSp>
+          </p:grpSp>
+          <p:sp>
+            <p:nvSpPr>
+              <p:cNvPr id="15498" name="TextBox 15497">
+                <a:extLst>
+                  <a:ext uri="{FF2B5EF4-FFF2-40B4-BE49-F238E27FC236}">
+                    <a16:creationId xmlns:a16="http://schemas.microsoft.com/office/drawing/2014/main" id="{477A1EE9-E5E5-6824-266B-1635FC9DBB6C}"/>
+                  </a:ext>
+                </a:extLst>
+              </p:cNvPr>
+              <p:cNvSpPr txBox="1"/>
+              <p:nvPr/>
+            </p:nvSpPr>
+            <p:spPr>
+              <a:xfrm rot="5400000">
+                <a:off x="16213844" y="27480909"/>
+                <a:ext cx="492443" cy="894559"/>
+              </a:xfrm>
+              <a:prstGeom prst="rect">
+                <a:avLst/>
+              </a:prstGeom>
+              <a:noFill/>
+            </p:spPr>
+            <p:txBody>
+              <a:bodyPr vert="vert270" wrap="square">
+                <a:spAutoFit/>
+              </a:bodyPr>
+              <a:lstStyle/>
+              <a:p>
+                <a:pPr algn="ctr"/>
+                <a:r>
+                  <a:rPr lang="en-US" sz="2000" dirty="0">
+                    <a:latin typeface="Helvetica"/>
+                    <a:ea typeface="MS PGothic"/>
+                  </a:rPr>
+                  <a:t>0</a:t>
+                </a:r>
+              </a:p>
+            </p:txBody>
+          </p:sp>
+        </p:grpSp>
+        <p:sp>
+          <p:nvSpPr>
+            <p:cNvPr id="15502" name="TextBox 15501">
+              <a:extLst>
+                <a:ext uri="{FF2B5EF4-FFF2-40B4-BE49-F238E27FC236}">
+                  <a16:creationId xmlns:a16="http://schemas.microsoft.com/office/drawing/2014/main" id="{43DB2953-AA93-0F11-DA93-B42076077EAC}"/>
+                </a:ext>
+              </a:extLst>
+            </p:cNvPr>
+            <p:cNvSpPr txBox="1"/>
+            <p:nvPr/>
+          </p:nvSpPr>
+          <p:spPr>
+            <a:xfrm rot="5400000">
+              <a:off x="16647360" y="30664325"/>
+              <a:ext cx="492443" cy="637225"/>
+            </a:xfrm>
+            <a:prstGeom prst="rect">
+              <a:avLst/>
+            </a:prstGeom>
+            <a:noFill/>
+          </p:spPr>
+          <p:txBody>
+            <a:bodyPr vert="vert270" wrap="square">
+              <a:spAutoFit/>
+            </a:bodyPr>
+            <a:lstStyle/>
+            <a:p>
+              <a:pPr algn="ctr"/>
+              <a:r>
+                <a:rPr lang="en-US" sz="2000" dirty="0">
+                  <a:latin typeface="Helvetica"/>
+                  <a:ea typeface="MS PGothic"/>
+                </a:rPr>
+                <a:t>-1</a:t>
+              </a:r>
+            </a:p>
+          </p:txBody>
+        </p:sp>
+      </p:grpSp>
+      <p:sp>
+        <p:nvSpPr>
+          <p:cNvPr id="15505" name="TextBox 15504">
+            <a:extLst>
+              <a:ext uri="{FF2B5EF4-FFF2-40B4-BE49-F238E27FC236}">
+                <a16:creationId xmlns:a16="http://schemas.microsoft.com/office/drawing/2014/main" id="{C7E50644-C212-0221-C878-B75C7841A6FE}"/>
+              </a:ext>
+            </a:extLst>
+          </p:cNvPr>
+          <p:cNvSpPr txBox="1"/>
+          <p:nvPr/>
+        </p:nvSpPr>
+        <p:spPr>
+          <a:xfrm rot="5400000">
+            <a:off x="22478589" y="30047597"/>
+            <a:ext cx="492443" cy="637225"/>
+          </a:xfrm>
+          <a:prstGeom prst="rect">
+            <a:avLst/>
+          </a:prstGeom>
+          <a:noFill/>
+        </p:spPr>
+        <p:txBody>
+          <a:bodyPr vert="vert270" wrap="square">
+            <a:spAutoFit/>
+          </a:bodyPr>
+          <a:lstStyle/>
+          <a:p>
+            <a:pPr algn="ctr"/>
+            <a:r>
+              <a:rPr lang="en-US" sz="2000" dirty="0">
+                <a:latin typeface="Helvetica"/>
+                <a:ea typeface="MS PGothic"/>
+              </a:rPr>
+              <a:t>7</a:t>
+            </a:r>
+          </a:p>
+        </p:txBody>
+      </p:sp>
+      <p:sp>
+        <p:nvSpPr>
+          <p:cNvPr id="15506" name="TextBox 15505">
+            <a:extLst>
+              <a:ext uri="{FF2B5EF4-FFF2-40B4-BE49-F238E27FC236}">
+                <a16:creationId xmlns:a16="http://schemas.microsoft.com/office/drawing/2014/main" id="{F6AA0DD9-AF8A-14EF-EE60-8F981B287B70}"/>
+              </a:ext>
+            </a:extLst>
+          </p:cNvPr>
+          <p:cNvSpPr txBox="1"/>
+          <p:nvPr/>
+        </p:nvSpPr>
+        <p:spPr>
+          <a:xfrm rot="5400000">
+            <a:off x="19500266" y="30009878"/>
+            <a:ext cx="492443" cy="637225"/>
+          </a:xfrm>
+          <a:prstGeom prst="rect">
+            <a:avLst/>
+          </a:prstGeom>
+          <a:noFill/>
+        </p:spPr>
+        <p:txBody>
+          <a:bodyPr vert="vert270" wrap="square">
+            <a:spAutoFit/>
+          </a:bodyPr>
+          <a:lstStyle/>
+          <a:p>
+            <a:pPr algn="ctr"/>
+            <a:r>
+              <a:rPr lang="en-US" sz="2000" dirty="0">
+                <a:latin typeface="Helvetica"/>
+                <a:ea typeface="MS PGothic"/>
+              </a:rPr>
+              <a:t>3</a:t>
+            </a:r>
+          </a:p>
+        </p:txBody>
+      </p:sp>
+      <p:sp>
+        <p:nvSpPr>
+          <p:cNvPr id="15507" name="TextBox 15506">
+            <a:extLst>
+              <a:ext uri="{FF2B5EF4-FFF2-40B4-BE49-F238E27FC236}">
+                <a16:creationId xmlns:a16="http://schemas.microsoft.com/office/drawing/2014/main" id="{AAFE7BAC-F7B5-54A6-6F9D-FC90E9E56E1C}"/>
+              </a:ext>
+            </a:extLst>
+          </p:cNvPr>
+          <p:cNvSpPr txBox="1"/>
+          <p:nvPr/>
+        </p:nvSpPr>
+        <p:spPr>
+          <a:xfrm rot="5400000">
+            <a:off x="19405757" y="27269918"/>
+            <a:ext cx="538609" cy="7047408"/>
+          </a:xfrm>
+          <a:prstGeom prst="rect">
+            <a:avLst/>
+          </a:prstGeom>
+          <a:noFill/>
+        </p:spPr>
+        <p:txBody>
+          <a:bodyPr vert="vert270" wrap="square">
+            <a:spAutoFit/>
+          </a:bodyPr>
+          <a:lstStyle/>
+          <a:p>
+            <a:pPr algn="ctr"/>
+            <a:r>
+              <a:rPr lang="en-US" sz="2300" dirty="0">
+                <a:latin typeface="Helvetica"/>
+              </a:rPr>
+              <a:t>Closeness with Friends - Closeness with Strangers</a:t>
+            </a:r>
+          </a:p>
+        </p:txBody>
+      </p:sp>
+      <p:grpSp>
+        <p:nvGrpSpPr>
+          <p:cNvPr id="15521" name="Group 15520">
+            <a:extLst>
+              <a:ext uri="{FF2B5EF4-FFF2-40B4-BE49-F238E27FC236}">
+                <a16:creationId xmlns:a16="http://schemas.microsoft.com/office/drawing/2014/main" id="{64719E14-F38F-FF1C-E91E-4FC7882FC372}"/>
+              </a:ext>
+            </a:extLst>
+          </p:cNvPr>
+          <p:cNvGrpSpPr/>
+          <p:nvPr/>
+        </p:nvGrpSpPr>
+        <p:grpSpPr>
+          <a:xfrm>
+            <a:off x="35583421" y="5816737"/>
+            <a:ext cx="8287372" cy="6693875"/>
+            <a:chOff x="36784826" y="6632182"/>
+            <a:chExt cx="6753481" cy="5222307"/>
+          </a:xfrm>
+        </p:grpSpPr>
+        <p:sp>
+          <p:nvSpPr>
+            <p:cNvPr id="15434" name="TextBox 15433">
+              <a:extLst>
+                <a:ext uri="{FF2B5EF4-FFF2-40B4-BE49-F238E27FC236}">
+                  <a16:creationId xmlns:a16="http://schemas.microsoft.com/office/drawing/2014/main" id="{F42DD616-45E9-33CA-3CBB-04AC7B550D62}"/>
+                </a:ext>
+              </a:extLst>
+            </p:cNvPr>
+            <p:cNvSpPr txBox="1"/>
+            <p:nvPr/>
+          </p:nvSpPr>
+          <p:spPr>
+            <a:xfrm>
+              <a:off x="36784826" y="6632182"/>
+              <a:ext cx="615553" cy="4368929"/>
+            </a:xfrm>
+            <a:prstGeom prst="rect">
+              <a:avLst/>
+            </a:prstGeom>
+            <a:noFill/>
+          </p:spPr>
+          <p:txBody>
+            <a:bodyPr vert="vert270" wrap="square">
+              <a:spAutoFit/>
+            </a:bodyPr>
+            <a:lstStyle/>
+            <a:p>
+              <a:pPr algn="ctr"/>
+              <a:r>
+                <a:rPr lang="en-US" sz="2800" dirty="0">
+                  <a:latin typeface="Helvetica"/>
+                  <a:ea typeface="MS PGothic"/>
+                </a:rPr>
+                <a:t>Precuneus Activation</a:t>
+              </a:r>
+            </a:p>
+          </p:txBody>
+        </p:sp>
+        <p:pic>
+          <p:nvPicPr>
+            <p:cNvPr id="15418" name="Picture 15417" descr="A graph with red dots&#10;&#10;Description automatically generated">
+              <a:extLst>
+                <a:ext uri="{FF2B5EF4-FFF2-40B4-BE49-F238E27FC236}">
+                  <a16:creationId xmlns:a16="http://schemas.microsoft.com/office/drawing/2014/main" id="{7AE9EF6F-6375-47A1-D536-FAF3F473B789}"/>
+                </a:ext>
+              </a:extLst>
+            </p:cNvPr>
+            <p:cNvPicPr>
+              <a:picLocks noChangeAspect="1"/>
+            </p:cNvPicPr>
+            <p:nvPr/>
+          </p:nvPicPr>
+          <p:blipFill rotWithShape="1">
+            <a:blip r:embed="rId10">
+              <a:extLst>
+                <a:ext uri="{28A0092B-C50C-407E-A947-70E740481C1C}">
+                  <a14:useLocalDpi xmlns:a14="http://schemas.microsoft.com/office/drawing/2010/main" val="0"/>
+                </a:ext>
+              </a:extLst>
+            </a:blip>
+            <a:srcRect l="3131"/>
+            <a:stretch/>
+          </p:blipFill>
+          <p:spPr>
+            <a:xfrm>
+              <a:off x="37850303" y="6924524"/>
+              <a:ext cx="5314627" cy="4025900"/>
+            </a:xfrm>
+            <a:prstGeom prst="rect">
+              <a:avLst/>
+            </a:prstGeom>
+          </p:spPr>
+        </p:pic>
+        <p:sp>
+          <p:nvSpPr>
+            <p:cNvPr id="15420" name="TextBox 15419">
+              <a:extLst>
+                <a:ext uri="{FF2B5EF4-FFF2-40B4-BE49-F238E27FC236}">
+                  <a16:creationId xmlns:a16="http://schemas.microsoft.com/office/drawing/2014/main" id="{069F462D-BFA5-DA6C-F8A4-6704B438B9AA}"/>
+                </a:ext>
+              </a:extLst>
+            </p:cNvPr>
+            <p:cNvSpPr txBox="1"/>
+            <p:nvPr/>
+          </p:nvSpPr>
+          <p:spPr>
+            <a:xfrm>
+              <a:off x="40013832" y="11300491"/>
+              <a:ext cx="867545" cy="553998"/>
+            </a:xfrm>
+            <a:prstGeom prst="rect">
+              <a:avLst/>
+            </a:prstGeom>
+            <a:noFill/>
+          </p:spPr>
+          <p:txBody>
+            <a:bodyPr wrap="none" rtlCol="0">
+              <a:spAutoFit/>
+            </a:bodyPr>
+            <a:lstStyle/>
+            <a:p>
+              <a:r>
+                <a:rPr lang="en-US" sz="3000" dirty="0"/>
+                <a:t>Age</a:t>
+              </a:r>
+            </a:p>
+          </p:txBody>
+        </p:sp>
+        <p:sp>
+          <p:nvSpPr>
+            <p:cNvPr id="15511" name="TextBox 15510">
+              <a:extLst>
+                <a:ext uri="{FF2B5EF4-FFF2-40B4-BE49-F238E27FC236}">
+                  <a16:creationId xmlns:a16="http://schemas.microsoft.com/office/drawing/2014/main" id="{973A9BDE-83AF-A703-4ACB-BD3D64A294A1}"/>
+                </a:ext>
+              </a:extLst>
+            </p:cNvPr>
+            <p:cNvSpPr txBox="1"/>
+            <p:nvPr/>
+          </p:nvSpPr>
+          <p:spPr>
+            <a:xfrm rot="5400000">
+              <a:off x="37377370" y="10243912"/>
+              <a:ext cx="492443" cy="894559"/>
+            </a:xfrm>
+            <a:prstGeom prst="rect">
+              <a:avLst/>
+            </a:prstGeom>
+            <a:noFill/>
+          </p:spPr>
+          <p:txBody>
+            <a:bodyPr vert="vert270" wrap="square">
+              <a:spAutoFit/>
+            </a:bodyPr>
+            <a:lstStyle/>
+            <a:p>
+              <a:pPr algn="ctr"/>
+              <a:r>
+                <a:rPr lang="en-US" sz="2000" dirty="0">
+                  <a:latin typeface="Helvetica"/>
+                  <a:ea typeface="MS PGothic"/>
+                </a:rPr>
+                <a:t>-300</a:t>
+              </a:r>
+            </a:p>
+          </p:txBody>
+        </p:sp>
+        <p:sp>
+          <p:nvSpPr>
+            <p:cNvPr id="15512" name="TextBox 15511">
+              <a:extLst>
+                <a:ext uri="{FF2B5EF4-FFF2-40B4-BE49-F238E27FC236}">
+                  <a16:creationId xmlns:a16="http://schemas.microsoft.com/office/drawing/2014/main" id="{E1070220-5A52-F0E6-B2E9-302B7EA961E1}"/>
+                </a:ext>
+              </a:extLst>
+            </p:cNvPr>
+            <p:cNvSpPr txBox="1"/>
+            <p:nvPr/>
+          </p:nvSpPr>
+          <p:spPr>
+            <a:xfrm rot="5400000">
+              <a:off x="37332998" y="6887202"/>
+              <a:ext cx="492443" cy="894559"/>
+            </a:xfrm>
+            <a:prstGeom prst="rect">
+              <a:avLst/>
+            </a:prstGeom>
+            <a:noFill/>
+          </p:spPr>
+          <p:txBody>
+            <a:bodyPr vert="vert270" wrap="square">
+              <a:spAutoFit/>
+            </a:bodyPr>
+            <a:lstStyle/>
+            <a:p>
+              <a:pPr algn="ctr"/>
+              <a:r>
+                <a:rPr lang="en-US" sz="2000" dirty="0">
+                  <a:latin typeface="Helvetica"/>
+                  <a:ea typeface="MS PGothic"/>
+                </a:rPr>
+                <a:t>500</a:t>
+              </a:r>
+            </a:p>
+          </p:txBody>
+        </p:sp>
+        <p:sp>
+          <p:nvSpPr>
+            <p:cNvPr id="15513" name="TextBox 15512">
+              <a:extLst>
+                <a:ext uri="{FF2B5EF4-FFF2-40B4-BE49-F238E27FC236}">
+                  <a16:creationId xmlns:a16="http://schemas.microsoft.com/office/drawing/2014/main" id="{0F8B9AF0-2622-2A04-F1ED-ED9368F9B986}"/>
+                </a:ext>
+              </a:extLst>
+            </p:cNvPr>
+            <p:cNvSpPr txBox="1"/>
+            <p:nvPr/>
+          </p:nvSpPr>
+          <p:spPr>
+            <a:xfrm rot="5400000">
+              <a:off x="42844806" y="10544726"/>
+              <a:ext cx="492443" cy="894559"/>
+            </a:xfrm>
+            <a:prstGeom prst="rect">
+              <a:avLst/>
+            </a:prstGeom>
+            <a:noFill/>
+          </p:spPr>
+          <p:txBody>
+            <a:bodyPr vert="vert270" wrap="square">
+              <a:spAutoFit/>
+            </a:bodyPr>
+            <a:lstStyle/>
+            <a:p>
+              <a:pPr algn="ctr"/>
+              <a:r>
+                <a:rPr lang="en-US" sz="2000" dirty="0">
+                  <a:latin typeface="Helvetica"/>
+                  <a:ea typeface="MS PGothic"/>
+                </a:rPr>
+                <a:t>73</a:t>
+              </a:r>
+            </a:p>
+          </p:txBody>
+        </p:sp>
+        <p:sp>
+          <p:nvSpPr>
+            <p:cNvPr id="15514" name="TextBox 15513">
+              <a:extLst>
+                <a:ext uri="{FF2B5EF4-FFF2-40B4-BE49-F238E27FC236}">
+                  <a16:creationId xmlns:a16="http://schemas.microsoft.com/office/drawing/2014/main" id="{E60AC3A4-3AE3-AE30-E0E3-896B8FAA10B3}"/>
+                </a:ext>
+              </a:extLst>
+            </p:cNvPr>
+            <p:cNvSpPr txBox="1"/>
+            <p:nvPr/>
+          </p:nvSpPr>
+          <p:spPr>
+            <a:xfrm rot="5400000">
+              <a:off x="38011338" y="10662467"/>
+              <a:ext cx="492443" cy="894559"/>
+            </a:xfrm>
+            <a:prstGeom prst="rect">
+              <a:avLst/>
+            </a:prstGeom>
+            <a:noFill/>
+          </p:spPr>
+          <p:txBody>
+            <a:bodyPr vert="vert270" wrap="square">
+              <a:spAutoFit/>
+            </a:bodyPr>
+            <a:lstStyle/>
+            <a:p>
+              <a:pPr algn="ctr"/>
+              <a:r>
+                <a:rPr lang="en-US" sz="2000" dirty="0">
+                  <a:latin typeface="Helvetica"/>
+                  <a:ea typeface="MS PGothic"/>
+                </a:rPr>
+                <a:t>21</a:t>
+              </a:r>
+            </a:p>
+          </p:txBody>
+        </p:sp>
+      </p:grpSp>
+      <p:sp>
+        <p:nvSpPr>
+          <p:cNvPr id="15516" name="Rectangle 15515">
+            <a:extLst>
+              <a:ext uri="{FF2B5EF4-FFF2-40B4-BE49-F238E27FC236}">
+                <a16:creationId xmlns:a16="http://schemas.microsoft.com/office/drawing/2014/main" id="{69025403-F6D7-C8C4-F5D8-FF27361E4E91}"/>
+              </a:ext>
+            </a:extLst>
+          </p:cNvPr>
+          <p:cNvSpPr/>
+          <p:nvPr/>
+        </p:nvSpPr>
+        <p:spPr>
+          <a:xfrm>
+            <a:off x="31178642" y="12908794"/>
+            <a:ext cx="12293617" cy="584775"/>
+          </a:xfrm>
+          <a:prstGeom prst="rect">
+            <a:avLst/>
+          </a:prstGeom>
+        </p:spPr>
+        <p:txBody>
+          <a:bodyPr wrap="square" lIns="91440" tIns="45720" rIns="91440" bIns="45720" anchor="t">
+            <a:spAutoFit/>
+          </a:bodyPr>
+          <a:lstStyle/>
+          <a:p>
+            <a:pPr algn="ctr"/>
+            <a:r>
+              <a:rPr lang="en-US" sz="3200" dirty="0">
+                <a:ea typeface="MS PGothic"/>
+                <a:cs typeface="Helvetica"/>
+              </a:rPr>
+              <a:t>We found an association between the precuneus and age</a:t>
+            </a:r>
+          </a:p>
+        </p:txBody>
+      </p:sp>
+      <p:pic>
+        <p:nvPicPr>
+          <p:cNvPr id="15519" name="Picture 15518">
+            <a:extLst>
+              <a:ext uri="{FF2B5EF4-FFF2-40B4-BE49-F238E27FC236}">
+                <a16:creationId xmlns:a16="http://schemas.microsoft.com/office/drawing/2014/main" id="{ED5B2D2C-98F6-DF06-D6F2-C1EB7BDB5BB2}"/>
+              </a:ext>
+            </a:extLst>
+          </p:cNvPr>
+          <p:cNvPicPr>
+            <a:picLocks noChangeAspect="1"/>
+          </p:cNvPicPr>
+          <p:nvPr/>
+        </p:nvPicPr>
+        <p:blipFill>
+          <a:blip r:embed="rId11"/>
+          <a:stretch>
+            <a:fillRect/>
+          </a:stretch>
+        </p:blipFill>
+        <p:spPr>
+          <a:xfrm>
+            <a:off x="31354424" y="15485476"/>
+            <a:ext cx="7216034" cy="7151686"/>
+          </a:xfrm>
+          <a:prstGeom prst="rect">
+            <a:avLst/>
+          </a:prstGeom>
+        </p:spPr>
+      </p:pic>
+      <p:sp>
+        <p:nvSpPr>
+          <p:cNvPr id="15520" name="Rectangle 15519">
+            <a:extLst>
+              <a:ext uri="{FF2B5EF4-FFF2-40B4-BE49-F238E27FC236}">
+                <a16:creationId xmlns:a16="http://schemas.microsoft.com/office/drawing/2014/main" id="{93FF6634-0FA7-FD32-F6D8-ADBE0C3DF974}"/>
+              </a:ext>
+            </a:extLst>
+          </p:cNvPr>
+          <p:cNvSpPr/>
+          <p:nvPr/>
+        </p:nvSpPr>
+        <p:spPr>
+          <a:xfrm>
+            <a:off x="31809199" y="22940971"/>
+            <a:ext cx="12293617" cy="1077218"/>
+          </a:xfrm>
+          <a:prstGeom prst="rect">
+            <a:avLst/>
+          </a:prstGeom>
+        </p:spPr>
+        <p:txBody>
+          <a:bodyPr wrap="square" lIns="91440" tIns="45720" rIns="91440" bIns="45720" anchor="t">
+            <a:spAutoFit/>
+          </a:bodyPr>
+          <a:lstStyle/>
+          <a:p>
+            <a:pPr algn="ctr"/>
+            <a:r>
+              <a:rPr lang="en-US" sz="3200" dirty="0">
+                <a:ea typeface="MS PGothic"/>
+                <a:cs typeface="Helvetica"/>
+              </a:rPr>
+              <a:t>We found Orbitofrontal Cortex activation in the three way effects model between IOS, age and OAFEM</a:t>
+            </a:r>
+          </a:p>
+        </p:txBody>
+      </p:sp>
+      <p:grpSp>
+        <p:nvGrpSpPr>
+          <p:cNvPr id="15524" name="Group 15523">
+            <a:extLst>
+              <a:ext uri="{FF2B5EF4-FFF2-40B4-BE49-F238E27FC236}">
+                <a16:creationId xmlns:a16="http://schemas.microsoft.com/office/drawing/2014/main" id="{2BE13E56-51BA-1AA5-3DFC-DFF18406D067}"/>
+              </a:ext>
+            </a:extLst>
+          </p:cNvPr>
+          <p:cNvGrpSpPr/>
+          <p:nvPr/>
+        </p:nvGrpSpPr>
+        <p:grpSpPr>
+          <a:xfrm>
+            <a:off x="175846" y="31162938"/>
+            <a:ext cx="14710114" cy="1521569"/>
+            <a:chOff x="348551" y="31162937"/>
+            <a:chExt cx="14710114" cy="1521569"/>
+          </a:xfrm>
+        </p:grpSpPr>
+        <p:sp>
+          <p:nvSpPr>
+            <p:cNvPr id="15522" name="Rectangle 162">
+              <a:extLst>
+                <a:ext uri="{FF2B5EF4-FFF2-40B4-BE49-F238E27FC236}">
+                  <a16:creationId xmlns:a16="http://schemas.microsoft.com/office/drawing/2014/main" id="{FE02C6A3-84E3-8711-744E-4E036833F418}"/>
+                </a:ext>
+              </a:extLst>
+            </p:cNvPr>
+            <p:cNvSpPr>
+              <a:spLocks noChangeArrowheads="1"/>
+            </p:cNvSpPr>
+            <p:nvPr/>
+          </p:nvSpPr>
+          <p:spPr bwMode="auto">
+            <a:xfrm>
+              <a:off x="348551" y="31162937"/>
+              <a:ext cx="14710114" cy="1521569"/>
+            </a:xfrm>
+            <a:prstGeom prst="rect">
+              <a:avLst/>
+            </a:prstGeom>
+            <a:noFill/>
+            <a:ln w="76200">
+              <a:solidFill>
+                <a:srgbClr val="C00000"/>
+              </a:solidFill>
+              <a:miter lim="800000"/>
+              <a:headEnd/>
+              <a:tailEnd/>
+            </a:ln>
+            <a:extLst>
+              <a:ext uri="{909E8E84-426E-40DD-AFC4-6F175D3DCCD1}">
+                <a14:hiddenFill xmlns:a14="http://schemas.microsoft.com/office/drawing/2010/main">
+                  <a:solidFill>
+                    <a:srgbClr val="FFFFFF"/>
+                  </a:solidFill>
+                </a14:hiddenFill>
+              </a:ext>
+            </a:extLst>
+          </p:spPr>
+          <p:txBody>
+            <a:bodyPr wrap="none" lIns="81274" tIns="40638" rIns="81274" bIns="40638" anchor="ctr"/>
+            <a:lstStyle>
+              <a:lvl1pPr>
+                <a:defRPr sz="2400">
+                  <a:solidFill>
+                    <a:schemeClr val="tx1"/>
+                  </a:solidFill>
+                  <a:latin typeface="Helvetica" panose="020B0604020202020204" pitchFamily="34" charset="0"/>
+                  <a:ea typeface="MS PGothic" panose="020B0600070205080204" pitchFamily="34" charset="-128"/>
+                </a:defRPr>
+              </a:lvl1pPr>
+              <a:lvl2pPr marL="742950" indent="-285750">
+                <a:defRPr sz="2400">
+                  <a:solidFill>
+                    <a:schemeClr val="tx1"/>
+                  </a:solidFill>
+                  <a:latin typeface="Helvetica" panose="020B0604020202020204" pitchFamily="34" charset="0"/>
+                  <a:ea typeface="MS PGothic" panose="020B0600070205080204" pitchFamily="34" charset="-128"/>
+                </a:defRPr>
+              </a:lvl2pPr>
+              <a:lvl3pPr marL="1143000" indent="-228600">
+                <a:defRPr sz="2400">
+                  <a:solidFill>
+                    <a:schemeClr val="tx1"/>
+                  </a:solidFill>
+                  <a:latin typeface="Helvetica" panose="020B0604020202020204" pitchFamily="34" charset="0"/>
+                  <a:ea typeface="MS PGothic" panose="020B0600070205080204" pitchFamily="34" charset="-128"/>
+                </a:defRPr>
+              </a:lvl3pPr>
+              <a:lvl4pPr marL="1600200" indent="-228600">
+                <a:defRPr sz="2400">
+                  <a:solidFill>
+                    <a:schemeClr val="tx1"/>
+                  </a:solidFill>
+                  <a:latin typeface="Helvetica" panose="020B0604020202020204" pitchFamily="34" charset="0"/>
+                  <a:ea typeface="MS PGothic" panose="020B0600070205080204" pitchFamily="34" charset="-128"/>
+                </a:defRPr>
+              </a:lvl4pPr>
+              <a:lvl5pPr marL="2057400" indent="-228600">
+                <a:defRPr sz="2400">
+                  <a:solidFill>
+                    <a:schemeClr val="tx1"/>
+                  </a:solidFill>
+                  <a:latin typeface="Helvetica" panose="020B0604020202020204" pitchFamily="34" charset="0"/>
+                  <a:ea typeface="MS PGothic" panose="020B0600070205080204" pitchFamily="34" charset="-128"/>
+                </a:defRPr>
+              </a:lvl5pPr>
+              <a:lvl6pPr marL="2514600" indent="-228600" eaLnBrk="0" fontAlgn="base" hangingPunct="0">
+                <a:spcBef>
+                  <a:spcPct val="0"/>
+                </a:spcBef>
+                <a:spcAft>
+                  <a:spcPct val="0"/>
+                </a:spcAft>
+                <a:defRPr sz="2400">
+                  <a:solidFill>
+                    <a:schemeClr val="tx1"/>
+                  </a:solidFill>
+                  <a:latin typeface="Helvetica" panose="020B0604020202020204" pitchFamily="34" charset="0"/>
+                  <a:ea typeface="MS PGothic" panose="020B0600070205080204" pitchFamily="34" charset="-128"/>
+                </a:defRPr>
+              </a:lvl6pPr>
+              <a:lvl7pPr marL="2971800" indent="-228600" eaLnBrk="0" fontAlgn="base" hangingPunct="0">
+                <a:spcBef>
+                  <a:spcPct val="0"/>
+                </a:spcBef>
+                <a:spcAft>
+                  <a:spcPct val="0"/>
+                </a:spcAft>
+                <a:defRPr sz="2400">
+                  <a:solidFill>
+                    <a:schemeClr val="tx1"/>
+                  </a:solidFill>
+                  <a:latin typeface="Helvetica" panose="020B0604020202020204" pitchFamily="34" charset="0"/>
+                  <a:ea typeface="MS PGothic" panose="020B0600070205080204" pitchFamily="34" charset="-128"/>
+                </a:defRPr>
+              </a:lvl7pPr>
+              <a:lvl8pPr marL="3429000" indent="-228600" eaLnBrk="0" fontAlgn="base" hangingPunct="0">
+                <a:spcBef>
+                  <a:spcPct val="0"/>
+                </a:spcBef>
+                <a:spcAft>
+                  <a:spcPct val="0"/>
+                </a:spcAft>
+                <a:defRPr sz="2400">
+                  <a:solidFill>
+                    <a:schemeClr val="tx1"/>
+                  </a:solidFill>
+                  <a:latin typeface="Helvetica" panose="020B0604020202020204" pitchFamily="34" charset="0"/>
+                  <a:ea typeface="MS PGothic" panose="020B0600070205080204" pitchFamily="34" charset="-128"/>
+                </a:defRPr>
+              </a:lvl8pPr>
+              <a:lvl9pPr marL="3886200" indent="-228600" eaLnBrk="0" fontAlgn="base" hangingPunct="0">
+                <a:spcBef>
+                  <a:spcPct val="0"/>
+                </a:spcBef>
+                <a:spcAft>
+                  <a:spcPct val="0"/>
+                </a:spcAft>
+                <a:defRPr sz="2400">
+                  <a:solidFill>
+                    <a:schemeClr val="tx1"/>
+                  </a:solidFill>
+                  <a:latin typeface="Helvetica" panose="020B0604020202020204" pitchFamily="34" charset="0"/>
+                  <a:ea typeface="MS PGothic" panose="020B0600070205080204" pitchFamily="34" charset="-128"/>
+                </a:defRPr>
+              </a:lvl9pPr>
+            </a:lstStyle>
+            <a:p>
+              <a:pPr eaLnBrk="1" hangingPunct="1"/>
+              <a:endParaRPr lang="en-US" altLang="en-US" sz="1245">
+                <a:latin typeface="Trebuchet MS" panose="020B0603020202020204" pitchFamily="34" charset="0"/>
+              </a:endParaRPr>
+            </a:p>
+          </p:txBody>
+        </p:sp>
+        <p:sp>
+          <p:nvSpPr>
+            <p:cNvPr id="15523" name="TextBox 15522">
+              <a:extLst>
+                <a:ext uri="{FF2B5EF4-FFF2-40B4-BE49-F238E27FC236}">
+                  <a16:creationId xmlns:a16="http://schemas.microsoft.com/office/drawing/2014/main" id="{D58D20F7-A26B-E2DB-0B9B-4184ACFBEF53}"/>
+                </a:ext>
+              </a:extLst>
+            </p:cNvPr>
+            <p:cNvSpPr txBox="1"/>
+            <p:nvPr/>
+          </p:nvSpPr>
+          <p:spPr>
+            <a:xfrm>
+              <a:off x="515553" y="31367653"/>
+              <a:ext cx="14106747" cy="954107"/>
+            </a:xfrm>
+            <a:prstGeom prst="rect">
+              <a:avLst/>
+            </a:prstGeom>
+            <a:noFill/>
+          </p:spPr>
+          <p:txBody>
+            <a:bodyPr wrap="none" rtlCol="0">
+              <a:spAutoFit/>
+            </a:bodyPr>
+            <a:lstStyle/>
+            <a:p>
+              <a:r>
+                <a:rPr lang="en-US" sz="2800" b="0" i="0" dirty="0">
+                  <a:effectLst/>
+                  <a:highlight>
+                    <a:srgbClr val="D8E3C1"/>
+                  </a:highlight>
+                  <a:latin typeface="Slack-Lato"/>
+                </a:rPr>
+                <a:t>This study was supported by National Institutes of Health grant R01-AG067011 (David V. Smith).</a:t>
+              </a:r>
+              <a:br>
+                <a:rPr lang="en-US" sz="2800" dirty="0">
+                  <a:highlight>
+                    <a:srgbClr val="D8E3C1"/>
+                  </a:highlight>
+                </a:rPr>
+              </a:br>
+              <a:r>
+                <a:rPr lang="en-US" sz="2800" b="0" i="0" dirty="0">
+                  <a:effectLst/>
+                  <a:highlight>
+                    <a:srgbClr val="D8E3C1"/>
+                  </a:highlight>
+                  <a:latin typeface="Slack-Lato"/>
+                </a:rPr>
+                <a:t>Contact information: </a:t>
+              </a:r>
+              <a:r>
+                <a:rPr lang="en-US" sz="2800" b="0" i="0" dirty="0" err="1">
+                  <a:effectLst/>
+                  <a:highlight>
+                    <a:srgbClr val="D8E3C1"/>
+                  </a:highlight>
+                  <a:latin typeface="Slack-Lato"/>
+                </a:rPr>
+                <a:t>Avi.Dachs@temple.edu</a:t>
+              </a:r>
+              <a:r>
+                <a:rPr lang="en-US" sz="2800" b="0" i="0" dirty="0">
+                  <a:effectLst/>
+                  <a:highlight>
+                    <a:srgbClr val="D8E3C1"/>
+                  </a:highlight>
+                  <a:latin typeface="Slack-Lato"/>
+                </a:rPr>
+                <a:t>, </a:t>
+              </a:r>
+              <a:r>
+                <a:rPr lang="en-US" sz="2800" b="0" i="0" dirty="0" err="1">
+                  <a:effectLst/>
+                  <a:highlight>
+                    <a:srgbClr val="D8E3C1"/>
+                  </a:highlight>
+                  <a:latin typeface="Slack-Lato"/>
+                </a:rPr>
+                <a:t>Cooper.sharp@temple.edu</a:t>
+              </a:r>
+              <a:endParaRPr lang="en-US" sz="2800" dirty="0">
+                <a:highlight>
+                  <a:srgbClr val="D8E3C1"/>
+                </a:highlight>
+              </a:endParaRPr>
+            </a:p>
+          </p:txBody>
+        </p:sp>
+      </p:grpSp>
+      <p:sp>
+        <p:nvSpPr>
+          <p:cNvPr id="15415" name="TextBox 86">
+            <a:extLst>
+              <a:ext uri="{FF2B5EF4-FFF2-40B4-BE49-F238E27FC236}">
+                <a16:creationId xmlns:a16="http://schemas.microsoft.com/office/drawing/2014/main" id="{B1E3A897-53DA-649F-39B9-6F4056C35336}"/>
+              </a:ext>
+            </a:extLst>
+          </p:cNvPr>
+          <p:cNvSpPr txBox="1">
+            <a:spLocks noChangeArrowheads="1"/>
+          </p:cNvSpPr>
+          <p:nvPr/>
+        </p:nvSpPr>
+        <p:spPr bwMode="auto">
+          <a:xfrm>
+            <a:off x="33696613" y="14379109"/>
+            <a:ext cx="7345905" cy="749436"/>
+          </a:xfrm>
+          <a:prstGeom prst="rect">
+            <a:avLst/>
+          </a:prstGeom>
+          <a:solidFill>
+            <a:schemeClr val="bg1"/>
+          </a:solidFill>
+          <a:ln>
+            <a:noFill/>
+          </a:ln>
+        </p:spPr>
+        <p:txBody>
+          <a:bodyPr wrap="square" lIns="91440" tIns="45720" rIns="91440" bIns="45720" anchor="t">
+            <a:spAutoFit/>
+          </a:bodyPr>
+          <a:lstStyle>
+            <a:lvl1pPr>
+              <a:defRPr sz="2400">
+                <a:solidFill>
+                  <a:schemeClr val="tx1"/>
+                </a:solidFill>
+                <a:latin typeface="Helvetica" panose="020B0604020202020204" pitchFamily="34" charset="0"/>
+                <a:ea typeface="MS PGothic" panose="020B0600070205080204" pitchFamily="34" charset="-128"/>
+              </a:defRPr>
+            </a:lvl1pPr>
+            <a:lvl2pPr marL="742950" indent="-285750">
+              <a:defRPr sz="2400">
+                <a:solidFill>
+                  <a:schemeClr val="tx1"/>
+                </a:solidFill>
+                <a:latin typeface="Helvetica" panose="020B0604020202020204" pitchFamily="34" charset="0"/>
+                <a:ea typeface="MS PGothic" panose="020B0600070205080204" pitchFamily="34" charset="-128"/>
+              </a:defRPr>
+            </a:lvl2pPr>
+            <a:lvl3pPr marL="1143000" indent="-228600">
+              <a:defRPr sz="2400">
+                <a:solidFill>
+                  <a:schemeClr val="tx1"/>
+                </a:solidFill>
+                <a:latin typeface="Helvetica" panose="020B0604020202020204" pitchFamily="34" charset="0"/>
+                <a:ea typeface="MS PGothic" panose="020B0600070205080204" pitchFamily="34" charset="-128"/>
+              </a:defRPr>
+            </a:lvl3pPr>
+            <a:lvl4pPr marL="1600200" indent="-228600">
+              <a:defRPr sz="2400">
+                <a:solidFill>
+                  <a:schemeClr val="tx1"/>
+                </a:solidFill>
+                <a:latin typeface="Helvetica" panose="020B0604020202020204" pitchFamily="34" charset="0"/>
+                <a:ea typeface="MS PGothic" panose="020B0600070205080204" pitchFamily="34" charset="-128"/>
+              </a:defRPr>
+            </a:lvl4pPr>
+            <a:lvl5pPr marL="2057400" indent="-228600">
+              <a:defRPr sz="2400">
+                <a:solidFill>
+                  <a:schemeClr val="tx1"/>
+                </a:solidFill>
+                <a:latin typeface="Helvetica" panose="020B0604020202020204" pitchFamily="34" charset="0"/>
+                <a:ea typeface="MS PGothic" panose="020B0600070205080204" pitchFamily="34" charset="-128"/>
+              </a:defRPr>
+            </a:lvl5pPr>
+            <a:lvl6pPr marL="2514600" indent="-228600" eaLnBrk="0" fontAlgn="base" hangingPunct="0">
+              <a:spcBef>
+                <a:spcPct val="0"/>
+              </a:spcBef>
+              <a:spcAft>
+                <a:spcPct val="0"/>
+              </a:spcAft>
+              <a:defRPr sz="2400">
+                <a:solidFill>
+                  <a:schemeClr val="tx1"/>
+                </a:solidFill>
+                <a:latin typeface="Helvetica" panose="020B0604020202020204" pitchFamily="34" charset="0"/>
+                <a:ea typeface="MS PGothic" panose="020B0600070205080204" pitchFamily="34" charset="-128"/>
+              </a:defRPr>
+            </a:lvl6pPr>
+            <a:lvl7pPr marL="2971800" indent="-228600" eaLnBrk="0" fontAlgn="base" hangingPunct="0">
+              <a:spcBef>
+                <a:spcPct val="0"/>
+              </a:spcBef>
+              <a:spcAft>
+                <a:spcPct val="0"/>
+              </a:spcAft>
+              <a:defRPr sz="2400">
+                <a:solidFill>
+                  <a:schemeClr val="tx1"/>
+                </a:solidFill>
+                <a:latin typeface="Helvetica" panose="020B0604020202020204" pitchFamily="34" charset="0"/>
+                <a:ea typeface="MS PGothic" panose="020B0600070205080204" pitchFamily="34" charset="-128"/>
+              </a:defRPr>
+            </a:lvl7pPr>
+            <a:lvl8pPr marL="3429000" indent="-228600" eaLnBrk="0" fontAlgn="base" hangingPunct="0">
+              <a:spcBef>
+                <a:spcPct val="0"/>
+              </a:spcBef>
+              <a:spcAft>
+                <a:spcPct val="0"/>
+              </a:spcAft>
+              <a:defRPr sz="2400">
+                <a:solidFill>
+                  <a:schemeClr val="tx1"/>
+                </a:solidFill>
+                <a:latin typeface="Helvetica" panose="020B0604020202020204" pitchFamily="34" charset="0"/>
+                <a:ea typeface="MS PGothic" panose="020B0600070205080204" pitchFamily="34" charset="-128"/>
+              </a:defRPr>
+            </a:lvl8pPr>
+            <a:lvl9pPr marL="3886200" indent="-228600" eaLnBrk="0" fontAlgn="base" hangingPunct="0">
+              <a:spcBef>
+                <a:spcPct val="0"/>
+              </a:spcBef>
+              <a:spcAft>
+                <a:spcPct val="0"/>
+              </a:spcAft>
+              <a:defRPr sz="2400">
+                <a:solidFill>
+                  <a:schemeClr val="tx1"/>
+                </a:solidFill>
+                <a:latin typeface="Helvetica" panose="020B0604020202020204" pitchFamily="34" charset="0"/>
+                <a:ea typeface="MS PGothic" panose="020B0600070205080204" pitchFamily="34" charset="-128"/>
+              </a:defRPr>
+            </a:lvl9pPr>
+          </a:lstStyle>
+          <a:p>
+            <a:pPr algn="ctr"/>
+            <a:r>
+              <a:rPr lang="en-US" altLang="en-US" sz="4270" b="1" dirty="0">
+                <a:solidFill>
+                  <a:srgbClr val="C00000"/>
+                </a:solidFill>
+                <a:latin typeface="Trebuchet MS"/>
+                <a:ea typeface="MS PGothic"/>
+              </a:rPr>
+              <a:t>7. IOS x Age x OAFEM</a:t>
+            </a:r>
+            <a:endParaRPr lang="en-US" altLang="en-US" sz="4270" b="1" dirty="0">
+              <a:solidFill>
+                <a:srgbClr val="C00000"/>
+              </a:solidFill>
+              <a:latin typeface="Trebuchet MS" panose="020B0603020202020204" pitchFamily="34" charset="0"/>
+            </a:endParaRPr>
+          </a:p>
+        </p:txBody>
+      </p:sp>
     </p:spTree>
   </p:cSld>
   <p:clrMapOvr>

</xml_diff>

<commit_message>
Added plots (small dots)
</commit_message>
<xml_diff>
--- a/SFN/2023_SFN_trust.pptx
+++ b/SFN/2023_SFN_trust.pptx
@@ -4435,10 +4435,10 @@
       </p:grpSpPr>
       <p:grpSp>
         <p:nvGrpSpPr>
-          <p:cNvPr id="15428" name="Group 15427">
+          <p:cNvPr id="36" name="Group 35">
             <a:extLst>
               <a:ext uri="{FF2B5EF4-FFF2-40B4-BE49-F238E27FC236}">
-                <a16:creationId xmlns:a16="http://schemas.microsoft.com/office/drawing/2014/main" id="{788D9291-9D84-C5C9-22EF-259D72BF4C72}"/>
+                <a16:creationId xmlns:a16="http://schemas.microsoft.com/office/drawing/2014/main" id="{BD86F45B-B6EA-D11B-FE87-C7FDF14080C8}"/>
               </a:ext>
             </a:extLst>
           </p:cNvPr>
@@ -4447,192 +4447,171 @@
         </p:nvGrpSpPr>
         <p:grpSpPr>
           <a:xfrm>
-            <a:off x="-12351685" y="24748572"/>
-            <a:ext cx="27124037" cy="5855069"/>
-            <a:chOff x="-13075441" y="16557233"/>
-            <a:chExt cx="27124037" cy="5855069"/>
+            <a:off x="10912317" y="28607914"/>
+            <a:ext cx="3543576" cy="1716829"/>
+            <a:chOff x="11083249" y="26380930"/>
+            <a:chExt cx="3543576" cy="1716829"/>
           </a:xfrm>
         </p:grpSpPr>
-        <p:grpSp>
-          <p:nvGrpSpPr>
-            <p:cNvPr id="65" name="Group 64">
+        <p:sp>
+          <p:nvSpPr>
+            <p:cNvPr id="15" name="Rectangle 14">
               <a:extLst>
                 <a:ext uri="{FF2B5EF4-FFF2-40B4-BE49-F238E27FC236}">
-                  <a16:creationId xmlns:a16="http://schemas.microsoft.com/office/drawing/2014/main" id="{89055108-BE18-C2C5-0FF5-A55BEBB4A05F}"/>
+                  <a16:creationId xmlns:a16="http://schemas.microsoft.com/office/drawing/2014/main" id="{353421B0-7681-A37B-CA3F-986E07C1DB77}"/>
                 </a:ext>
               </a:extLst>
             </p:cNvPr>
-            <p:cNvGrpSpPr/>
+            <p:cNvSpPr/>
             <p:nvPr/>
-          </p:nvGrpSpPr>
-          <p:grpSpPr>
+          </p:nvSpPr>
+          <p:spPr bwMode="auto">
             <a:xfrm>
-              <a:off x="-13075441" y="16557233"/>
-              <a:ext cx="7981099" cy="1956293"/>
-              <a:chOff x="-13057094" y="16450839"/>
-              <a:chExt cx="7981099" cy="1956293"/>
-            </a:xfrm>
-          </p:grpSpPr>
-          <p:sp>
-            <p:nvSpPr>
-              <p:cNvPr id="15" name="Rectangle 14">
-                <a:extLst>
-                  <a:ext uri="{FF2B5EF4-FFF2-40B4-BE49-F238E27FC236}">
-                    <a16:creationId xmlns:a16="http://schemas.microsoft.com/office/drawing/2014/main" id="{353421B0-7681-A37B-CA3F-986E07C1DB77}"/>
-                  </a:ext>
-                </a:extLst>
-              </p:cNvPr>
-              <p:cNvSpPr/>
-              <p:nvPr/>
-            </p:nvSpPr>
-            <p:spPr bwMode="auto">
-              <a:xfrm>
-                <a:off x="-13057094" y="16450839"/>
-                <a:ext cx="3543576" cy="1716829"/>
-              </a:xfrm>
-              <a:prstGeom prst="rect">
-                <a:avLst/>
-              </a:prstGeom>
-              <a:solidFill>
-                <a:srgbClr val="FAF86D">
-                  <a:alpha val="82294"/>
-                </a:srgbClr>
-              </a:solidFill>
-              <a:ln w="57150" cap="flat" cmpd="sng" algn="ctr">
-                <a:solidFill>
-                  <a:schemeClr val="tx1"/>
-                </a:solidFill>
-                <a:prstDash val="solid"/>
-                <a:round/>
-                <a:headEnd type="none" w="med" len="med"/>
-                <a:tailEnd type="none" w="med" len="med"/>
-              </a:ln>
-              <a:effectLst/>
-            </p:spPr>
-            <p:txBody>
-              <a:bodyPr vert="horz" wrap="square" lIns="91440" tIns="45720" rIns="91440" bIns="45720" numCol="1" rtlCol="0" anchor="t" anchorCtr="0" compatLnSpc="1">
-                <a:prstTxWarp prst="textNoShape">
-                  <a:avLst/>
-                </a:prstTxWarp>
-              </a:bodyPr>
-              <a:lstStyle/>
-              <a:p>
-                <a:pPr marL="0" marR="0" indent="0" algn="l" defTabSz="4389438" rtl="0" eaLnBrk="1" fontAlgn="base" latinLnBrk="0" hangingPunct="1">
-                  <a:lnSpc>
-                    <a:spcPct val="100000"/>
-                  </a:lnSpc>
-                  <a:spcBef>
-                    <a:spcPct val="0"/>
-                  </a:spcBef>
-                  <a:spcAft>
-                    <a:spcPct val="0"/>
-                  </a:spcAft>
-                  <a:buClrTx/>
-                  <a:buSzTx/>
-                  <a:buFontTx/>
-                  <a:buNone/>
-                  <a:tabLst/>
-                </a:pPr>
-                <a:endParaRPr kumimoji="0" lang="en-US" sz="1800" b="0" i="0" u="none" strike="noStrike" cap="none" normalizeH="0" baseline="0">
-                  <a:ln>
-                    <a:noFill/>
-                  </a:ln>
-                  <a:solidFill>
-                    <a:schemeClr val="tx1"/>
-                  </a:solidFill>
-                  <a:effectLst/>
-                  <a:latin typeface="Arial" charset="0"/>
-                  <a:cs typeface="Arial" charset="0"/>
-                </a:endParaRPr>
-              </a:p>
-            </p:txBody>
-          </p:sp>
-          <p:sp>
-            <p:nvSpPr>
-              <p:cNvPr id="8" name="TextBox 7">
-                <a:extLst>
-                  <a:ext uri="{FF2B5EF4-FFF2-40B4-BE49-F238E27FC236}">
-                    <a16:creationId xmlns:a16="http://schemas.microsoft.com/office/drawing/2014/main" id="{8F94C34F-C114-09E7-7592-2C68A047774A}"/>
-                  </a:ext>
-                </a:extLst>
-              </p:cNvPr>
-              <p:cNvSpPr txBox="1"/>
-              <p:nvPr/>
-            </p:nvSpPr>
-            <p:spPr>
-              <a:xfrm>
-                <a:off x="-8462360" y="16837472"/>
-                <a:ext cx="3386365" cy="1569660"/>
-              </a:xfrm>
-              <a:prstGeom prst="rect">
-                <a:avLst/>
-              </a:prstGeom>
-              <a:noFill/>
-            </p:spPr>
-            <p:txBody>
-              <a:bodyPr rot="0" spcFirstLastPara="0" vertOverflow="overflow" horzOverflow="overflow" vert="horz" wrap="square" lIns="91440" tIns="45720" rIns="91440" bIns="45720" numCol="1" spcCol="0" rtlCol="0" fromWordArt="0" anchor="t" anchorCtr="0" forceAA="0" compatLnSpc="1">
-                <a:prstTxWarp prst="textNoShape">
-                  <a:avLst/>
-                </a:prstTxWarp>
-                <a:spAutoFit/>
-              </a:bodyPr>
-              <a:lstStyle/>
-              <a:p>
-                <a:pPr algn="ctr"/>
-                <a:r>
-                  <a:rPr lang="en-US" sz="3200" b="1" dirty="0">
-                    <a:latin typeface="Helvetica"/>
-                    <a:ea typeface="MS PGothic"/>
-                  </a:rPr>
-                  <a:t>Scan the QR code to see the</a:t>
-                </a:r>
-                <a:endParaRPr lang="en-US" sz="3200" b="1" dirty="0"/>
-              </a:p>
-              <a:p>
-                <a:pPr algn="ctr"/>
-                <a:r>
-                  <a:rPr lang="en-US" sz="3200" b="1" u="sng" dirty="0">
-                    <a:latin typeface="Helvetica"/>
-                    <a:ea typeface="MS PGothic"/>
-                  </a:rPr>
-                  <a:t>Pre-registration!</a:t>
-                </a:r>
-                <a:endParaRPr lang="en-US" sz="3200" b="1" u="sng" dirty="0"/>
-              </a:p>
-            </p:txBody>
-          </p:sp>
-        </p:grpSp>
-        <p:pic>
-          <p:nvPicPr>
-            <p:cNvPr id="7" name="Picture 6">
-              <a:extLst>
-                <a:ext uri="{FF2B5EF4-FFF2-40B4-BE49-F238E27FC236}">
-                  <a16:creationId xmlns:a16="http://schemas.microsoft.com/office/drawing/2014/main" id="{E5B61256-0745-91A9-AD49-FA138651C227}"/>
-                </a:ext>
-              </a:extLst>
-            </p:cNvPr>
-            <p:cNvPicPr>
-              <a:picLocks noChangeAspect="1"/>
-            </p:cNvPicPr>
-            <p:nvPr/>
-          </p:nvPicPr>
-          <p:blipFill>
-            <a:blip r:embed="rId4"/>
-            <a:stretch>
-              <a:fillRect/>
-            </a:stretch>
-          </p:blipFill>
-          <p:spPr>
-            <a:xfrm>
-              <a:off x="11004958" y="19378946"/>
-              <a:ext cx="3043638" cy="3033356"/>
+              <a:off x="11083249" y="26380930"/>
+              <a:ext cx="3543576" cy="1716829"/>
             </a:xfrm>
             <a:prstGeom prst="rect">
               <a:avLst/>
             </a:prstGeom>
+            <a:solidFill>
+              <a:srgbClr val="FAF86D">
+                <a:alpha val="82294"/>
+              </a:srgbClr>
+            </a:solidFill>
+            <a:ln w="57150" cap="flat" cmpd="sng" algn="ctr">
+              <a:solidFill>
+                <a:schemeClr val="tx1"/>
+              </a:solidFill>
+              <a:prstDash val="solid"/>
+              <a:round/>
+              <a:headEnd type="none" w="med" len="med"/>
+              <a:tailEnd type="none" w="med" len="med"/>
+            </a:ln>
+            <a:effectLst/>
           </p:spPr>
-        </p:pic>
+          <p:txBody>
+            <a:bodyPr vert="horz" wrap="square" lIns="91440" tIns="45720" rIns="91440" bIns="45720" numCol="1" rtlCol="0" anchor="t" anchorCtr="0" compatLnSpc="1">
+              <a:prstTxWarp prst="textNoShape">
+                <a:avLst/>
+              </a:prstTxWarp>
+            </a:bodyPr>
+            <a:lstStyle/>
+            <a:p>
+              <a:pPr marL="0" marR="0" indent="0" algn="l" defTabSz="4389438" rtl="0" eaLnBrk="1" fontAlgn="base" latinLnBrk="0" hangingPunct="1">
+                <a:lnSpc>
+                  <a:spcPct val="100000"/>
+                </a:lnSpc>
+                <a:spcBef>
+                  <a:spcPct val="0"/>
+                </a:spcBef>
+                <a:spcAft>
+                  <a:spcPct val="0"/>
+                </a:spcAft>
+                <a:buClrTx/>
+                <a:buSzTx/>
+                <a:buFontTx/>
+                <a:buNone/>
+                <a:tabLst/>
+              </a:pPr>
+              <a:endParaRPr kumimoji="0" lang="en-US" sz="1800" b="0" i="0" u="none" strike="noStrike" cap="none" normalizeH="0" baseline="0">
+                <a:ln>
+                  <a:noFill/>
+                </a:ln>
+                <a:solidFill>
+                  <a:schemeClr val="tx1"/>
+                </a:solidFill>
+                <a:effectLst/>
+                <a:latin typeface="Arial" charset="0"/>
+                <a:cs typeface="Arial" charset="0"/>
+              </a:endParaRPr>
+            </a:p>
+          </p:txBody>
+        </p:sp>
+        <p:sp>
+          <p:nvSpPr>
+            <p:cNvPr id="8" name="TextBox 7">
+              <a:extLst>
+                <a:ext uri="{FF2B5EF4-FFF2-40B4-BE49-F238E27FC236}">
+                  <a16:creationId xmlns:a16="http://schemas.microsoft.com/office/drawing/2014/main" id="{8F94C34F-C114-09E7-7592-2C68A047774A}"/>
+                </a:ext>
+              </a:extLst>
+            </p:cNvPr>
+            <p:cNvSpPr txBox="1"/>
+            <p:nvPr/>
+          </p:nvSpPr>
+          <p:spPr>
+            <a:xfrm>
+              <a:off x="11186208" y="26454514"/>
+              <a:ext cx="3386365" cy="1569660"/>
+            </a:xfrm>
+            <a:prstGeom prst="rect">
+              <a:avLst/>
+            </a:prstGeom>
+            <a:noFill/>
+          </p:spPr>
+          <p:txBody>
+            <a:bodyPr rot="0" spcFirstLastPara="0" vertOverflow="overflow" horzOverflow="overflow" vert="horz" wrap="square" lIns="91440" tIns="45720" rIns="91440" bIns="45720" numCol="1" spcCol="0" rtlCol="0" fromWordArt="0" anchor="t" anchorCtr="0" forceAA="0" compatLnSpc="1">
+              <a:prstTxWarp prst="textNoShape">
+                <a:avLst/>
+              </a:prstTxWarp>
+              <a:spAutoFit/>
+            </a:bodyPr>
+            <a:lstStyle/>
+            <a:p>
+              <a:pPr algn="ctr"/>
+              <a:r>
+                <a:rPr lang="en-US" sz="3200" b="1" dirty="0">
+                  <a:latin typeface="Helvetica"/>
+                  <a:ea typeface="MS PGothic"/>
+                </a:rPr>
+                <a:t>Scan the QR code to see the</a:t>
+              </a:r>
+              <a:endParaRPr lang="en-US" sz="3200" b="1" dirty="0"/>
+            </a:p>
+            <a:p>
+              <a:pPr algn="ctr"/>
+              <a:r>
+                <a:rPr lang="en-US" sz="3200" b="1" u="sng" dirty="0">
+                  <a:latin typeface="Helvetica"/>
+                  <a:ea typeface="MS PGothic"/>
+                </a:rPr>
+                <a:t>Pre-registration!</a:t>
+              </a:r>
+              <a:endParaRPr lang="en-US" sz="3200" b="1" u="sng" dirty="0"/>
+            </a:p>
+          </p:txBody>
+        </p:sp>
       </p:grpSp>
+      <p:pic>
+        <p:nvPicPr>
+          <p:cNvPr id="7" name="Picture 6">
+            <a:extLst>
+              <a:ext uri="{FF2B5EF4-FFF2-40B4-BE49-F238E27FC236}">
+                <a16:creationId xmlns:a16="http://schemas.microsoft.com/office/drawing/2014/main" id="{E5B61256-0745-91A9-AD49-FA138651C227}"/>
+              </a:ext>
+            </a:extLst>
+          </p:cNvPr>
+          <p:cNvPicPr>
+            <a:picLocks noChangeAspect="1"/>
+          </p:cNvPicPr>
+          <p:nvPr/>
+        </p:nvPicPr>
+        <p:blipFill>
+          <a:blip r:embed="rId4"/>
+          <a:stretch>
+            <a:fillRect/>
+          </a:stretch>
+        </p:blipFill>
+        <p:spPr>
+          <a:xfrm>
+            <a:off x="11507902" y="26012680"/>
+            <a:ext cx="2340933" cy="2333025"/>
+          </a:xfrm>
+          <a:prstGeom prst="rect">
+            <a:avLst/>
+          </a:prstGeom>
+        </p:spPr>
+      </p:pic>
       <p:sp>
         <p:nvSpPr>
           <p:cNvPr id="15365" name="Rectangle 162"/>
@@ -4643,8 +4622,8 @@
         </p:nvSpPr>
         <p:spPr bwMode="auto">
           <a:xfrm>
-            <a:off x="162957" y="12488003"/>
-            <a:ext cx="14710114" cy="18312188"/>
+            <a:off x="162957" y="13516081"/>
+            <a:ext cx="14710114" cy="17284110"/>
           </a:xfrm>
           <a:prstGeom prst="rect">
             <a:avLst/>
@@ -5414,7 +5393,7 @@
         </p:nvSpPr>
         <p:spPr bwMode="auto">
           <a:xfrm>
-            <a:off x="5483063" y="12207796"/>
+            <a:off x="5450339" y="13204012"/>
             <a:ext cx="4095681" cy="748988"/>
           </a:xfrm>
           <a:prstGeom prst="rect">
@@ -6430,7 +6409,7 @@
         <p:grpSpPr>
           <a:xfrm>
             <a:off x="169367" y="3967558"/>
-            <a:ext cx="14831195" cy="8123743"/>
+            <a:ext cx="14831195" cy="9230365"/>
             <a:chOff x="211346" y="3968278"/>
             <a:chExt cx="14831195" cy="8123743"/>
           </a:xfrm>
@@ -7863,342 +7842,6 @@
           </p:txBody>
         </p:sp>
       </p:grpSp>
-      <p:grpSp>
-        <p:nvGrpSpPr>
-          <p:cNvPr id="15583" name="Group 15582">
-            <a:extLst>
-              <a:ext uri="{FF2B5EF4-FFF2-40B4-BE49-F238E27FC236}">
-                <a16:creationId xmlns:a16="http://schemas.microsoft.com/office/drawing/2014/main" id="{81424957-973F-2BA6-23A6-71C1377BD2AF}"/>
-              </a:ext>
-            </a:extLst>
-          </p:cNvPr>
-          <p:cNvGrpSpPr/>
-          <p:nvPr/>
-        </p:nvGrpSpPr>
-        <p:grpSpPr>
-          <a:xfrm>
-            <a:off x="23079238" y="5095222"/>
-            <a:ext cx="6472299" cy="6595040"/>
-            <a:chOff x="23205210" y="4927197"/>
-            <a:chExt cx="5400682" cy="6202336"/>
-          </a:xfrm>
-        </p:grpSpPr>
-        <p:pic>
-          <p:nvPicPr>
-            <p:cNvPr id="15574" name="Picture 15573" descr="A graph of a line&#10;&#10;Description automatically generated with medium confidence">
-              <a:extLst>
-                <a:ext uri="{FF2B5EF4-FFF2-40B4-BE49-F238E27FC236}">
-                  <a16:creationId xmlns:a16="http://schemas.microsoft.com/office/drawing/2014/main" id="{C54D0E15-DCC7-A19B-7997-13F421CEA2FB}"/>
-                </a:ext>
-              </a:extLst>
-            </p:cNvPr>
-            <p:cNvPicPr>
-              <a:picLocks noChangeAspect="1"/>
-            </p:cNvPicPr>
-            <p:nvPr/>
-          </p:nvPicPr>
-          <p:blipFill rotWithShape="1">
-            <a:blip r:embed="rId6">
-              <a:extLst>
-                <a:ext uri="{28A0092B-C50C-407E-A947-70E740481C1C}">
-                  <a14:useLocalDpi xmlns:a14="http://schemas.microsoft.com/office/drawing/2010/main" val="0"/>
-                </a:ext>
-              </a:extLst>
-            </a:blip>
-            <a:srcRect r="3644" b="9068"/>
-            <a:stretch/>
-          </p:blipFill>
-          <p:spPr>
-            <a:xfrm>
-              <a:off x="24004670" y="4927197"/>
-              <a:ext cx="4601222" cy="5427765"/>
-            </a:xfrm>
-            <a:prstGeom prst="rect">
-              <a:avLst/>
-            </a:prstGeom>
-          </p:spPr>
-        </p:pic>
-        <p:sp>
-          <p:nvSpPr>
-            <p:cNvPr id="15575" name="TextBox 15574">
-              <a:extLst>
-                <a:ext uri="{FF2B5EF4-FFF2-40B4-BE49-F238E27FC236}">
-                  <a16:creationId xmlns:a16="http://schemas.microsoft.com/office/drawing/2014/main" id="{136D78E5-71EA-17ED-91C9-F9CCADA262FF}"/>
-                </a:ext>
-              </a:extLst>
-            </p:cNvPr>
-            <p:cNvSpPr txBox="1"/>
-            <p:nvPr/>
-          </p:nvSpPr>
-          <p:spPr>
-            <a:xfrm rot="16200000">
-              <a:off x="21066163" y="7584362"/>
-              <a:ext cx="4647426" cy="369332"/>
-            </a:xfrm>
-            <a:prstGeom prst="rect">
-              <a:avLst/>
-            </a:prstGeom>
-            <a:noFill/>
-          </p:spPr>
-          <p:txBody>
-            <a:bodyPr wrap="none" rtlCol="0">
-              <a:spAutoFit/>
-            </a:bodyPr>
-            <a:lstStyle/>
-            <a:p>
-              <a:r>
-                <a:rPr lang="en-US" dirty="0"/>
-                <a:t>Sharing with Friend – Sharing with Stranger</a:t>
-              </a:r>
-            </a:p>
-          </p:txBody>
-        </p:sp>
-        <p:sp>
-          <p:nvSpPr>
-            <p:cNvPr id="15576" name="TextBox 15575">
-              <a:extLst>
-                <a:ext uri="{FF2B5EF4-FFF2-40B4-BE49-F238E27FC236}">
-                  <a16:creationId xmlns:a16="http://schemas.microsoft.com/office/drawing/2014/main" id="{7E602785-88A0-0942-659B-9A750B46996F}"/>
-                </a:ext>
-              </a:extLst>
-            </p:cNvPr>
-            <p:cNvSpPr txBox="1"/>
-            <p:nvPr/>
-          </p:nvSpPr>
-          <p:spPr>
-            <a:xfrm>
-              <a:off x="23603500" y="9333929"/>
-              <a:ext cx="389850" cy="369332"/>
-            </a:xfrm>
-            <a:prstGeom prst="rect">
-              <a:avLst/>
-            </a:prstGeom>
-            <a:noFill/>
-          </p:spPr>
-          <p:txBody>
-            <a:bodyPr wrap="none" rtlCol="0">
-              <a:spAutoFit/>
-            </a:bodyPr>
-            <a:lstStyle/>
-            <a:p>
-              <a:r>
-                <a:rPr lang="en-US" dirty="0"/>
-                <a:t>-2</a:t>
-              </a:r>
-            </a:p>
-          </p:txBody>
-        </p:sp>
-        <p:sp>
-          <p:nvSpPr>
-            <p:cNvPr id="15577" name="TextBox 15576">
-              <a:extLst>
-                <a:ext uri="{FF2B5EF4-FFF2-40B4-BE49-F238E27FC236}">
-                  <a16:creationId xmlns:a16="http://schemas.microsoft.com/office/drawing/2014/main" id="{44C014BB-4057-CE6F-8488-5075607DFC5B}"/>
-                </a:ext>
-              </a:extLst>
-            </p:cNvPr>
-            <p:cNvSpPr txBox="1"/>
-            <p:nvPr/>
-          </p:nvSpPr>
-          <p:spPr>
-            <a:xfrm>
-              <a:off x="23684874" y="6124920"/>
-              <a:ext cx="312906" cy="369332"/>
-            </a:xfrm>
-            <a:prstGeom prst="rect">
-              <a:avLst/>
-            </a:prstGeom>
-            <a:noFill/>
-          </p:spPr>
-          <p:txBody>
-            <a:bodyPr wrap="none" rtlCol="0">
-              <a:spAutoFit/>
-            </a:bodyPr>
-            <a:lstStyle/>
-            <a:p>
-              <a:r>
-                <a:rPr lang="en-US" dirty="0"/>
-                <a:t>2</a:t>
-              </a:r>
-            </a:p>
-          </p:txBody>
-        </p:sp>
-        <p:sp>
-          <p:nvSpPr>
-            <p:cNvPr id="15578" name="TextBox 15577">
-              <a:extLst>
-                <a:ext uri="{FF2B5EF4-FFF2-40B4-BE49-F238E27FC236}">
-                  <a16:creationId xmlns:a16="http://schemas.microsoft.com/office/drawing/2014/main" id="{7FC9F9D2-B5EE-482C-7F35-E7345B0CA197}"/>
-                </a:ext>
-              </a:extLst>
-            </p:cNvPr>
-            <p:cNvSpPr txBox="1"/>
-            <p:nvPr/>
-          </p:nvSpPr>
-          <p:spPr>
-            <a:xfrm>
-              <a:off x="23666269" y="7699893"/>
-              <a:ext cx="312906" cy="369332"/>
-            </a:xfrm>
-            <a:prstGeom prst="rect">
-              <a:avLst/>
-            </a:prstGeom>
-            <a:noFill/>
-          </p:spPr>
-          <p:txBody>
-            <a:bodyPr wrap="none" rtlCol="0">
-              <a:spAutoFit/>
-            </a:bodyPr>
-            <a:lstStyle/>
-            <a:p>
-              <a:r>
-                <a:rPr lang="en-US" dirty="0"/>
-                <a:t>0</a:t>
-              </a:r>
-            </a:p>
-          </p:txBody>
-        </p:sp>
-        <p:sp>
-          <p:nvSpPr>
-            <p:cNvPr id="15579" name="TextBox 15578">
-              <a:extLst>
-                <a:ext uri="{FF2B5EF4-FFF2-40B4-BE49-F238E27FC236}">
-                  <a16:creationId xmlns:a16="http://schemas.microsoft.com/office/drawing/2014/main" id="{115532EB-4683-39F0-80DC-27E22F24AA20}"/>
-                </a:ext>
-              </a:extLst>
-            </p:cNvPr>
-            <p:cNvSpPr txBox="1"/>
-            <p:nvPr/>
-          </p:nvSpPr>
-          <p:spPr>
-            <a:xfrm>
-              <a:off x="23984464" y="10392031"/>
-              <a:ext cx="441146" cy="369332"/>
-            </a:xfrm>
-            <a:prstGeom prst="rect">
-              <a:avLst/>
-            </a:prstGeom>
-            <a:noFill/>
-          </p:spPr>
-          <p:txBody>
-            <a:bodyPr wrap="none" rtlCol="0">
-              <a:spAutoFit/>
-            </a:bodyPr>
-            <a:lstStyle/>
-            <a:p>
-              <a:r>
-                <a:rPr lang="en-US" dirty="0"/>
-                <a:t>20</a:t>
-              </a:r>
-            </a:p>
-          </p:txBody>
-        </p:sp>
-        <p:sp>
-          <p:nvSpPr>
-            <p:cNvPr id="15580" name="TextBox 15579">
-              <a:extLst>
-                <a:ext uri="{FF2B5EF4-FFF2-40B4-BE49-F238E27FC236}">
-                  <a16:creationId xmlns:a16="http://schemas.microsoft.com/office/drawing/2014/main" id="{3A319DEB-B897-3E25-DF07-7B459ED170BF}"/>
-                </a:ext>
-              </a:extLst>
-            </p:cNvPr>
-            <p:cNvSpPr txBox="1"/>
-            <p:nvPr/>
-          </p:nvSpPr>
-          <p:spPr>
-            <a:xfrm>
-              <a:off x="25529056" y="10429100"/>
-              <a:ext cx="441146" cy="369332"/>
-            </a:xfrm>
-            <a:prstGeom prst="rect">
-              <a:avLst/>
-            </a:prstGeom>
-            <a:noFill/>
-          </p:spPr>
-          <p:txBody>
-            <a:bodyPr wrap="none" rtlCol="0">
-              <a:spAutoFit/>
-            </a:bodyPr>
-            <a:lstStyle/>
-            <a:p>
-              <a:r>
-                <a:rPr lang="en-US" dirty="0"/>
-                <a:t>40</a:t>
-              </a:r>
-            </a:p>
-          </p:txBody>
-        </p:sp>
-        <p:sp>
-          <p:nvSpPr>
-            <p:cNvPr id="15581" name="TextBox 15580">
-              <a:extLst>
-                <a:ext uri="{FF2B5EF4-FFF2-40B4-BE49-F238E27FC236}">
-                  <a16:creationId xmlns:a16="http://schemas.microsoft.com/office/drawing/2014/main" id="{92207841-AB47-B838-56C4-7A8991CBC082}"/>
-                </a:ext>
-              </a:extLst>
-            </p:cNvPr>
-            <p:cNvSpPr txBox="1"/>
-            <p:nvPr/>
-          </p:nvSpPr>
-          <p:spPr>
-            <a:xfrm>
-              <a:off x="27155348" y="10416605"/>
-              <a:ext cx="441146" cy="369332"/>
-            </a:xfrm>
-            <a:prstGeom prst="rect">
-              <a:avLst/>
-            </a:prstGeom>
-            <a:noFill/>
-          </p:spPr>
-          <p:txBody>
-            <a:bodyPr wrap="none" rtlCol="0">
-              <a:spAutoFit/>
-            </a:bodyPr>
-            <a:lstStyle/>
-            <a:p>
-              <a:r>
-                <a:rPr lang="en-US" dirty="0"/>
-                <a:t>60</a:t>
-              </a:r>
-            </a:p>
-          </p:txBody>
-        </p:sp>
-        <p:sp>
-          <p:nvSpPr>
-            <p:cNvPr id="15582" name="TextBox 15581">
-              <a:extLst>
-                <a:ext uri="{FF2B5EF4-FFF2-40B4-BE49-F238E27FC236}">
-                  <a16:creationId xmlns:a16="http://schemas.microsoft.com/office/drawing/2014/main" id="{3BD77EC1-C3D3-3CE1-B336-0F6F0DC0255C}"/>
-                </a:ext>
-              </a:extLst>
-            </p:cNvPr>
-            <p:cNvSpPr txBox="1"/>
-            <p:nvPr/>
-          </p:nvSpPr>
-          <p:spPr>
-            <a:xfrm>
-              <a:off x="25933780" y="10760201"/>
-              <a:ext cx="595035" cy="369332"/>
-            </a:xfrm>
-            <a:prstGeom prst="rect">
-              <a:avLst/>
-            </a:prstGeom>
-            <a:noFill/>
-          </p:spPr>
-          <p:txBody>
-            <a:bodyPr wrap="none" rtlCol="0">
-              <a:spAutoFit/>
-            </a:bodyPr>
-            <a:lstStyle/>
-            <a:p>
-              <a:r>
-                <a:rPr lang="en-US" dirty="0"/>
-                <a:t>Age</a:t>
-              </a:r>
-            </a:p>
-          </p:txBody>
-        </p:sp>
-      </p:grpSp>
       <p:sp>
         <p:nvSpPr>
           <p:cNvPr id="15653" name="TextBox 15652">
@@ -8259,8 +7902,8 @@
         </p:nvSpPr>
         <p:spPr>
           <a:xfrm>
-            <a:off x="306661" y="25149656"/>
-            <a:ext cx="9825551" cy="3062377"/>
+            <a:off x="423843" y="26895455"/>
+            <a:ext cx="9969217" cy="2631490"/>
           </a:xfrm>
           <a:prstGeom prst="rect">
             <a:avLst/>
@@ -8422,13 +8065,13 @@
             <p:nvPr/>
           </p:nvPicPr>
           <p:blipFill rotWithShape="1">
-            <a:blip r:embed="rId7">
+            <a:blip r:embed="rId6">
               <a:extLst>
                 <a:ext uri="{28A0092B-C50C-407E-A947-70E740481C1C}">
                   <a14:useLocalDpi xmlns:a14="http://schemas.microsoft.com/office/drawing/2010/main" val="0"/>
                 </a:ext>
                 <a:ext uri="{96DAC541-7B7A-43D3-8B79-37D633B846F1}">
-                  <asvg:svgBlip xmlns:asvg="http://schemas.microsoft.com/office/drawing/2016/SVG/main" r:embed="rId8"/>
+                  <asvg:svgBlip xmlns:asvg="http://schemas.microsoft.com/office/drawing/2016/SVG/main" r:embed="rId7"/>
                 </a:ext>
               </a:extLst>
             </a:blip>
@@ -8672,7 +8315,7 @@
         </p:nvGrpSpPr>
         <p:grpSpPr>
           <a:xfrm>
-            <a:off x="485487" y="13108557"/>
+            <a:off x="574224" y="14845624"/>
             <a:ext cx="13946934" cy="10995653"/>
             <a:chOff x="530502" y="15050793"/>
             <a:chExt cx="13946934" cy="10995653"/>
@@ -8733,7 +8376,7 @@
                 <p:nvPr/>
               </p:nvPicPr>
               <p:blipFill rotWithShape="1">
-                <a:blip r:embed="rId9"/>
+                <a:blip r:embed="rId8"/>
                 <a:srcRect l="14791" t="15087" r="12450" b="22936"/>
                 <a:stretch/>
               </p:blipFill>
@@ -8792,7 +8435,7 @@
                 <p:nvPr/>
               </p:nvPicPr>
               <p:blipFill rotWithShape="1">
-                <a:blip r:embed="rId10"/>
+                <a:blip r:embed="rId9"/>
                 <a:srcRect l="17658" t="18357" r="18046" b="25816"/>
                 <a:stretch/>
               </p:blipFill>
@@ -8851,7 +8494,7 @@
                 <p:nvPr/>
               </p:nvPicPr>
               <p:blipFill rotWithShape="1">
-                <a:blip r:embed="rId11"/>
+                <a:blip r:embed="rId10"/>
                 <a:srcRect l="2620" t="7420" r="2620" b="4981"/>
                 <a:stretch/>
               </p:blipFill>
@@ -8910,7 +8553,7 @@
                 <p:nvPr/>
               </p:nvPicPr>
               <p:blipFill>
-                <a:blip r:embed="rId12"/>
+                <a:blip r:embed="rId11"/>
                 <a:stretch>
                   <a:fillRect/>
                 </a:stretch>
@@ -8970,7 +8613,7 @@
                 <p:nvPr/>
               </p:nvPicPr>
               <p:blipFill rotWithShape="1">
-                <a:blip r:embed="rId13"/>
+                <a:blip r:embed="rId12"/>
                 <a:srcRect l="2378" t="5420" r="2378" b="9853"/>
                 <a:stretch/>
               </p:blipFill>
@@ -9049,7 +8692,7 @@
                   <p:nvPr/>
                 </p:nvPicPr>
                 <p:blipFill>
-                  <a:blip r:embed="rId14"/>
+                  <a:blip r:embed="rId13"/>
                   <a:stretch>
                     <a:fillRect/>
                   </a:stretch>
@@ -9109,7 +8752,7 @@
                   <p:nvPr/>
                 </p:nvPicPr>
                 <p:blipFill>
-                  <a:blip r:embed="rId15"/>
+                  <a:blip r:embed="rId14"/>
                   <a:stretch>
                     <a:fillRect/>
                   </a:stretch>
@@ -9169,7 +8812,7 @@
                   <p:nvPr/>
                 </p:nvPicPr>
                 <p:blipFill>
-                  <a:blip r:embed="rId16"/>
+                  <a:blip r:embed="rId15"/>
                   <a:stretch>
                     <a:fillRect/>
                   </a:stretch>
@@ -10279,7 +9922,7 @@
             <p:nvPr/>
           </p:nvPicPr>
           <p:blipFill>
-            <a:blip r:embed="rId17">
+            <a:blip r:embed="rId16">
               <a:extLst>
                 <a:ext uri="{28A0092B-C50C-407E-A947-70E740481C1C}">
                   <a14:useLocalDpi xmlns:a14="http://schemas.microsoft.com/office/drawing/2010/main" val="0"/>
@@ -10411,7 +10054,7 @@
             <p:nvPr/>
           </p:nvPicPr>
           <p:blipFill>
-            <a:blip r:embed="rId18">
+            <a:blip r:embed="rId17">
               <a:extLst>
                 <a:ext uri="{28A0092B-C50C-407E-A947-70E740481C1C}">
                   <a14:useLocalDpi xmlns:a14="http://schemas.microsoft.com/office/drawing/2010/main" val="0"/>
@@ -10712,13 +10355,13 @@
                 <p:nvPr/>
               </p:nvPicPr>
               <p:blipFill rotWithShape="1">
-                <a:blip r:embed="rId19">
+                <a:blip r:embed="rId18">
                   <a:extLst>
                     <a:ext uri="{28A0092B-C50C-407E-A947-70E740481C1C}">
                       <a14:useLocalDpi xmlns:a14="http://schemas.microsoft.com/office/drawing/2010/main" val="0"/>
                     </a:ext>
                     <a:ext uri="{96DAC541-7B7A-43D3-8B79-37D633B846F1}">
-                      <asvg:svgBlip xmlns:asvg="http://schemas.microsoft.com/office/drawing/2016/SVG/main" r:embed="rId20"/>
+                      <asvg:svgBlip xmlns:asvg="http://schemas.microsoft.com/office/drawing/2016/SVG/main" r:embed="rId19"/>
                     </a:ext>
                   </a:extLst>
                 </a:blip>
@@ -11073,13 +10716,13 @@
               <p:nvPr/>
             </p:nvPicPr>
             <p:blipFill rotWithShape="1">
-              <a:blip r:embed="rId21">
+              <a:blip r:embed="rId20">
                 <a:extLst>
                   <a:ext uri="{28A0092B-C50C-407E-A947-70E740481C1C}">
                     <a14:useLocalDpi xmlns:a14="http://schemas.microsoft.com/office/drawing/2010/main" val="0"/>
                   </a:ext>
                   <a:ext uri="{96DAC541-7B7A-43D3-8B79-37D633B846F1}">
-                    <asvg:svgBlip xmlns:asvg="http://schemas.microsoft.com/office/drawing/2016/SVG/main" r:embed="rId22"/>
+                    <asvg:svgBlip xmlns:asvg="http://schemas.microsoft.com/office/drawing/2016/SVG/main" r:embed="rId21"/>
                   </a:ext>
                 </a:extLst>
               </a:blip>
@@ -11589,13 +11232,13 @@
             <p:nvPr/>
           </p:nvPicPr>
           <p:blipFill rotWithShape="1">
-            <a:blip r:embed="rId23">
+            <a:blip r:embed="rId22">
               <a:extLst>
                 <a:ext uri="{28A0092B-C50C-407E-A947-70E740481C1C}">
                   <a14:useLocalDpi xmlns:a14="http://schemas.microsoft.com/office/drawing/2010/main" val="0"/>
                 </a:ext>
                 <a:ext uri="{96DAC541-7B7A-43D3-8B79-37D633B846F1}">
-                  <asvg:svgBlip xmlns:asvg="http://schemas.microsoft.com/office/drawing/2016/SVG/main" r:embed="rId24"/>
+                  <asvg:svgBlip xmlns:asvg="http://schemas.microsoft.com/office/drawing/2016/SVG/main" r:embed="rId23"/>
                 </a:ext>
               </a:extLst>
             </a:blip>
@@ -11737,7 +11380,7 @@
           <p:nvPr/>
         </p:nvPicPr>
         <p:blipFill>
-          <a:blip r:embed="rId25">
+          <a:blip r:embed="rId24">
             <a:extLst>
               <a:ext uri="{28A0092B-C50C-407E-A947-70E740481C1C}">
                 <a14:useLocalDpi xmlns:a14="http://schemas.microsoft.com/office/drawing/2010/main" val="0"/>
@@ -11784,7 +11427,7 @@
           <p:nvPr/>
         </p:nvPicPr>
         <p:blipFill>
-          <a:blip r:embed="rId25">
+          <a:blip r:embed="rId24">
             <a:extLst>
               <a:ext uri="{28A0092B-C50C-407E-A947-70E740481C1C}">
                 <a14:useLocalDpi xmlns:a14="http://schemas.microsoft.com/office/drawing/2010/main" val="0"/>
@@ -11831,7 +11474,7 @@
           <p:nvPr/>
         </p:nvPicPr>
         <p:blipFill>
-          <a:blip r:embed="rId26">
+          <a:blip r:embed="rId25">
             <a:extLst>
               <a:ext uri="{28A0092B-C50C-407E-A947-70E740481C1C}">
                 <a14:useLocalDpi xmlns:a14="http://schemas.microsoft.com/office/drawing/2010/main" val="0"/>
@@ -11878,7 +11521,7 @@
           <p:nvPr/>
         </p:nvPicPr>
         <p:blipFill>
-          <a:blip r:embed="rId27">
+          <a:blip r:embed="rId26">
             <a:extLst>
               <a:ext uri="{28A0092B-C50C-407E-A947-70E740481C1C}">
                 <a14:useLocalDpi xmlns:a14="http://schemas.microsoft.com/office/drawing/2010/main" val="0"/>
@@ -12040,6 +11683,866 @@
           </a:p>
         </p:txBody>
       </p:sp>
+      <p:grpSp>
+        <p:nvGrpSpPr>
+          <p:cNvPr id="32" name="Group 31">
+            <a:extLst>
+              <a:ext uri="{FF2B5EF4-FFF2-40B4-BE49-F238E27FC236}">
+                <a16:creationId xmlns:a16="http://schemas.microsoft.com/office/drawing/2014/main" id="{9EB1F679-B03D-7ABA-4916-B7FDEEB0D1A4}"/>
+              </a:ext>
+            </a:extLst>
+          </p:cNvPr>
+          <p:cNvGrpSpPr/>
+          <p:nvPr/>
+        </p:nvGrpSpPr>
+        <p:grpSpPr>
+          <a:xfrm>
+            <a:off x="23148115" y="5384800"/>
+            <a:ext cx="6758936" cy="6609771"/>
+            <a:chOff x="23148115" y="5384800"/>
+            <a:chExt cx="6758936" cy="6609771"/>
+          </a:xfrm>
+        </p:grpSpPr>
+        <p:pic>
+          <p:nvPicPr>
+            <p:cNvPr id="11" name="Graphic 10">
+              <a:extLst>
+                <a:ext uri="{FF2B5EF4-FFF2-40B4-BE49-F238E27FC236}">
+                  <a16:creationId xmlns:a16="http://schemas.microsoft.com/office/drawing/2014/main" id="{B46F0626-1999-AF24-21F0-FAE5DF9DEC26}"/>
+                </a:ext>
+              </a:extLst>
+            </p:cNvPr>
+            <p:cNvPicPr>
+              <a:picLocks noChangeAspect="1"/>
+            </p:cNvPicPr>
+            <p:nvPr/>
+          </p:nvPicPr>
+          <p:blipFill rotWithShape="1">
+            <a:blip r:embed="rId27">
+              <a:extLst>
+                <a:ext uri="{28A0092B-C50C-407E-A947-70E740481C1C}">
+                  <a14:useLocalDpi xmlns:a14="http://schemas.microsoft.com/office/drawing/2010/main" val="0"/>
+                </a:ext>
+                <a:ext uri="{96DAC541-7B7A-43D3-8B79-37D633B846F1}">
+                  <asvg:svgBlip xmlns:asvg="http://schemas.microsoft.com/office/drawing/2016/SVG/main" r:embed="rId28"/>
+                </a:ext>
+              </a:extLst>
+            </a:blip>
+            <a:srcRect l="8522" t="6842" r="2180" b="9488"/>
+            <a:stretch/>
+          </p:blipFill>
+          <p:spPr>
+            <a:xfrm>
+              <a:off x="23745788" y="5384800"/>
+              <a:ext cx="6161263" cy="5986876"/>
+            </a:xfrm>
+            <a:prstGeom prst="rect">
+              <a:avLst/>
+            </a:prstGeom>
+          </p:spPr>
+        </p:pic>
+        <p:sp>
+          <p:nvSpPr>
+            <p:cNvPr id="12" name="TextBox 11">
+              <a:extLst>
+                <a:ext uri="{FF2B5EF4-FFF2-40B4-BE49-F238E27FC236}">
+                  <a16:creationId xmlns:a16="http://schemas.microsoft.com/office/drawing/2014/main" id="{95E4488D-320E-3C93-EC8D-7C3BAA78FA30}"/>
+                </a:ext>
+              </a:extLst>
+            </p:cNvPr>
+            <p:cNvSpPr txBox="1"/>
+            <p:nvPr/>
+          </p:nvSpPr>
+          <p:spPr>
+            <a:xfrm rot="16200000">
+              <a:off x="21388338" y="7970314"/>
+              <a:ext cx="4073551" cy="553998"/>
+            </a:xfrm>
+            <a:prstGeom prst="rect">
+              <a:avLst/>
+            </a:prstGeom>
+            <a:noFill/>
+          </p:spPr>
+          <p:txBody>
+            <a:bodyPr wrap="none" rtlCol="0">
+              <a:spAutoFit/>
+            </a:bodyPr>
+            <a:lstStyle/>
+            <a:p>
+              <a:r>
+                <a:rPr lang="en-US" sz="3000" dirty="0"/>
+                <a:t>IOS Friend - Computer</a:t>
+              </a:r>
+            </a:p>
+          </p:txBody>
+        </p:sp>
+        <p:sp>
+          <p:nvSpPr>
+            <p:cNvPr id="13" name="TextBox 12">
+              <a:extLst>
+                <a:ext uri="{FF2B5EF4-FFF2-40B4-BE49-F238E27FC236}">
+                  <a16:creationId xmlns:a16="http://schemas.microsoft.com/office/drawing/2014/main" id="{F8B9CE20-98EC-DB3B-E27B-D3E16039CA7B}"/>
+                </a:ext>
+              </a:extLst>
+            </p:cNvPr>
+            <p:cNvSpPr txBox="1"/>
+            <p:nvPr/>
+          </p:nvSpPr>
+          <p:spPr>
+            <a:xfrm>
+              <a:off x="26458500" y="11440573"/>
+              <a:ext cx="867545" cy="553998"/>
+            </a:xfrm>
+            <a:prstGeom prst="rect">
+              <a:avLst/>
+            </a:prstGeom>
+            <a:noFill/>
+          </p:spPr>
+          <p:txBody>
+            <a:bodyPr wrap="none" rtlCol="0">
+              <a:spAutoFit/>
+            </a:bodyPr>
+            <a:lstStyle/>
+            <a:p>
+              <a:r>
+                <a:rPr lang="en-US" sz="3000" dirty="0"/>
+                <a:t>Age</a:t>
+              </a:r>
+            </a:p>
+          </p:txBody>
+        </p:sp>
+        <p:sp>
+          <p:nvSpPr>
+            <p:cNvPr id="16" name="TextBox 15">
+              <a:extLst>
+                <a:ext uri="{FF2B5EF4-FFF2-40B4-BE49-F238E27FC236}">
+                  <a16:creationId xmlns:a16="http://schemas.microsoft.com/office/drawing/2014/main" id="{02F055F7-F4AD-16D6-0DC4-090889B5AC94}"/>
+                </a:ext>
+              </a:extLst>
+            </p:cNvPr>
+            <p:cNvSpPr txBox="1"/>
+            <p:nvPr/>
+          </p:nvSpPr>
+          <p:spPr>
+            <a:xfrm>
+              <a:off x="23201591" y="10960780"/>
+              <a:ext cx="389850" cy="369332"/>
+            </a:xfrm>
+            <a:prstGeom prst="rect">
+              <a:avLst/>
+            </a:prstGeom>
+            <a:noFill/>
+          </p:spPr>
+          <p:txBody>
+            <a:bodyPr wrap="none" rtlCol="0">
+              <a:spAutoFit/>
+            </a:bodyPr>
+            <a:lstStyle/>
+            <a:p>
+              <a:r>
+                <a:rPr lang="en-US" dirty="0"/>
+                <a:t>-2</a:t>
+              </a:r>
+            </a:p>
+          </p:txBody>
+        </p:sp>
+        <p:sp>
+          <p:nvSpPr>
+            <p:cNvPr id="18" name="TextBox 17">
+              <a:extLst>
+                <a:ext uri="{FF2B5EF4-FFF2-40B4-BE49-F238E27FC236}">
+                  <a16:creationId xmlns:a16="http://schemas.microsoft.com/office/drawing/2014/main" id="{C9F335FD-74A6-0034-2C62-5E101F9EF9FA}"/>
+                </a:ext>
+              </a:extLst>
+            </p:cNvPr>
+            <p:cNvSpPr txBox="1"/>
+            <p:nvPr/>
+          </p:nvSpPr>
+          <p:spPr>
+            <a:xfrm>
+              <a:off x="23315993" y="5536168"/>
+              <a:ext cx="312906" cy="369332"/>
+            </a:xfrm>
+            <a:prstGeom prst="rect">
+              <a:avLst/>
+            </a:prstGeom>
+            <a:noFill/>
+          </p:spPr>
+          <p:txBody>
+            <a:bodyPr wrap="none" rtlCol="0">
+              <a:spAutoFit/>
+            </a:bodyPr>
+            <a:lstStyle/>
+            <a:p>
+              <a:r>
+                <a:rPr lang="en-US" dirty="0"/>
+                <a:t>6</a:t>
+              </a:r>
+            </a:p>
+          </p:txBody>
+        </p:sp>
+        <p:sp>
+          <p:nvSpPr>
+            <p:cNvPr id="19" name="TextBox 18">
+              <a:extLst>
+                <a:ext uri="{FF2B5EF4-FFF2-40B4-BE49-F238E27FC236}">
+                  <a16:creationId xmlns:a16="http://schemas.microsoft.com/office/drawing/2014/main" id="{E2A872D9-BAA2-926E-8BF6-557B36359A89}"/>
+                </a:ext>
+              </a:extLst>
+            </p:cNvPr>
+            <p:cNvSpPr txBox="1"/>
+            <p:nvPr/>
+          </p:nvSpPr>
+          <p:spPr>
+            <a:xfrm>
+              <a:off x="23772582" y="11480474"/>
+              <a:ext cx="441146" cy="369332"/>
+            </a:xfrm>
+            <a:prstGeom prst="rect">
+              <a:avLst/>
+            </a:prstGeom>
+            <a:noFill/>
+          </p:spPr>
+          <p:txBody>
+            <a:bodyPr wrap="none" rtlCol="0">
+              <a:spAutoFit/>
+            </a:bodyPr>
+            <a:lstStyle/>
+            <a:p>
+              <a:r>
+                <a:rPr lang="en-US" dirty="0"/>
+                <a:t>20</a:t>
+              </a:r>
+            </a:p>
+          </p:txBody>
+        </p:sp>
+        <p:sp>
+          <p:nvSpPr>
+            <p:cNvPr id="20" name="TextBox 19">
+              <a:extLst>
+                <a:ext uri="{FF2B5EF4-FFF2-40B4-BE49-F238E27FC236}">
+                  <a16:creationId xmlns:a16="http://schemas.microsoft.com/office/drawing/2014/main" id="{FB7890C1-56FC-BC07-26D2-E3906F91A2E1}"/>
+                </a:ext>
+              </a:extLst>
+            </p:cNvPr>
+            <p:cNvSpPr txBox="1"/>
+            <p:nvPr/>
+          </p:nvSpPr>
+          <p:spPr>
+            <a:xfrm>
+              <a:off x="29136171" y="11480474"/>
+              <a:ext cx="441146" cy="369332"/>
+            </a:xfrm>
+            <a:prstGeom prst="rect">
+              <a:avLst/>
+            </a:prstGeom>
+            <a:noFill/>
+          </p:spPr>
+          <p:txBody>
+            <a:bodyPr wrap="none" rtlCol="0">
+              <a:spAutoFit/>
+            </a:bodyPr>
+            <a:lstStyle/>
+            <a:p>
+              <a:r>
+                <a:rPr lang="en-US" dirty="0"/>
+                <a:t>70</a:t>
+              </a:r>
+            </a:p>
+          </p:txBody>
+        </p:sp>
+      </p:grpSp>
+      <p:grpSp>
+        <p:nvGrpSpPr>
+          <p:cNvPr id="30" name="Group 29">
+            <a:extLst>
+              <a:ext uri="{FF2B5EF4-FFF2-40B4-BE49-F238E27FC236}">
+                <a16:creationId xmlns:a16="http://schemas.microsoft.com/office/drawing/2014/main" id="{3F1414F7-3E57-76CD-1C5A-70BE29BA366D}"/>
+              </a:ext>
+            </a:extLst>
+          </p:cNvPr>
+          <p:cNvGrpSpPr/>
+          <p:nvPr/>
+        </p:nvGrpSpPr>
+        <p:grpSpPr>
+          <a:xfrm>
+            <a:off x="15661774" y="13131455"/>
+            <a:ext cx="6737168" cy="6699112"/>
+            <a:chOff x="15911046" y="13078023"/>
+            <a:chExt cx="6737168" cy="6699112"/>
+          </a:xfrm>
+        </p:grpSpPr>
+        <p:pic>
+          <p:nvPicPr>
+            <p:cNvPr id="9" name="Graphic 8">
+              <a:extLst>
+                <a:ext uri="{FF2B5EF4-FFF2-40B4-BE49-F238E27FC236}">
+                  <a16:creationId xmlns:a16="http://schemas.microsoft.com/office/drawing/2014/main" id="{282843A3-A752-B35C-D565-E19252213ACA}"/>
+                </a:ext>
+              </a:extLst>
+            </p:cNvPr>
+            <p:cNvPicPr>
+              <a:picLocks noChangeAspect="1"/>
+            </p:cNvPicPr>
+            <p:nvPr/>
+          </p:nvPicPr>
+          <p:blipFill rotWithShape="1">
+            <a:blip r:embed="rId29">
+              <a:extLst>
+                <a:ext uri="{28A0092B-C50C-407E-A947-70E740481C1C}">
+                  <a14:useLocalDpi xmlns:a14="http://schemas.microsoft.com/office/drawing/2010/main" val="0"/>
+                </a:ext>
+                <a:ext uri="{96DAC541-7B7A-43D3-8B79-37D633B846F1}">
+                  <asvg:svgBlip xmlns:asvg="http://schemas.microsoft.com/office/drawing/2016/SVG/main" r:embed="rId30"/>
+                </a:ext>
+              </a:extLst>
+            </a:blip>
+            <a:srcRect l="9868" t="6783" r="2069" b="8627"/>
+            <a:stretch/>
+          </p:blipFill>
+          <p:spPr>
+            <a:xfrm>
+              <a:off x="16500268" y="13078023"/>
+              <a:ext cx="6147946" cy="6124247"/>
+            </a:xfrm>
+            <a:prstGeom prst="rect">
+              <a:avLst/>
+            </a:prstGeom>
+          </p:spPr>
+        </p:pic>
+        <p:sp>
+          <p:nvSpPr>
+            <p:cNvPr id="21" name="TextBox 20">
+              <a:extLst>
+                <a:ext uri="{FF2B5EF4-FFF2-40B4-BE49-F238E27FC236}">
+                  <a16:creationId xmlns:a16="http://schemas.microsoft.com/office/drawing/2014/main" id="{49D692A7-4FAE-7F86-3669-63E5EB7B73B4}"/>
+                </a:ext>
+              </a:extLst>
+            </p:cNvPr>
+            <p:cNvSpPr txBox="1"/>
+            <p:nvPr/>
+          </p:nvSpPr>
+          <p:spPr>
+            <a:xfrm>
+              <a:off x="16059122" y="13297224"/>
+              <a:ext cx="441146" cy="369332"/>
+            </a:xfrm>
+            <a:prstGeom prst="rect">
+              <a:avLst/>
+            </a:prstGeom>
+            <a:noFill/>
+          </p:spPr>
+          <p:txBody>
+            <a:bodyPr wrap="none" rtlCol="0">
+              <a:spAutoFit/>
+            </a:bodyPr>
+            <a:lstStyle/>
+            <a:p>
+              <a:r>
+                <a:rPr lang="en-US" dirty="0"/>
+                <a:t>35</a:t>
+              </a:r>
+            </a:p>
+          </p:txBody>
+        </p:sp>
+        <p:sp>
+          <p:nvSpPr>
+            <p:cNvPr id="22" name="TextBox 21">
+              <a:extLst>
+                <a:ext uri="{FF2B5EF4-FFF2-40B4-BE49-F238E27FC236}">
+                  <a16:creationId xmlns:a16="http://schemas.microsoft.com/office/drawing/2014/main" id="{EC6D13B2-263D-82AD-D27A-9146F541402C}"/>
+                </a:ext>
+              </a:extLst>
+            </p:cNvPr>
+            <p:cNvSpPr txBox="1"/>
+            <p:nvPr/>
+          </p:nvSpPr>
+          <p:spPr>
+            <a:xfrm>
+              <a:off x="16147265" y="18712557"/>
+              <a:ext cx="312906" cy="369332"/>
+            </a:xfrm>
+            <a:prstGeom prst="rect">
+              <a:avLst/>
+            </a:prstGeom>
+            <a:noFill/>
+          </p:spPr>
+          <p:txBody>
+            <a:bodyPr wrap="none" rtlCol="0">
+              <a:spAutoFit/>
+            </a:bodyPr>
+            <a:lstStyle/>
+            <a:p>
+              <a:r>
+                <a:rPr lang="en-US" dirty="0"/>
+                <a:t>0</a:t>
+              </a:r>
+            </a:p>
+          </p:txBody>
+        </p:sp>
+        <p:sp>
+          <p:nvSpPr>
+            <p:cNvPr id="23" name="TextBox 22">
+              <a:extLst>
+                <a:ext uri="{FF2B5EF4-FFF2-40B4-BE49-F238E27FC236}">
+                  <a16:creationId xmlns:a16="http://schemas.microsoft.com/office/drawing/2014/main" id="{AB573673-D070-01BC-38C0-015CC202624E}"/>
+                </a:ext>
+              </a:extLst>
+            </p:cNvPr>
+            <p:cNvSpPr txBox="1"/>
+            <p:nvPr/>
+          </p:nvSpPr>
+          <p:spPr>
+            <a:xfrm rot="16200000">
+              <a:off x="15411230" y="15931050"/>
+              <a:ext cx="1553630" cy="553998"/>
+            </a:xfrm>
+            <a:prstGeom prst="rect">
+              <a:avLst/>
+            </a:prstGeom>
+            <a:noFill/>
+          </p:spPr>
+          <p:txBody>
+            <a:bodyPr wrap="none" rtlCol="0">
+              <a:spAutoFit/>
+            </a:bodyPr>
+            <a:lstStyle/>
+            <a:p>
+              <a:r>
+                <a:rPr lang="en-US" sz="3000" dirty="0"/>
+                <a:t>OAFEM</a:t>
+              </a:r>
+            </a:p>
+          </p:txBody>
+        </p:sp>
+        <p:sp>
+          <p:nvSpPr>
+            <p:cNvPr id="24" name="TextBox 23">
+              <a:extLst>
+                <a:ext uri="{FF2B5EF4-FFF2-40B4-BE49-F238E27FC236}">
+                  <a16:creationId xmlns:a16="http://schemas.microsoft.com/office/drawing/2014/main" id="{9BA56891-1EA7-63D6-781A-F4B314CA5404}"/>
+                </a:ext>
+              </a:extLst>
+            </p:cNvPr>
+            <p:cNvSpPr txBox="1"/>
+            <p:nvPr/>
+          </p:nvSpPr>
+          <p:spPr>
+            <a:xfrm>
+              <a:off x="19201039" y="19223137"/>
+              <a:ext cx="867545" cy="553998"/>
+            </a:xfrm>
+            <a:prstGeom prst="rect">
+              <a:avLst/>
+            </a:prstGeom>
+            <a:noFill/>
+          </p:spPr>
+          <p:txBody>
+            <a:bodyPr wrap="none" rtlCol="0">
+              <a:spAutoFit/>
+            </a:bodyPr>
+            <a:lstStyle/>
+            <a:p>
+              <a:r>
+                <a:rPr lang="en-US" sz="3000" dirty="0"/>
+                <a:t>Age</a:t>
+              </a:r>
+            </a:p>
+          </p:txBody>
+        </p:sp>
+        <p:sp>
+          <p:nvSpPr>
+            <p:cNvPr id="25" name="TextBox 24">
+              <a:extLst>
+                <a:ext uri="{FF2B5EF4-FFF2-40B4-BE49-F238E27FC236}">
+                  <a16:creationId xmlns:a16="http://schemas.microsoft.com/office/drawing/2014/main" id="{E1D0DA85-42B5-2604-1257-444398E49E78}"/>
+                </a:ext>
+              </a:extLst>
+            </p:cNvPr>
+            <p:cNvSpPr txBox="1"/>
+            <p:nvPr/>
+          </p:nvSpPr>
+          <p:spPr>
+            <a:xfrm>
+              <a:off x="16515121" y="19263038"/>
+              <a:ext cx="441146" cy="369332"/>
+            </a:xfrm>
+            <a:prstGeom prst="rect">
+              <a:avLst/>
+            </a:prstGeom>
+            <a:noFill/>
+          </p:spPr>
+          <p:txBody>
+            <a:bodyPr wrap="none" rtlCol="0">
+              <a:spAutoFit/>
+            </a:bodyPr>
+            <a:lstStyle/>
+            <a:p>
+              <a:r>
+                <a:rPr lang="en-US" dirty="0"/>
+                <a:t>20</a:t>
+              </a:r>
+            </a:p>
+          </p:txBody>
+        </p:sp>
+        <p:sp>
+          <p:nvSpPr>
+            <p:cNvPr id="26" name="TextBox 25">
+              <a:extLst>
+                <a:ext uri="{FF2B5EF4-FFF2-40B4-BE49-F238E27FC236}">
+                  <a16:creationId xmlns:a16="http://schemas.microsoft.com/office/drawing/2014/main" id="{6809160B-2F6C-BA84-02F1-D80F287E78AE}"/>
+                </a:ext>
+              </a:extLst>
+            </p:cNvPr>
+            <p:cNvSpPr txBox="1"/>
+            <p:nvPr/>
+          </p:nvSpPr>
+          <p:spPr>
+            <a:xfrm>
+              <a:off x="21878710" y="19263038"/>
+              <a:ext cx="441146" cy="369332"/>
+            </a:xfrm>
+            <a:prstGeom prst="rect">
+              <a:avLst/>
+            </a:prstGeom>
+            <a:noFill/>
+          </p:spPr>
+          <p:txBody>
+            <a:bodyPr wrap="none" rtlCol="0">
+              <a:spAutoFit/>
+            </a:bodyPr>
+            <a:lstStyle/>
+            <a:p>
+              <a:r>
+                <a:rPr lang="en-US" dirty="0"/>
+                <a:t>70</a:t>
+              </a:r>
+            </a:p>
+          </p:txBody>
+        </p:sp>
+      </p:grpSp>
+      <p:grpSp>
+        <p:nvGrpSpPr>
+          <p:cNvPr id="31" name="Group 30">
+            <a:extLst>
+              <a:ext uri="{FF2B5EF4-FFF2-40B4-BE49-F238E27FC236}">
+                <a16:creationId xmlns:a16="http://schemas.microsoft.com/office/drawing/2014/main" id="{4BDD7E15-33CB-E293-2CA9-95B8CCDF48ED}"/>
+              </a:ext>
+            </a:extLst>
+          </p:cNvPr>
+          <p:cNvGrpSpPr/>
+          <p:nvPr/>
+        </p:nvGrpSpPr>
+        <p:grpSpPr>
+          <a:xfrm>
+            <a:off x="23056612" y="13074616"/>
+            <a:ext cx="6850435" cy="6849449"/>
+            <a:chOff x="23056612" y="13074616"/>
+            <a:chExt cx="6850435" cy="6849449"/>
+          </a:xfrm>
+        </p:grpSpPr>
+        <p:grpSp>
+          <p:nvGrpSpPr>
+            <p:cNvPr id="15583" name="Group 15582">
+              <a:extLst>
+                <a:ext uri="{FF2B5EF4-FFF2-40B4-BE49-F238E27FC236}">
+                  <a16:creationId xmlns:a16="http://schemas.microsoft.com/office/drawing/2014/main" id="{81424957-973F-2BA6-23A6-71C1377BD2AF}"/>
+                </a:ext>
+              </a:extLst>
+            </p:cNvPr>
+            <p:cNvGrpSpPr/>
+            <p:nvPr/>
+          </p:nvGrpSpPr>
+          <p:grpSpPr>
+            <a:xfrm>
+              <a:off x="23056612" y="13074616"/>
+              <a:ext cx="6850435" cy="6786447"/>
+              <a:chOff x="23252603" y="4927197"/>
+              <a:chExt cx="5353289" cy="5834166"/>
+            </a:xfrm>
+          </p:grpSpPr>
+          <p:pic>
+            <p:nvPicPr>
+              <p:cNvPr id="15574" name="Picture 15573" descr="A graph of a line&#10;&#10;Description automatically generated with medium confidence">
+                <a:extLst>
+                  <a:ext uri="{FF2B5EF4-FFF2-40B4-BE49-F238E27FC236}">
+                    <a16:creationId xmlns:a16="http://schemas.microsoft.com/office/drawing/2014/main" id="{C54D0E15-DCC7-A19B-7997-13F421CEA2FB}"/>
+                  </a:ext>
+                </a:extLst>
+              </p:cNvPr>
+              <p:cNvPicPr>
+                <a:picLocks noChangeAspect="1"/>
+              </p:cNvPicPr>
+              <p:nvPr/>
+            </p:nvPicPr>
+            <p:blipFill rotWithShape="1">
+              <a:blip r:embed="rId31">
+                <a:extLst>
+                  <a:ext uri="{28A0092B-C50C-407E-A947-70E740481C1C}">
+                    <a14:useLocalDpi xmlns:a14="http://schemas.microsoft.com/office/drawing/2010/main" val="0"/>
+                  </a:ext>
+                </a:extLst>
+              </a:blip>
+              <a:srcRect r="3644" b="9068"/>
+              <a:stretch/>
+            </p:blipFill>
+            <p:spPr>
+              <a:xfrm>
+                <a:off x="24004670" y="4927197"/>
+                <a:ext cx="4601222" cy="5427765"/>
+              </a:xfrm>
+              <a:prstGeom prst="rect">
+                <a:avLst/>
+              </a:prstGeom>
+            </p:spPr>
+          </p:pic>
+          <p:sp>
+            <p:nvSpPr>
+              <p:cNvPr id="15575" name="TextBox 15574">
+                <a:extLst>
+                  <a:ext uri="{FF2B5EF4-FFF2-40B4-BE49-F238E27FC236}">
+                    <a16:creationId xmlns:a16="http://schemas.microsoft.com/office/drawing/2014/main" id="{136D78E5-71EA-17ED-91C9-F9CCADA262FF}"/>
+                  </a:ext>
+                </a:extLst>
+              </p:cNvPr>
+              <p:cNvSpPr txBox="1"/>
+              <p:nvPr/>
+            </p:nvSpPr>
+            <p:spPr>
+              <a:xfrm rot="16200000">
+                <a:off x="20819591" y="7575196"/>
+                <a:ext cx="5298947" cy="432923"/>
+              </a:xfrm>
+              <a:prstGeom prst="rect">
+                <a:avLst/>
+              </a:prstGeom>
+              <a:noFill/>
+            </p:spPr>
+            <p:txBody>
+              <a:bodyPr wrap="none" rtlCol="0">
+                <a:spAutoFit/>
+              </a:bodyPr>
+              <a:lstStyle/>
+              <a:p>
+                <a:r>
+                  <a:rPr lang="en-US" sz="3000" dirty="0"/>
+                  <a:t>Sharing with Friend –With Stranger</a:t>
+                </a:r>
+              </a:p>
+            </p:txBody>
+          </p:sp>
+          <p:sp>
+            <p:nvSpPr>
+              <p:cNvPr id="15576" name="TextBox 15575">
+                <a:extLst>
+                  <a:ext uri="{FF2B5EF4-FFF2-40B4-BE49-F238E27FC236}">
+                    <a16:creationId xmlns:a16="http://schemas.microsoft.com/office/drawing/2014/main" id="{7E602785-88A0-0942-659B-9A750B46996F}"/>
+                  </a:ext>
+                </a:extLst>
+              </p:cNvPr>
+              <p:cNvSpPr txBox="1"/>
+              <p:nvPr/>
+            </p:nvSpPr>
+            <p:spPr>
+              <a:xfrm>
+                <a:off x="23603500" y="9333929"/>
+                <a:ext cx="389850" cy="369332"/>
+              </a:xfrm>
+              <a:prstGeom prst="rect">
+                <a:avLst/>
+              </a:prstGeom>
+              <a:noFill/>
+            </p:spPr>
+            <p:txBody>
+              <a:bodyPr wrap="none" rtlCol="0">
+                <a:spAutoFit/>
+              </a:bodyPr>
+              <a:lstStyle/>
+              <a:p>
+                <a:r>
+                  <a:rPr lang="en-US" dirty="0"/>
+                  <a:t>-2</a:t>
+                </a:r>
+              </a:p>
+            </p:txBody>
+          </p:sp>
+          <p:sp>
+            <p:nvSpPr>
+              <p:cNvPr id="15577" name="TextBox 15576">
+                <a:extLst>
+                  <a:ext uri="{FF2B5EF4-FFF2-40B4-BE49-F238E27FC236}">
+                    <a16:creationId xmlns:a16="http://schemas.microsoft.com/office/drawing/2014/main" id="{44C014BB-4057-CE6F-8488-5075607DFC5B}"/>
+                  </a:ext>
+                </a:extLst>
+              </p:cNvPr>
+              <p:cNvSpPr txBox="1"/>
+              <p:nvPr/>
+            </p:nvSpPr>
+            <p:spPr>
+              <a:xfrm>
+                <a:off x="23684874" y="6124920"/>
+                <a:ext cx="312906" cy="369332"/>
+              </a:xfrm>
+              <a:prstGeom prst="rect">
+                <a:avLst/>
+              </a:prstGeom>
+              <a:noFill/>
+            </p:spPr>
+            <p:txBody>
+              <a:bodyPr wrap="none" rtlCol="0">
+                <a:spAutoFit/>
+              </a:bodyPr>
+              <a:lstStyle/>
+              <a:p>
+                <a:r>
+                  <a:rPr lang="en-US" dirty="0"/>
+                  <a:t>2</a:t>
+                </a:r>
+              </a:p>
+            </p:txBody>
+          </p:sp>
+          <p:sp>
+            <p:nvSpPr>
+              <p:cNvPr id="15578" name="TextBox 15577">
+                <a:extLst>
+                  <a:ext uri="{FF2B5EF4-FFF2-40B4-BE49-F238E27FC236}">
+                    <a16:creationId xmlns:a16="http://schemas.microsoft.com/office/drawing/2014/main" id="{7FC9F9D2-B5EE-482C-7F35-E7345B0CA197}"/>
+                  </a:ext>
+                </a:extLst>
+              </p:cNvPr>
+              <p:cNvSpPr txBox="1"/>
+              <p:nvPr/>
+            </p:nvSpPr>
+            <p:spPr>
+              <a:xfrm>
+                <a:off x="23666269" y="7699893"/>
+                <a:ext cx="312906" cy="369332"/>
+              </a:xfrm>
+              <a:prstGeom prst="rect">
+                <a:avLst/>
+              </a:prstGeom>
+              <a:noFill/>
+            </p:spPr>
+            <p:txBody>
+              <a:bodyPr wrap="none" rtlCol="0">
+                <a:spAutoFit/>
+              </a:bodyPr>
+              <a:lstStyle/>
+              <a:p>
+                <a:r>
+                  <a:rPr lang="en-US" dirty="0"/>
+                  <a:t>0</a:t>
+                </a:r>
+              </a:p>
+            </p:txBody>
+          </p:sp>
+          <p:sp>
+            <p:nvSpPr>
+              <p:cNvPr id="15579" name="TextBox 15578">
+                <a:extLst>
+                  <a:ext uri="{FF2B5EF4-FFF2-40B4-BE49-F238E27FC236}">
+                    <a16:creationId xmlns:a16="http://schemas.microsoft.com/office/drawing/2014/main" id="{115532EB-4683-39F0-80DC-27E22F24AA20}"/>
+                  </a:ext>
+                </a:extLst>
+              </p:cNvPr>
+              <p:cNvSpPr txBox="1"/>
+              <p:nvPr/>
+            </p:nvSpPr>
+            <p:spPr>
+              <a:xfrm>
+                <a:off x="23984464" y="10392031"/>
+                <a:ext cx="441146" cy="369332"/>
+              </a:xfrm>
+              <a:prstGeom prst="rect">
+                <a:avLst/>
+              </a:prstGeom>
+              <a:noFill/>
+            </p:spPr>
+            <p:txBody>
+              <a:bodyPr wrap="none" rtlCol="0">
+                <a:spAutoFit/>
+              </a:bodyPr>
+              <a:lstStyle/>
+              <a:p>
+                <a:r>
+                  <a:rPr lang="en-US" dirty="0"/>
+                  <a:t>20</a:t>
+                </a:r>
+              </a:p>
+            </p:txBody>
+          </p:sp>
+        </p:grpSp>
+        <p:sp>
+          <p:nvSpPr>
+            <p:cNvPr id="27" name="TextBox 26">
+              <a:extLst>
+                <a:ext uri="{FF2B5EF4-FFF2-40B4-BE49-F238E27FC236}">
+                  <a16:creationId xmlns:a16="http://schemas.microsoft.com/office/drawing/2014/main" id="{B971FA06-90F6-38D8-E376-EAC7F8F86D37}"/>
+                </a:ext>
+              </a:extLst>
+            </p:cNvPr>
+            <p:cNvSpPr txBox="1"/>
+            <p:nvPr/>
+          </p:nvSpPr>
+          <p:spPr>
+            <a:xfrm>
+              <a:off x="26534606" y="19370067"/>
+              <a:ext cx="867545" cy="553998"/>
+            </a:xfrm>
+            <a:prstGeom prst="rect">
+              <a:avLst/>
+            </a:prstGeom>
+            <a:noFill/>
+          </p:spPr>
+          <p:txBody>
+            <a:bodyPr wrap="none" rtlCol="0">
+              <a:spAutoFit/>
+            </a:bodyPr>
+            <a:lstStyle/>
+            <a:p>
+              <a:r>
+                <a:rPr lang="en-US" sz="3000" dirty="0"/>
+                <a:t>Age</a:t>
+              </a:r>
+            </a:p>
+          </p:txBody>
+        </p:sp>
+        <p:sp>
+          <p:nvSpPr>
+            <p:cNvPr id="29" name="TextBox 28">
+              <a:extLst>
+                <a:ext uri="{FF2B5EF4-FFF2-40B4-BE49-F238E27FC236}">
+                  <a16:creationId xmlns:a16="http://schemas.microsoft.com/office/drawing/2014/main" id="{ECA8551F-72DA-08BF-83FF-D876E48BD6C0}"/>
+                </a:ext>
+              </a:extLst>
+            </p:cNvPr>
+            <p:cNvSpPr txBox="1"/>
+            <p:nvPr/>
+          </p:nvSpPr>
+          <p:spPr>
+            <a:xfrm>
+              <a:off x="29379086" y="19390085"/>
+              <a:ext cx="441146" cy="369332"/>
+            </a:xfrm>
+            <a:prstGeom prst="rect">
+              <a:avLst/>
+            </a:prstGeom>
+            <a:noFill/>
+          </p:spPr>
+          <p:txBody>
+            <a:bodyPr wrap="none" rtlCol="0">
+              <a:spAutoFit/>
+            </a:bodyPr>
+            <a:lstStyle/>
+            <a:p>
+              <a:r>
+                <a:rPr lang="en-US" dirty="0"/>
+                <a:t>70</a:t>
+              </a:r>
+            </a:p>
+          </p:txBody>
+        </p:sp>
+      </p:grpSp>
     </p:spTree>
   </p:cSld>
   <p:clrMapOvr>
@@ -18238,15 +18741,6 @@
 </file>
 
 <file path=customXml/item1.xml><?xml version="1.0" encoding="utf-8"?>
-<?mso-contentType ?>
-<FormTemplates xmlns="http://schemas.microsoft.com/sharepoint/v3/contenttype/forms">
-  <Display>DocumentLibraryForm</Display>
-  <Edit>DocumentLibraryForm</Edit>
-  <New>DocumentLibraryForm</New>
-</FormTemplates>
-</file>
-
-<file path=customXml/item2.xml><?xml version="1.0" encoding="utf-8"?>
 <ct:contentTypeSchema xmlns:ct="http://schemas.microsoft.com/office/2006/metadata/contentType" xmlns:ma="http://schemas.microsoft.com/office/2006/metadata/properties/metaAttributes" ct:_="" ma:_="" ma:contentTypeName="Document" ma:contentTypeID="0x01010080DE0AC601CE7945A16C28BE7D604718" ma:contentTypeVersion="16" ma:contentTypeDescription="Create a new document." ma:contentTypeScope="" ma:versionID="7200742d51933ad5859751156d985908">
   <xsd:schema xmlns:xsd="http://www.w3.org/2001/XMLSchema" xmlns:xs="http://www.w3.org/2001/XMLSchema" xmlns:p="http://schemas.microsoft.com/office/2006/metadata/properties" xmlns:ns2="068132b6-27af-4cc5-9624-46e0bc309f9c" xmlns:ns3="1ec1d487-840c-40ff-aca1-00ff13008544" targetNamespace="http://schemas.microsoft.com/office/2006/metadata/properties" ma:root="true" ma:fieldsID="ef3bb859774f4d5f12e6e11e5f5551df" ns2:_="" ns3:_="">
     <xsd:import namespace="068132b6-27af-4cc5-9624-46e0bc309f9c"/>
@@ -18489,15 +18983,16 @@
 </ct:contentTypeSchema>
 </file>
 
-<file path=customXml/itemProps1.xml><?xml version="1.0" encoding="utf-8"?>
-<ds:datastoreItem xmlns:ds="http://schemas.openxmlformats.org/officeDocument/2006/customXml" ds:itemID="{D5CAE7E8-1A3A-4A91-86FB-BA9E1762341A}">
-  <ds:schemaRefs>
-    <ds:schemaRef ds:uri="http://schemas.microsoft.com/sharepoint/v3/contenttype/forms"/>
-  </ds:schemaRefs>
-</ds:datastoreItem>
+<file path=customXml/item2.xml><?xml version="1.0" encoding="utf-8"?>
+<?mso-contentType ?>
+<FormTemplates xmlns="http://schemas.microsoft.com/sharepoint/v3/contenttype/forms">
+  <Display>DocumentLibraryForm</Display>
+  <Edit>DocumentLibraryForm</Edit>
+  <New>DocumentLibraryForm</New>
+</FormTemplates>
 </file>
 
-<file path=customXml/itemProps2.xml><?xml version="1.0" encoding="utf-8"?>
+<file path=customXml/itemProps1.xml><?xml version="1.0" encoding="utf-8"?>
 <ds:datastoreItem xmlns:ds="http://schemas.openxmlformats.org/officeDocument/2006/customXml" ds:itemID="{36138A07-987C-4A73-AAED-022482DDD0A4}">
   <ds:schemaRefs>
     <ds:schemaRef ds:uri="068132b6-27af-4cc5-9624-46e0bc309f9c"/>
@@ -18514,4 +19009,12 @@
     <ds:schemaRef ds:uri="http://www.w3.org/2001/XMLSchema"/>
   </ds:schemaRefs>
 </ds:datastoreItem>
+</file>
+
+<file path=customXml/itemProps2.xml><?xml version="1.0" encoding="utf-8"?>
+<ds:datastoreItem xmlns:ds="http://schemas.openxmlformats.org/officeDocument/2006/customXml" ds:itemID="{D5CAE7E8-1A3A-4A91-86FB-BA9E1762341A}">
+  <ds:schemaRefs>
+    <ds:schemaRef ds:uri="http://schemas.microsoft.com/sharepoint/v3/contenttype/forms"/>
+  </ds:schemaRefs>
+</ds:datastoreItem>
 </file>
</xml_diff>

<commit_message>
finished adding the dope ass cool fucking big balls plots
</commit_message>
<xml_diff>
--- a/SFN/2023_SFN_trust.pptx
+++ b/SFN/2023_SFN_trust.pptx
@@ -7670,17 +7670,12 @@
               <a:spcAft>
                 <a:spcPts val="0"/>
               </a:spcAft>
-              <a:buFont typeface="Arial" panose="020B0604020202020204" pitchFamily="34" charset="0"/>
-              <a:buChar char="•"/>
             </a:pPr>
-            <a:r>
-              <a:rPr lang="en-US" sz="4000" b="1" dirty="0">
-                <a:latin typeface="Helvetica"/>
-                <a:ea typeface="MS PGothic"/>
-                <a:cs typeface="Helvetica"/>
-              </a:rPr>
-              <a:t> </a:t>
-            </a:r>
+            <a:endParaRPr lang="en-US" sz="4000" b="1" dirty="0">
+              <a:latin typeface="Helvetica"/>
+              <a:ea typeface="MS PGothic"/>
+              <a:cs typeface="Helvetica"/>
+            </a:endParaRPr>
           </a:p>
           <a:p>
             <a:pPr>
@@ -10326,10 +10321,10 @@
       </p:sp>
       <p:grpSp>
         <p:nvGrpSpPr>
-          <p:cNvPr id="15731" name="Group 15730">
+          <p:cNvPr id="15637" name="Group 15636">
             <a:extLst>
               <a:ext uri="{FF2B5EF4-FFF2-40B4-BE49-F238E27FC236}">
-                <a16:creationId xmlns:a16="http://schemas.microsoft.com/office/drawing/2014/main" id="{06155C43-338B-1F84-917E-F663403BFB29}"/>
+                <a16:creationId xmlns:a16="http://schemas.microsoft.com/office/drawing/2014/main" id="{3A2B419D-DEB8-5DE4-6994-E09E435EDE6A}"/>
               </a:ext>
             </a:extLst>
           </p:cNvPr>
@@ -10338,18 +10333,18 @@
         </p:nvGrpSpPr>
         <p:grpSpPr>
           <a:xfrm>
-            <a:off x="22124222" y="22377639"/>
-            <a:ext cx="7775433" cy="8491864"/>
-            <a:chOff x="22963078" y="15328939"/>
-            <a:chExt cx="6820488" cy="7219447"/>
+            <a:off x="22124221" y="23761217"/>
+            <a:ext cx="6126173" cy="7108285"/>
+            <a:chOff x="23532472" y="16411504"/>
+            <a:chExt cx="4693010" cy="5263937"/>
           </a:xfrm>
         </p:grpSpPr>
         <p:grpSp>
           <p:nvGrpSpPr>
-            <p:cNvPr id="15637" name="Group 15636">
+            <p:cNvPr id="15627" name="Group 15626">
               <a:extLst>
                 <a:ext uri="{FF2B5EF4-FFF2-40B4-BE49-F238E27FC236}">
-                  <a16:creationId xmlns:a16="http://schemas.microsoft.com/office/drawing/2014/main" id="{3A2B419D-DEB8-5DE4-6994-E09E435EDE6A}"/>
+                  <a16:creationId xmlns:a16="http://schemas.microsoft.com/office/drawing/2014/main" id="{06AA4FCA-34DA-E471-770A-8C935B50E788}"/>
                 </a:ext>
               </a:extLst>
             </p:cNvPr>
@@ -10358,147 +10353,18 @@
           </p:nvGrpSpPr>
           <p:grpSpPr>
             <a:xfrm>
-              <a:off x="22963078" y="15328939"/>
-              <a:ext cx="6820488" cy="7219447"/>
-              <a:chOff x="23532472" y="15386915"/>
-              <a:chExt cx="5956440" cy="6288526"/>
+              <a:off x="23684560" y="16939790"/>
+              <a:ext cx="3160310" cy="4735651"/>
+              <a:chOff x="23684560" y="16939790"/>
+              <a:chExt cx="3160310" cy="4735651"/>
             </a:xfrm>
           </p:grpSpPr>
-          <p:grpSp>
-            <p:nvGrpSpPr>
-              <p:cNvPr id="15627" name="Group 15626">
+          <p:sp>
+            <p:nvSpPr>
+              <p:cNvPr id="15625" name="TextBox 15624">
                 <a:extLst>
                   <a:ext uri="{FF2B5EF4-FFF2-40B4-BE49-F238E27FC236}">
-                    <a16:creationId xmlns:a16="http://schemas.microsoft.com/office/drawing/2014/main" id="{06AA4FCA-34DA-E471-770A-8C935B50E788}"/>
-                  </a:ext>
-                </a:extLst>
-              </p:cNvPr>
-              <p:cNvGrpSpPr/>
-              <p:nvPr/>
-            </p:nvGrpSpPr>
-            <p:grpSpPr>
-              <a:xfrm>
-                <a:off x="23684560" y="15386915"/>
-                <a:ext cx="5804352" cy="6288526"/>
-                <a:chOff x="23684560" y="15386915"/>
-                <a:chExt cx="5804352" cy="6288526"/>
-              </a:xfrm>
-            </p:grpSpPr>
-            <p:pic>
-              <p:nvPicPr>
-                <p:cNvPr id="15623" name="Graphic 15622">
-                  <a:extLst>
-                    <a:ext uri="{FF2B5EF4-FFF2-40B4-BE49-F238E27FC236}">
-                      <a16:creationId xmlns:a16="http://schemas.microsoft.com/office/drawing/2014/main" id="{D58E3C64-D70B-D4DC-2B91-07C64E19369D}"/>
-                    </a:ext>
-                  </a:extLst>
-                </p:cNvPr>
-                <p:cNvPicPr>
-                  <a:picLocks noChangeAspect="1"/>
-                </p:cNvPicPr>
-                <p:nvPr/>
-              </p:nvPicPr>
-              <p:blipFill rotWithShape="1">
-                <a:blip r:embed="rId18">
-                  <a:extLst>
-                    <a:ext uri="{28A0092B-C50C-407E-A947-70E740481C1C}">
-                      <a14:useLocalDpi xmlns:a14="http://schemas.microsoft.com/office/drawing/2010/main" val="0"/>
-                    </a:ext>
-                    <a:ext uri="{96DAC541-7B7A-43D3-8B79-37D633B846F1}">
-                      <asvg:svgBlip xmlns:asvg="http://schemas.microsoft.com/office/drawing/2016/SVG/main" r:embed="rId19"/>
-                    </a:ext>
-                  </a:extLst>
-                </a:blip>
-                <a:srcRect l="10234" b="7938"/>
-                <a:stretch/>
-              </p:blipFill>
-              <p:spPr>
-                <a:xfrm>
-                  <a:off x="24165170" y="15386915"/>
-                  <a:ext cx="5323742" cy="5662134"/>
-                </a:xfrm>
-                <a:prstGeom prst="rect">
-                  <a:avLst/>
-                </a:prstGeom>
-              </p:spPr>
-            </p:pic>
-            <p:sp>
-              <p:nvSpPr>
-                <p:cNvPr id="15625" name="TextBox 15624">
-                  <a:extLst>
-                    <a:ext uri="{FF2B5EF4-FFF2-40B4-BE49-F238E27FC236}">
-                      <a16:creationId xmlns:a16="http://schemas.microsoft.com/office/drawing/2014/main" id="{7328C975-6B3E-4A8B-7D28-2CBF3C3AA243}"/>
-                    </a:ext>
-                  </a:extLst>
-                </p:cNvPr>
-                <p:cNvSpPr txBox="1"/>
-                <p:nvPr/>
-              </p:nvSpPr>
-              <p:spPr>
-                <a:xfrm>
-                  <a:off x="25887039" y="21058834"/>
-                  <a:ext cx="957831" cy="616607"/>
-                </a:xfrm>
-                <a:prstGeom prst="rect">
-                  <a:avLst/>
-                </a:prstGeom>
-                <a:noFill/>
-              </p:spPr>
-              <p:txBody>
-                <a:bodyPr wrap="none" rtlCol="0">
-                  <a:spAutoFit/>
-                </a:bodyPr>
-                <a:lstStyle/>
-                <a:p>
-                  <a:r>
-                    <a:rPr lang="en-US" sz="4000" dirty="0"/>
-                    <a:t>Age</a:t>
-                  </a:r>
-                </a:p>
-              </p:txBody>
-            </p:sp>
-            <p:sp>
-              <p:nvSpPr>
-                <p:cNvPr id="15626" name="TextBox 15625">
-                  <a:extLst>
-                    <a:ext uri="{FF2B5EF4-FFF2-40B4-BE49-F238E27FC236}">
-                      <a16:creationId xmlns:a16="http://schemas.microsoft.com/office/drawing/2014/main" id="{0741CC01-E666-6FF6-4DCF-5C0AEA54A228}"/>
-                    </a:ext>
-                  </a:extLst>
-                </p:cNvPr>
-                <p:cNvSpPr txBox="1"/>
-                <p:nvPr/>
-              </p:nvSpPr>
-              <p:spPr>
-                <a:xfrm rot="16200000">
-                  <a:off x="22278692" y="18345658"/>
-                  <a:ext cx="3295551" cy="483815"/>
-                </a:xfrm>
-                <a:prstGeom prst="rect">
-                  <a:avLst/>
-                </a:prstGeom>
-                <a:noFill/>
-              </p:spPr>
-              <p:txBody>
-                <a:bodyPr wrap="none" rtlCol="0">
-                  <a:spAutoFit/>
-                </a:bodyPr>
-                <a:lstStyle/>
-                <a:p>
-                  <a:r>
-                    <a:rPr lang="en-US" sz="3000" dirty="0"/>
-                    <a:t>Reciprocate &gt; Defect</a:t>
-                  </a:r>
-                </a:p>
-              </p:txBody>
-            </p:sp>
-          </p:grpSp>
-          <p:sp>
-            <p:nvSpPr>
-              <p:cNvPr id="15632" name="TextBox 15631">
-                <a:extLst>
-                  <a:ext uri="{FF2B5EF4-FFF2-40B4-BE49-F238E27FC236}">
-                    <a16:creationId xmlns:a16="http://schemas.microsoft.com/office/drawing/2014/main" id="{DB5643A6-0963-1889-743A-BE329E7DFA26}"/>
+                    <a16:creationId xmlns:a16="http://schemas.microsoft.com/office/drawing/2014/main" id="{7328C975-6B3E-4A8B-7D28-2CBF3C3AA243}"/>
                   </a:ext>
                 </a:extLst>
               </p:cNvPr>
@@ -10507,477 +10373,8 @@
             </p:nvSpPr>
             <p:spPr>
               <a:xfrm>
-                <a:off x="23532472" y="16411504"/>
-                <a:ext cx="601964" cy="387463"/>
-              </a:xfrm>
-              <a:prstGeom prst="rect">
-                <a:avLst/>
-              </a:prstGeom>
-              <a:noFill/>
-            </p:spPr>
-            <p:txBody>
-              <a:bodyPr wrap="none" rtlCol="0">
-                <a:spAutoFit/>
-              </a:bodyPr>
-              <a:lstStyle/>
-              <a:p>
-                <a:r>
-                  <a:rPr lang="en-US" sz="2800" dirty="0"/>
-                  <a:t>400</a:t>
-                </a:r>
-              </a:p>
-            </p:txBody>
-          </p:sp>
-          <p:sp>
-            <p:nvSpPr>
-              <p:cNvPr id="15633" name="TextBox 15632">
-                <a:extLst>
-                  <a:ext uri="{FF2B5EF4-FFF2-40B4-BE49-F238E27FC236}">
-                    <a16:creationId xmlns:a16="http://schemas.microsoft.com/office/drawing/2014/main" id="{F005320C-94E9-2CF4-6842-98DA1FA46221}"/>
-                  </a:ext>
-                </a:extLst>
-              </p:cNvPr>
-              <p:cNvSpPr txBox="1"/>
-              <p:nvPr/>
-            </p:nvSpPr>
-            <p:spPr>
-              <a:xfrm>
-                <a:off x="23611670" y="20489922"/>
-                <a:ext cx="694062" cy="387463"/>
-              </a:xfrm>
-              <a:prstGeom prst="rect">
-                <a:avLst/>
-              </a:prstGeom>
-              <a:noFill/>
-            </p:spPr>
-            <p:txBody>
-              <a:bodyPr wrap="none" rtlCol="0">
-                <a:spAutoFit/>
-              </a:bodyPr>
-              <a:lstStyle/>
-              <a:p>
-                <a:r>
-                  <a:rPr lang="en-US" sz="2800" dirty="0"/>
-                  <a:t>-200</a:t>
-                </a:r>
-              </a:p>
-            </p:txBody>
-          </p:sp>
-          <p:sp>
-            <p:nvSpPr>
-              <p:cNvPr id="15634" name="TextBox 15633">
-                <a:extLst>
-                  <a:ext uri="{FF2B5EF4-FFF2-40B4-BE49-F238E27FC236}">
-                    <a16:creationId xmlns:a16="http://schemas.microsoft.com/office/drawing/2014/main" id="{E721D839-B7EC-B05A-38DA-D9704D0EBA2E}"/>
-                  </a:ext>
-                </a:extLst>
-              </p:cNvPr>
-              <p:cNvSpPr txBox="1"/>
-              <p:nvPr/>
-            </p:nvSpPr>
-            <p:spPr>
-              <a:xfrm>
-                <a:off x="24150950" y="21022056"/>
-                <a:ext cx="448464" cy="387463"/>
-              </a:xfrm>
-              <a:prstGeom prst="rect">
-                <a:avLst/>
-              </a:prstGeom>
-              <a:noFill/>
-            </p:spPr>
-            <p:txBody>
-              <a:bodyPr wrap="none" rtlCol="0">
-                <a:spAutoFit/>
-              </a:bodyPr>
-              <a:lstStyle/>
-              <a:p>
-                <a:r>
-                  <a:rPr lang="en-US" sz="2800" dirty="0"/>
-                  <a:t>20</a:t>
-                </a:r>
-              </a:p>
-            </p:txBody>
-          </p:sp>
-          <p:sp>
-            <p:nvSpPr>
-              <p:cNvPr id="15635" name="TextBox 15634">
-                <a:extLst>
-                  <a:ext uri="{FF2B5EF4-FFF2-40B4-BE49-F238E27FC236}">
-                    <a16:creationId xmlns:a16="http://schemas.microsoft.com/office/drawing/2014/main" id="{61C5ED5A-0A65-9C1A-0AC3-7712D59B3795}"/>
-                  </a:ext>
-                </a:extLst>
-              </p:cNvPr>
-              <p:cNvSpPr txBox="1"/>
-              <p:nvPr/>
-            </p:nvSpPr>
-            <p:spPr>
-              <a:xfrm>
-                <a:off x="27777018" y="21022056"/>
-                <a:ext cx="448464" cy="387463"/>
-              </a:xfrm>
-              <a:prstGeom prst="rect">
-                <a:avLst/>
-              </a:prstGeom>
-              <a:noFill/>
-            </p:spPr>
-            <p:txBody>
-              <a:bodyPr wrap="none" rtlCol="0">
-                <a:spAutoFit/>
-              </a:bodyPr>
-              <a:lstStyle/>
-              <a:p>
-                <a:r>
-                  <a:rPr lang="en-US" sz="2800" dirty="0"/>
-                  <a:t>60</a:t>
-                </a:r>
-              </a:p>
-            </p:txBody>
-          </p:sp>
-        </p:grpSp>
-        <p:sp>
-          <p:nvSpPr>
-            <p:cNvPr id="15730" name="Rectangle 15729">
-              <a:extLst>
-                <a:ext uri="{FF2B5EF4-FFF2-40B4-BE49-F238E27FC236}">
-                  <a16:creationId xmlns:a16="http://schemas.microsoft.com/office/drawing/2014/main" id="{FDF15931-1516-DE49-340B-5A133AA95A93}"/>
-                </a:ext>
-              </a:extLst>
-            </p:cNvPr>
-            <p:cNvSpPr/>
-            <p:nvPr/>
-          </p:nvSpPr>
-          <p:spPr bwMode="auto">
-            <a:xfrm>
-              <a:off x="23923841" y="15957914"/>
-              <a:ext cx="5627696" cy="5591284"/>
-            </a:xfrm>
-            <a:prstGeom prst="rect">
-              <a:avLst/>
-            </a:prstGeom>
-            <a:noFill/>
-            <a:ln w="38100" cap="flat" cmpd="sng" algn="ctr">
-              <a:solidFill>
-                <a:schemeClr val="tx1"/>
-              </a:solidFill>
-              <a:prstDash val="solid"/>
-              <a:round/>
-              <a:headEnd type="none" w="med" len="med"/>
-              <a:tailEnd type="none" w="med" len="med"/>
-            </a:ln>
-            <a:effectLst/>
-          </p:spPr>
-          <p:txBody>
-            <a:bodyPr vert="horz" wrap="square" lIns="91440" tIns="45720" rIns="91440" bIns="45720" numCol="1" rtlCol="0" anchor="t" anchorCtr="0" compatLnSpc="1">
-              <a:prstTxWarp prst="textNoShape">
-                <a:avLst/>
-              </a:prstTxWarp>
-            </a:bodyPr>
-            <a:lstStyle/>
-            <a:p>
-              <a:pPr marL="0" marR="0" indent="0" algn="l" defTabSz="4389438" rtl="0" eaLnBrk="1" fontAlgn="base" latinLnBrk="0" hangingPunct="1">
-                <a:lnSpc>
-                  <a:spcPct val="100000"/>
-                </a:lnSpc>
-                <a:spcBef>
-                  <a:spcPct val="0"/>
-                </a:spcBef>
-                <a:spcAft>
-                  <a:spcPct val="0"/>
-                </a:spcAft>
-                <a:buClrTx/>
-                <a:buSzTx/>
-                <a:buFontTx/>
-                <a:buNone/>
-                <a:tabLst/>
-              </a:pPr>
-              <a:endParaRPr kumimoji="0" lang="en-US" sz="1800" b="0" i="0" u="none" strike="noStrike" cap="none" normalizeH="0" baseline="0">
-                <a:ln>
-                  <a:noFill/>
-                </a:ln>
-                <a:solidFill>
-                  <a:schemeClr val="tx1"/>
-                </a:solidFill>
-                <a:effectLst/>
-                <a:latin typeface="Arial" charset="0"/>
-                <a:cs typeface="Arial" charset="0"/>
-              </a:endParaRPr>
-            </a:p>
-          </p:txBody>
-        </p:sp>
-      </p:grpSp>
-      <p:grpSp>
-        <p:nvGrpSpPr>
-          <p:cNvPr id="2" name="Group 1">
-            <a:extLst>
-              <a:ext uri="{FF2B5EF4-FFF2-40B4-BE49-F238E27FC236}">
-                <a16:creationId xmlns:a16="http://schemas.microsoft.com/office/drawing/2014/main" id="{A94EC582-60D1-2B41-B3B4-7BDF0B9C3848}"/>
-              </a:ext>
-            </a:extLst>
-          </p:cNvPr>
-          <p:cNvGrpSpPr/>
-          <p:nvPr/>
-        </p:nvGrpSpPr>
-        <p:grpSpPr>
-          <a:xfrm>
-            <a:off x="35263511" y="11894668"/>
-            <a:ext cx="7923930" cy="8561607"/>
-            <a:chOff x="37324753" y="15097157"/>
-            <a:chExt cx="6030525" cy="6738219"/>
-          </a:xfrm>
-        </p:grpSpPr>
-        <p:grpSp>
-          <p:nvGrpSpPr>
-            <p:cNvPr id="15726" name="Group 15725">
-              <a:extLst>
-                <a:ext uri="{FF2B5EF4-FFF2-40B4-BE49-F238E27FC236}">
-                  <a16:creationId xmlns:a16="http://schemas.microsoft.com/office/drawing/2014/main" id="{B3430D81-BB79-4C3F-9F94-3445BBB422F8}"/>
-                </a:ext>
-              </a:extLst>
-            </p:cNvPr>
-            <p:cNvGrpSpPr/>
-            <p:nvPr/>
-          </p:nvGrpSpPr>
-          <p:grpSpPr>
-            <a:xfrm>
-              <a:off x="37324753" y="15097157"/>
-              <a:ext cx="5956404" cy="6738219"/>
-              <a:chOff x="37462544" y="15444990"/>
-              <a:chExt cx="5956404" cy="6738219"/>
-            </a:xfrm>
-          </p:grpSpPr>
-          <p:pic>
-            <p:nvPicPr>
-              <p:cNvPr id="15654" name="Graphic 15653">
-                <a:extLst>
-                  <a:ext uri="{FF2B5EF4-FFF2-40B4-BE49-F238E27FC236}">
-                    <a16:creationId xmlns:a16="http://schemas.microsoft.com/office/drawing/2014/main" id="{10803621-C472-7ABD-EBF3-5EE9AE8C4D09}"/>
-                  </a:ext>
-                </a:extLst>
-              </p:cNvPr>
-              <p:cNvPicPr>
-                <a:picLocks noChangeAspect="1"/>
-              </p:cNvPicPr>
-              <p:nvPr/>
-            </p:nvPicPr>
-            <p:blipFill rotWithShape="1">
-              <a:blip r:embed="rId20">
-                <a:extLst>
-                  <a:ext uri="{28A0092B-C50C-407E-A947-70E740481C1C}">
-                    <a14:useLocalDpi xmlns:a14="http://schemas.microsoft.com/office/drawing/2010/main" val="0"/>
-                  </a:ext>
-                  <a:ext uri="{96DAC541-7B7A-43D3-8B79-37D633B846F1}">
-                    <asvg:svgBlip xmlns:asvg="http://schemas.microsoft.com/office/drawing/2016/SVG/main" r:embed="rId21"/>
-                  </a:ext>
-                </a:extLst>
-              </a:blip>
-              <a:srcRect l="12332" r="4359" b="8540"/>
-              <a:stretch/>
-            </p:blipFill>
-            <p:spPr>
-              <a:xfrm>
-                <a:off x="38085758" y="15444990"/>
-                <a:ext cx="5333190" cy="6071802"/>
-              </a:xfrm>
-              <a:prstGeom prst="rect">
-                <a:avLst/>
-              </a:prstGeom>
-            </p:spPr>
-          </p:pic>
-          <p:sp>
-            <p:nvSpPr>
-              <p:cNvPr id="15719" name="TextBox 15718">
-                <a:extLst>
-                  <a:ext uri="{FF2B5EF4-FFF2-40B4-BE49-F238E27FC236}">
-                    <a16:creationId xmlns:a16="http://schemas.microsoft.com/office/drawing/2014/main" id="{F04F4CFA-B833-1DD9-86EC-A956DC37137A}"/>
-                  </a:ext>
-                </a:extLst>
-              </p:cNvPr>
-              <p:cNvSpPr txBox="1"/>
-              <p:nvPr/>
-            </p:nvSpPr>
-            <p:spPr>
-              <a:xfrm>
-                <a:off x="37516370" y="16909110"/>
-                <a:ext cx="598030" cy="411788"/>
-              </a:xfrm>
-              <a:prstGeom prst="rect">
-                <a:avLst/>
-              </a:prstGeom>
-              <a:noFill/>
-            </p:spPr>
-            <p:txBody>
-              <a:bodyPr wrap="none" rtlCol="0">
-                <a:spAutoFit/>
-              </a:bodyPr>
-              <a:lstStyle/>
-              <a:p>
-                <a:r>
-                  <a:rPr lang="en-US" sz="2800" dirty="0"/>
-                  <a:t>400</a:t>
-                </a:r>
-              </a:p>
-            </p:txBody>
-          </p:sp>
-          <p:sp>
-            <p:nvSpPr>
-              <p:cNvPr id="15720" name="TextBox 15719">
-                <a:extLst>
-                  <a:ext uri="{FF2B5EF4-FFF2-40B4-BE49-F238E27FC236}">
-                    <a16:creationId xmlns:a16="http://schemas.microsoft.com/office/drawing/2014/main" id="{0D17E5B2-CB95-D5BD-E169-9C1854A0AD37}"/>
-                  </a:ext>
-                </a:extLst>
-              </p:cNvPr>
-              <p:cNvSpPr txBox="1"/>
-              <p:nvPr/>
-            </p:nvSpPr>
-            <p:spPr>
-              <a:xfrm>
-                <a:off x="37462544" y="20542022"/>
-                <a:ext cx="689526" cy="411788"/>
-              </a:xfrm>
-              <a:prstGeom prst="rect">
-                <a:avLst/>
-              </a:prstGeom>
-              <a:noFill/>
-            </p:spPr>
-            <p:txBody>
-              <a:bodyPr wrap="none" rtlCol="0">
-                <a:spAutoFit/>
-              </a:bodyPr>
-              <a:lstStyle/>
-              <a:p>
-                <a:r>
-                  <a:rPr lang="en-US" sz="2800" dirty="0"/>
-                  <a:t>-200</a:t>
-                </a:r>
-              </a:p>
-            </p:txBody>
-          </p:sp>
-          <p:sp>
-            <p:nvSpPr>
-              <p:cNvPr id="15721" name="TextBox 15720">
-                <a:extLst>
-                  <a:ext uri="{FF2B5EF4-FFF2-40B4-BE49-F238E27FC236}">
-                    <a16:creationId xmlns:a16="http://schemas.microsoft.com/office/drawing/2014/main" id="{81E64089-644A-E436-A434-45AF685F62E1}"/>
-                  </a:ext>
-                </a:extLst>
-              </p:cNvPr>
-              <p:cNvSpPr txBox="1"/>
-              <p:nvPr/>
-            </p:nvSpPr>
-            <p:spPr>
-              <a:xfrm rot="16200000">
-                <a:off x="36531370" y="18699129"/>
-                <a:ext cx="2471242" cy="440654"/>
-              </a:xfrm>
-              <a:prstGeom prst="rect">
-                <a:avLst/>
-              </a:prstGeom>
-              <a:noFill/>
-            </p:spPr>
-            <p:txBody>
-              <a:bodyPr wrap="none" rtlCol="0">
-                <a:spAutoFit/>
-              </a:bodyPr>
-              <a:lstStyle/>
-              <a:p>
-                <a:r>
-                  <a:rPr lang="en-US" sz="3000" dirty="0" err="1"/>
-                  <a:t>mPFC</a:t>
-                </a:r>
-                <a:r>
-                  <a:rPr lang="en-US" sz="3000" dirty="0"/>
-                  <a:t> activation</a:t>
-                </a:r>
-              </a:p>
-            </p:txBody>
-          </p:sp>
-          <p:sp>
-            <p:nvSpPr>
-              <p:cNvPr id="15722" name="TextBox 15721">
-                <a:extLst>
-                  <a:ext uri="{FF2B5EF4-FFF2-40B4-BE49-F238E27FC236}">
-                    <a16:creationId xmlns:a16="http://schemas.microsoft.com/office/drawing/2014/main" id="{D6E3B518-3825-F962-6455-6381AEA6B615}"/>
-                  </a:ext>
-                </a:extLst>
-              </p:cNvPr>
-              <p:cNvSpPr txBox="1"/>
-              <p:nvPr/>
-            </p:nvSpPr>
-            <p:spPr>
-              <a:xfrm>
-                <a:off x="38109468" y="21552103"/>
-                <a:ext cx="445533" cy="411788"/>
-              </a:xfrm>
-              <a:prstGeom prst="rect">
-                <a:avLst/>
-              </a:prstGeom>
-              <a:noFill/>
-            </p:spPr>
-            <p:txBody>
-              <a:bodyPr wrap="none" rtlCol="0">
-                <a:spAutoFit/>
-              </a:bodyPr>
-              <a:lstStyle/>
-              <a:p>
-                <a:r>
-                  <a:rPr lang="en-US" sz="2800" dirty="0"/>
-                  <a:t>20</a:t>
-                </a:r>
-              </a:p>
-            </p:txBody>
-          </p:sp>
-          <p:sp>
-            <p:nvSpPr>
-              <p:cNvPr id="15723" name="TextBox 15722">
-                <a:extLst>
-                  <a:ext uri="{FF2B5EF4-FFF2-40B4-BE49-F238E27FC236}">
-                    <a16:creationId xmlns:a16="http://schemas.microsoft.com/office/drawing/2014/main" id="{8B001207-DE47-3A09-905A-EBCA2F9F5C56}"/>
-                  </a:ext>
-                </a:extLst>
-              </p:cNvPr>
-              <p:cNvSpPr txBox="1"/>
-              <p:nvPr/>
-            </p:nvSpPr>
-            <p:spPr>
-              <a:xfrm>
-                <a:off x="41781537" y="21614547"/>
-                <a:ext cx="445533" cy="411788"/>
-              </a:xfrm>
-              <a:prstGeom prst="rect">
-                <a:avLst/>
-              </a:prstGeom>
-              <a:noFill/>
-            </p:spPr>
-            <p:txBody>
-              <a:bodyPr wrap="none" rtlCol="0">
-                <a:spAutoFit/>
-              </a:bodyPr>
-              <a:lstStyle/>
-              <a:p>
-                <a:r>
-                  <a:rPr lang="en-US" sz="2800" dirty="0"/>
-                  <a:t>60</a:t>
-                </a:r>
-              </a:p>
-            </p:txBody>
-          </p:sp>
-          <p:sp>
-            <p:nvSpPr>
-              <p:cNvPr id="15724" name="TextBox 15723">
-                <a:extLst>
-                  <a:ext uri="{FF2B5EF4-FFF2-40B4-BE49-F238E27FC236}">
-                    <a16:creationId xmlns:a16="http://schemas.microsoft.com/office/drawing/2014/main" id="{A7A779AE-265E-DD6C-9D50-6736DE453C86}"/>
-                  </a:ext>
-                </a:extLst>
-              </p:cNvPr>
-              <p:cNvSpPr txBox="1"/>
-              <p:nvPr/>
-            </p:nvSpPr>
-            <p:spPr>
-              <a:xfrm>
-                <a:off x="39784621" y="21475323"/>
-                <a:ext cx="1096775" cy="707886"/>
+                <a:off x="25887039" y="21058834"/>
+                <a:ext cx="957831" cy="616607"/>
               </a:xfrm>
               <a:prstGeom prst="rect">
                 <a:avLst/>
@@ -10997,74 +10394,414 @@
               </a:p>
             </p:txBody>
           </p:sp>
+          <p:sp>
+            <p:nvSpPr>
+              <p:cNvPr id="15626" name="TextBox 15625">
+                <a:extLst>
+                  <a:ext uri="{FF2B5EF4-FFF2-40B4-BE49-F238E27FC236}">
+                    <a16:creationId xmlns:a16="http://schemas.microsoft.com/office/drawing/2014/main" id="{0741CC01-E666-6FF6-4DCF-5C0AEA54A228}"/>
+                  </a:ext>
+                </a:extLst>
+              </p:cNvPr>
+              <p:cNvSpPr txBox="1"/>
+              <p:nvPr/>
+            </p:nvSpPr>
+            <p:spPr>
+              <a:xfrm rot="16200000">
+                <a:off x="22278692" y="18345658"/>
+                <a:ext cx="3295551" cy="483815"/>
+              </a:xfrm>
+              <a:prstGeom prst="rect">
+                <a:avLst/>
+              </a:prstGeom>
+              <a:noFill/>
+            </p:spPr>
+            <p:txBody>
+              <a:bodyPr wrap="none" rtlCol="0">
+                <a:spAutoFit/>
+              </a:bodyPr>
+              <a:lstStyle/>
+              <a:p>
+                <a:r>
+                  <a:rPr lang="en-US" sz="3000" dirty="0"/>
+                  <a:t>Reciprocate &gt; Defect</a:t>
+                </a:r>
+              </a:p>
+            </p:txBody>
+          </p:sp>
         </p:grpSp>
         <p:sp>
           <p:nvSpPr>
-            <p:cNvPr id="15736" name="Rectangle 15735">
+            <p:cNvPr id="15632" name="TextBox 15631">
               <a:extLst>
                 <a:ext uri="{FF2B5EF4-FFF2-40B4-BE49-F238E27FC236}">
-                  <a16:creationId xmlns:a16="http://schemas.microsoft.com/office/drawing/2014/main" id="{885157CA-2A93-73F2-A17C-8ACD95507E22}"/>
+                  <a16:creationId xmlns:a16="http://schemas.microsoft.com/office/drawing/2014/main" id="{DB5643A6-0963-1889-743A-BE329E7DFA26}"/>
                 </a:ext>
               </a:extLst>
             </p:cNvPr>
-            <p:cNvSpPr/>
+            <p:cNvSpPr txBox="1"/>
             <p:nvPr/>
           </p:nvSpPr>
-          <p:spPr bwMode="auto">
+          <p:spPr>
             <a:xfrm>
-              <a:off x="38024698" y="15618426"/>
-              <a:ext cx="5330580" cy="5411310"/>
+              <a:off x="23532472" y="16411504"/>
+              <a:ext cx="601964" cy="387463"/>
             </a:xfrm>
             <a:prstGeom prst="rect">
               <a:avLst/>
             </a:prstGeom>
             <a:noFill/>
-            <a:ln w="38100" cap="flat" cmpd="sng" algn="ctr">
-              <a:solidFill>
-                <a:schemeClr val="tx1"/>
-              </a:solidFill>
-              <a:prstDash val="solid"/>
-              <a:round/>
-              <a:headEnd type="none" w="med" len="med"/>
-              <a:tailEnd type="none" w="med" len="med"/>
-            </a:ln>
-            <a:effectLst/>
           </p:spPr>
           <p:txBody>
-            <a:bodyPr vert="horz" wrap="square" lIns="91440" tIns="45720" rIns="91440" bIns="45720" numCol="1" rtlCol="0" anchor="t" anchorCtr="0" compatLnSpc="1">
-              <a:prstTxWarp prst="textNoShape">
-                <a:avLst/>
-              </a:prstTxWarp>
+            <a:bodyPr wrap="none" rtlCol="0">
+              <a:spAutoFit/>
             </a:bodyPr>
             <a:lstStyle/>
             <a:p>
-              <a:pPr marL="0" marR="0" indent="0" algn="l" defTabSz="4389438" rtl="0" eaLnBrk="1" fontAlgn="base" latinLnBrk="0" hangingPunct="1">
-                <a:lnSpc>
-                  <a:spcPct val="100000"/>
-                </a:lnSpc>
-                <a:spcBef>
-                  <a:spcPct val="0"/>
-                </a:spcBef>
-                <a:spcAft>
-                  <a:spcPct val="0"/>
-                </a:spcAft>
-                <a:buClrTx/>
-                <a:buSzTx/>
-                <a:buFontTx/>
-                <a:buNone/>
-                <a:tabLst/>
-              </a:pPr>
-              <a:endParaRPr kumimoji="0" lang="en-US" sz="1800" b="0" i="0" u="none" strike="noStrike" cap="none" normalizeH="0" baseline="0">
-                <a:ln>
-                  <a:noFill/>
-                </a:ln>
-                <a:solidFill>
-                  <a:schemeClr val="tx1"/>
-                </a:solidFill>
-                <a:effectLst/>
-                <a:latin typeface="Arial" charset="0"/>
-                <a:cs typeface="Arial" charset="0"/>
-              </a:endParaRPr>
+              <a:r>
+                <a:rPr lang="en-US" sz="2800" dirty="0"/>
+                <a:t>400</a:t>
+              </a:r>
+            </a:p>
+          </p:txBody>
+        </p:sp>
+        <p:sp>
+          <p:nvSpPr>
+            <p:cNvPr id="15633" name="TextBox 15632">
+              <a:extLst>
+                <a:ext uri="{FF2B5EF4-FFF2-40B4-BE49-F238E27FC236}">
+                  <a16:creationId xmlns:a16="http://schemas.microsoft.com/office/drawing/2014/main" id="{F005320C-94E9-2CF4-6842-98DA1FA46221}"/>
+                </a:ext>
+              </a:extLst>
+            </p:cNvPr>
+            <p:cNvSpPr txBox="1"/>
+            <p:nvPr/>
+          </p:nvSpPr>
+          <p:spPr>
+            <a:xfrm>
+              <a:off x="23611670" y="20489922"/>
+              <a:ext cx="694062" cy="387463"/>
+            </a:xfrm>
+            <a:prstGeom prst="rect">
+              <a:avLst/>
+            </a:prstGeom>
+            <a:noFill/>
+          </p:spPr>
+          <p:txBody>
+            <a:bodyPr wrap="none" rtlCol="0">
+              <a:spAutoFit/>
+            </a:bodyPr>
+            <a:lstStyle/>
+            <a:p>
+              <a:r>
+                <a:rPr lang="en-US" sz="2800" dirty="0"/>
+                <a:t>-200</a:t>
+              </a:r>
+            </a:p>
+          </p:txBody>
+        </p:sp>
+        <p:sp>
+          <p:nvSpPr>
+            <p:cNvPr id="15634" name="TextBox 15633">
+              <a:extLst>
+                <a:ext uri="{FF2B5EF4-FFF2-40B4-BE49-F238E27FC236}">
+                  <a16:creationId xmlns:a16="http://schemas.microsoft.com/office/drawing/2014/main" id="{E721D839-B7EC-B05A-38DA-D9704D0EBA2E}"/>
+                </a:ext>
+              </a:extLst>
+            </p:cNvPr>
+            <p:cNvSpPr txBox="1"/>
+            <p:nvPr/>
+          </p:nvSpPr>
+          <p:spPr>
+            <a:xfrm>
+              <a:off x="24150950" y="21022056"/>
+              <a:ext cx="448464" cy="387463"/>
+            </a:xfrm>
+            <a:prstGeom prst="rect">
+              <a:avLst/>
+            </a:prstGeom>
+            <a:noFill/>
+          </p:spPr>
+          <p:txBody>
+            <a:bodyPr wrap="none" rtlCol="0">
+              <a:spAutoFit/>
+            </a:bodyPr>
+            <a:lstStyle/>
+            <a:p>
+              <a:r>
+                <a:rPr lang="en-US" sz="2800" dirty="0"/>
+                <a:t>20</a:t>
+              </a:r>
+            </a:p>
+          </p:txBody>
+        </p:sp>
+        <p:sp>
+          <p:nvSpPr>
+            <p:cNvPr id="15635" name="TextBox 15634">
+              <a:extLst>
+                <a:ext uri="{FF2B5EF4-FFF2-40B4-BE49-F238E27FC236}">
+                  <a16:creationId xmlns:a16="http://schemas.microsoft.com/office/drawing/2014/main" id="{61C5ED5A-0A65-9C1A-0AC3-7712D59B3795}"/>
+                </a:ext>
+              </a:extLst>
+            </p:cNvPr>
+            <p:cNvSpPr txBox="1"/>
+            <p:nvPr/>
+          </p:nvSpPr>
+          <p:spPr>
+            <a:xfrm>
+              <a:off x="27777018" y="21022056"/>
+              <a:ext cx="448464" cy="387463"/>
+            </a:xfrm>
+            <a:prstGeom prst="rect">
+              <a:avLst/>
+            </a:prstGeom>
+            <a:noFill/>
+          </p:spPr>
+          <p:txBody>
+            <a:bodyPr wrap="none" rtlCol="0">
+              <a:spAutoFit/>
+            </a:bodyPr>
+            <a:lstStyle/>
+            <a:p>
+              <a:r>
+                <a:rPr lang="en-US" sz="2800" dirty="0"/>
+                <a:t>60</a:t>
+              </a:r>
+            </a:p>
+          </p:txBody>
+        </p:sp>
+      </p:grpSp>
+      <p:grpSp>
+        <p:nvGrpSpPr>
+          <p:cNvPr id="15726" name="Group 15725">
+            <a:extLst>
+              <a:ext uri="{FF2B5EF4-FFF2-40B4-BE49-F238E27FC236}">
+                <a16:creationId xmlns:a16="http://schemas.microsoft.com/office/drawing/2014/main" id="{B3430D81-BB79-4C3F-9F94-3445BBB422F8}"/>
+              </a:ext>
+            </a:extLst>
+          </p:cNvPr>
+          <p:cNvGrpSpPr/>
+          <p:nvPr/>
+        </p:nvGrpSpPr>
+        <p:grpSpPr>
+          <a:xfrm>
+            <a:off x="35263511" y="13754984"/>
+            <a:ext cx="6764367" cy="6581465"/>
+            <a:chOff x="37462544" y="16909110"/>
+            <a:chExt cx="5148037" cy="5179793"/>
+          </a:xfrm>
+        </p:grpSpPr>
+        <p:sp>
+          <p:nvSpPr>
+            <p:cNvPr id="15719" name="TextBox 15718">
+              <a:extLst>
+                <a:ext uri="{FF2B5EF4-FFF2-40B4-BE49-F238E27FC236}">
+                  <a16:creationId xmlns:a16="http://schemas.microsoft.com/office/drawing/2014/main" id="{F04F4CFA-B833-1DD9-86EC-A956DC37137A}"/>
+                </a:ext>
+              </a:extLst>
+            </p:cNvPr>
+            <p:cNvSpPr txBox="1"/>
+            <p:nvPr/>
+          </p:nvSpPr>
+          <p:spPr>
+            <a:xfrm>
+              <a:off x="37516370" y="16909110"/>
+              <a:ext cx="598030" cy="411788"/>
+            </a:xfrm>
+            <a:prstGeom prst="rect">
+              <a:avLst/>
+            </a:prstGeom>
+            <a:noFill/>
+          </p:spPr>
+          <p:txBody>
+            <a:bodyPr wrap="none" rtlCol="0">
+              <a:spAutoFit/>
+            </a:bodyPr>
+            <a:lstStyle/>
+            <a:p>
+              <a:r>
+                <a:rPr lang="en-US" sz="2800" dirty="0"/>
+                <a:t>400</a:t>
+              </a:r>
+            </a:p>
+          </p:txBody>
+        </p:sp>
+        <p:sp>
+          <p:nvSpPr>
+            <p:cNvPr id="15720" name="TextBox 15719">
+              <a:extLst>
+                <a:ext uri="{FF2B5EF4-FFF2-40B4-BE49-F238E27FC236}">
+                  <a16:creationId xmlns:a16="http://schemas.microsoft.com/office/drawing/2014/main" id="{0D17E5B2-CB95-D5BD-E169-9C1854A0AD37}"/>
+                </a:ext>
+              </a:extLst>
+            </p:cNvPr>
+            <p:cNvSpPr txBox="1"/>
+            <p:nvPr/>
+          </p:nvSpPr>
+          <p:spPr>
+            <a:xfrm>
+              <a:off x="37462544" y="20542022"/>
+              <a:ext cx="689526" cy="411788"/>
+            </a:xfrm>
+            <a:prstGeom prst="rect">
+              <a:avLst/>
+            </a:prstGeom>
+            <a:noFill/>
+          </p:spPr>
+          <p:txBody>
+            <a:bodyPr wrap="none" rtlCol="0">
+              <a:spAutoFit/>
+            </a:bodyPr>
+            <a:lstStyle/>
+            <a:p>
+              <a:r>
+                <a:rPr lang="en-US" sz="2800" dirty="0"/>
+                <a:t>-200</a:t>
+              </a:r>
+            </a:p>
+          </p:txBody>
+        </p:sp>
+        <p:sp>
+          <p:nvSpPr>
+            <p:cNvPr id="15721" name="TextBox 15720">
+              <a:extLst>
+                <a:ext uri="{FF2B5EF4-FFF2-40B4-BE49-F238E27FC236}">
+                  <a16:creationId xmlns:a16="http://schemas.microsoft.com/office/drawing/2014/main" id="{81E64089-644A-E436-A434-45AF685F62E1}"/>
+                </a:ext>
+              </a:extLst>
+            </p:cNvPr>
+            <p:cNvSpPr txBox="1"/>
+            <p:nvPr/>
+          </p:nvSpPr>
+          <p:spPr>
+            <a:xfrm rot="16200000">
+              <a:off x="36531370" y="18699129"/>
+              <a:ext cx="2471242" cy="440654"/>
+            </a:xfrm>
+            <a:prstGeom prst="rect">
+              <a:avLst/>
+            </a:prstGeom>
+            <a:noFill/>
+          </p:spPr>
+          <p:txBody>
+            <a:bodyPr wrap="none" rtlCol="0">
+              <a:spAutoFit/>
+            </a:bodyPr>
+            <a:lstStyle/>
+            <a:p>
+              <a:r>
+                <a:rPr lang="en-US" sz="3000" dirty="0" err="1"/>
+                <a:t>mPFC</a:t>
+              </a:r>
+              <a:r>
+                <a:rPr lang="en-US" sz="3000" dirty="0"/>
+                <a:t> activation</a:t>
+              </a:r>
+            </a:p>
+          </p:txBody>
+        </p:sp>
+        <p:sp>
+          <p:nvSpPr>
+            <p:cNvPr id="15722" name="TextBox 15721">
+              <a:extLst>
+                <a:ext uri="{FF2B5EF4-FFF2-40B4-BE49-F238E27FC236}">
+                  <a16:creationId xmlns:a16="http://schemas.microsoft.com/office/drawing/2014/main" id="{D6E3B518-3825-F962-6455-6381AEA6B615}"/>
+                </a:ext>
+              </a:extLst>
+            </p:cNvPr>
+            <p:cNvSpPr txBox="1"/>
+            <p:nvPr/>
+          </p:nvSpPr>
+          <p:spPr>
+            <a:xfrm>
+              <a:off x="38109468" y="21552103"/>
+              <a:ext cx="445533" cy="411788"/>
+            </a:xfrm>
+            <a:prstGeom prst="rect">
+              <a:avLst/>
+            </a:prstGeom>
+            <a:noFill/>
+          </p:spPr>
+          <p:txBody>
+            <a:bodyPr wrap="none" rtlCol="0">
+              <a:spAutoFit/>
+            </a:bodyPr>
+            <a:lstStyle/>
+            <a:p>
+              <a:r>
+                <a:rPr lang="en-US" sz="2800" dirty="0"/>
+                <a:t>20</a:t>
+              </a:r>
+            </a:p>
+          </p:txBody>
+        </p:sp>
+        <p:sp>
+          <p:nvSpPr>
+            <p:cNvPr id="15723" name="TextBox 15722">
+              <a:extLst>
+                <a:ext uri="{FF2B5EF4-FFF2-40B4-BE49-F238E27FC236}">
+                  <a16:creationId xmlns:a16="http://schemas.microsoft.com/office/drawing/2014/main" id="{8B001207-DE47-3A09-905A-EBCA2F9F5C56}"/>
+                </a:ext>
+              </a:extLst>
+            </p:cNvPr>
+            <p:cNvSpPr txBox="1"/>
+            <p:nvPr/>
+          </p:nvSpPr>
+          <p:spPr>
+            <a:xfrm>
+              <a:off x="42165048" y="21461542"/>
+              <a:ext cx="445533" cy="411788"/>
+            </a:xfrm>
+            <a:prstGeom prst="rect">
+              <a:avLst/>
+            </a:prstGeom>
+            <a:noFill/>
+          </p:spPr>
+          <p:txBody>
+            <a:bodyPr wrap="none" rtlCol="0">
+              <a:spAutoFit/>
+            </a:bodyPr>
+            <a:lstStyle/>
+            <a:p>
+              <a:r>
+                <a:rPr lang="en-US" sz="2800" dirty="0"/>
+                <a:t>70</a:t>
+              </a:r>
+            </a:p>
+          </p:txBody>
+        </p:sp>
+        <p:sp>
+          <p:nvSpPr>
+            <p:cNvPr id="15724" name="TextBox 15723">
+              <a:extLst>
+                <a:ext uri="{FF2B5EF4-FFF2-40B4-BE49-F238E27FC236}">
+                  <a16:creationId xmlns:a16="http://schemas.microsoft.com/office/drawing/2014/main" id="{A7A779AE-265E-DD6C-9D50-6736DE453C86}"/>
+                </a:ext>
+              </a:extLst>
+            </p:cNvPr>
+            <p:cNvSpPr txBox="1"/>
+            <p:nvPr/>
+          </p:nvSpPr>
+          <p:spPr>
+            <a:xfrm>
+              <a:off x="39987911" y="21381017"/>
+              <a:ext cx="1096775" cy="707886"/>
+            </a:xfrm>
+            <a:prstGeom prst="rect">
+              <a:avLst/>
+            </a:prstGeom>
+            <a:noFill/>
+          </p:spPr>
+          <p:txBody>
+            <a:bodyPr wrap="none" rtlCol="0">
+              <a:spAutoFit/>
+            </a:bodyPr>
+            <a:lstStyle/>
+            <a:p>
+              <a:r>
+                <a:rPr lang="en-US" sz="4000" dirty="0"/>
+                <a:t>Age</a:t>
+              </a:r>
             </a:p>
           </p:txBody>
         </p:sp>
@@ -11083,10 +10820,10 @@
         </p:nvGrpSpPr>
         <p:grpSpPr>
           <a:xfrm>
-            <a:off x="35398188" y="4514399"/>
-            <a:ext cx="8025077" cy="7764103"/>
-            <a:chOff x="37564868" y="5920531"/>
-            <a:chExt cx="6139033" cy="6306638"/>
+            <a:off x="35398192" y="5817533"/>
+            <a:ext cx="6887588" cy="6463045"/>
+            <a:chOff x="37564868" y="6979043"/>
+            <a:chExt cx="5268875" cy="5249812"/>
           </a:xfrm>
         </p:grpSpPr>
         <p:sp>
@@ -11208,7 +10945,7 @@
           </p:nvSpPr>
           <p:spPr>
             <a:xfrm>
-              <a:off x="41883268" y="11791390"/>
+              <a:off x="42385910" y="11803853"/>
               <a:ext cx="447833" cy="425002"/>
             </a:xfrm>
             <a:prstGeom prst="rect">
@@ -11224,7 +10961,7 @@
             <a:p>
               <a:r>
                 <a:rPr lang="en-US" sz="2800" dirty="0"/>
-                <a:t>60</a:t>
+                <a:t>70</a:t>
               </a:r>
             </a:p>
           </p:txBody>
@@ -11261,44 +10998,6 @@
             </a:p>
           </p:txBody>
         </p:sp>
-        <p:pic>
-          <p:nvPicPr>
-            <p:cNvPr id="15650" name="Graphic 15649">
-              <a:extLst>
-                <a:ext uri="{FF2B5EF4-FFF2-40B4-BE49-F238E27FC236}">
-                  <a16:creationId xmlns:a16="http://schemas.microsoft.com/office/drawing/2014/main" id="{A066B4DE-396E-E58D-5D45-BFC7D72F81D7}"/>
-                </a:ext>
-              </a:extLst>
-            </p:cNvPr>
-            <p:cNvPicPr>
-              <a:picLocks noChangeAspect="1"/>
-            </p:cNvPicPr>
-            <p:nvPr/>
-          </p:nvPicPr>
-          <p:blipFill rotWithShape="1">
-            <a:blip r:embed="rId22">
-              <a:extLst>
-                <a:ext uri="{28A0092B-C50C-407E-A947-70E740481C1C}">
-                  <a14:useLocalDpi xmlns:a14="http://schemas.microsoft.com/office/drawing/2010/main" val="0"/>
-                </a:ext>
-                <a:ext uri="{96DAC541-7B7A-43D3-8B79-37D633B846F1}">
-                  <asvg:svgBlip xmlns:asvg="http://schemas.microsoft.com/office/drawing/2016/SVG/main" r:embed="rId23"/>
-                </a:ext>
-              </a:extLst>
-            </a:blip>
-            <a:srcRect l="10653" b="8997"/>
-            <a:stretch/>
-          </p:blipFill>
-          <p:spPr>
-            <a:xfrm>
-              <a:off x="38145721" y="5920531"/>
-              <a:ext cx="5558180" cy="5870860"/>
-            </a:xfrm>
-            <a:prstGeom prst="rect">
-              <a:avLst/>
-            </a:prstGeom>
-          </p:spPr>
-        </p:pic>
         <p:sp>
           <p:nvSpPr>
             <p:cNvPr id="15715" name="TextBox 15714">
@@ -11338,76 +11037,6 @@
             </a:p>
           </p:txBody>
         </p:sp>
-        <p:sp>
-          <p:nvSpPr>
-            <p:cNvPr id="15737" name="Rectangle 15736">
-              <a:extLst>
-                <a:ext uri="{FF2B5EF4-FFF2-40B4-BE49-F238E27FC236}">
-                  <a16:creationId xmlns:a16="http://schemas.microsoft.com/office/drawing/2014/main" id="{EEA0696C-64C6-F5A4-E63B-F257E6A68B97}"/>
-                </a:ext>
-              </a:extLst>
-            </p:cNvPr>
-            <p:cNvSpPr/>
-            <p:nvPr/>
-          </p:nvSpPr>
-          <p:spPr bwMode="auto">
-            <a:xfrm>
-              <a:off x="38192920" y="6275932"/>
-              <a:ext cx="5330580" cy="5411310"/>
-            </a:xfrm>
-            <a:prstGeom prst="rect">
-              <a:avLst/>
-            </a:prstGeom>
-            <a:noFill/>
-            <a:ln w="38100" cap="flat" cmpd="sng" algn="ctr">
-              <a:solidFill>
-                <a:schemeClr val="tx1"/>
-              </a:solidFill>
-              <a:prstDash val="solid"/>
-              <a:round/>
-              <a:headEnd type="none" w="med" len="med"/>
-              <a:tailEnd type="none" w="med" len="med"/>
-            </a:ln>
-            <a:effectLst/>
-          </p:spPr>
-          <p:txBody>
-            <a:bodyPr vert="horz" wrap="square" lIns="91440" tIns="45720" rIns="91440" bIns="45720" numCol="1" rtlCol="0" anchor="t" anchorCtr="0" compatLnSpc="1">
-              <a:prstTxWarp prst="textNoShape">
-                <a:avLst/>
-              </a:prstTxWarp>
-            </a:bodyPr>
-            <a:lstStyle/>
-            <a:p>
-              <a:pPr marL="0" marR="0" indent="0" algn="l" defTabSz="4389438" rtl="0" eaLnBrk="1" fontAlgn="base" latinLnBrk="0" hangingPunct="1">
-                <a:lnSpc>
-                  <a:spcPct val="100000"/>
-                </a:lnSpc>
-                <a:spcBef>
-                  <a:spcPct val="0"/>
-                </a:spcBef>
-                <a:spcAft>
-                  <a:spcPct val="0"/>
-                </a:spcAft>
-                <a:buClrTx/>
-                <a:buSzTx/>
-                <a:buFontTx/>
-                <a:buNone/>
-                <a:tabLst/>
-              </a:pPr>
-              <a:endParaRPr kumimoji="0" lang="en-US" sz="1800" b="0" i="0" u="none" strike="noStrike" cap="none" normalizeH="0" baseline="0">
-                <a:ln>
-                  <a:noFill/>
-                </a:ln>
-                <a:solidFill>
-                  <a:schemeClr val="tx1"/>
-                </a:solidFill>
-                <a:effectLst/>
-                <a:latin typeface="Arial" charset="0"/>
-                <a:cs typeface="Arial" charset="0"/>
-              </a:endParaRPr>
-            </a:p>
-          </p:txBody>
-        </p:sp>
       </p:grpSp>
       <p:pic>
         <p:nvPicPr>
@@ -11424,7 +11053,7 @@
           <p:nvPr/>
         </p:nvPicPr>
         <p:blipFill>
-          <a:blip r:embed="rId24">
+          <a:blip r:embed="rId18">
             <a:extLst>
               <a:ext uri="{28A0092B-C50C-407E-A947-70E740481C1C}">
                 <a14:useLocalDpi xmlns:a14="http://schemas.microsoft.com/office/drawing/2010/main" val="0"/>
@@ -11471,7 +11100,7 @@
           <p:nvPr/>
         </p:nvPicPr>
         <p:blipFill>
-          <a:blip r:embed="rId24">
+          <a:blip r:embed="rId18">
             <a:extLst>
               <a:ext uri="{28A0092B-C50C-407E-A947-70E740481C1C}">
                 <a14:useLocalDpi xmlns:a14="http://schemas.microsoft.com/office/drawing/2010/main" val="0"/>
@@ -11518,7 +11147,7 @@
           <p:nvPr/>
         </p:nvPicPr>
         <p:blipFill>
-          <a:blip r:embed="rId25">
+          <a:blip r:embed="rId19">
             <a:extLst>
               <a:ext uri="{28A0092B-C50C-407E-A947-70E740481C1C}">
                 <a14:useLocalDpi xmlns:a14="http://schemas.microsoft.com/office/drawing/2010/main" val="0"/>
@@ -11565,7 +11194,7 @@
           <p:nvPr/>
         </p:nvPicPr>
         <p:blipFill>
-          <a:blip r:embed="rId26">
+          <a:blip r:embed="rId20">
             <a:extLst>
               <a:ext uri="{28A0092B-C50C-407E-A947-70E740481C1C}">
                 <a14:useLocalDpi xmlns:a14="http://schemas.microsoft.com/office/drawing/2010/main" val="0"/>
@@ -11973,13 +11602,13 @@
           <p:nvPr/>
         </p:nvPicPr>
         <p:blipFill rotWithShape="1">
-          <a:blip r:embed="rId27">
+          <a:blip r:embed="rId21">
             <a:extLst>
               <a:ext uri="{28A0092B-C50C-407E-A947-70E740481C1C}">
                 <a14:useLocalDpi xmlns:a14="http://schemas.microsoft.com/office/drawing/2010/main" val="0"/>
               </a:ext>
               <a:ext uri="{96DAC541-7B7A-43D3-8B79-37D633B846F1}">
-                <asvg:svgBlip xmlns:asvg="http://schemas.microsoft.com/office/drawing/2016/SVG/main" r:embed="rId28"/>
+                <asvg:svgBlip xmlns:asvg="http://schemas.microsoft.com/office/drawing/2016/SVG/main" r:embed="rId22"/>
               </a:ext>
             </a:extLst>
           </a:blip>
@@ -12011,9 +11640,9 @@
         <p:grpSpPr>
           <a:xfrm>
             <a:off x="15661773" y="13603786"/>
-            <a:ext cx="6919486" cy="5929306"/>
+            <a:ext cx="6786687" cy="5929306"/>
             <a:chOff x="15661774" y="13558986"/>
-            <a:chExt cx="6906547" cy="6069205"/>
+            <a:chExt cx="6773997" cy="6069205"/>
           </a:xfrm>
         </p:grpSpPr>
         <p:grpSp>
@@ -12262,23 +11891,23 @@
             <p:nvPr/>
           </p:nvPicPr>
           <p:blipFill rotWithShape="1">
-            <a:blip r:embed="rId29">
+            <a:blip r:embed="rId23">
               <a:extLst>
                 <a:ext uri="{28A0092B-C50C-407E-A947-70E740481C1C}">
                   <a14:useLocalDpi xmlns:a14="http://schemas.microsoft.com/office/drawing/2010/main" val="0"/>
                 </a:ext>
                 <a:ext uri="{96DAC541-7B7A-43D3-8B79-37D633B846F1}">
-                  <asvg:svgBlip xmlns:asvg="http://schemas.microsoft.com/office/drawing/2016/SVG/main" r:embed="rId30"/>
+                  <asvg:svgBlip xmlns:asvg="http://schemas.microsoft.com/office/drawing/2016/SVG/main" r:embed="rId24"/>
                 </a:ext>
               </a:extLst>
             </a:blip>
-            <a:srcRect l="14908" t="13111" r="4415" b="16123"/>
+            <a:srcRect l="15526" t="13111" r="4415" b="16123"/>
             <a:stretch/>
           </p:blipFill>
           <p:spPr>
             <a:xfrm>
-              <a:off x="16243525" y="13558986"/>
-              <a:ext cx="6324796" cy="5570606"/>
+              <a:off x="16334560" y="13558986"/>
+              <a:ext cx="6010236" cy="5570606"/>
             </a:xfrm>
             <a:prstGeom prst="rect">
               <a:avLst/>
@@ -12608,13 +12237,13 @@
             <p:nvPr/>
           </p:nvPicPr>
           <p:blipFill rotWithShape="1">
-            <a:blip r:embed="rId31">
+            <a:blip r:embed="rId25">
               <a:extLst>
                 <a:ext uri="{28A0092B-C50C-407E-A947-70E740481C1C}">
                   <a14:useLocalDpi xmlns:a14="http://schemas.microsoft.com/office/drawing/2010/main" val="0"/>
                 </a:ext>
                 <a:ext uri="{96DAC541-7B7A-43D3-8B79-37D633B846F1}">
-                  <asvg:svgBlip xmlns:asvg="http://schemas.microsoft.com/office/drawing/2016/SVG/main" r:embed="rId32"/>
+                  <asvg:svgBlip xmlns:asvg="http://schemas.microsoft.com/office/drawing/2016/SVG/main" r:embed="rId26"/>
                 </a:ext>
               </a:extLst>
             </a:blip>
@@ -12632,6 +12261,120 @@
           </p:spPr>
         </p:pic>
       </p:grpSp>
+      <p:pic>
+        <p:nvPicPr>
+          <p:cNvPr id="14" name="Graphic 13">
+            <a:extLst>
+              <a:ext uri="{FF2B5EF4-FFF2-40B4-BE49-F238E27FC236}">
+                <a16:creationId xmlns:a16="http://schemas.microsoft.com/office/drawing/2014/main" id="{0DBA9C41-5EEA-0E79-D93D-F2C5795C3DCD}"/>
+              </a:ext>
+            </a:extLst>
+          </p:cNvPr>
+          <p:cNvPicPr>
+            <a:picLocks noChangeAspect="1"/>
+          </p:cNvPicPr>
+          <p:nvPr/>
+        </p:nvPicPr>
+        <p:blipFill rotWithShape="1">
+          <a:blip r:embed="rId27">
+            <a:extLst>
+              <a:ext uri="{28A0092B-C50C-407E-A947-70E740481C1C}">
+                <a14:useLocalDpi xmlns:a14="http://schemas.microsoft.com/office/drawing/2010/main" val="0"/>
+              </a:ext>
+              <a:ext uri="{96DAC541-7B7A-43D3-8B79-37D633B846F1}">
+                <asvg:svgBlip xmlns:asvg="http://schemas.microsoft.com/office/drawing/2016/SVG/main" r:embed="rId28"/>
+              </a:ext>
+            </a:extLst>
+          </a:blip>
+          <a:srcRect l="18562" t="11969" r="3825" b="15026"/>
+          <a:stretch/>
+        </p:blipFill>
+        <p:spPr>
+          <a:xfrm>
+            <a:off x="23160827" y="23793039"/>
+            <a:ext cx="6466501" cy="5861542"/>
+          </a:xfrm>
+          <a:prstGeom prst="rect">
+            <a:avLst/>
+          </a:prstGeom>
+        </p:spPr>
+      </p:pic>
+      <p:pic>
+        <p:nvPicPr>
+          <p:cNvPr id="33" name="Graphic 32">
+            <a:extLst>
+              <a:ext uri="{FF2B5EF4-FFF2-40B4-BE49-F238E27FC236}">
+                <a16:creationId xmlns:a16="http://schemas.microsoft.com/office/drawing/2014/main" id="{6675D385-CC29-7E91-4E7F-87D48DE5C9A4}"/>
+              </a:ext>
+            </a:extLst>
+          </p:cNvPr>
+          <p:cNvPicPr>
+            <a:picLocks noChangeAspect="1"/>
+          </p:cNvPicPr>
+          <p:nvPr/>
+        </p:nvPicPr>
+        <p:blipFill rotWithShape="1">
+          <a:blip r:embed="rId29">
+            <a:extLst>
+              <a:ext uri="{28A0092B-C50C-407E-A947-70E740481C1C}">
+                <a14:useLocalDpi xmlns:a14="http://schemas.microsoft.com/office/drawing/2010/main" val="0"/>
+              </a:ext>
+              <a:ext uri="{96DAC541-7B7A-43D3-8B79-37D633B846F1}">
+                <asvg:svgBlip xmlns:asvg="http://schemas.microsoft.com/office/drawing/2016/SVG/main" r:embed="rId30"/>
+              </a:ext>
+            </a:extLst>
+          </a:blip>
+          <a:srcRect l="18919" t="11022" r="2620" b="15715"/>
+          <a:stretch/>
+        </p:blipFill>
+        <p:spPr>
+          <a:xfrm>
+            <a:off x="36133103" y="5701660"/>
+            <a:ext cx="6627629" cy="5963480"/>
+          </a:xfrm>
+          <a:prstGeom prst="rect">
+            <a:avLst/>
+          </a:prstGeom>
+        </p:spPr>
+      </p:pic>
+      <p:pic>
+        <p:nvPicPr>
+          <p:cNvPr id="40" name="Graphic 39">
+            <a:extLst>
+              <a:ext uri="{FF2B5EF4-FFF2-40B4-BE49-F238E27FC236}">
+                <a16:creationId xmlns:a16="http://schemas.microsoft.com/office/drawing/2014/main" id="{41694A69-FEA8-BBFE-413A-1817DD4A1775}"/>
+              </a:ext>
+            </a:extLst>
+          </p:cNvPr>
+          <p:cNvPicPr>
+            <a:picLocks noChangeAspect="1"/>
+          </p:cNvPicPr>
+          <p:nvPr/>
+        </p:nvPicPr>
+        <p:blipFill rotWithShape="1">
+          <a:blip r:embed="rId31">
+            <a:extLst>
+              <a:ext uri="{28A0092B-C50C-407E-A947-70E740481C1C}">
+                <a14:useLocalDpi xmlns:a14="http://schemas.microsoft.com/office/drawing/2010/main" val="0"/>
+              </a:ext>
+              <a:ext uri="{96DAC541-7B7A-43D3-8B79-37D633B846F1}">
+                <asvg:svgBlip xmlns:asvg="http://schemas.microsoft.com/office/drawing/2016/SVG/main" r:embed="rId32"/>
+              </a:ext>
+            </a:extLst>
+          </a:blip>
+          <a:srcRect l="18942" t="11890" r="2700" b="15431"/>
+          <a:stretch/>
+        </p:blipFill>
+        <p:spPr>
+          <a:xfrm>
+            <a:off x="36252115" y="13880865"/>
+            <a:ext cx="6114905" cy="5465499"/>
+          </a:xfrm>
+          <a:prstGeom prst="rect">
+            <a:avLst/>
+          </a:prstGeom>
+        </p:spPr>
+      </p:pic>
     </p:spTree>
   </p:cSld>
   <p:clrMapOvr>
@@ -18830,6 +18573,15 @@
 </file>
 
 <file path=customXml/item1.xml><?xml version="1.0" encoding="utf-8"?>
+<?mso-contentType ?>
+<FormTemplates xmlns="http://schemas.microsoft.com/sharepoint/v3/contenttype/forms">
+  <Display>DocumentLibraryForm</Display>
+  <Edit>DocumentLibraryForm</Edit>
+  <New>DocumentLibraryForm</New>
+</FormTemplates>
+</file>
+
+<file path=customXml/item2.xml><?xml version="1.0" encoding="utf-8"?>
 <ct:contentTypeSchema xmlns:ct="http://schemas.microsoft.com/office/2006/metadata/contentType" xmlns:ma="http://schemas.microsoft.com/office/2006/metadata/properties/metaAttributes" ct:_="" ma:_="" ma:contentTypeName="Document" ma:contentTypeID="0x01010080DE0AC601CE7945A16C28BE7D604718" ma:contentTypeVersion="16" ma:contentTypeDescription="Create a new document." ma:contentTypeScope="" ma:versionID="7200742d51933ad5859751156d985908">
   <xsd:schema xmlns:xsd="http://www.w3.org/2001/XMLSchema" xmlns:xs="http://www.w3.org/2001/XMLSchema" xmlns:p="http://schemas.microsoft.com/office/2006/metadata/properties" xmlns:ns2="068132b6-27af-4cc5-9624-46e0bc309f9c" xmlns:ns3="1ec1d487-840c-40ff-aca1-00ff13008544" targetNamespace="http://schemas.microsoft.com/office/2006/metadata/properties" ma:root="true" ma:fieldsID="ef3bb859774f4d5f12e6e11e5f5551df" ns2:_="" ns3:_="">
     <xsd:import namespace="068132b6-27af-4cc5-9624-46e0bc309f9c"/>
@@ -19072,16 +18824,15 @@
 </ct:contentTypeSchema>
 </file>
 
-<file path=customXml/item2.xml><?xml version="1.0" encoding="utf-8"?>
-<?mso-contentType ?>
-<FormTemplates xmlns="http://schemas.microsoft.com/sharepoint/v3/contenttype/forms">
-  <Display>DocumentLibraryForm</Display>
-  <Edit>DocumentLibraryForm</Edit>
-  <New>DocumentLibraryForm</New>
-</FormTemplates>
+<file path=customXml/itemProps1.xml><?xml version="1.0" encoding="utf-8"?>
+<ds:datastoreItem xmlns:ds="http://schemas.openxmlformats.org/officeDocument/2006/customXml" ds:itemID="{D5CAE7E8-1A3A-4A91-86FB-BA9E1762341A}">
+  <ds:schemaRefs>
+    <ds:schemaRef ds:uri="http://schemas.microsoft.com/sharepoint/v3/contenttype/forms"/>
+  </ds:schemaRefs>
+</ds:datastoreItem>
 </file>
 
-<file path=customXml/itemProps1.xml><?xml version="1.0" encoding="utf-8"?>
+<file path=customXml/itemProps2.xml><?xml version="1.0" encoding="utf-8"?>
 <ds:datastoreItem xmlns:ds="http://schemas.openxmlformats.org/officeDocument/2006/customXml" ds:itemID="{36138A07-987C-4A73-AAED-022482DDD0A4}">
   <ds:schemaRefs>
     <ds:schemaRef ds:uri="068132b6-27af-4cc5-9624-46e0bc309f9c"/>
@@ -19098,12 +18849,4 @@
     <ds:schemaRef ds:uri="http://www.w3.org/2001/XMLSchema"/>
   </ds:schemaRefs>
 </ds:datastoreItem>
-</file>
-
-<file path=customXml/itemProps2.xml><?xml version="1.0" encoding="utf-8"?>
-<ds:datastoreItem xmlns:ds="http://schemas.openxmlformats.org/officeDocument/2006/customXml" ds:itemID="{D5CAE7E8-1A3A-4A91-86FB-BA9E1762341A}">
-  <ds:schemaRefs>
-    <ds:schemaRef ds:uri="http://schemas.microsoft.com/sharepoint/v3/contenttype/forms"/>
-  </ds:schemaRefs>
-</ds:datastoreItem>
 </file>
</xml_diff>

<commit_message>
Updated for Dave and Dominic
</commit_message>
<xml_diff>
--- a/SFN/2023_SFN_trust.pptx
+++ b/SFN/2023_SFN_trust.pptx
@@ -12856,8 +12856,8 @@
         </p:nvGrpSpPr>
         <p:grpSpPr>
           <a:xfrm>
-            <a:off x="10912317" y="28607914"/>
-            <a:ext cx="3543576" cy="1716829"/>
+            <a:off x="12078302" y="29152243"/>
+            <a:ext cx="2276038" cy="1215276"/>
             <a:chOff x="11083249" y="26380930"/>
             <a:chExt cx="3543576" cy="1716829"/>
           </a:xfrm>
@@ -12951,7 +12951,7 @@
           <p:spPr>
             <a:xfrm>
               <a:off x="11186208" y="26454514"/>
-              <a:ext cx="3386365" cy="1569660"/>
+              <a:ext cx="3386365" cy="475748"/>
             </a:xfrm>
             <a:prstGeom prst="rect">
               <a:avLst/>
@@ -12969,24 +12969,24 @@
             <a:p>
               <a:pPr algn="ctr"/>
               <a:r>
-                <a:rPr lang="en-US" sz="3200" b="1" dirty="0">
+                <a:rPr lang="en-US" sz="2000" b="1" dirty="0">
                   <a:latin typeface="Helvetica"/>
                   <a:ea typeface="MS PGothic"/>
                 </a:rPr>
                 <a:t>Scan the QR code to see the</a:t>
               </a:r>
-              <a:endParaRPr lang="en-US" sz="3200" b="1" dirty="0"/>
+              <a:endParaRPr lang="en-US" sz="2000" b="1" dirty="0"/>
             </a:p>
             <a:p>
               <a:pPr algn="ctr"/>
               <a:r>
-                <a:rPr lang="en-US" sz="3200" b="1" dirty="0">
+                <a:rPr lang="en-US" sz="2000" b="1" dirty="0">
                   <a:latin typeface="Helvetica"/>
                   <a:ea typeface="MS PGothic"/>
                 </a:rPr>
                 <a:t>Pre-registration!</a:t>
               </a:r>
-              <a:endParaRPr lang="en-US" sz="3200" b="1" dirty="0"/>
+              <a:endParaRPr lang="en-US" sz="2000" b="1" dirty="0"/>
             </a:p>
           </p:txBody>
         </p:sp>
@@ -13013,7 +13013,7 @@
         </p:blipFill>
         <p:spPr>
           <a:xfrm>
-            <a:off x="11507902" y="26012680"/>
+            <a:off x="12039403" y="26237378"/>
             <a:ext cx="2340933" cy="2333025"/>
           </a:xfrm>
           <a:prstGeom prst="rect">
@@ -13812,8 +13812,8 @@
         </p:nvSpPr>
         <p:spPr>
           <a:xfrm>
-            <a:off x="15472636" y="30409771"/>
-            <a:ext cx="14650695" cy="1569660"/>
+            <a:off x="15511210" y="30424481"/>
+            <a:ext cx="14212155" cy="2062103"/>
           </a:xfrm>
           <a:prstGeom prst="rect">
             <a:avLst/>
@@ -13832,7 +13832,7 @@
                 <a:latin typeface="Helvetica"/>
                 <a:ea typeface="MS PGothic"/>
               </a:rPr>
-              <a:t>We found activation in the VS when participants were presented with a reciprocate outcome as opposed to a defect outcome, however, there was no significant interaction with age.  </a:t>
+              <a:t>We found activation in the ventral striatum (VS) when participants were presented with a reciprocate outcome as opposed to a defect outcome, however, there was no significant association with age for any condition (Friend &gt; Stranger and Friend &gt; Computer).  </a:t>
             </a:r>
           </a:p>
         </p:txBody>
@@ -13896,10 +13896,10 @@
         </p:nvGrpSpPr>
         <p:grpSpPr>
           <a:xfrm>
-            <a:off x="16139778" y="23993605"/>
-            <a:ext cx="5301753" cy="5349637"/>
-            <a:chOff x="14804687" y="15406812"/>
-            <a:chExt cx="6982983" cy="7047494"/>
+            <a:off x="16012194" y="23993603"/>
+            <a:ext cx="5429343" cy="5001859"/>
+            <a:chOff x="14636639" y="15406812"/>
+            <a:chExt cx="7151031" cy="6589340"/>
           </a:xfrm>
         </p:grpSpPr>
         <p:pic>
@@ -13946,8 +13946,8 @@
           </p:nvSpPr>
           <p:spPr>
             <a:xfrm>
-              <a:off x="14968255" y="21477908"/>
-              <a:ext cx="2635746" cy="976398"/>
+              <a:off x="15108298" y="21225782"/>
+              <a:ext cx="1193324" cy="770370"/>
             </a:xfrm>
             <a:prstGeom prst="rect">
               <a:avLst/>
@@ -13961,20 +13961,11 @@
             <a:lstStyle/>
             <a:p>
               <a:r>
-                <a:rPr lang="en-US" dirty="0">
-                  <a:latin typeface="Helvetica"/>
-                  <a:ea typeface="MS PGothic"/>
-                </a:rPr>
-                <a:t>Ventral Striatum</a:t>
-              </a:r>
-            </a:p>
-            <a:p>
-              <a:r>
                 <a:rPr lang="en-US" sz="3200" b="1" dirty="0">
                   <a:latin typeface="Helvetica"/>
                   <a:ea typeface="MS PGothic"/>
                 </a:rPr>
-                <a:t>(VS)</a:t>
+                <a:t>VS</a:t>
               </a:r>
               <a:endParaRPr lang="en-US" sz="3200" b="1" dirty="0">
                 <a:latin typeface="Helvetica"/>
@@ -13996,8 +13987,8 @@
           </p:nvSpPr>
           <p:spPr>
             <a:xfrm>
-              <a:off x="14804687" y="15690148"/>
-              <a:ext cx="2222101" cy="1500194"/>
+              <a:off x="14636639" y="15690148"/>
+              <a:ext cx="2222101" cy="1500193"/>
             </a:xfrm>
             <a:prstGeom prst="rect">
               <a:avLst/>
@@ -14352,8 +14343,8 @@
         </p:nvSpPr>
         <p:spPr>
           <a:xfrm>
-            <a:off x="30912368" y="25095850"/>
-            <a:ext cx="12496564" cy="7068602"/>
+            <a:off x="30892503" y="25333818"/>
+            <a:ext cx="12496564" cy="6453049"/>
           </a:xfrm>
           <a:prstGeom prst="rect">
             <a:avLst/>
@@ -14432,7 +14423,7 @@
                 <a:ea typeface="MS PGothic"/>
                 <a:cs typeface="Helvetica"/>
               </a:rPr>
-              <a:t> Additionally, we find that the </a:t>
+              <a:t> Additionally, we find that activation of the </a:t>
             </a:r>
             <a:r>
               <a:rPr lang="en-US" sz="4000" b="1" dirty="0" err="1">
@@ -14443,12 +14434,20 @@
               <a:t>dlPFC</a:t>
             </a:r>
             <a:r>
+              <a:rPr lang="en-US" sz="4000" b="1" dirty="0">
+                <a:latin typeface="Helvetica"/>
+                <a:ea typeface="MS PGothic"/>
+                <a:cs typeface="Helvetica"/>
+              </a:rPr>
+              <a:t> increased, </a:t>
+            </a:r>
+            <a:r>
               <a:rPr lang="en-US" sz="4000" dirty="0">
                 <a:latin typeface="Helvetica"/>
                 <a:ea typeface="MS PGothic"/>
                 <a:cs typeface="Helvetica"/>
               </a:rPr>
-              <a:t> and </a:t>
+              <a:t>and </a:t>
             </a:r>
             <a:r>
               <a:rPr lang="en-US" sz="4000" b="1" dirty="0" err="1">
@@ -14464,7 +14463,7 @@
                 <a:ea typeface="MS PGothic"/>
                 <a:cs typeface="Helvetica"/>
               </a:rPr>
-              <a:t> activation </a:t>
+              <a:t> </a:t>
             </a:r>
             <a:r>
               <a:rPr lang="en-US" sz="4000" b="1" dirty="0">
@@ -14472,7 +14471,7 @@
                 <a:ea typeface="MS PGothic"/>
                 <a:cs typeface="Helvetica"/>
               </a:rPr>
-              <a:t>differs between older and younger adults </a:t>
+              <a:t>decreased,</a:t>
             </a:r>
             <a:r>
               <a:rPr lang="en-US" sz="4000" dirty="0">
@@ -14480,7 +14479,23 @@
                 <a:ea typeface="MS PGothic"/>
                 <a:cs typeface="Helvetica"/>
               </a:rPr>
-              <a:t>relative to social context. </a:t>
+              <a:t> during the processing of social outcomes </a:t>
+            </a:r>
+            <a:r>
+              <a:rPr lang="en-US" sz="4000" b="1" dirty="0">
+                <a:latin typeface="Helvetica"/>
+                <a:ea typeface="MS PGothic"/>
+                <a:cs typeface="Helvetica"/>
+              </a:rPr>
+              <a:t>as a function of age</a:t>
+            </a:r>
+            <a:r>
+              <a:rPr lang="en-US" sz="4000" dirty="0">
+                <a:latin typeface="Helvetica"/>
+                <a:ea typeface="MS PGothic"/>
+                <a:cs typeface="Helvetica"/>
+              </a:rPr>
+              <a:t>. </a:t>
             </a:r>
           </a:p>
           <a:p>
@@ -14523,7 +14538,7 @@
                 <a:ea typeface="MS PGothic"/>
                 <a:cs typeface="Helvetica"/>
               </a:rPr>
-              <a:t>Future analyses will further examine age-related differences in neural responses to monetary outcomes relative to social context and risk of financial exploitation. </a:t>
+              <a:t>Future analyses will examine how neural and behavioral responses to trust are associated with risk for financial exploitation. </a:t>
             </a:r>
             <a:endParaRPr lang="en-US" sz="4000" b="1" dirty="0">
               <a:latin typeface="Helvetica"/>
@@ -14543,7 +14558,7 @@
         </p:nvSpPr>
         <p:spPr bwMode="auto">
           <a:xfrm>
-            <a:off x="473574" y="4727572"/>
+            <a:off x="283673" y="4727486"/>
             <a:ext cx="14526988" cy="6247864"/>
           </a:xfrm>
           <a:prstGeom prst="rect">
@@ -14711,7 +14726,7 @@
                 <a:effectLst/>
                 <a:latin typeface="Helvetica" pitchFamily="2" charset="0"/>
               </a:rPr>
-              <a:t>Social relationships influence our behaviors and may modulate our neural responses to reward. (</a:t>
+              <a:t>Social relationships influence our behaviors and modulate our neural responses to reward (</a:t>
             </a:r>
             <a:r>
               <a:rPr lang="en-US" sz="4000" b="0" i="0" dirty="0" err="1">
@@ -14731,7 +14746,7 @@
                 <a:effectLst/>
                 <a:latin typeface="Helvetica" pitchFamily="2" charset="0"/>
               </a:rPr>
-              <a:t> et al., 2015)</a:t>
+              <a:t> et al., 2015).</a:t>
             </a:r>
           </a:p>
           <a:p>
@@ -14789,7 +14804,7 @@
                 <a:effectLst/>
                 <a:latin typeface="Helvetica" pitchFamily="2" charset="0"/>
               </a:rPr>
-              <a:t>e effect of relationships on behavior and reward activation may change as we age. (</a:t>
+              <a:t>e effect of relationships on behavior and reward activation change as we age (</a:t>
             </a:r>
             <a:r>
               <a:rPr lang="en-US" sz="4000" b="0" i="0" dirty="0" err="1">
@@ -14809,7 +14824,7 @@
                 <a:effectLst/>
                 <a:latin typeface="Helvetica" pitchFamily="2" charset="0"/>
               </a:rPr>
-              <a:t> et al., 2022)</a:t>
+              <a:t> et al., 2022).</a:t>
             </a:r>
           </a:p>
           <a:p>
@@ -15493,8 +15508,8 @@
         </p:nvSpPr>
         <p:spPr>
           <a:xfrm>
-            <a:off x="423843" y="26895455"/>
-            <a:ext cx="10236647" cy="3431709"/>
+            <a:off x="348830" y="26164352"/>
+            <a:ext cx="11690573" cy="4909036"/>
           </a:xfrm>
           <a:prstGeom prst="rect">
             <a:avLst/>
@@ -15507,40 +15522,18 @@
           </a:bodyPr>
           <a:lstStyle/>
           <a:p>
-            <a:pPr algn="ctr"/>
-            <a:r>
-              <a:rPr lang="en-US" sz="3200" dirty="0">
-                <a:effectLst/>
-                <a:latin typeface="Helvetica"/>
-                <a:ea typeface="Times New Roman" panose="02020603050405020304" pitchFamily="18" charset="0"/>
-                <a:cs typeface="Helvetica"/>
-              </a:rPr>
-              <a:t>N =</a:t>
-            </a:r>
+            <a:pPr algn="ctr">
+              <a:spcAft>
+                <a:spcPts val="15"/>
+              </a:spcAft>
+            </a:pPr>
             <a:r>
               <a:rPr lang="en-US" sz="3200" dirty="0">
                 <a:latin typeface="Helvetica"/>
                 <a:ea typeface="Times New Roman" panose="02020603050405020304" pitchFamily="18" charset="0"/>
                 <a:cs typeface="Helvetica"/>
               </a:rPr>
-              <a:t> 62</a:t>
-            </a:r>
-            <a:r>
-              <a:rPr lang="en-US" sz="3200" dirty="0">
-                <a:effectLst/>
-                <a:latin typeface="Helvetica"/>
-                <a:ea typeface="Times New Roman" panose="02020603050405020304" pitchFamily="18" charset="0"/>
-                <a:cs typeface="Helvetica"/>
-              </a:rPr>
-              <a:t> </a:t>
-            </a:r>
-            <a:r>
-              <a:rPr lang="en-US" sz="3200" dirty="0">
-                <a:latin typeface="Helvetica" pitchFamily="2" charset="0"/>
-                <a:ea typeface="Times New Roman" panose="02020603050405020304" pitchFamily="18" charset="0"/>
-                <a:cs typeface="Helvetica"/>
-              </a:rPr>
-              <a:t>C</a:t>
+              <a:t>We used</a:t>
             </a:r>
             <a:r>
               <a:rPr lang="en-US" sz="3200" dirty="0">
@@ -15549,7 +15542,7 @@
                 <a:ea typeface="Times New Roman" panose="02020603050405020304" pitchFamily="18" charset="0"/>
                 <a:cs typeface="Helvetica"/>
               </a:rPr>
-              <a:t>ompleted the </a:t>
+              <a:t> the </a:t>
             </a:r>
             <a:r>
               <a:rPr lang="en-US" sz="3200" b="0" i="0" dirty="0">
@@ -15572,11 +15565,15 @@
                 <a:effectLst/>
                 <a:latin typeface="Helvetica" pitchFamily="2" charset="0"/>
               </a:rPr>
-              <a:t>Older Adults Financial Exploitation Measure (OAFEM).</a:t>
+              <a:t>Older Adults Financial Exploitation Measure (OAFEM) to measure closeness ratings and risk for financial exploitation.</a:t>
             </a:r>
           </a:p>
           <a:p>
-            <a:pPr algn="ctr"/>
+            <a:pPr algn="ctr">
+              <a:spcAft>
+                <a:spcPts val="15"/>
+              </a:spcAft>
+            </a:pPr>
             <a:endParaRPr lang="en-US" sz="3200" dirty="0">
               <a:latin typeface="Helvetica" pitchFamily="2" charset="0"/>
               <a:ea typeface="Times New Roman" panose="02020603050405020304" pitchFamily="18" charset="0"/>
@@ -15584,7 +15581,11 @@
             </a:endParaRPr>
           </a:p>
           <a:p>
-            <a:pPr algn="ctr"/>
+            <a:pPr algn="ctr">
+              <a:spcAft>
+                <a:spcPts val="15"/>
+              </a:spcAft>
+            </a:pPr>
             <a:r>
               <a:rPr lang="en-US" sz="3200" dirty="0">
                 <a:latin typeface="Helvetica"/>
@@ -15608,6 +15609,52 @@
                 <a:cs typeface="Helvetica"/>
               </a:rPr>
               <a:t> at Z &gt; 3.1 and Family Wise Error corrected at p &gt; .05</a:t>
+            </a:r>
+          </a:p>
+          <a:p>
+            <a:pPr algn="ctr">
+              <a:spcAft>
+                <a:spcPts val="15"/>
+              </a:spcAft>
+            </a:pPr>
+            <a:endParaRPr lang="en-US" sz="3200" dirty="0">
+              <a:latin typeface="Helvetica"/>
+              <a:ea typeface="MS PGothic"/>
+              <a:cs typeface="Helvetica"/>
+            </a:endParaRPr>
+          </a:p>
+          <a:p>
+            <a:pPr algn="ctr">
+              <a:spcAft>
+                <a:spcPts val="15"/>
+              </a:spcAft>
+            </a:pPr>
+            <a:r>
+              <a:rPr lang="en-US" sz="3200" dirty="0">
+                <a:effectLst/>
+                <a:latin typeface="Helvetica"/>
+                <a:ea typeface="MS PGothic"/>
+                <a:cs typeface="Helvetica"/>
+              </a:rPr>
+              <a:t>fMRI data were preprocessed with </a:t>
+            </a:r>
+            <a:r>
+              <a:rPr lang="en-US" sz="3200" dirty="0" err="1">
+                <a:effectLst/>
+                <a:latin typeface="Helvetica"/>
+                <a:ea typeface="MS PGothic"/>
+                <a:cs typeface="Helvetica"/>
+              </a:rPr>
+              <a:t>fMRIprep</a:t>
+            </a:r>
+            <a:r>
+              <a:rPr lang="en-US" sz="3200" dirty="0">
+                <a:effectLst/>
+                <a:latin typeface="Helvetica"/>
+                <a:ea typeface="MS PGothic"/>
+                <a:cs typeface="Helvetica"/>
+              </a:rPr>
+              <a:t> and statistical analyses were performed using FSL</a:t>
             </a:r>
             <a:endParaRPr lang="en-US" sz="3200" dirty="0">
               <a:effectLst/>
@@ -15763,8 +15810,8 @@
           </p:nvSpPr>
           <p:spPr>
             <a:xfrm>
-              <a:off x="16838470" y="8664303"/>
-              <a:ext cx="838691" cy="369332"/>
+              <a:off x="16897735" y="8562924"/>
+              <a:ext cx="805531" cy="336081"/>
             </a:xfrm>
             <a:prstGeom prst="rect">
               <a:avLst/>
@@ -15779,7 +15826,7 @@
             <a:p>
               <a:pPr algn="ctr"/>
               <a:r>
-                <a:rPr lang="en-US" dirty="0"/>
+                <a:rPr lang="en-US" sz="3000" dirty="0"/>
                 <a:t>Friend</a:t>
               </a:r>
             </a:p>
@@ -15799,8 +15846,8 @@
           </p:nvSpPr>
           <p:spPr>
             <a:xfrm>
-              <a:off x="18105047" y="8664303"/>
-              <a:ext cx="1069524" cy="369332"/>
+              <a:off x="17943587" y="8561101"/>
+              <a:ext cx="1048955" cy="336081"/>
             </a:xfrm>
             <a:prstGeom prst="rect">
               <a:avLst/>
@@ -15814,7 +15861,7 @@
             <a:lstStyle/>
             <a:p>
               <a:r>
-                <a:rPr lang="en-US" dirty="0"/>
+                <a:rPr lang="en-US" sz="3000" dirty="0"/>
                 <a:t>Stranger</a:t>
               </a:r>
             </a:p>
@@ -15834,8 +15881,8 @@
           </p:nvSpPr>
           <p:spPr>
             <a:xfrm>
-              <a:off x="19079432" y="8666185"/>
-              <a:ext cx="1197764" cy="369332"/>
+              <a:off x="19099843" y="8562985"/>
+              <a:ext cx="1183852" cy="336081"/>
             </a:xfrm>
             <a:prstGeom prst="rect">
               <a:avLst/>
@@ -15850,7 +15897,7 @@
             <a:p>
               <a:pPr algn="ctr"/>
               <a:r>
-                <a:rPr lang="en-US" dirty="0"/>
+                <a:rPr lang="en-US" sz="3000" dirty="0"/>
                 <a:t>Computer</a:t>
               </a:r>
             </a:p>
@@ -15859,10 +15906,10 @@
       </p:grpSp>
       <p:grpSp>
         <p:nvGrpSpPr>
-          <p:cNvPr id="3" name="Group 2">
+          <p:cNvPr id="6" name="Group 5">
             <a:extLst>
               <a:ext uri="{FF2B5EF4-FFF2-40B4-BE49-F238E27FC236}">
-                <a16:creationId xmlns:a16="http://schemas.microsoft.com/office/drawing/2014/main" id="{FE925EB6-326B-8343-87E7-5F037676B4C3}"/>
+                <a16:creationId xmlns:a16="http://schemas.microsoft.com/office/drawing/2014/main" id="{38C18AD7-82F0-2340-9AF5-4FA312159648}"/>
               </a:ext>
             </a:extLst>
           </p:cNvPr>
@@ -15871,18 +15918,18 @@
         </p:nvGrpSpPr>
         <p:grpSpPr>
           <a:xfrm>
-            <a:off x="574224" y="14845624"/>
-            <a:ext cx="13946934" cy="10995653"/>
-            <a:chOff x="530502" y="15050793"/>
-            <a:chExt cx="13946934" cy="10995653"/>
+            <a:off x="597367" y="16568871"/>
+            <a:ext cx="13063327" cy="9292257"/>
+            <a:chOff x="572915" y="16098706"/>
+            <a:chExt cx="13946934" cy="10056750"/>
           </a:xfrm>
         </p:grpSpPr>
         <p:grpSp>
           <p:nvGrpSpPr>
-            <p:cNvPr id="15621" name="Group 15620">
+            <p:cNvPr id="3" name="Group 2">
               <a:extLst>
                 <a:ext uri="{FF2B5EF4-FFF2-40B4-BE49-F238E27FC236}">
-                  <a16:creationId xmlns:a16="http://schemas.microsoft.com/office/drawing/2014/main" id="{5C45E275-5A15-8C98-B9C5-16C75C23860A}"/>
+                  <a16:creationId xmlns:a16="http://schemas.microsoft.com/office/drawing/2014/main" id="{FE925EB6-326B-8343-87E7-5F037676B4C3}"/>
                 </a:ext>
               </a:extLst>
             </p:cNvPr>
@@ -15891,18 +15938,18 @@
           </p:nvGrpSpPr>
           <p:grpSpPr>
             <a:xfrm>
-              <a:off x="3779671" y="15989696"/>
-              <a:ext cx="10697765" cy="10056750"/>
-              <a:chOff x="3779671" y="16218296"/>
-              <a:chExt cx="10697765" cy="10056750"/>
+              <a:off x="572915" y="16098706"/>
+              <a:ext cx="13946934" cy="10056750"/>
+              <a:chOff x="530502" y="15989696"/>
+              <a:chExt cx="13946934" cy="10056750"/>
             </a:xfrm>
           </p:grpSpPr>
           <p:grpSp>
             <p:nvGrpSpPr>
-              <p:cNvPr id="15606" name="Group 15605">
+              <p:cNvPr id="15621" name="Group 15620">
                 <a:extLst>
                   <a:ext uri="{FF2B5EF4-FFF2-40B4-BE49-F238E27FC236}">
-                    <a16:creationId xmlns:a16="http://schemas.microsoft.com/office/drawing/2014/main" id="{B0CC5957-EC01-CDC2-ADAF-5A0141831C57}"/>
+                    <a16:creationId xmlns:a16="http://schemas.microsoft.com/office/drawing/2014/main" id="{5C45E275-5A15-8C98-B9C5-16C75C23860A}"/>
                   </a:ext>
                 </a:extLst>
               </p:cNvPr>
@@ -15911,314 +15958,18 @@
             </p:nvGrpSpPr>
             <p:grpSpPr>
               <a:xfrm>
-                <a:off x="3779671" y="16218296"/>
+                <a:off x="3779671" y="15989696"/>
                 <a:ext cx="10697765" cy="10056750"/>
-                <a:chOff x="18887859" y="360968"/>
-                <a:chExt cx="6543891" cy="6151778"/>
+                <a:chOff x="3779671" y="16218296"/>
+                <a:chExt cx="10697765" cy="10056750"/>
               </a:xfrm>
             </p:grpSpPr>
-            <p:pic>
-              <p:nvPicPr>
-                <p:cNvPr id="15607" name="Picture 15606" descr="A green check mark on a grey background&#10;&#10;Description automatically generated">
+            <p:grpSp>
+              <p:nvGrpSpPr>
+                <p:cNvPr id="15606" name="Group 15605">
                   <a:extLst>
                     <a:ext uri="{FF2B5EF4-FFF2-40B4-BE49-F238E27FC236}">
-                      <a16:creationId xmlns:a16="http://schemas.microsoft.com/office/drawing/2014/main" id="{BFD42068-273C-19B5-B61E-D2752FACB16C}"/>
-                    </a:ext>
-                  </a:extLst>
-                </p:cNvPr>
-                <p:cNvPicPr>
-                  <a:picLocks noChangeAspect="1"/>
-                </p:cNvPicPr>
-                <p:nvPr/>
-              </p:nvPicPr>
-              <p:blipFill rotWithShape="1">
-                <a:blip r:embed="rId7"/>
-                <a:srcRect l="14791" t="15087" r="12450" b="22936"/>
-                <a:stretch/>
-              </p:blipFill>
-              <p:spPr>
-                <a:xfrm>
-                  <a:off x="19244972" y="4622666"/>
-                  <a:ext cx="2991981" cy="1890080"/>
-                </a:xfrm>
-                <a:prstGeom prst="rect">
-                  <a:avLst/>
-                </a:prstGeom>
-                <a:solidFill>
-                  <a:srgbClr val="FFFFFF">
-                    <a:shade val="85000"/>
-                  </a:srgbClr>
-                </a:solidFill>
-                <a:ln w="88900" cap="sq">
-                  <a:solidFill>
-                    <a:srgbClr val="C00000"/>
-                  </a:solidFill>
-                  <a:miter lim="800000"/>
-                </a:ln>
-                <a:effectLst>
-                  <a:outerShdw blurRad="55000" dist="18000" dir="5400000" algn="tl" rotWithShape="0">
-                    <a:srgbClr val="000000">
-                      <a:alpha val="40000"/>
-                    </a:srgbClr>
-                  </a:outerShdw>
-                </a:effectLst>
-                <a:scene3d>
-                  <a:camera prst="orthographicFront"/>
-                  <a:lightRig rig="twoPt" dir="t">
-                    <a:rot lat="0" lon="0" rev="7200000"/>
-                  </a:lightRig>
-                </a:scene3d>
-                <a:sp3d>
-                  <a:bevelT w="25400" h="19050"/>
-                  <a:contourClr>
-                    <a:srgbClr val="FFFFFF"/>
-                  </a:contourClr>
-                </a:sp3d>
-              </p:spPr>
-            </p:pic>
-            <p:pic>
-              <p:nvPicPr>
-                <p:cNvPr id="15608" name="Picture 15607" descr="A computer screen shot&#10;&#10;Description automatically generated">
-                  <a:extLst>
-                    <a:ext uri="{FF2B5EF4-FFF2-40B4-BE49-F238E27FC236}">
-                      <a16:creationId xmlns:a16="http://schemas.microsoft.com/office/drawing/2014/main" id="{7AF89E18-68CC-9284-01FB-59B8ECC6A7F3}"/>
-                    </a:ext>
-                  </a:extLst>
-                </p:cNvPr>
-                <p:cNvPicPr>
-                  <a:picLocks noChangeAspect="1"/>
-                </p:cNvPicPr>
-                <p:nvPr/>
-              </p:nvPicPr>
-              <p:blipFill rotWithShape="1">
-                <a:blip r:embed="rId8"/>
-                <a:srcRect l="17658" t="18357" r="18046" b="25816"/>
-                <a:stretch/>
-              </p:blipFill>
-              <p:spPr>
-                <a:xfrm>
-                  <a:off x="22543408" y="4676154"/>
-                  <a:ext cx="2888342" cy="1819031"/>
-                </a:xfrm>
-                <a:prstGeom prst="rect">
-                  <a:avLst/>
-                </a:prstGeom>
-                <a:solidFill>
-                  <a:srgbClr val="FFFFFF">
-                    <a:shade val="85000"/>
-                  </a:srgbClr>
-                </a:solidFill>
-                <a:ln w="88900" cap="sq">
-                  <a:solidFill>
-                    <a:srgbClr val="C00000"/>
-                  </a:solidFill>
-                  <a:miter lim="800000"/>
-                </a:ln>
-                <a:effectLst>
-                  <a:outerShdw blurRad="55000" dist="18000" dir="5400000" algn="tl" rotWithShape="0">
-                    <a:srgbClr val="000000">
-                      <a:alpha val="40000"/>
-                    </a:srgbClr>
-                  </a:outerShdw>
-                </a:effectLst>
-                <a:scene3d>
-                  <a:camera prst="orthographicFront"/>
-                  <a:lightRig rig="twoPt" dir="t">
-                    <a:rot lat="0" lon="0" rev="7200000"/>
-                  </a:lightRig>
-                </a:scene3d>
-                <a:sp3d>
-                  <a:bevelT w="25400" h="19050"/>
-                  <a:contourClr>
-                    <a:srgbClr val="FFFFFF"/>
-                  </a:contourClr>
-                </a:sp3d>
-              </p:spPr>
-            </p:pic>
-            <p:pic>
-              <p:nvPicPr>
-                <p:cNvPr id="15609" name="Picture 15608" descr="A white cross on a gray background&#10;&#10;Description automatically generated">
-                  <a:extLst>
-                    <a:ext uri="{FF2B5EF4-FFF2-40B4-BE49-F238E27FC236}">
-                      <a16:creationId xmlns:a16="http://schemas.microsoft.com/office/drawing/2014/main" id="{A316990F-59C7-631E-47E9-456D55904891}"/>
-                    </a:ext>
-                  </a:extLst>
-                </p:cNvPr>
-                <p:cNvPicPr>
-                  <a:picLocks noChangeAspect="1"/>
-                </p:cNvPicPr>
-                <p:nvPr/>
-              </p:nvPicPr>
-              <p:blipFill rotWithShape="1">
-                <a:blip r:embed="rId9"/>
-                <a:srcRect l="2620" t="7420" r="2620" b="4981"/>
-                <a:stretch/>
-              </p:blipFill>
-              <p:spPr>
-                <a:xfrm>
-                  <a:off x="20965957" y="2971697"/>
-                  <a:ext cx="2848448" cy="1890080"/>
-                </a:xfrm>
-                <a:prstGeom prst="rect">
-                  <a:avLst/>
-                </a:prstGeom>
-                <a:solidFill>
-                  <a:srgbClr val="FFFFFF">
-                    <a:shade val="85000"/>
-                  </a:srgbClr>
-                </a:solidFill>
-                <a:ln w="88900" cap="sq">
-                  <a:solidFill>
-                    <a:srgbClr val="C00000"/>
-                  </a:solidFill>
-                  <a:miter lim="800000"/>
-                </a:ln>
-                <a:effectLst>
-                  <a:outerShdw blurRad="55000" dist="18000" dir="5400000" algn="tl" rotWithShape="0">
-                    <a:srgbClr val="000000">
-                      <a:alpha val="40000"/>
-                    </a:srgbClr>
-                  </a:outerShdw>
-                </a:effectLst>
-                <a:scene3d>
-                  <a:camera prst="orthographicFront"/>
-                  <a:lightRig rig="twoPt" dir="t">
-                    <a:rot lat="0" lon="0" rev="7200000"/>
-                  </a:lightRig>
-                </a:scene3d>
-                <a:sp3d>
-                  <a:bevelT w="25400" h="19050"/>
-                  <a:contourClr>
-                    <a:srgbClr val="FFFFFF"/>
-                  </a:contourClr>
-                </a:sp3d>
-              </p:spPr>
-            </p:pic>
-            <p:pic>
-              <p:nvPicPr>
-                <p:cNvPr id="15610" name="Picture 15609" descr="A grey background with white text&#10;&#10;Description automatically generated">
-                  <a:extLst>
-                    <a:ext uri="{FF2B5EF4-FFF2-40B4-BE49-F238E27FC236}">
-                      <a16:creationId xmlns:a16="http://schemas.microsoft.com/office/drawing/2014/main" id="{E95A9EFF-122D-C651-FDF5-564B82E90BBA}"/>
-                    </a:ext>
-                  </a:extLst>
-                </p:cNvPr>
-                <p:cNvPicPr>
-                  <a:picLocks noChangeAspect="1"/>
-                </p:cNvPicPr>
-                <p:nvPr/>
-              </p:nvPicPr>
-              <p:blipFill>
-                <a:blip r:embed="rId10"/>
-                <a:stretch>
-                  <a:fillRect/>
-                </a:stretch>
-              </p:blipFill>
-              <p:spPr>
-                <a:xfrm>
-                  <a:off x="19926908" y="1639461"/>
-                  <a:ext cx="2848448" cy="1943823"/>
-                </a:xfrm>
-                <a:prstGeom prst="rect">
-                  <a:avLst/>
-                </a:prstGeom>
-                <a:solidFill>
-                  <a:srgbClr val="FFFFFF">
-                    <a:shade val="85000"/>
-                  </a:srgbClr>
-                </a:solidFill>
-                <a:ln w="88900" cap="sq">
-                  <a:solidFill>
-                    <a:srgbClr val="C00000"/>
-                  </a:solidFill>
-                  <a:miter lim="800000"/>
-                </a:ln>
-                <a:effectLst>
-                  <a:outerShdw blurRad="55000" dist="18000" dir="5400000" algn="tl" rotWithShape="0">
-                    <a:srgbClr val="000000">
-                      <a:alpha val="40000"/>
-                    </a:srgbClr>
-                  </a:outerShdw>
-                </a:effectLst>
-                <a:scene3d>
-                  <a:camera prst="orthographicFront"/>
-                  <a:lightRig rig="twoPt" dir="t">
-                    <a:rot lat="0" lon="0" rev="7200000"/>
-                  </a:lightRig>
-                </a:scene3d>
-                <a:sp3d>
-                  <a:bevelT w="25400" h="19050"/>
-                  <a:contourClr>
-                    <a:srgbClr val="FFFFFF"/>
-                  </a:contourClr>
-                </a:sp3d>
-              </p:spPr>
-            </p:pic>
-            <p:pic>
-              <p:nvPicPr>
-                <p:cNvPr id="15611" name="Picture 15610" descr="A computer and a keyboard&#10;&#10;Description automatically generated with medium confidence">
-                  <a:extLst>
-                    <a:ext uri="{FF2B5EF4-FFF2-40B4-BE49-F238E27FC236}">
-                      <a16:creationId xmlns:a16="http://schemas.microsoft.com/office/drawing/2014/main" id="{BD10086D-C152-9AEB-CD34-13177C8F6D4A}"/>
-                    </a:ext>
-                  </a:extLst>
-                </p:cNvPr>
-                <p:cNvPicPr>
-                  <a:picLocks noChangeAspect="1"/>
-                </p:cNvPicPr>
-                <p:nvPr/>
-              </p:nvPicPr>
-              <p:blipFill rotWithShape="1">
-                <a:blip r:embed="rId11"/>
-                <a:srcRect l="2378" t="5420" r="2378" b="9853"/>
-                <a:stretch/>
-              </p:blipFill>
-              <p:spPr>
-                <a:xfrm>
-                  <a:off x="18887859" y="360968"/>
-                  <a:ext cx="2848448" cy="1919430"/>
-                </a:xfrm>
-                <a:prstGeom prst="rect">
-                  <a:avLst/>
-                </a:prstGeom>
-                <a:solidFill>
-                  <a:srgbClr val="FFFFFF">
-                    <a:shade val="85000"/>
-                  </a:srgbClr>
-                </a:solidFill>
-                <a:ln w="88900" cap="sq">
-                  <a:solidFill>
-                    <a:srgbClr val="C00000"/>
-                  </a:solidFill>
-                  <a:miter lim="800000"/>
-                </a:ln>
-                <a:effectLst>
-                  <a:outerShdw blurRad="55000" dist="18000" dir="5400000" algn="tl" rotWithShape="0">
-                    <a:srgbClr val="000000">
-                      <a:alpha val="40000"/>
-                    </a:srgbClr>
-                  </a:outerShdw>
-                </a:effectLst>
-                <a:scene3d>
-                  <a:camera prst="orthographicFront"/>
-                  <a:lightRig rig="twoPt" dir="t">
-                    <a:rot lat="0" lon="0" rev="7200000"/>
-                  </a:lightRig>
-                </a:scene3d>
-                <a:sp3d>
-                  <a:bevelT w="25400" h="19050"/>
-                  <a:contourClr>
-                    <a:srgbClr val="FFFFFF"/>
-                  </a:contourClr>
-                </a:sp3d>
-              </p:spPr>
-            </p:pic>
-            <p:grpSp>
-              <p:nvGrpSpPr>
-                <p:cNvPr id="15612" name="Group 15611">
-                  <a:extLst>
-                    <a:ext uri="{FF2B5EF4-FFF2-40B4-BE49-F238E27FC236}">
-                      <a16:creationId xmlns:a16="http://schemas.microsoft.com/office/drawing/2014/main" id="{60B2107B-4199-FD0C-4076-CA2B2F109B20}"/>
+                      <a16:creationId xmlns:a16="http://schemas.microsoft.com/office/drawing/2014/main" id="{B0CC5957-EC01-CDC2-ADAF-5A0141831C57}"/>
                     </a:ext>
                   </a:extLst>
                 </p:cNvPr>
@@ -16227,18 +15978,18 @@
               </p:nvGrpSpPr>
               <p:grpSpPr>
                 <a:xfrm>
-                  <a:off x="22071524" y="360968"/>
-                  <a:ext cx="3360226" cy="995434"/>
-                  <a:chOff x="3514264" y="206684"/>
-                  <a:chExt cx="3360226" cy="995434"/>
+                  <a:off x="3779671" y="16218296"/>
+                  <a:ext cx="10697765" cy="10056750"/>
+                  <a:chOff x="18887859" y="360968"/>
+                  <a:chExt cx="6543891" cy="6151778"/>
                 </a:xfrm>
               </p:grpSpPr>
               <p:pic>
                 <p:nvPicPr>
-                  <p:cNvPr id="15613" name="Picture 15612">
+                  <p:cNvPr id="15607" name="Picture 15606" descr="A green check mark on a grey background&#10;&#10;Description automatically generated">
                     <a:extLst>
                       <a:ext uri="{FF2B5EF4-FFF2-40B4-BE49-F238E27FC236}">
-                        <a16:creationId xmlns:a16="http://schemas.microsoft.com/office/drawing/2014/main" id="{8F1F804F-2F4C-1C69-0ED4-456A517A34F3}"/>
+                        <a16:creationId xmlns:a16="http://schemas.microsoft.com/office/drawing/2014/main" id="{BFD42068-273C-19B5-B61E-D2752FACB16C}"/>
                       </a:ext>
                     </a:extLst>
                   </p:cNvPr>
@@ -16247,16 +15998,15 @@
                   </p:cNvPicPr>
                   <p:nvPr/>
                 </p:nvPicPr>
-                <p:blipFill>
-                  <a:blip r:embed="rId12"/>
-                  <a:stretch>
-                    <a:fillRect/>
-                  </a:stretch>
+                <p:blipFill rotWithShape="1">
+                  <a:blip r:embed="rId7"/>
+                  <a:srcRect l="14791" t="15087" r="12450" b="22936"/>
+                  <a:stretch/>
                 </p:blipFill>
                 <p:spPr>
                   <a:xfrm>
-                    <a:off x="3514264" y="206684"/>
-                    <a:ext cx="1027916" cy="990673"/>
+                    <a:off x="19244972" y="4622666"/>
+                    <a:ext cx="2991981" cy="1890080"/>
                   </a:xfrm>
                   <a:prstGeom prst="rect">
                     <a:avLst/>
@@ -16295,10 +16045,10 @@
               </p:pic>
               <p:pic>
                 <p:nvPicPr>
-                  <p:cNvPr id="15614" name="Picture 15613" descr="A grey square with a person's head&#10;&#10;Description automatically generated">
+                  <p:cNvPr id="15608" name="Picture 15607" descr="A computer screen shot&#10;&#10;Description automatically generated">
                     <a:extLst>
                       <a:ext uri="{FF2B5EF4-FFF2-40B4-BE49-F238E27FC236}">
-                        <a16:creationId xmlns:a16="http://schemas.microsoft.com/office/drawing/2014/main" id="{2172C1AD-5BEC-2CFE-FCB3-472B60E2C225}"/>
+                        <a16:creationId xmlns:a16="http://schemas.microsoft.com/office/drawing/2014/main" id="{7AF89E18-68CC-9284-01FB-59B8ECC6A7F3}"/>
                       </a:ext>
                     </a:extLst>
                   </p:cNvPr>
@@ -16307,16 +16057,15 @@
                   </p:cNvPicPr>
                   <p:nvPr/>
                 </p:nvPicPr>
-                <p:blipFill>
-                  <a:blip r:embed="rId13"/>
-                  <a:stretch>
-                    <a:fillRect/>
-                  </a:stretch>
+                <p:blipFill rotWithShape="1">
+                  <a:blip r:embed="rId8"/>
+                  <a:srcRect l="17658" t="18357" r="18046" b="25816"/>
+                  <a:stretch/>
                 </p:blipFill>
                 <p:spPr>
                   <a:xfrm>
-                    <a:off x="4717835" y="206684"/>
-                    <a:ext cx="982991" cy="995434"/>
+                    <a:off x="22543408" y="4676154"/>
+                    <a:ext cx="2888342" cy="1819031"/>
                   </a:xfrm>
                   <a:prstGeom prst="rect">
                     <a:avLst/>
@@ -16355,10 +16104,10 @@
               </p:pic>
               <p:pic>
                 <p:nvPicPr>
-                  <p:cNvPr id="15615" name="Picture 15614" descr="A person with a smile on his face&#10;&#10;Description automatically generated">
+                  <p:cNvPr id="15609" name="Picture 15608" descr="A white cross on a gray background&#10;&#10;Description automatically generated">
                     <a:extLst>
                       <a:ext uri="{FF2B5EF4-FFF2-40B4-BE49-F238E27FC236}">
-                        <a16:creationId xmlns:a16="http://schemas.microsoft.com/office/drawing/2014/main" id="{7957BC4D-151A-EB1E-5CAE-777FF2B16B20}"/>
+                        <a16:creationId xmlns:a16="http://schemas.microsoft.com/office/drawing/2014/main" id="{A316990F-59C7-631E-47E9-456D55904891}"/>
                       </a:ext>
                     </a:extLst>
                   </p:cNvPr>
@@ -16367,16 +16116,15 @@
                   </p:cNvPicPr>
                   <p:nvPr/>
                 </p:nvPicPr>
-                <p:blipFill>
-                  <a:blip r:embed="rId14"/>
-                  <a:stretch>
-                    <a:fillRect/>
-                  </a:stretch>
+                <p:blipFill rotWithShape="1">
+                  <a:blip r:embed="rId9"/>
+                  <a:srcRect l="2620" t="7420" r="2620" b="4981"/>
+                  <a:stretch/>
                 </p:blipFill>
                 <p:spPr>
                   <a:xfrm>
-                    <a:off x="5883817" y="206684"/>
-                    <a:ext cx="990673" cy="990673"/>
+                    <a:off x="20965957" y="2971697"/>
+                    <a:ext cx="2848448" cy="1890080"/>
                   </a:xfrm>
                   <a:prstGeom prst="rect">
                     <a:avLst/>
@@ -16413,14 +16161,1042 @@
                   </a:sp3d>
                 </p:spPr>
               </p:pic>
+              <p:pic>
+                <p:nvPicPr>
+                  <p:cNvPr id="15610" name="Picture 15609" descr="A grey background with white text&#10;&#10;Description automatically generated">
+                    <a:extLst>
+                      <a:ext uri="{FF2B5EF4-FFF2-40B4-BE49-F238E27FC236}">
+                        <a16:creationId xmlns:a16="http://schemas.microsoft.com/office/drawing/2014/main" id="{E95A9EFF-122D-C651-FDF5-564B82E90BBA}"/>
+                      </a:ext>
+                    </a:extLst>
+                  </p:cNvPr>
+                  <p:cNvPicPr>
+                    <a:picLocks noChangeAspect="1"/>
+                  </p:cNvPicPr>
+                  <p:nvPr/>
+                </p:nvPicPr>
+                <p:blipFill>
+                  <a:blip r:embed="rId10"/>
+                  <a:stretch>
+                    <a:fillRect/>
+                  </a:stretch>
+                </p:blipFill>
+                <p:spPr>
+                  <a:xfrm>
+                    <a:off x="19926908" y="1639461"/>
+                    <a:ext cx="2848448" cy="1943823"/>
+                  </a:xfrm>
+                  <a:prstGeom prst="rect">
+                    <a:avLst/>
+                  </a:prstGeom>
+                  <a:solidFill>
+                    <a:srgbClr val="FFFFFF">
+                      <a:shade val="85000"/>
+                    </a:srgbClr>
+                  </a:solidFill>
+                  <a:ln w="88900" cap="sq">
+                    <a:solidFill>
+                      <a:srgbClr val="C00000"/>
+                    </a:solidFill>
+                    <a:miter lim="800000"/>
+                  </a:ln>
+                  <a:effectLst>
+                    <a:outerShdw blurRad="55000" dist="18000" dir="5400000" algn="tl" rotWithShape="0">
+                      <a:srgbClr val="000000">
+                        <a:alpha val="40000"/>
+                      </a:srgbClr>
+                    </a:outerShdw>
+                  </a:effectLst>
+                  <a:scene3d>
+                    <a:camera prst="orthographicFront"/>
+                    <a:lightRig rig="twoPt" dir="t">
+                      <a:rot lat="0" lon="0" rev="7200000"/>
+                    </a:lightRig>
+                  </a:scene3d>
+                  <a:sp3d>
+                    <a:bevelT w="25400" h="19050"/>
+                    <a:contourClr>
+                      <a:srgbClr val="FFFFFF"/>
+                    </a:contourClr>
+                  </a:sp3d>
+                </p:spPr>
+              </p:pic>
+              <p:pic>
+                <p:nvPicPr>
+                  <p:cNvPr id="15611" name="Picture 15610" descr="A computer and a keyboard&#10;&#10;Description automatically generated with medium confidence">
+                    <a:extLst>
+                      <a:ext uri="{FF2B5EF4-FFF2-40B4-BE49-F238E27FC236}">
+                        <a16:creationId xmlns:a16="http://schemas.microsoft.com/office/drawing/2014/main" id="{BD10086D-C152-9AEB-CD34-13177C8F6D4A}"/>
+                      </a:ext>
+                    </a:extLst>
+                  </p:cNvPr>
+                  <p:cNvPicPr>
+                    <a:picLocks noChangeAspect="1"/>
+                  </p:cNvPicPr>
+                  <p:nvPr/>
+                </p:nvPicPr>
+                <p:blipFill rotWithShape="1">
+                  <a:blip r:embed="rId11"/>
+                  <a:srcRect l="2378" t="5420" r="2378" b="9853"/>
+                  <a:stretch/>
+                </p:blipFill>
+                <p:spPr>
+                  <a:xfrm>
+                    <a:off x="18887859" y="360968"/>
+                    <a:ext cx="2848448" cy="1919430"/>
+                  </a:xfrm>
+                  <a:prstGeom prst="rect">
+                    <a:avLst/>
+                  </a:prstGeom>
+                  <a:solidFill>
+                    <a:srgbClr val="FFFFFF">
+                      <a:shade val="85000"/>
+                    </a:srgbClr>
+                  </a:solidFill>
+                  <a:ln w="88900" cap="sq">
+                    <a:solidFill>
+                      <a:srgbClr val="C00000"/>
+                    </a:solidFill>
+                    <a:miter lim="800000"/>
+                  </a:ln>
+                  <a:effectLst>
+                    <a:outerShdw blurRad="55000" dist="18000" dir="5400000" algn="tl" rotWithShape="0">
+                      <a:srgbClr val="000000">
+                        <a:alpha val="40000"/>
+                      </a:srgbClr>
+                    </a:outerShdw>
+                  </a:effectLst>
+                  <a:scene3d>
+                    <a:camera prst="orthographicFront"/>
+                    <a:lightRig rig="twoPt" dir="t">
+                      <a:rot lat="0" lon="0" rev="7200000"/>
+                    </a:lightRig>
+                  </a:scene3d>
+                  <a:sp3d>
+                    <a:bevelT w="25400" h="19050"/>
+                    <a:contourClr>
+                      <a:srgbClr val="FFFFFF"/>
+                    </a:contourClr>
+                  </a:sp3d>
+                </p:spPr>
+              </p:pic>
+              <p:grpSp>
+                <p:nvGrpSpPr>
+                  <p:cNvPr id="15612" name="Group 15611">
+                    <a:extLst>
+                      <a:ext uri="{FF2B5EF4-FFF2-40B4-BE49-F238E27FC236}">
+                        <a16:creationId xmlns:a16="http://schemas.microsoft.com/office/drawing/2014/main" id="{60B2107B-4199-FD0C-4076-CA2B2F109B20}"/>
+                      </a:ext>
+                    </a:extLst>
+                  </p:cNvPr>
+                  <p:cNvGrpSpPr/>
+                  <p:nvPr/>
+                </p:nvGrpSpPr>
+                <p:grpSpPr>
+                  <a:xfrm>
+                    <a:off x="22071524" y="360968"/>
+                    <a:ext cx="3360226" cy="995434"/>
+                    <a:chOff x="3514264" y="206684"/>
+                    <a:chExt cx="3360226" cy="995434"/>
+                  </a:xfrm>
+                </p:grpSpPr>
+                <p:pic>
+                  <p:nvPicPr>
+                    <p:cNvPr id="15613" name="Picture 15612">
+                      <a:extLst>
+                        <a:ext uri="{FF2B5EF4-FFF2-40B4-BE49-F238E27FC236}">
+                          <a16:creationId xmlns:a16="http://schemas.microsoft.com/office/drawing/2014/main" id="{8F1F804F-2F4C-1C69-0ED4-456A517A34F3}"/>
+                        </a:ext>
+                      </a:extLst>
+                    </p:cNvPr>
+                    <p:cNvPicPr>
+                      <a:picLocks noChangeAspect="1"/>
+                    </p:cNvPicPr>
+                    <p:nvPr/>
+                  </p:nvPicPr>
+                  <p:blipFill>
+                    <a:blip r:embed="rId12"/>
+                    <a:stretch>
+                      <a:fillRect/>
+                    </a:stretch>
+                  </p:blipFill>
+                  <p:spPr>
+                    <a:xfrm>
+                      <a:off x="3514264" y="206684"/>
+                      <a:ext cx="1027916" cy="990673"/>
+                    </a:xfrm>
+                    <a:prstGeom prst="rect">
+                      <a:avLst/>
+                    </a:prstGeom>
+                    <a:solidFill>
+                      <a:srgbClr val="FFFFFF">
+                        <a:shade val="85000"/>
+                      </a:srgbClr>
+                    </a:solidFill>
+                    <a:ln w="88900" cap="sq">
+                      <a:solidFill>
+                        <a:srgbClr val="C00000"/>
+                      </a:solidFill>
+                      <a:miter lim="800000"/>
+                    </a:ln>
+                    <a:effectLst>
+                      <a:outerShdw blurRad="55000" dist="18000" dir="5400000" algn="tl" rotWithShape="0">
+                        <a:srgbClr val="000000">
+                          <a:alpha val="40000"/>
+                        </a:srgbClr>
+                      </a:outerShdw>
+                    </a:effectLst>
+                    <a:scene3d>
+                      <a:camera prst="orthographicFront"/>
+                      <a:lightRig rig="twoPt" dir="t">
+                        <a:rot lat="0" lon="0" rev="7200000"/>
+                      </a:lightRig>
+                    </a:scene3d>
+                    <a:sp3d>
+                      <a:bevelT w="25400" h="19050"/>
+                      <a:contourClr>
+                        <a:srgbClr val="FFFFFF"/>
+                      </a:contourClr>
+                    </a:sp3d>
+                  </p:spPr>
+                </p:pic>
+                <p:pic>
+                  <p:nvPicPr>
+                    <p:cNvPr id="15614" name="Picture 15613" descr="A grey square with a person's head&#10;&#10;Description automatically generated">
+                      <a:extLst>
+                        <a:ext uri="{FF2B5EF4-FFF2-40B4-BE49-F238E27FC236}">
+                          <a16:creationId xmlns:a16="http://schemas.microsoft.com/office/drawing/2014/main" id="{2172C1AD-5BEC-2CFE-FCB3-472B60E2C225}"/>
+                        </a:ext>
+                      </a:extLst>
+                    </p:cNvPr>
+                    <p:cNvPicPr>
+                      <a:picLocks noChangeAspect="1"/>
+                    </p:cNvPicPr>
+                    <p:nvPr/>
+                  </p:nvPicPr>
+                  <p:blipFill>
+                    <a:blip r:embed="rId13"/>
+                    <a:stretch>
+                      <a:fillRect/>
+                    </a:stretch>
+                  </p:blipFill>
+                  <p:spPr>
+                    <a:xfrm>
+                      <a:off x="4717835" y="206684"/>
+                      <a:ext cx="982991" cy="995434"/>
+                    </a:xfrm>
+                    <a:prstGeom prst="rect">
+                      <a:avLst/>
+                    </a:prstGeom>
+                    <a:solidFill>
+                      <a:srgbClr val="FFFFFF">
+                        <a:shade val="85000"/>
+                      </a:srgbClr>
+                    </a:solidFill>
+                    <a:ln w="88900" cap="sq">
+                      <a:solidFill>
+                        <a:srgbClr val="C00000"/>
+                      </a:solidFill>
+                      <a:miter lim="800000"/>
+                    </a:ln>
+                    <a:effectLst>
+                      <a:outerShdw blurRad="55000" dist="18000" dir="5400000" algn="tl" rotWithShape="0">
+                        <a:srgbClr val="000000">
+                          <a:alpha val="40000"/>
+                        </a:srgbClr>
+                      </a:outerShdw>
+                    </a:effectLst>
+                    <a:scene3d>
+                      <a:camera prst="orthographicFront"/>
+                      <a:lightRig rig="twoPt" dir="t">
+                        <a:rot lat="0" lon="0" rev="7200000"/>
+                      </a:lightRig>
+                    </a:scene3d>
+                    <a:sp3d>
+                      <a:bevelT w="25400" h="19050"/>
+                      <a:contourClr>
+                        <a:srgbClr val="FFFFFF"/>
+                      </a:contourClr>
+                    </a:sp3d>
+                  </p:spPr>
+                </p:pic>
+                <p:pic>
+                  <p:nvPicPr>
+                    <p:cNvPr id="15615" name="Picture 15614" descr="A person with a smile on his face&#10;&#10;Description automatically generated">
+                      <a:extLst>
+                        <a:ext uri="{FF2B5EF4-FFF2-40B4-BE49-F238E27FC236}">
+                          <a16:creationId xmlns:a16="http://schemas.microsoft.com/office/drawing/2014/main" id="{7957BC4D-151A-EB1E-5CAE-777FF2B16B20}"/>
+                        </a:ext>
+                      </a:extLst>
+                    </p:cNvPr>
+                    <p:cNvPicPr>
+                      <a:picLocks noChangeAspect="1"/>
+                    </p:cNvPicPr>
+                    <p:nvPr/>
+                  </p:nvPicPr>
+                  <p:blipFill>
+                    <a:blip r:embed="rId14"/>
+                    <a:stretch>
+                      <a:fillRect/>
+                    </a:stretch>
+                  </p:blipFill>
+                  <p:spPr>
+                    <a:xfrm>
+                      <a:off x="5883817" y="206684"/>
+                      <a:ext cx="990673" cy="990673"/>
+                    </a:xfrm>
+                    <a:prstGeom prst="rect">
+                      <a:avLst/>
+                    </a:prstGeom>
+                    <a:solidFill>
+                      <a:srgbClr val="FFFFFF">
+                        <a:shade val="85000"/>
+                      </a:srgbClr>
+                    </a:solidFill>
+                    <a:ln w="88900" cap="sq">
+                      <a:solidFill>
+                        <a:srgbClr val="C00000"/>
+                      </a:solidFill>
+                      <a:miter lim="800000"/>
+                    </a:ln>
+                    <a:effectLst>
+                      <a:outerShdw blurRad="55000" dist="18000" dir="5400000" algn="tl" rotWithShape="0">
+                        <a:srgbClr val="000000">
+                          <a:alpha val="40000"/>
+                        </a:srgbClr>
+                      </a:outerShdw>
+                    </a:effectLst>
+                    <a:scene3d>
+                      <a:camera prst="orthographicFront"/>
+                      <a:lightRig rig="twoPt" dir="t">
+                        <a:rot lat="0" lon="0" rev="7200000"/>
+                      </a:lightRig>
+                    </a:scene3d>
+                    <a:sp3d>
+                      <a:bevelT w="25400" h="19050"/>
+                      <a:contourClr>
+                        <a:srgbClr val="FFFFFF"/>
+                      </a:contourClr>
+                    </a:sp3d>
+                  </p:spPr>
+                </p:pic>
+              </p:grpSp>
             </p:grpSp>
+            <p:sp>
+              <p:nvSpPr>
+                <p:cNvPr id="15616" name="Rectangle 15615">
+                  <a:extLst>
+                    <a:ext uri="{FF2B5EF4-FFF2-40B4-BE49-F238E27FC236}">
+                      <a16:creationId xmlns:a16="http://schemas.microsoft.com/office/drawing/2014/main" id="{946783DC-D597-2C29-6191-5B3893CFCF5D}"/>
+                    </a:ext>
+                  </a:extLst>
+                </p:cNvPr>
+                <p:cNvSpPr/>
+                <p:nvPr/>
+              </p:nvSpPr>
+              <p:spPr bwMode="auto">
+                <a:xfrm>
+                  <a:off x="4071341" y="18677659"/>
+                  <a:ext cx="2147590" cy="340451"/>
+                </a:xfrm>
+                <a:prstGeom prst="rect">
+                  <a:avLst/>
+                </a:prstGeom>
+                <a:solidFill>
+                  <a:srgbClr val="848484"/>
+                </a:solidFill>
+                <a:ln w="9525" cap="flat" cmpd="sng" algn="ctr">
+                  <a:noFill/>
+                  <a:prstDash val="solid"/>
+                  <a:round/>
+                  <a:headEnd type="none" w="med" len="med"/>
+                  <a:tailEnd type="none" w="med" len="med"/>
+                </a:ln>
+                <a:effectLst/>
+              </p:spPr>
+              <p:txBody>
+                <a:bodyPr vert="horz" wrap="square" lIns="91440" tIns="45720" rIns="91440" bIns="45720" numCol="1" rtlCol="0" anchor="t" anchorCtr="0" compatLnSpc="1">
+                  <a:prstTxWarp prst="textNoShape">
+                    <a:avLst/>
+                  </a:prstTxWarp>
+                </a:bodyPr>
+                <a:lstStyle/>
+                <a:p>
+                  <a:pPr marL="0" marR="0" indent="0" algn="l" defTabSz="4389438" rtl="0" eaLnBrk="1" fontAlgn="base" latinLnBrk="0" hangingPunct="1">
+                    <a:lnSpc>
+                      <a:spcPct val="100000"/>
+                    </a:lnSpc>
+                    <a:spcBef>
+                      <a:spcPct val="0"/>
+                    </a:spcBef>
+                    <a:spcAft>
+                      <a:spcPct val="0"/>
+                    </a:spcAft>
+                    <a:buClrTx/>
+                    <a:buSzTx/>
+                    <a:buFontTx/>
+                    <a:buNone/>
+                    <a:tabLst/>
+                  </a:pPr>
+                  <a:r>
+                    <a:rPr kumimoji="0" lang="en-US" sz="3000" b="0" i="0" u="none" strike="noStrike" cap="none" normalizeH="0" baseline="0" dirty="0">
+                      <a:ln>
+                        <a:noFill/>
+                      </a:ln>
+                      <a:solidFill>
+                        <a:schemeClr val="bg1"/>
+                      </a:solidFill>
+                      <a:effectLst/>
+                      <a:latin typeface="Arial" charset="0"/>
+                      <a:cs typeface="Arial" charset="0"/>
+                    </a:rPr>
+                    <a:t>Share $8</a:t>
+                  </a:r>
+                </a:p>
+              </p:txBody>
+            </p:sp>
+            <p:sp>
+              <p:nvSpPr>
+                <p:cNvPr id="15618" name="Rectangle 15617">
+                  <a:extLst>
+                    <a:ext uri="{FF2B5EF4-FFF2-40B4-BE49-F238E27FC236}">
+                      <a16:creationId xmlns:a16="http://schemas.microsoft.com/office/drawing/2014/main" id="{C6024063-9D2C-50D8-70B5-FC3D7C6F49F8}"/>
+                    </a:ext>
+                  </a:extLst>
+                </p:cNvPr>
+                <p:cNvSpPr/>
+                <p:nvPr/>
+              </p:nvSpPr>
+              <p:spPr bwMode="auto">
+                <a:xfrm>
+                  <a:off x="6320475" y="18660155"/>
+                  <a:ext cx="1942901" cy="552682"/>
+                </a:xfrm>
+                <a:prstGeom prst="rect">
+                  <a:avLst/>
+                </a:prstGeom>
+                <a:solidFill>
+                  <a:srgbClr val="848484"/>
+                </a:solidFill>
+                <a:ln w="9525" cap="flat" cmpd="sng" algn="ctr">
+                  <a:noFill/>
+                  <a:prstDash val="solid"/>
+                  <a:round/>
+                  <a:headEnd type="none" w="med" len="med"/>
+                  <a:tailEnd type="none" w="med" len="med"/>
+                </a:ln>
+                <a:effectLst/>
+              </p:spPr>
+              <p:txBody>
+                <a:bodyPr vert="horz" wrap="square" lIns="91440" tIns="45720" rIns="91440" bIns="45720" numCol="1" rtlCol="0" anchor="t" anchorCtr="0" compatLnSpc="1">
+                  <a:prstTxWarp prst="textNoShape">
+                    <a:avLst/>
+                  </a:prstTxWarp>
+                </a:bodyPr>
+                <a:lstStyle/>
+                <a:p>
+                  <a:pPr marL="0" marR="0" indent="0" algn="l" defTabSz="4389438" rtl="0" eaLnBrk="1" fontAlgn="base" latinLnBrk="0" hangingPunct="1">
+                    <a:lnSpc>
+                      <a:spcPct val="100000"/>
+                    </a:lnSpc>
+                    <a:spcBef>
+                      <a:spcPct val="0"/>
+                    </a:spcBef>
+                    <a:spcAft>
+                      <a:spcPct val="0"/>
+                    </a:spcAft>
+                    <a:buClrTx/>
+                    <a:buSzTx/>
+                    <a:buFontTx/>
+                    <a:buNone/>
+                    <a:tabLst/>
+                  </a:pPr>
+                  <a:r>
+                    <a:rPr kumimoji="0" lang="en-US" sz="3000" b="0" i="0" u="none" strike="noStrike" cap="none" normalizeH="0" baseline="0" dirty="0">
+                      <a:ln>
+                        <a:noFill/>
+                      </a:ln>
+                      <a:solidFill>
+                        <a:schemeClr val="bg1"/>
+                      </a:solidFill>
+                      <a:effectLst/>
+                      <a:latin typeface="Arial" charset="0"/>
+                      <a:cs typeface="Arial" charset="0"/>
+                    </a:rPr>
+                    <a:t>Share $2</a:t>
+                  </a:r>
+                </a:p>
+              </p:txBody>
+            </p:sp>
+            <p:sp>
+              <p:nvSpPr>
+                <p:cNvPr id="15619" name="Rectangle 15618">
+                  <a:extLst>
+                    <a:ext uri="{FF2B5EF4-FFF2-40B4-BE49-F238E27FC236}">
+                      <a16:creationId xmlns:a16="http://schemas.microsoft.com/office/drawing/2014/main" id="{8EBB5886-1680-B3C7-DEC7-CD388B0CA60C}"/>
+                    </a:ext>
+                  </a:extLst>
+                </p:cNvPr>
+                <p:cNvSpPr/>
+                <p:nvPr/>
+              </p:nvSpPr>
+              <p:spPr bwMode="auto">
+                <a:xfrm>
+                  <a:off x="6772254" y="19789015"/>
+                  <a:ext cx="2503191" cy="552682"/>
+                </a:xfrm>
+                <a:prstGeom prst="rect">
+                  <a:avLst/>
+                </a:prstGeom>
+                <a:solidFill>
+                  <a:srgbClr val="848484"/>
+                </a:solidFill>
+                <a:ln w="9525" cap="flat" cmpd="sng" algn="ctr">
+                  <a:noFill/>
+                  <a:prstDash val="solid"/>
+                  <a:round/>
+                  <a:headEnd type="none" w="med" len="med"/>
+                  <a:tailEnd type="none" w="med" len="med"/>
+                </a:ln>
+                <a:effectLst/>
+              </p:spPr>
+              <p:txBody>
+                <a:bodyPr vert="horz" wrap="square" lIns="91440" tIns="45720" rIns="91440" bIns="45720" numCol="1" rtlCol="0" anchor="t" anchorCtr="0" compatLnSpc="1">
+                  <a:prstTxWarp prst="textNoShape">
+                    <a:avLst/>
+                  </a:prstTxWarp>
+                </a:bodyPr>
+                <a:lstStyle/>
+                <a:p>
+                  <a:pPr marL="0" marR="0" indent="0" algn="l" defTabSz="4389438" rtl="0" eaLnBrk="1" fontAlgn="base" latinLnBrk="0" hangingPunct="1">
+                    <a:lnSpc>
+                      <a:spcPct val="100000"/>
+                    </a:lnSpc>
+                    <a:spcBef>
+                      <a:spcPct val="0"/>
+                    </a:spcBef>
+                    <a:spcAft>
+                      <a:spcPct val="0"/>
+                    </a:spcAft>
+                    <a:buClrTx/>
+                    <a:buSzTx/>
+                    <a:buFontTx/>
+                    <a:buNone/>
+                    <a:tabLst/>
+                  </a:pPr>
+                  <a:r>
+                    <a:rPr kumimoji="0" lang="en-US" sz="3000" b="0" i="0" u="none" strike="noStrike" cap="none" normalizeH="0" baseline="0" dirty="0">
+                      <a:ln>
+                        <a:noFill/>
+                      </a:ln>
+                      <a:solidFill>
+                        <a:schemeClr val="bg1"/>
+                      </a:solidFill>
+                      <a:effectLst/>
+                      <a:latin typeface="Arial" charset="0"/>
+                      <a:cs typeface="Arial" charset="0"/>
+                    </a:rPr>
+                    <a:t>Loading…</a:t>
+                  </a:r>
+                </a:p>
+              </p:txBody>
+            </p:sp>
+            <p:sp>
+              <p:nvSpPr>
+                <p:cNvPr id="15620" name="Rectangle 15619">
+                  <a:extLst>
+                    <a:ext uri="{FF2B5EF4-FFF2-40B4-BE49-F238E27FC236}">
+                      <a16:creationId xmlns:a16="http://schemas.microsoft.com/office/drawing/2014/main" id="{98A52E85-D70D-5398-4E75-D523A6EBBF49}"/>
+                    </a:ext>
+                  </a:extLst>
+                </p:cNvPr>
+                <p:cNvSpPr/>
+                <p:nvPr/>
+              </p:nvSpPr>
+              <p:spPr bwMode="auto">
+                <a:xfrm>
+                  <a:off x="9139048" y="21549198"/>
+                  <a:ext cx="704737" cy="718761"/>
+                </a:xfrm>
+                <a:prstGeom prst="rect">
+                  <a:avLst/>
+                </a:prstGeom>
+                <a:solidFill>
+                  <a:srgbClr val="848484"/>
+                </a:solidFill>
+                <a:ln w="9525" cap="flat" cmpd="sng" algn="ctr">
+                  <a:noFill/>
+                  <a:prstDash val="solid"/>
+                  <a:round/>
+                  <a:headEnd type="none" w="med" len="med"/>
+                  <a:tailEnd type="none" w="med" len="med"/>
+                </a:ln>
+                <a:effectLst/>
+              </p:spPr>
+              <p:txBody>
+                <a:bodyPr vert="horz" wrap="square" lIns="91440" tIns="45720" rIns="91440" bIns="45720" numCol="1" rtlCol="0" anchor="t" anchorCtr="0" compatLnSpc="1">
+                  <a:prstTxWarp prst="textNoShape">
+                    <a:avLst/>
+                  </a:prstTxWarp>
+                </a:bodyPr>
+                <a:lstStyle/>
+                <a:p>
+                  <a:pPr marL="0" marR="0" indent="0" algn="ctr" defTabSz="4389438" rtl="0" eaLnBrk="1" fontAlgn="base" latinLnBrk="0" hangingPunct="1">
+                    <a:lnSpc>
+                      <a:spcPct val="100000"/>
+                    </a:lnSpc>
+                    <a:spcBef>
+                      <a:spcPct val="0"/>
+                    </a:spcBef>
+                    <a:spcAft>
+                      <a:spcPct val="0"/>
+                    </a:spcAft>
+                    <a:buClrTx/>
+                    <a:buSzTx/>
+                    <a:buFontTx/>
+                    <a:buNone/>
+                    <a:tabLst/>
+                  </a:pPr>
+                  <a:r>
+                    <a:rPr kumimoji="0" lang="en-US" sz="5000" b="0" i="0" u="none" strike="noStrike" cap="none" normalizeH="0" baseline="0" dirty="0">
+                      <a:ln>
+                        <a:noFill/>
+                      </a:ln>
+                      <a:solidFill>
+                        <a:schemeClr val="bg1"/>
+                      </a:solidFill>
+                      <a:effectLst/>
+                      <a:latin typeface="Arial" charset="0"/>
+                      <a:cs typeface="Arial" charset="0"/>
+                    </a:rPr>
+                    <a:t>+</a:t>
+                  </a:r>
+                </a:p>
+              </p:txBody>
+            </p:sp>
+          </p:grpSp>
+          <p:grpSp>
+            <p:nvGrpSpPr>
+              <p:cNvPr id="15592" name="Group 15591">
+                <a:extLst>
+                  <a:ext uri="{FF2B5EF4-FFF2-40B4-BE49-F238E27FC236}">
+                    <a16:creationId xmlns:a16="http://schemas.microsoft.com/office/drawing/2014/main" id="{415B0EBC-8379-F485-6113-E5DF57F87E19}"/>
+                  </a:ext>
+                </a:extLst>
+              </p:cNvPr>
+              <p:cNvGrpSpPr/>
+              <p:nvPr/>
+            </p:nvGrpSpPr>
+            <p:grpSpPr>
+              <a:xfrm>
+                <a:off x="1532700" y="21512239"/>
+                <a:ext cx="5203251" cy="1323439"/>
+                <a:chOff x="1154328" y="21740839"/>
+                <a:chExt cx="5203251" cy="1323439"/>
+              </a:xfrm>
+            </p:grpSpPr>
+            <p:sp>
+              <p:nvSpPr>
+                <p:cNvPr id="52" name="TextBox 51">
+                  <a:extLst>
+                    <a:ext uri="{FF2B5EF4-FFF2-40B4-BE49-F238E27FC236}">
+                      <a16:creationId xmlns:a16="http://schemas.microsoft.com/office/drawing/2014/main" id="{4707B45F-027B-576B-4808-66F0A5D95489}"/>
+                    </a:ext>
+                  </a:extLst>
+                </p:cNvPr>
+                <p:cNvSpPr txBox="1"/>
+                <p:nvPr/>
+              </p:nvSpPr>
+              <p:spPr>
+                <a:xfrm>
+                  <a:off x="5031575" y="21740839"/>
+                  <a:ext cx="1326004" cy="1323439"/>
+                </a:xfrm>
+                <a:prstGeom prst="rect">
+                  <a:avLst/>
+                </a:prstGeom>
+                <a:noFill/>
+              </p:spPr>
+              <p:txBody>
+                <a:bodyPr wrap="none" rtlCol="0">
+                  <a:spAutoFit/>
+                </a:bodyPr>
+                <a:lstStyle/>
+                <a:p>
+                  <a:r>
+                    <a:rPr lang="en-US" sz="8000" b="1" dirty="0">
+                      <a:solidFill>
+                        <a:srgbClr val="03DF04"/>
+                      </a:solidFill>
+                    </a:rPr>
+                    <a:t>x3</a:t>
+                  </a:r>
+                </a:p>
+              </p:txBody>
+            </p:sp>
+            <p:sp>
+              <p:nvSpPr>
+                <p:cNvPr id="15433" name="Rounded Rectangle 15432">
+                  <a:extLst>
+                    <a:ext uri="{FF2B5EF4-FFF2-40B4-BE49-F238E27FC236}">
+                      <a16:creationId xmlns:a16="http://schemas.microsoft.com/office/drawing/2014/main" id="{9D770554-0135-2E8B-9BC3-8228F9631C8A}"/>
+                    </a:ext>
+                  </a:extLst>
+                </p:cNvPr>
+                <p:cNvSpPr/>
+                <p:nvPr/>
+              </p:nvSpPr>
+              <p:spPr bwMode="auto">
+                <a:xfrm>
+                  <a:off x="1154328" y="21817902"/>
+                  <a:ext cx="3412362" cy="1168944"/>
+                </a:xfrm>
+                <a:prstGeom prst="roundRect">
+                  <a:avLst/>
+                </a:prstGeom>
+                <a:solidFill>
+                  <a:schemeClr val="accent1"/>
+                </a:solidFill>
+                <a:ln w="50800" cap="flat" cmpd="sng" algn="ctr">
+                  <a:solidFill>
+                    <a:schemeClr val="tx1"/>
+                  </a:solidFill>
+                  <a:prstDash val="solid"/>
+                  <a:round/>
+                  <a:headEnd type="none" w="med" len="med"/>
+                  <a:tailEnd type="none" w="med" len="med"/>
+                </a:ln>
+                <a:effectLst/>
+              </p:spPr>
+              <p:txBody>
+                <a:bodyPr vert="horz" wrap="square" lIns="91440" tIns="45720" rIns="91440" bIns="45720" numCol="1" rtlCol="0" anchor="t" anchorCtr="0" compatLnSpc="1">
+                  <a:prstTxWarp prst="textNoShape">
+                    <a:avLst/>
+                  </a:prstTxWarp>
+                </a:bodyPr>
+                <a:lstStyle/>
+                <a:p>
+                  <a:pPr algn="ctr" defTabSz="4389438" eaLnBrk="1" hangingPunct="1"/>
+                  <a:r>
+                    <a:rPr lang="en-US" sz="3000" dirty="0"/>
+                    <a:t>The money you  sent is tripled</a:t>
+                  </a:r>
+                </a:p>
+                <a:p>
+                  <a:pPr marL="0" marR="0" indent="0" algn="l" defTabSz="4389438" rtl="0" eaLnBrk="1" fontAlgn="base" latinLnBrk="0" hangingPunct="1">
+                    <a:lnSpc>
+                      <a:spcPct val="100000"/>
+                    </a:lnSpc>
+                    <a:spcBef>
+                      <a:spcPct val="0"/>
+                    </a:spcBef>
+                    <a:spcAft>
+                      <a:spcPct val="0"/>
+                    </a:spcAft>
+                    <a:buClrTx/>
+                    <a:buSzTx/>
+                    <a:buFontTx/>
+                    <a:buNone/>
+                    <a:tabLst/>
+                  </a:pPr>
+                  <a:endParaRPr kumimoji="0" lang="en-US" sz="1800" b="0" i="0" u="none" strike="noStrike" cap="none" normalizeH="0" baseline="0" dirty="0">
+                    <a:ln>
+                      <a:noFill/>
+                    </a:ln>
+                    <a:solidFill>
+                      <a:schemeClr val="tx1"/>
+                    </a:solidFill>
+                    <a:effectLst/>
+                    <a:latin typeface="Arial" charset="0"/>
+                    <a:cs typeface="Arial" charset="0"/>
+                  </a:endParaRPr>
+                </a:p>
+              </p:txBody>
+            </p:sp>
+          </p:grpSp>
+          <p:grpSp>
+            <p:nvGrpSpPr>
+              <p:cNvPr id="15490" name="Group 15489">
+                <a:extLst>
+                  <a:ext uri="{FF2B5EF4-FFF2-40B4-BE49-F238E27FC236}">
+                    <a16:creationId xmlns:a16="http://schemas.microsoft.com/office/drawing/2014/main" id="{26CF14B9-FE18-01D5-1A0A-E19BE8376A0A}"/>
+                  </a:ext>
+                </a:extLst>
+              </p:cNvPr>
+              <p:cNvGrpSpPr/>
+              <p:nvPr/>
+            </p:nvGrpSpPr>
+            <p:grpSpPr>
+              <a:xfrm>
+                <a:off x="530502" y="18979791"/>
+                <a:ext cx="4534151" cy="2464546"/>
+                <a:chOff x="533974" y="18532980"/>
+                <a:chExt cx="4534151" cy="2464546"/>
+              </a:xfrm>
+            </p:grpSpPr>
+            <p:sp>
+              <p:nvSpPr>
+                <p:cNvPr id="15432" name="Rounded Rectangle 15431">
+                  <a:extLst>
+                    <a:ext uri="{FF2B5EF4-FFF2-40B4-BE49-F238E27FC236}">
+                      <a16:creationId xmlns:a16="http://schemas.microsoft.com/office/drawing/2014/main" id="{29E5F4B4-9ECB-A12A-6B3F-C0855A0CDE34}"/>
+                    </a:ext>
+                  </a:extLst>
+                </p:cNvPr>
+                <p:cNvSpPr/>
+                <p:nvPr/>
+              </p:nvSpPr>
+              <p:spPr bwMode="auto">
+                <a:xfrm>
+                  <a:off x="533974" y="19334093"/>
+                  <a:ext cx="4534151" cy="1663433"/>
+                </a:xfrm>
+                <a:prstGeom prst="roundRect">
+                  <a:avLst/>
+                </a:prstGeom>
+                <a:solidFill>
+                  <a:schemeClr val="accent1"/>
+                </a:solidFill>
+                <a:ln w="50800" cap="flat" cmpd="sng" algn="ctr">
+                  <a:solidFill>
+                    <a:schemeClr val="tx1"/>
+                  </a:solidFill>
+                  <a:prstDash val="solid"/>
+                  <a:round/>
+                  <a:headEnd type="none" w="med" len="med"/>
+                  <a:tailEnd type="none" w="med" len="med"/>
+                </a:ln>
+                <a:effectLst/>
+              </p:spPr>
+              <p:txBody>
+                <a:bodyPr vert="horz" wrap="square" lIns="91440" tIns="45720" rIns="91440" bIns="45720" numCol="1" rtlCol="0" anchor="t" anchorCtr="0" compatLnSpc="1">
+                  <a:prstTxWarp prst="textNoShape">
+                    <a:avLst/>
+                  </a:prstTxWarp>
+                </a:bodyPr>
+                <a:lstStyle/>
+                <a:p>
+                  <a:pPr algn="ctr" defTabSz="4389438" eaLnBrk="1" hangingPunct="1"/>
+                  <a:r>
+                    <a:rPr lang="en-US" sz="3000" dirty="0"/>
+                    <a:t>You choose a higher or lower amount to share with your partner.</a:t>
+                  </a:r>
+                </a:p>
+                <a:p>
+                  <a:pPr marL="0" marR="0" indent="0" algn="l" defTabSz="4389438" rtl="0" eaLnBrk="1" fontAlgn="base" latinLnBrk="0" hangingPunct="1">
+                    <a:lnSpc>
+                      <a:spcPct val="100000"/>
+                    </a:lnSpc>
+                    <a:spcBef>
+                      <a:spcPct val="0"/>
+                    </a:spcBef>
+                    <a:spcAft>
+                      <a:spcPct val="0"/>
+                    </a:spcAft>
+                    <a:buClrTx/>
+                    <a:buSzTx/>
+                    <a:buFontTx/>
+                    <a:buNone/>
+                    <a:tabLst/>
+                  </a:pPr>
+                  <a:endParaRPr kumimoji="0" lang="en-US" sz="1800" b="0" i="0" u="none" strike="noStrike" cap="none" normalizeH="0" baseline="0" dirty="0">
+                    <a:ln>
+                      <a:noFill/>
+                    </a:ln>
+                    <a:solidFill>
+                      <a:schemeClr val="tx1"/>
+                    </a:solidFill>
+                    <a:effectLst/>
+                    <a:latin typeface="Arial" charset="0"/>
+                    <a:cs typeface="Arial" charset="0"/>
+                  </a:endParaRPr>
+                </a:p>
+              </p:txBody>
+            </p:sp>
+            <p:cxnSp>
+              <p:nvCxnSpPr>
+                <p:cNvPr id="15442" name="Elbow Connector 15441">
+                  <a:extLst>
+                    <a:ext uri="{FF2B5EF4-FFF2-40B4-BE49-F238E27FC236}">
+                      <a16:creationId xmlns:a16="http://schemas.microsoft.com/office/drawing/2014/main" id="{FD357802-D2BB-A2AC-2582-D36E431D92F1}"/>
+                    </a:ext>
+                  </a:extLst>
+                </p:cNvPr>
+                <p:cNvCxnSpPr>
+                  <a:cxnSpLocks/>
+                </p:cNvCxnSpPr>
+                <p:nvPr/>
+              </p:nvCxnSpPr>
+              <p:spPr bwMode="auto">
+                <a:xfrm flipV="1">
+                  <a:off x="2361558" y="18532980"/>
+                  <a:ext cx="953880" cy="801113"/>
+                </a:xfrm>
+                <a:prstGeom prst="bentConnector3">
+                  <a:avLst>
+                    <a:gd name="adj1" fmla="val -3922"/>
+                  </a:avLst>
+                </a:prstGeom>
+                <a:solidFill>
+                  <a:schemeClr val="accent1"/>
+                </a:solidFill>
+                <a:ln w="50800" cap="flat" cmpd="sng" algn="ctr">
+                  <a:solidFill>
+                    <a:schemeClr val="tx1"/>
+                  </a:solidFill>
+                  <a:prstDash val="solid"/>
+                  <a:round/>
+                  <a:headEnd type="none" w="med" len="med"/>
+                  <a:tailEnd type="triangle"/>
+                </a:ln>
+                <a:effectLst/>
+              </p:spPr>
+            </p:cxnSp>
+          </p:grpSp>
+          <p:grpSp>
+            <p:nvGrpSpPr>
+              <p:cNvPr id="15538" name="Group 15537">
+                <a:extLst>
+                  <a:ext uri="{FF2B5EF4-FFF2-40B4-BE49-F238E27FC236}">
+                    <a16:creationId xmlns:a16="http://schemas.microsoft.com/office/drawing/2014/main" id="{4ABA81B2-5B67-77D2-5517-08033E19241B}"/>
+                  </a:ext>
+                </a:extLst>
+              </p:cNvPr>
+              <p:cNvGrpSpPr/>
+              <p:nvPr/>
+            </p:nvGrpSpPr>
+            <p:grpSpPr>
+              <a:xfrm>
+                <a:off x="795814" y="16818784"/>
+                <a:ext cx="4146785" cy="1569660"/>
+                <a:chOff x="829782" y="16644992"/>
+                <a:chExt cx="4146785" cy="1569660"/>
+              </a:xfrm>
+            </p:grpSpPr>
+            <p:sp>
+              <p:nvSpPr>
+                <p:cNvPr id="15528" name="Rounded Rectangle 15527">
+                  <a:extLst>
+                    <a:ext uri="{FF2B5EF4-FFF2-40B4-BE49-F238E27FC236}">
+                      <a16:creationId xmlns:a16="http://schemas.microsoft.com/office/drawing/2014/main" id="{AD2DBFD4-1DD0-D27D-7CB0-35408A9E32E4}"/>
+                    </a:ext>
+                  </a:extLst>
+                </p:cNvPr>
+                <p:cNvSpPr/>
+                <p:nvPr/>
+              </p:nvSpPr>
+              <p:spPr bwMode="auto">
+                <a:xfrm>
+                  <a:off x="829782" y="16644992"/>
+                  <a:ext cx="2516152" cy="1569660"/>
+                </a:xfrm>
+                <a:prstGeom prst="roundRect">
+                  <a:avLst/>
+                </a:prstGeom>
+                <a:solidFill>
+                  <a:schemeClr val="accent1"/>
+                </a:solidFill>
+                <a:ln w="50800" cap="flat" cmpd="sng" algn="ctr">
+                  <a:solidFill>
+                    <a:schemeClr val="tx1"/>
+                  </a:solidFill>
+                  <a:prstDash val="solid"/>
+                  <a:round/>
+                  <a:headEnd type="none" w="med" len="med"/>
+                  <a:tailEnd type="none" w="med" len="med"/>
+                </a:ln>
+                <a:effectLst/>
+              </p:spPr>
+              <p:txBody>
+                <a:bodyPr vert="horz" wrap="square" lIns="91440" tIns="45720" rIns="91440" bIns="45720" numCol="1" rtlCol="0" anchor="t" anchorCtr="0" compatLnSpc="1">
+                  <a:prstTxWarp prst="textNoShape">
+                    <a:avLst/>
+                  </a:prstTxWarp>
+                </a:bodyPr>
+                <a:lstStyle/>
+                <a:p>
+                  <a:pPr algn="ctr" defTabSz="4389438" eaLnBrk="1" hangingPunct="1"/>
+                  <a:r>
+                    <a:rPr lang="en-US" sz="3000" dirty="0"/>
+                    <a:t>You are assigned a partner.</a:t>
+                  </a:r>
+                </a:p>
+                <a:p>
+                  <a:pPr marL="0" marR="0" indent="0" algn="l" defTabSz="4389438" rtl="0" eaLnBrk="1" fontAlgn="base" latinLnBrk="0" hangingPunct="1">
+                    <a:lnSpc>
+                      <a:spcPct val="100000"/>
+                    </a:lnSpc>
+                    <a:spcBef>
+                      <a:spcPct val="0"/>
+                    </a:spcBef>
+                    <a:spcAft>
+                      <a:spcPct val="0"/>
+                    </a:spcAft>
+                    <a:buClrTx/>
+                    <a:buSzTx/>
+                    <a:buFontTx/>
+                    <a:buNone/>
+                    <a:tabLst/>
+                  </a:pPr>
+                  <a:endParaRPr kumimoji="0" lang="en-US" sz="1800" b="0" i="0" u="none" strike="noStrike" cap="none" normalizeH="0" baseline="0" dirty="0">
+                    <a:ln>
+                      <a:noFill/>
+                    </a:ln>
+                    <a:solidFill>
+                      <a:schemeClr val="tx1"/>
+                    </a:solidFill>
+                    <a:effectLst/>
+                    <a:latin typeface="Arial" charset="0"/>
+                    <a:cs typeface="Arial" charset="0"/>
+                  </a:endParaRPr>
+                </a:p>
+              </p:txBody>
+            </p:sp>
+            <p:cxnSp>
+              <p:nvCxnSpPr>
+                <p:cNvPr id="15537" name="Straight Arrow Connector 15536">
+                  <a:extLst>
+                    <a:ext uri="{FF2B5EF4-FFF2-40B4-BE49-F238E27FC236}">
+                      <a16:creationId xmlns:a16="http://schemas.microsoft.com/office/drawing/2014/main" id="{7A1CFB10-A83A-AA5A-7CB9-EC39B260985E}"/>
+                    </a:ext>
+                  </a:extLst>
+                </p:cNvPr>
+                <p:cNvCxnSpPr>
+                  <a:cxnSpLocks/>
+                  <a:stCxn id="15528" idx="3"/>
+                </p:cNvCxnSpPr>
+                <p:nvPr/>
+              </p:nvCxnSpPr>
+              <p:spPr bwMode="auto">
+                <a:xfrm>
+                  <a:off x="3345934" y="17429822"/>
+                  <a:ext cx="1630633" cy="0"/>
+                </a:xfrm>
+                <a:prstGeom prst="straightConnector1">
+                  <a:avLst/>
+                </a:prstGeom>
+                <a:solidFill>
+                  <a:schemeClr val="accent1"/>
+                </a:solidFill>
+                <a:ln w="50800" cap="flat" cmpd="sng" algn="ctr">
+                  <a:solidFill>
+                    <a:schemeClr val="tx1"/>
+                  </a:solidFill>
+                  <a:prstDash val="solid"/>
+                  <a:round/>
+                  <a:headEnd type="none" w="med" len="med"/>
+                  <a:tailEnd type="triangle"/>
+                </a:ln>
+                <a:effectLst/>
+              </p:spPr>
+            </p:cxnSp>
           </p:grpSp>
           <p:sp>
             <p:nvSpPr>
-              <p:cNvPr id="15616" name="Rectangle 15615">
+              <p:cNvPr id="15542" name="Rounded Rectangle 15541">
                 <a:extLst>
                   <a:ext uri="{FF2B5EF4-FFF2-40B4-BE49-F238E27FC236}">
-                    <a16:creationId xmlns:a16="http://schemas.microsoft.com/office/drawing/2014/main" id="{946783DC-D597-2C29-6191-5B3893CFCF5D}"/>
+                    <a16:creationId xmlns:a16="http://schemas.microsoft.com/office/drawing/2014/main" id="{F919F17A-D127-CAD0-86F8-9896BB472FB5}"/>
                   </a:ext>
                 </a:extLst>
               </p:cNvPr>
@@ -16429,17 +17205,19 @@
             </p:nvSpPr>
             <p:spPr bwMode="auto">
               <a:xfrm>
-                <a:off x="4019981" y="18563950"/>
-                <a:ext cx="1803026" cy="552682"/>
+                <a:off x="1019445" y="25077499"/>
+                <a:ext cx="2843041" cy="764088"/>
               </a:xfrm>
-              <a:prstGeom prst="rect">
+              <a:prstGeom prst="roundRect">
                 <a:avLst/>
               </a:prstGeom>
               <a:solidFill>
-                <a:srgbClr val="848484"/>
+                <a:schemeClr val="accent1"/>
               </a:solidFill>
-              <a:ln w="9525" cap="flat" cmpd="sng" algn="ctr">
-                <a:noFill/>
+              <a:ln w="50800" cap="flat" cmpd="sng" algn="ctr">
+                <a:solidFill>
+                  <a:schemeClr val="tx1"/>
+                </a:solidFill>
                 <a:prstDash val="solid"/>
                 <a:round/>
                 <a:headEnd type="none" w="med" len="med"/>
@@ -16454,6 +17232,13 @@
                 </a:prstTxWarp>
               </a:bodyPr>
               <a:lstStyle/>
+              <a:p>
+                <a:pPr algn="ctr" defTabSz="4389438" eaLnBrk="1" hangingPunct="1"/>
+                <a:r>
+                  <a:rPr lang="en-US" sz="3500" dirty="0"/>
+                  <a:t>End of trial</a:t>
+                </a:r>
+              </a:p>
               <a:p>
                 <a:pPr marL="0" marR="0" indent="0" algn="l" defTabSz="4389438" rtl="0" eaLnBrk="1" fontAlgn="base" latinLnBrk="0" hangingPunct="1">
                   <a:lnSpc>
@@ -16471,29 +17256,26 @@
                   <a:buNone/>
                   <a:tabLst/>
                 </a:pPr>
-                <a:r>
-                  <a:rPr kumimoji="0" lang="en-US" sz="3000" b="0" i="0" u="none" strike="noStrike" cap="none" normalizeH="0" baseline="0" dirty="0">
-                    <a:ln>
-                      <a:noFill/>
-                    </a:ln>
-                    <a:solidFill>
-                      <a:schemeClr val="bg1"/>
-                    </a:solidFill>
-                    <a:effectLst/>
-                    <a:latin typeface="Arial" charset="0"/>
-                    <a:cs typeface="Arial" charset="0"/>
-                  </a:rPr>
-                  <a:t>Share $8</a:t>
-                </a:r>
+                <a:endParaRPr kumimoji="0" lang="en-US" sz="1800" b="0" i="0" u="none" strike="noStrike" cap="none" normalizeH="0" baseline="0" dirty="0">
+                  <a:ln>
+                    <a:noFill/>
+                  </a:ln>
+                  <a:solidFill>
+                    <a:schemeClr val="tx1"/>
+                  </a:solidFill>
+                  <a:effectLst/>
+                  <a:latin typeface="Arial" charset="0"/>
+                  <a:cs typeface="Arial" charset="0"/>
+                </a:endParaRPr>
               </a:p>
             </p:txBody>
           </p:sp>
           <p:sp>
             <p:nvSpPr>
-              <p:cNvPr id="15618" name="Rectangle 15617">
+              <p:cNvPr id="15667" name="Rounded Rectangle 15666">
                 <a:extLst>
                   <a:ext uri="{FF2B5EF4-FFF2-40B4-BE49-F238E27FC236}">
-                    <a16:creationId xmlns:a16="http://schemas.microsoft.com/office/drawing/2014/main" id="{C6024063-9D2C-50D8-70B5-FC3D7C6F49F8}"/>
+                    <a16:creationId xmlns:a16="http://schemas.microsoft.com/office/drawing/2014/main" id="{A04AF92B-DBCA-68B5-49E1-F021F79663D4}"/>
                   </a:ext>
                 </a:extLst>
               </p:cNvPr>
@@ -16502,374 +17284,8 @@
             </p:nvSpPr>
             <p:spPr bwMode="auto">
               <a:xfrm>
-                <a:off x="6502102" y="18568097"/>
-                <a:ext cx="1803026" cy="552682"/>
-              </a:xfrm>
-              <a:prstGeom prst="rect">
-                <a:avLst/>
-              </a:prstGeom>
-              <a:solidFill>
-                <a:srgbClr val="848484"/>
-              </a:solidFill>
-              <a:ln w="9525" cap="flat" cmpd="sng" algn="ctr">
-                <a:noFill/>
-                <a:prstDash val="solid"/>
-                <a:round/>
-                <a:headEnd type="none" w="med" len="med"/>
-                <a:tailEnd type="none" w="med" len="med"/>
-              </a:ln>
-              <a:effectLst/>
-            </p:spPr>
-            <p:txBody>
-              <a:bodyPr vert="horz" wrap="square" lIns="91440" tIns="45720" rIns="91440" bIns="45720" numCol="1" rtlCol="0" anchor="t" anchorCtr="0" compatLnSpc="1">
-                <a:prstTxWarp prst="textNoShape">
-                  <a:avLst/>
-                </a:prstTxWarp>
-              </a:bodyPr>
-              <a:lstStyle/>
-              <a:p>
-                <a:pPr marL="0" marR="0" indent="0" algn="l" defTabSz="4389438" rtl="0" eaLnBrk="1" fontAlgn="base" latinLnBrk="0" hangingPunct="1">
-                  <a:lnSpc>
-                    <a:spcPct val="100000"/>
-                  </a:lnSpc>
-                  <a:spcBef>
-                    <a:spcPct val="0"/>
-                  </a:spcBef>
-                  <a:spcAft>
-                    <a:spcPct val="0"/>
-                  </a:spcAft>
-                  <a:buClrTx/>
-                  <a:buSzTx/>
-                  <a:buFontTx/>
-                  <a:buNone/>
-                  <a:tabLst/>
-                </a:pPr>
-                <a:r>
-                  <a:rPr kumimoji="0" lang="en-US" sz="3000" b="0" i="0" u="none" strike="noStrike" cap="none" normalizeH="0" baseline="0" dirty="0">
-                    <a:ln>
-                      <a:noFill/>
-                    </a:ln>
-                    <a:solidFill>
-                      <a:schemeClr val="bg1"/>
-                    </a:solidFill>
-                    <a:effectLst/>
-                    <a:latin typeface="Arial" charset="0"/>
-                    <a:cs typeface="Arial" charset="0"/>
-                  </a:rPr>
-                  <a:t>Share $2</a:t>
-                </a:r>
-              </a:p>
-            </p:txBody>
-          </p:sp>
-          <p:sp>
-            <p:nvSpPr>
-              <p:cNvPr id="15619" name="Rectangle 15618">
-                <a:extLst>
-                  <a:ext uri="{FF2B5EF4-FFF2-40B4-BE49-F238E27FC236}">
-                    <a16:creationId xmlns:a16="http://schemas.microsoft.com/office/drawing/2014/main" id="{8EBB5886-1680-B3C7-DEC7-CD388B0CA60C}"/>
-                  </a:ext>
-                </a:extLst>
-              </p:cNvPr>
-              <p:cNvSpPr/>
-              <p:nvPr/>
-            </p:nvSpPr>
-            <p:spPr bwMode="auto">
-              <a:xfrm>
-                <a:off x="7005674" y="19674283"/>
-                <a:ext cx="1978245" cy="552682"/>
-              </a:xfrm>
-              <a:prstGeom prst="rect">
-                <a:avLst/>
-              </a:prstGeom>
-              <a:solidFill>
-                <a:srgbClr val="848484"/>
-              </a:solidFill>
-              <a:ln w="9525" cap="flat" cmpd="sng" algn="ctr">
-                <a:noFill/>
-                <a:prstDash val="solid"/>
-                <a:round/>
-                <a:headEnd type="none" w="med" len="med"/>
-                <a:tailEnd type="none" w="med" len="med"/>
-              </a:ln>
-              <a:effectLst/>
-            </p:spPr>
-            <p:txBody>
-              <a:bodyPr vert="horz" wrap="square" lIns="91440" tIns="45720" rIns="91440" bIns="45720" numCol="1" rtlCol="0" anchor="t" anchorCtr="0" compatLnSpc="1">
-                <a:prstTxWarp prst="textNoShape">
-                  <a:avLst/>
-                </a:prstTxWarp>
-              </a:bodyPr>
-              <a:lstStyle/>
-              <a:p>
-                <a:pPr marL="0" marR="0" indent="0" algn="l" defTabSz="4389438" rtl="0" eaLnBrk="1" fontAlgn="base" latinLnBrk="0" hangingPunct="1">
-                  <a:lnSpc>
-                    <a:spcPct val="100000"/>
-                  </a:lnSpc>
-                  <a:spcBef>
-                    <a:spcPct val="0"/>
-                  </a:spcBef>
-                  <a:spcAft>
-                    <a:spcPct val="0"/>
-                  </a:spcAft>
-                  <a:buClrTx/>
-                  <a:buSzTx/>
-                  <a:buFontTx/>
-                  <a:buNone/>
-                  <a:tabLst/>
-                </a:pPr>
-                <a:r>
-                  <a:rPr kumimoji="0" lang="en-US" sz="3000" b="0" i="0" u="none" strike="noStrike" cap="none" normalizeH="0" baseline="0" dirty="0">
-                    <a:ln>
-                      <a:noFill/>
-                    </a:ln>
-                    <a:solidFill>
-                      <a:schemeClr val="bg1"/>
-                    </a:solidFill>
-                    <a:effectLst/>
-                    <a:latin typeface="Arial" charset="0"/>
-                    <a:cs typeface="Arial" charset="0"/>
-                  </a:rPr>
-                  <a:t>Loading…</a:t>
-                </a:r>
-              </a:p>
-            </p:txBody>
-          </p:sp>
-          <p:sp>
-            <p:nvSpPr>
-              <p:cNvPr id="15620" name="Rectangle 15619">
-                <a:extLst>
-                  <a:ext uri="{FF2B5EF4-FFF2-40B4-BE49-F238E27FC236}">
-                    <a16:creationId xmlns:a16="http://schemas.microsoft.com/office/drawing/2014/main" id="{98A52E85-D70D-5398-4E75-D523A6EBBF49}"/>
-                  </a:ext>
-                </a:extLst>
-              </p:cNvPr>
-              <p:cNvSpPr/>
-              <p:nvPr/>
-            </p:nvSpPr>
-            <p:spPr bwMode="auto">
-              <a:xfrm>
-                <a:off x="9139048" y="21549198"/>
-                <a:ext cx="704737" cy="718761"/>
-              </a:xfrm>
-              <a:prstGeom prst="rect">
-                <a:avLst/>
-              </a:prstGeom>
-              <a:solidFill>
-                <a:srgbClr val="848484"/>
-              </a:solidFill>
-              <a:ln w="9525" cap="flat" cmpd="sng" algn="ctr">
-                <a:noFill/>
-                <a:prstDash val="solid"/>
-                <a:round/>
-                <a:headEnd type="none" w="med" len="med"/>
-                <a:tailEnd type="none" w="med" len="med"/>
-              </a:ln>
-              <a:effectLst/>
-            </p:spPr>
-            <p:txBody>
-              <a:bodyPr vert="horz" wrap="square" lIns="91440" tIns="45720" rIns="91440" bIns="45720" numCol="1" rtlCol="0" anchor="t" anchorCtr="0" compatLnSpc="1">
-                <a:prstTxWarp prst="textNoShape">
-                  <a:avLst/>
-                </a:prstTxWarp>
-              </a:bodyPr>
-              <a:lstStyle/>
-              <a:p>
-                <a:pPr marL="0" marR="0" indent="0" algn="ctr" defTabSz="4389438" rtl="0" eaLnBrk="1" fontAlgn="base" latinLnBrk="0" hangingPunct="1">
-                  <a:lnSpc>
-                    <a:spcPct val="100000"/>
-                  </a:lnSpc>
-                  <a:spcBef>
-                    <a:spcPct val="0"/>
-                  </a:spcBef>
-                  <a:spcAft>
-                    <a:spcPct val="0"/>
-                  </a:spcAft>
-                  <a:buClrTx/>
-                  <a:buSzTx/>
-                  <a:buFontTx/>
-                  <a:buNone/>
-                  <a:tabLst/>
-                </a:pPr>
-                <a:r>
-                  <a:rPr kumimoji="0" lang="en-US" sz="5000" b="0" i="0" u="none" strike="noStrike" cap="none" normalizeH="0" baseline="0" dirty="0">
-                    <a:ln>
-                      <a:noFill/>
-                    </a:ln>
-                    <a:solidFill>
-                      <a:schemeClr val="bg1"/>
-                    </a:solidFill>
-                    <a:effectLst/>
-                    <a:latin typeface="Arial" charset="0"/>
-                    <a:cs typeface="Arial" charset="0"/>
-                  </a:rPr>
-                  <a:t>+</a:t>
-                </a:r>
-              </a:p>
-            </p:txBody>
-          </p:sp>
-        </p:grpSp>
-        <p:sp>
-          <p:nvSpPr>
-            <p:cNvPr id="15429" name="Rounded Rectangle 15428">
-              <a:extLst>
-                <a:ext uri="{FF2B5EF4-FFF2-40B4-BE49-F238E27FC236}">
-                  <a16:creationId xmlns:a16="http://schemas.microsoft.com/office/drawing/2014/main" id="{4B7D9A17-B83C-E5E9-1709-3AF83FDD5AD6}"/>
-                </a:ext>
-              </a:extLst>
-            </p:cNvPr>
-            <p:cNvSpPr/>
-            <p:nvPr/>
-          </p:nvSpPr>
-          <p:spPr bwMode="auto">
-            <a:xfrm>
-              <a:off x="530502" y="15050793"/>
-              <a:ext cx="6101659" cy="707229"/>
-            </a:xfrm>
-            <a:prstGeom prst="roundRect">
-              <a:avLst/>
-            </a:prstGeom>
-            <a:solidFill>
-              <a:schemeClr val="accent1"/>
-            </a:solidFill>
-            <a:ln w="50800" cap="flat" cmpd="sng" algn="ctr">
-              <a:solidFill>
-                <a:schemeClr val="tx1"/>
-              </a:solidFill>
-              <a:prstDash val="solid"/>
-              <a:round/>
-              <a:headEnd type="none" w="med" len="med"/>
-              <a:tailEnd type="none" w="med" len="med"/>
-            </a:ln>
-            <a:effectLst/>
-          </p:spPr>
-          <p:txBody>
-            <a:bodyPr vert="horz" wrap="square" lIns="91440" tIns="45720" rIns="91440" bIns="45720" numCol="1" rtlCol="0" anchor="t" anchorCtr="0" compatLnSpc="1">
-              <a:prstTxWarp prst="textNoShape">
-                <a:avLst/>
-              </a:prstTxWarp>
-            </a:bodyPr>
-            <a:lstStyle/>
-            <a:p>
-              <a:pPr algn="ctr" defTabSz="4389438" eaLnBrk="1" hangingPunct="1"/>
-              <a:r>
-                <a:rPr lang="en-US" sz="3500" dirty="0"/>
-                <a:t>You are given </a:t>
-              </a:r>
-              <a:r>
-                <a:rPr lang="en-US" sz="3500" b="1" dirty="0"/>
-                <a:t>$8</a:t>
-              </a:r>
-              <a:r>
-                <a:rPr lang="en-US" sz="3500" dirty="0"/>
-                <a:t> for the trial. </a:t>
-              </a:r>
-            </a:p>
-            <a:p>
-              <a:pPr marL="0" marR="0" indent="0" algn="l" defTabSz="4389438" rtl="0" eaLnBrk="1" fontAlgn="base" latinLnBrk="0" hangingPunct="1">
-                <a:lnSpc>
-                  <a:spcPct val="100000"/>
-                </a:lnSpc>
-                <a:spcBef>
-                  <a:spcPct val="0"/>
-                </a:spcBef>
-                <a:spcAft>
-                  <a:spcPct val="0"/>
-                </a:spcAft>
-                <a:buClrTx/>
-                <a:buSzTx/>
-                <a:buFontTx/>
-                <a:buNone/>
-                <a:tabLst/>
-              </a:pPr>
-              <a:endParaRPr kumimoji="0" lang="en-US" sz="1800" b="0" i="0" u="none" strike="noStrike" cap="none" normalizeH="0" baseline="0" dirty="0">
-                <a:ln>
-                  <a:noFill/>
-                </a:ln>
-                <a:solidFill>
-                  <a:schemeClr val="tx1"/>
-                </a:solidFill>
-                <a:effectLst/>
-                <a:latin typeface="Arial" charset="0"/>
-                <a:cs typeface="Arial" charset="0"/>
-              </a:endParaRPr>
-            </a:p>
-          </p:txBody>
-        </p:sp>
-        <p:grpSp>
-          <p:nvGrpSpPr>
-            <p:cNvPr id="15592" name="Group 15591">
-              <a:extLst>
-                <a:ext uri="{FF2B5EF4-FFF2-40B4-BE49-F238E27FC236}">
-                  <a16:creationId xmlns:a16="http://schemas.microsoft.com/office/drawing/2014/main" id="{415B0EBC-8379-F485-6113-E5DF57F87E19}"/>
-                </a:ext>
-              </a:extLst>
-            </p:cNvPr>
-            <p:cNvGrpSpPr/>
-            <p:nvPr/>
-          </p:nvGrpSpPr>
-          <p:grpSpPr>
-            <a:xfrm>
-              <a:off x="1977783" y="21512239"/>
-              <a:ext cx="4758168" cy="1323439"/>
-              <a:chOff x="1599411" y="21740839"/>
-              <a:chExt cx="4758168" cy="1323439"/>
-            </a:xfrm>
-          </p:grpSpPr>
-          <p:sp>
-            <p:nvSpPr>
-              <p:cNvPr id="52" name="TextBox 51">
-                <a:extLst>
-                  <a:ext uri="{FF2B5EF4-FFF2-40B4-BE49-F238E27FC236}">
-                    <a16:creationId xmlns:a16="http://schemas.microsoft.com/office/drawing/2014/main" id="{4707B45F-027B-576B-4808-66F0A5D95489}"/>
-                  </a:ext>
-                </a:extLst>
-              </p:cNvPr>
-              <p:cNvSpPr txBox="1"/>
-              <p:nvPr/>
-            </p:nvSpPr>
-            <p:spPr>
-              <a:xfrm>
-                <a:off x="5031575" y="21740839"/>
-                <a:ext cx="1326004" cy="1323439"/>
-              </a:xfrm>
-              <a:prstGeom prst="rect">
-                <a:avLst/>
-              </a:prstGeom>
-              <a:noFill/>
-            </p:spPr>
-            <p:txBody>
-              <a:bodyPr wrap="none" rtlCol="0">
-                <a:spAutoFit/>
-              </a:bodyPr>
-              <a:lstStyle/>
-              <a:p>
-                <a:r>
-                  <a:rPr lang="en-US" sz="8000" b="1" dirty="0">
-                    <a:solidFill>
-                      <a:srgbClr val="03DF04"/>
-                    </a:solidFill>
-                  </a:rPr>
-                  <a:t>x3</a:t>
-                </a:r>
-              </a:p>
-            </p:txBody>
-          </p:sp>
-          <p:sp>
-            <p:nvSpPr>
-              <p:cNvPr id="15433" name="Rounded Rectangle 15432">
-                <a:extLst>
-                  <a:ext uri="{FF2B5EF4-FFF2-40B4-BE49-F238E27FC236}">
-                    <a16:creationId xmlns:a16="http://schemas.microsoft.com/office/drawing/2014/main" id="{9D770554-0135-2E8B-9BC3-8228F9631C8A}"/>
-                  </a:ext>
-                </a:extLst>
-              </p:cNvPr>
-              <p:cNvSpPr/>
-              <p:nvPr/>
-            </p:nvSpPr>
-            <p:spPr bwMode="auto">
-              <a:xfrm>
-                <a:off x="1599411" y="21817902"/>
-                <a:ext cx="2967279" cy="1168944"/>
+                <a:off x="530502" y="23379694"/>
+                <a:ext cx="3455135" cy="546012"/>
               </a:xfrm>
               <a:prstGeom prst="roundRect">
                 <a:avLst/>
@@ -16899,7 +17315,7 @@
                 <a:pPr algn="ctr" defTabSz="4389438" eaLnBrk="1" hangingPunct="1"/>
                 <a:r>
                   <a:rPr lang="en-US" sz="3000" dirty="0"/>
-                  <a:t>The money you  sent is tripled</a:t>
+                  <a:t>Outcome Phase</a:t>
                 </a:r>
               </a:p>
               <a:p>
@@ -16934,289 +17350,12 @@
             </p:txBody>
           </p:sp>
         </p:grpSp>
-        <p:grpSp>
-          <p:nvGrpSpPr>
-            <p:cNvPr id="15490" name="Group 15489">
+        <p:sp>
+          <p:nvSpPr>
+            <p:cNvPr id="15668" name="Rectangle 15667">
               <a:extLst>
                 <a:ext uri="{FF2B5EF4-FFF2-40B4-BE49-F238E27FC236}">
-                  <a16:creationId xmlns:a16="http://schemas.microsoft.com/office/drawing/2014/main" id="{26CF14B9-FE18-01D5-1A0A-E19BE8376A0A}"/>
-                </a:ext>
-              </a:extLst>
-            </p:cNvPr>
-            <p:cNvGrpSpPr/>
-            <p:nvPr/>
-          </p:nvGrpSpPr>
-          <p:grpSpPr>
-            <a:xfrm>
-              <a:off x="530502" y="18979791"/>
-              <a:ext cx="4534151" cy="2464546"/>
-              <a:chOff x="533974" y="18532980"/>
-              <a:chExt cx="4534151" cy="2464546"/>
-            </a:xfrm>
-          </p:grpSpPr>
-          <p:sp>
-            <p:nvSpPr>
-              <p:cNvPr id="15432" name="Rounded Rectangle 15431">
-                <a:extLst>
-                  <a:ext uri="{FF2B5EF4-FFF2-40B4-BE49-F238E27FC236}">
-                    <a16:creationId xmlns:a16="http://schemas.microsoft.com/office/drawing/2014/main" id="{29E5F4B4-9ECB-A12A-6B3F-C0855A0CDE34}"/>
-                  </a:ext>
-                </a:extLst>
-              </p:cNvPr>
-              <p:cNvSpPr/>
-              <p:nvPr/>
-            </p:nvSpPr>
-            <p:spPr bwMode="auto">
-              <a:xfrm>
-                <a:off x="533974" y="19334093"/>
-                <a:ext cx="4534151" cy="1663433"/>
-              </a:xfrm>
-              <a:prstGeom prst="roundRect">
-                <a:avLst/>
-              </a:prstGeom>
-              <a:solidFill>
-                <a:schemeClr val="accent1"/>
-              </a:solidFill>
-              <a:ln w="50800" cap="flat" cmpd="sng" algn="ctr">
-                <a:solidFill>
-                  <a:schemeClr val="tx1"/>
-                </a:solidFill>
-                <a:prstDash val="solid"/>
-                <a:round/>
-                <a:headEnd type="none" w="med" len="med"/>
-                <a:tailEnd type="none" w="med" len="med"/>
-              </a:ln>
-              <a:effectLst/>
-            </p:spPr>
-            <p:txBody>
-              <a:bodyPr vert="horz" wrap="square" lIns="91440" tIns="45720" rIns="91440" bIns="45720" numCol="1" rtlCol="0" anchor="t" anchorCtr="0" compatLnSpc="1">
-                <a:prstTxWarp prst="textNoShape">
-                  <a:avLst/>
-                </a:prstTxWarp>
-              </a:bodyPr>
-              <a:lstStyle/>
-              <a:p>
-                <a:pPr algn="ctr" defTabSz="4389438" eaLnBrk="1" hangingPunct="1"/>
-                <a:r>
-                  <a:rPr lang="en-US" sz="3000" dirty="0"/>
-                  <a:t>You choose a higher or lower amount to share with your partner.</a:t>
-                </a:r>
-              </a:p>
-              <a:p>
-                <a:pPr marL="0" marR="0" indent="0" algn="l" defTabSz="4389438" rtl="0" eaLnBrk="1" fontAlgn="base" latinLnBrk="0" hangingPunct="1">
-                  <a:lnSpc>
-                    <a:spcPct val="100000"/>
-                  </a:lnSpc>
-                  <a:spcBef>
-                    <a:spcPct val="0"/>
-                  </a:spcBef>
-                  <a:spcAft>
-                    <a:spcPct val="0"/>
-                  </a:spcAft>
-                  <a:buClrTx/>
-                  <a:buSzTx/>
-                  <a:buFontTx/>
-                  <a:buNone/>
-                  <a:tabLst/>
-                </a:pPr>
-                <a:endParaRPr kumimoji="0" lang="en-US" sz="1800" b="0" i="0" u="none" strike="noStrike" cap="none" normalizeH="0" baseline="0" dirty="0">
-                  <a:ln>
-                    <a:noFill/>
-                  </a:ln>
-                  <a:solidFill>
-                    <a:schemeClr val="tx1"/>
-                  </a:solidFill>
-                  <a:effectLst/>
-                  <a:latin typeface="Arial" charset="0"/>
-                  <a:cs typeface="Arial" charset="0"/>
-                </a:endParaRPr>
-              </a:p>
-            </p:txBody>
-          </p:sp>
-          <p:cxnSp>
-            <p:nvCxnSpPr>
-              <p:cNvPr id="15442" name="Elbow Connector 15441">
-                <a:extLst>
-                  <a:ext uri="{FF2B5EF4-FFF2-40B4-BE49-F238E27FC236}">
-                    <a16:creationId xmlns:a16="http://schemas.microsoft.com/office/drawing/2014/main" id="{FD357802-D2BB-A2AC-2582-D36E431D92F1}"/>
-                  </a:ext>
-                </a:extLst>
-              </p:cNvPr>
-              <p:cNvCxnSpPr>
-                <a:cxnSpLocks/>
-              </p:cNvCxnSpPr>
-              <p:nvPr/>
-            </p:nvCxnSpPr>
-            <p:spPr bwMode="auto">
-              <a:xfrm flipV="1">
-                <a:off x="2361558" y="18532980"/>
-                <a:ext cx="953880" cy="801113"/>
-              </a:xfrm>
-              <a:prstGeom prst="bentConnector3">
-                <a:avLst>
-                  <a:gd name="adj1" fmla="val -3922"/>
-                </a:avLst>
-              </a:prstGeom>
-              <a:solidFill>
-                <a:schemeClr val="accent1"/>
-              </a:solidFill>
-              <a:ln w="50800" cap="flat" cmpd="sng" algn="ctr">
-                <a:solidFill>
-                  <a:schemeClr val="tx1"/>
-                </a:solidFill>
-                <a:prstDash val="solid"/>
-                <a:round/>
-                <a:headEnd type="none" w="med" len="med"/>
-                <a:tailEnd type="triangle"/>
-              </a:ln>
-              <a:effectLst/>
-            </p:spPr>
-          </p:cxnSp>
-        </p:grpSp>
-        <p:grpSp>
-          <p:nvGrpSpPr>
-            <p:cNvPr id="15538" name="Group 15537">
-              <a:extLst>
-                <a:ext uri="{FF2B5EF4-FFF2-40B4-BE49-F238E27FC236}">
-                  <a16:creationId xmlns:a16="http://schemas.microsoft.com/office/drawing/2014/main" id="{4ABA81B2-5B67-77D2-5517-08033E19241B}"/>
-                </a:ext>
-              </a:extLst>
-            </p:cNvPr>
-            <p:cNvGrpSpPr/>
-            <p:nvPr/>
-          </p:nvGrpSpPr>
-          <p:grpSpPr>
-            <a:xfrm>
-              <a:off x="1364527" y="16818784"/>
-              <a:ext cx="3578072" cy="1569660"/>
-              <a:chOff x="1398495" y="16644992"/>
-              <a:chExt cx="3578072" cy="1569660"/>
-            </a:xfrm>
-          </p:grpSpPr>
-          <p:sp>
-            <p:nvSpPr>
-              <p:cNvPr id="15528" name="Rounded Rectangle 15527">
-                <a:extLst>
-                  <a:ext uri="{FF2B5EF4-FFF2-40B4-BE49-F238E27FC236}">
-                    <a16:creationId xmlns:a16="http://schemas.microsoft.com/office/drawing/2014/main" id="{AD2DBFD4-1DD0-D27D-7CB0-35408A9E32E4}"/>
-                  </a:ext>
-                </a:extLst>
-              </p:cNvPr>
-              <p:cNvSpPr/>
-              <p:nvPr/>
-            </p:nvSpPr>
-            <p:spPr bwMode="auto">
-              <a:xfrm>
-                <a:off x="1398495" y="16644992"/>
-                <a:ext cx="1947439" cy="1569660"/>
-              </a:xfrm>
-              <a:prstGeom prst="roundRect">
-                <a:avLst/>
-              </a:prstGeom>
-              <a:solidFill>
-                <a:schemeClr val="accent1"/>
-              </a:solidFill>
-              <a:ln w="50800" cap="flat" cmpd="sng" algn="ctr">
-                <a:solidFill>
-                  <a:schemeClr val="tx1"/>
-                </a:solidFill>
-                <a:prstDash val="solid"/>
-                <a:round/>
-                <a:headEnd type="none" w="med" len="med"/>
-                <a:tailEnd type="none" w="med" len="med"/>
-              </a:ln>
-              <a:effectLst/>
-            </p:spPr>
-            <p:txBody>
-              <a:bodyPr vert="horz" wrap="square" lIns="91440" tIns="45720" rIns="91440" bIns="45720" numCol="1" rtlCol="0" anchor="t" anchorCtr="0" compatLnSpc="1">
-                <a:prstTxWarp prst="textNoShape">
-                  <a:avLst/>
-                </a:prstTxWarp>
-              </a:bodyPr>
-              <a:lstStyle/>
-              <a:p>
-                <a:pPr algn="ctr" defTabSz="4389438" eaLnBrk="1" hangingPunct="1"/>
-                <a:r>
-                  <a:rPr lang="en-US" sz="3000" dirty="0"/>
-                  <a:t>You are assigned a partner.</a:t>
-                </a:r>
-              </a:p>
-              <a:p>
-                <a:pPr marL="0" marR="0" indent="0" algn="l" defTabSz="4389438" rtl="0" eaLnBrk="1" fontAlgn="base" latinLnBrk="0" hangingPunct="1">
-                  <a:lnSpc>
-                    <a:spcPct val="100000"/>
-                  </a:lnSpc>
-                  <a:spcBef>
-                    <a:spcPct val="0"/>
-                  </a:spcBef>
-                  <a:spcAft>
-                    <a:spcPct val="0"/>
-                  </a:spcAft>
-                  <a:buClrTx/>
-                  <a:buSzTx/>
-                  <a:buFontTx/>
-                  <a:buNone/>
-                  <a:tabLst/>
-                </a:pPr>
-                <a:endParaRPr kumimoji="0" lang="en-US" sz="1800" b="0" i="0" u="none" strike="noStrike" cap="none" normalizeH="0" baseline="0" dirty="0">
-                  <a:ln>
-                    <a:noFill/>
-                  </a:ln>
-                  <a:solidFill>
-                    <a:schemeClr val="tx1"/>
-                  </a:solidFill>
-                  <a:effectLst/>
-                  <a:latin typeface="Arial" charset="0"/>
-                  <a:cs typeface="Arial" charset="0"/>
-                </a:endParaRPr>
-              </a:p>
-            </p:txBody>
-          </p:sp>
-          <p:cxnSp>
-            <p:nvCxnSpPr>
-              <p:cNvPr id="15537" name="Straight Arrow Connector 15536">
-                <a:extLst>
-                  <a:ext uri="{FF2B5EF4-FFF2-40B4-BE49-F238E27FC236}">
-                    <a16:creationId xmlns:a16="http://schemas.microsoft.com/office/drawing/2014/main" id="{7A1CFB10-A83A-AA5A-7CB9-EC39B260985E}"/>
-                  </a:ext>
-                </a:extLst>
-              </p:cNvPr>
-              <p:cNvCxnSpPr>
-                <a:cxnSpLocks/>
-                <a:stCxn id="15528" idx="3"/>
-              </p:cNvCxnSpPr>
-              <p:nvPr/>
-            </p:nvCxnSpPr>
-            <p:spPr bwMode="auto">
-              <a:xfrm>
-                <a:off x="3345934" y="17429822"/>
-                <a:ext cx="1630633" cy="0"/>
-              </a:xfrm>
-              <a:prstGeom prst="straightConnector1">
-                <a:avLst/>
-              </a:prstGeom>
-              <a:solidFill>
-                <a:schemeClr val="accent1"/>
-              </a:solidFill>
-              <a:ln w="50800" cap="flat" cmpd="sng" algn="ctr">
-                <a:solidFill>
-                  <a:schemeClr val="tx1"/>
-                </a:solidFill>
-                <a:prstDash val="solid"/>
-                <a:round/>
-                <a:headEnd type="none" w="med" len="med"/>
-                <a:tailEnd type="triangle"/>
-              </a:ln>
-              <a:effectLst/>
-            </p:spPr>
-          </p:cxnSp>
-        </p:grpSp>
-        <p:sp>
-          <p:nvSpPr>
-            <p:cNvPr id="15542" name="Rounded Rectangle 15541">
-              <a:extLst>
-                <a:ext uri="{FF2B5EF4-FFF2-40B4-BE49-F238E27FC236}">
-                  <a16:creationId xmlns:a16="http://schemas.microsoft.com/office/drawing/2014/main" id="{F919F17A-D127-CAD0-86F8-9896BB472FB5}"/>
+                  <a16:creationId xmlns:a16="http://schemas.microsoft.com/office/drawing/2014/main" id="{313395CF-F0BD-08A4-741C-0E58C7C64F02}"/>
                 </a:ext>
               </a:extLst>
             </p:cNvPr>
@@ -17225,19 +17364,17 @@
           </p:nvSpPr>
           <p:spPr bwMode="auto">
             <a:xfrm>
-              <a:off x="1019445" y="25077499"/>
-              <a:ext cx="2843041" cy="764088"/>
+              <a:off x="5210967" y="17385583"/>
+              <a:ext cx="1984189" cy="552682"/>
             </a:xfrm>
-            <a:prstGeom prst="roundRect">
+            <a:prstGeom prst="rect">
               <a:avLst/>
             </a:prstGeom>
             <a:solidFill>
-              <a:schemeClr val="accent1"/>
+              <a:srgbClr val="848484"/>
             </a:solidFill>
-            <a:ln w="50800" cap="flat" cmpd="sng" algn="ctr">
-              <a:solidFill>
-                <a:schemeClr val="tx1"/>
-              </a:solidFill>
+            <a:ln w="9525" cap="flat" cmpd="sng" algn="ctr">
+              <a:noFill/>
               <a:prstDash val="solid"/>
               <a:round/>
               <a:headEnd type="none" w="med" len="med"/>
@@ -17252,13 +17389,6 @@
               </a:prstTxWarp>
             </a:bodyPr>
             <a:lstStyle/>
-            <a:p>
-              <a:pPr algn="ctr" defTabSz="4389438" eaLnBrk="1" hangingPunct="1"/>
-              <a:r>
-                <a:rPr lang="en-US" sz="3500" dirty="0"/>
-                <a:t>End of trial</a:t>
-              </a:r>
-            </a:p>
             <a:p>
               <a:pPr marL="0" marR="0" indent="0" algn="l" defTabSz="4389438" rtl="0" eaLnBrk="1" fontAlgn="base" latinLnBrk="0" hangingPunct="1">
                 <a:lnSpc>
@@ -17276,370 +17406,24 @@
                 <a:buNone/>
                 <a:tabLst/>
               </a:pPr>
-              <a:endParaRPr kumimoji="0" lang="en-US" sz="1800" b="0" i="0" u="none" strike="noStrike" cap="none" normalizeH="0" baseline="0" dirty="0">
-                <a:ln>
-                  <a:noFill/>
-                </a:ln>
-                <a:solidFill>
-                  <a:schemeClr val="tx1"/>
-                </a:solidFill>
-                <a:effectLst/>
-                <a:latin typeface="Arial" charset="0"/>
-                <a:cs typeface="Arial" charset="0"/>
-              </a:endParaRPr>
-            </a:p>
-          </p:txBody>
-        </p:sp>
-        <p:sp>
-          <p:nvSpPr>
-            <p:cNvPr id="15667" name="Rounded Rectangle 15666">
-              <a:extLst>
-                <a:ext uri="{FF2B5EF4-FFF2-40B4-BE49-F238E27FC236}">
-                  <a16:creationId xmlns:a16="http://schemas.microsoft.com/office/drawing/2014/main" id="{A04AF92B-DBCA-68B5-49E1-F021F79663D4}"/>
-                </a:ext>
-              </a:extLst>
-            </p:cNvPr>
-            <p:cNvSpPr/>
-            <p:nvPr/>
-          </p:nvSpPr>
-          <p:spPr bwMode="auto">
-            <a:xfrm>
-              <a:off x="882727" y="23270530"/>
-              <a:ext cx="3102910" cy="655177"/>
-            </a:xfrm>
-            <a:prstGeom prst="roundRect">
-              <a:avLst/>
-            </a:prstGeom>
-            <a:solidFill>
-              <a:schemeClr val="accent1"/>
-            </a:solidFill>
-            <a:ln w="50800" cap="flat" cmpd="sng" algn="ctr">
-              <a:solidFill>
-                <a:schemeClr val="tx1"/>
-              </a:solidFill>
-              <a:prstDash val="solid"/>
-              <a:round/>
-              <a:headEnd type="none" w="med" len="med"/>
-              <a:tailEnd type="none" w="med" len="med"/>
-            </a:ln>
-            <a:effectLst/>
-          </p:spPr>
-          <p:txBody>
-            <a:bodyPr vert="horz" wrap="square" lIns="91440" tIns="45720" rIns="91440" bIns="45720" numCol="1" rtlCol="0" anchor="t" anchorCtr="0" compatLnSpc="1">
-              <a:prstTxWarp prst="textNoShape">
-                <a:avLst/>
-              </a:prstTxWarp>
-            </a:bodyPr>
-            <a:lstStyle/>
-            <a:p>
-              <a:pPr algn="ctr" defTabSz="4389438" eaLnBrk="1" hangingPunct="1"/>
               <a:r>
-                <a:rPr lang="en-US" sz="3000" dirty="0"/>
-                <a:t>Outcome Phase</a:t>
-              </a:r>
-            </a:p>
-            <a:p>
-              <a:pPr marL="0" marR="0" indent="0" algn="l" defTabSz="4389438" rtl="0" eaLnBrk="1" fontAlgn="base" latinLnBrk="0" hangingPunct="1">
-                <a:lnSpc>
-                  <a:spcPct val="100000"/>
-                </a:lnSpc>
-                <a:spcBef>
-                  <a:spcPct val="0"/>
-                </a:spcBef>
-                <a:spcAft>
-                  <a:spcPct val="0"/>
-                </a:spcAft>
-                <a:buClrTx/>
-                <a:buSzTx/>
-                <a:buFontTx/>
-                <a:buNone/>
-                <a:tabLst/>
-              </a:pPr>
-              <a:endParaRPr kumimoji="0" lang="en-US" sz="1800" b="0" i="0" u="none" strike="noStrike" cap="none" normalizeH="0" baseline="0" dirty="0">
-                <a:ln>
-                  <a:noFill/>
-                </a:ln>
-                <a:solidFill>
-                  <a:schemeClr val="tx1"/>
-                </a:solidFill>
-                <a:effectLst/>
-                <a:latin typeface="Arial" charset="0"/>
-                <a:cs typeface="Arial" charset="0"/>
-              </a:endParaRPr>
-            </a:p>
-          </p:txBody>
-        </p:sp>
-      </p:grpSp>
-      <p:sp>
-        <p:nvSpPr>
-          <p:cNvPr id="15668" name="Rectangle 15667">
-            <a:extLst>
-              <a:ext uri="{FF2B5EF4-FFF2-40B4-BE49-F238E27FC236}">
-                <a16:creationId xmlns:a16="http://schemas.microsoft.com/office/drawing/2014/main" id="{313395CF-F0BD-08A4-741C-0E58C7C64F02}"/>
-              </a:ext>
-            </a:extLst>
-          </p:cNvPr>
-          <p:cNvSpPr/>
-          <p:nvPr/>
-        </p:nvSpPr>
-        <p:spPr bwMode="auto">
-          <a:xfrm>
-            <a:off x="5250937" y="17041236"/>
-            <a:ext cx="1984189" cy="552682"/>
-          </a:xfrm>
-          <a:prstGeom prst="rect">
-            <a:avLst/>
-          </a:prstGeom>
-          <a:solidFill>
-            <a:srgbClr val="848484"/>
-          </a:solidFill>
-          <a:ln w="9525" cap="flat" cmpd="sng" algn="ctr">
-            <a:noFill/>
-            <a:prstDash val="solid"/>
-            <a:round/>
-            <a:headEnd type="none" w="med" len="med"/>
-            <a:tailEnd type="none" w="med" len="med"/>
-          </a:ln>
-          <a:effectLst/>
-        </p:spPr>
-        <p:txBody>
-          <a:bodyPr vert="horz" wrap="square" lIns="91440" tIns="45720" rIns="91440" bIns="45720" numCol="1" rtlCol="0" anchor="t" anchorCtr="0" compatLnSpc="1">
-            <a:prstTxWarp prst="textNoShape">
-              <a:avLst/>
-            </a:prstTxWarp>
-          </a:bodyPr>
-          <a:lstStyle/>
-          <a:p>
-            <a:pPr marL="0" marR="0" indent="0" algn="l" defTabSz="4389438" rtl="0" eaLnBrk="1" fontAlgn="base" latinLnBrk="0" hangingPunct="1">
-              <a:lnSpc>
-                <a:spcPct val="100000"/>
-              </a:lnSpc>
-              <a:spcBef>
-                <a:spcPct val="0"/>
-              </a:spcBef>
-              <a:spcAft>
-                <a:spcPct val="0"/>
-              </a:spcAft>
-              <a:buClrTx/>
-              <a:buSzTx/>
-              <a:buFontTx/>
-              <a:buNone/>
-              <a:tabLst/>
-            </a:pPr>
-            <a:r>
-              <a:rPr kumimoji="0" lang="en-US" sz="3000" b="0" i="0" u="none" strike="noStrike" cap="none" normalizeH="0" baseline="0" dirty="0">
-                <a:ln>
-                  <a:noFill/>
-                </a:ln>
-                <a:solidFill>
-                  <a:schemeClr val="bg1"/>
-                </a:solidFill>
-                <a:effectLst/>
-                <a:latin typeface="Arial" charset="0"/>
-                <a:cs typeface="Arial" charset="0"/>
-              </a:rPr>
-              <a:t>Computer</a:t>
-            </a:r>
-          </a:p>
-        </p:txBody>
-      </p:sp>
-      <p:grpSp>
-        <p:nvGrpSpPr>
-          <p:cNvPr id="15708" name="Group 15707">
-            <a:extLst>
-              <a:ext uri="{FF2B5EF4-FFF2-40B4-BE49-F238E27FC236}">
-                <a16:creationId xmlns:a16="http://schemas.microsoft.com/office/drawing/2014/main" id="{F3365FFA-9BF5-9EF3-928F-677A1E435CFE}"/>
-              </a:ext>
-            </a:extLst>
-          </p:cNvPr>
-          <p:cNvGrpSpPr/>
-          <p:nvPr/>
-        </p:nvGrpSpPr>
-        <p:grpSpPr>
-          <a:xfrm>
-            <a:off x="30903522" y="7424174"/>
-            <a:ext cx="4158601" cy="4608107"/>
-            <a:chOff x="30952728" y="4266720"/>
-            <a:chExt cx="6212381" cy="7672821"/>
-          </a:xfrm>
-        </p:grpSpPr>
-        <p:pic>
-          <p:nvPicPr>
-            <p:cNvPr id="15670" name="Picture 15669" descr="A brain with a red spot&#10;&#10;Description automatically generated">
-              <a:extLst>
-                <a:ext uri="{FF2B5EF4-FFF2-40B4-BE49-F238E27FC236}">
-                  <a16:creationId xmlns:a16="http://schemas.microsoft.com/office/drawing/2014/main" id="{BA2FE39D-46B1-0722-481F-CB4E6283E65E}"/>
-                </a:ext>
-              </a:extLst>
-            </p:cNvPr>
-            <p:cNvPicPr>
-              <a:picLocks noChangeAspect="1"/>
-            </p:cNvPicPr>
-            <p:nvPr/>
-          </p:nvPicPr>
-          <p:blipFill>
-            <a:blip r:embed="rId15">
-              <a:extLst>
-                <a:ext uri="{28A0092B-C50C-407E-A947-70E740481C1C}">
-                  <a14:useLocalDpi xmlns:a14="http://schemas.microsoft.com/office/drawing/2010/main" val="0"/>
-                </a:ext>
-              </a:extLst>
-            </a:blip>
-            <a:stretch>
-              <a:fillRect/>
-            </a:stretch>
-          </p:blipFill>
-          <p:spPr>
-            <a:xfrm>
-              <a:off x="31172216" y="5328136"/>
-              <a:ext cx="5683649" cy="4771937"/>
-            </a:xfrm>
-            <a:prstGeom prst="rect">
-              <a:avLst/>
-            </a:prstGeom>
-          </p:spPr>
-        </p:pic>
-        <p:sp>
-          <p:nvSpPr>
-            <p:cNvPr id="15674" name="TextBox 15673">
-              <a:extLst>
-                <a:ext uri="{FF2B5EF4-FFF2-40B4-BE49-F238E27FC236}">
-                  <a16:creationId xmlns:a16="http://schemas.microsoft.com/office/drawing/2014/main" id="{6D1FEF78-5231-7339-DB44-5A31EBAD6F9E}"/>
-                </a:ext>
-              </a:extLst>
-            </p:cNvPr>
-            <p:cNvSpPr txBox="1"/>
-            <p:nvPr/>
-          </p:nvSpPr>
-          <p:spPr>
-            <a:xfrm>
-              <a:off x="30952728" y="4266720"/>
-              <a:ext cx="1539203" cy="707886"/>
-            </a:xfrm>
-            <a:prstGeom prst="rect">
-              <a:avLst/>
-            </a:prstGeom>
-            <a:noFill/>
-          </p:spPr>
-          <p:txBody>
-            <a:bodyPr wrap="none" rtlCol="0">
-              <a:spAutoFit/>
-            </a:bodyPr>
-            <a:lstStyle/>
-            <a:p>
-              <a:r>
-                <a:rPr lang="en-US" sz="4000" dirty="0"/>
-                <a:t>X= 52</a:t>
-              </a:r>
-            </a:p>
-          </p:txBody>
-        </p:sp>
-        <p:sp>
-          <p:nvSpPr>
-            <p:cNvPr id="15680" name="TextBox 15679">
-              <a:extLst>
-                <a:ext uri="{FF2B5EF4-FFF2-40B4-BE49-F238E27FC236}">
-                  <a16:creationId xmlns:a16="http://schemas.microsoft.com/office/drawing/2014/main" id="{0FE2F447-254E-923E-162C-DC99AACAFC55}"/>
-                </a:ext>
-              </a:extLst>
-            </p:cNvPr>
-            <p:cNvSpPr txBox="1"/>
-            <p:nvPr/>
-          </p:nvSpPr>
-          <p:spPr>
-            <a:xfrm>
-              <a:off x="31154497" y="10453379"/>
-              <a:ext cx="6010612" cy="1486162"/>
-            </a:xfrm>
-            <a:prstGeom prst="rect">
-              <a:avLst/>
-            </a:prstGeom>
-            <a:noFill/>
-          </p:spPr>
-          <p:txBody>
-            <a:bodyPr wrap="square">
-              <a:spAutoFit/>
-            </a:bodyPr>
-            <a:lstStyle/>
-            <a:p>
-              <a:r>
-                <a:rPr lang="en-US" sz="2000" dirty="0">
-                  <a:latin typeface="Helvetica"/>
+                <a:rPr kumimoji="0" lang="en-US" sz="3000" b="0" i="0" u="none" strike="noStrike" cap="none" normalizeH="0" baseline="0" dirty="0">
+                  <a:ln>
+                    <a:noFill/>
+                  </a:ln>
+                  <a:solidFill>
+                    <a:schemeClr val="bg1"/>
+                  </a:solidFill>
+                  <a:effectLst/>
+                  <a:latin typeface="Arial" charset="0"/>
+                  <a:cs typeface="Arial" charset="0"/>
                 </a:rPr>
-                <a:t>Dorsolateral Prefrontal Cortex</a:t>
-              </a:r>
-            </a:p>
-            <a:p>
-              <a:r>
-                <a:rPr lang="en-US" sz="3200" b="1" dirty="0">
-                  <a:latin typeface="Helvetica"/>
-                </a:rPr>
-                <a:t>(</a:t>
-              </a:r>
-              <a:r>
-                <a:rPr lang="en-US" sz="3200" b="1" dirty="0" err="1">
-                  <a:latin typeface="Helvetica"/>
-                </a:rPr>
-                <a:t>dlPFC</a:t>
-              </a:r>
-              <a:r>
-                <a:rPr lang="en-US" sz="3200" b="1" dirty="0">
-                  <a:latin typeface="Helvetica"/>
-                </a:rPr>
-                <a:t>)</a:t>
+                <a:t>Computer</a:t>
               </a:r>
             </a:p>
           </p:txBody>
         </p:sp>
       </p:grpSp>
-      <p:sp>
-        <p:nvSpPr>
-          <p:cNvPr id="15707" name="TextBox 15706">
-            <a:extLst>
-              <a:ext uri="{FF2B5EF4-FFF2-40B4-BE49-F238E27FC236}">
-                <a16:creationId xmlns:a16="http://schemas.microsoft.com/office/drawing/2014/main" id="{0830B512-1237-C170-3104-978D2CC18E8D}"/>
-              </a:ext>
-            </a:extLst>
-          </p:cNvPr>
-          <p:cNvSpPr txBox="1"/>
-          <p:nvPr/>
-        </p:nvSpPr>
-        <p:spPr>
-          <a:xfrm>
-            <a:off x="31126040" y="5975181"/>
-            <a:ext cx="4272148" cy="1077218"/>
-          </a:xfrm>
-          <a:prstGeom prst="rect">
-            <a:avLst/>
-          </a:prstGeom>
-          <a:noFill/>
-        </p:spPr>
-        <p:txBody>
-          <a:bodyPr wrap="square" rtlCol="0">
-            <a:spAutoFit/>
-          </a:bodyPr>
-          <a:lstStyle/>
-          <a:p>
-            <a:r>
-              <a:rPr lang="en-US" sz="3200" b="0" i="0" dirty="0">
-                <a:effectLst/>
-                <a:latin typeface="Helvetica" pitchFamily="2" charset="0"/>
-              </a:rPr>
-              <a:t>Friend Defecting &gt;</a:t>
-            </a:r>
-            <a:r>
-              <a:rPr lang="en-US" sz="3200" dirty="0">
-                <a:latin typeface="Helvetica" pitchFamily="2" charset="0"/>
-              </a:rPr>
-              <a:t> Computer Defecting</a:t>
-            </a:r>
-            <a:endParaRPr lang="en-US" sz="3200" i="0" dirty="0">
-              <a:effectLst/>
-              <a:latin typeface="Helvetica" pitchFamily="2" charset="0"/>
-            </a:endParaRPr>
-          </a:p>
-        </p:txBody>
-      </p:sp>
       <p:grpSp>
         <p:nvGrpSpPr>
           <p:cNvPr id="15637" name="Group 15636">
@@ -17654,10 +17438,10 @@
         </p:nvGrpSpPr>
         <p:grpSpPr>
           <a:xfrm>
-            <a:off x="22279873" y="23179900"/>
-            <a:ext cx="7100482" cy="6722925"/>
-            <a:chOff x="23651698" y="15981033"/>
-            <a:chExt cx="5439385" cy="4978568"/>
+            <a:off x="22103183" y="23179902"/>
+            <a:ext cx="7277183" cy="6638191"/>
+            <a:chOff x="23516336" y="15981033"/>
+            <a:chExt cx="5574747" cy="4915819"/>
           </a:xfrm>
         </p:grpSpPr>
         <p:grpSp>
@@ -17674,10 +17458,10 @@
           </p:nvGrpSpPr>
           <p:grpSpPr>
             <a:xfrm>
-              <a:off x="23697980" y="17116394"/>
-              <a:ext cx="3687265" cy="3843207"/>
-              <a:chOff x="23697980" y="17116394"/>
-              <a:chExt cx="3687265" cy="3843207"/>
+              <a:off x="23516336" y="16721772"/>
+              <a:ext cx="3469498" cy="4175080"/>
+              <a:chOff x="23516336" y="16721772"/>
+              <a:chExt cx="3469498" cy="4175080"/>
             </a:xfrm>
           </p:grpSpPr>
           <p:sp>
@@ -17694,8 +17478,8 @@
             </p:nvSpPr>
             <p:spPr>
               <a:xfrm>
-                <a:off x="26427414" y="20342994"/>
-                <a:ext cx="957831" cy="616607"/>
+                <a:off x="26321244" y="20486597"/>
+                <a:ext cx="664590" cy="410255"/>
               </a:xfrm>
               <a:prstGeom prst="rect">
                 <a:avLst/>
@@ -17709,7 +17493,7 @@
               <a:lstStyle/>
               <a:p>
                 <a:r>
-                  <a:rPr lang="en-US" sz="4000" dirty="0"/>
+                  <a:rPr lang="en-US" sz="3000" dirty="0"/>
                   <a:t>Age</a:t>
                 </a:r>
               </a:p>
@@ -17729,8 +17513,8 @@
             </p:nvSpPr>
             <p:spPr>
               <a:xfrm rot="16200000">
-                <a:off x="22492430" y="18321944"/>
-                <a:ext cx="2835495" cy="424395"/>
+                <a:off x="22259180" y="17978928"/>
+                <a:ext cx="2938707" cy="424395"/>
               </a:xfrm>
               <a:prstGeom prst="rect">
                 <a:avLst/>
@@ -17894,10 +17678,10 @@
       </p:grpSp>
       <p:grpSp>
         <p:nvGrpSpPr>
-          <p:cNvPr id="4" name="Group 3">
+          <p:cNvPr id="38" name="Group 37">
             <a:extLst>
               <a:ext uri="{FF2B5EF4-FFF2-40B4-BE49-F238E27FC236}">
-                <a16:creationId xmlns:a16="http://schemas.microsoft.com/office/drawing/2014/main" id="{1655AFED-3947-A740-B235-4AE33711962C}"/>
+                <a16:creationId xmlns:a16="http://schemas.microsoft.com/office/drawing/2014/main" id="{7D2FE0E2-6053-4146-B370-FB37B649225A}"/>
               </a:ext>
             </a:extLst>
           </p:cNvPr>
@@ -17906,18 +17690,150 @@
         </p:nvGrpSpPr>
         <p:grpSpPr>
           <a:xfrm>
-            <a:off x="35398172" y="5929252"/>
-            <a:ext cx="7128218" cy="6349248"/>
-            <a:chOff x="37564868" y="7069792"/>
-            <a:chExt cx="5452955" cy="5157377"/>
+            <a:off x="31053369" y="6779852"/>
+            <a:ext cx="11558081" cy="6349248"/>
+            <a:chOff x="30968309" y="6482142"/>
+            <a:chExt cx="11558081" cy="6349248"/>
           </a:xfrm>
         </p:grpSpPr>
+        <p:grpSp>
+          <p:nvGrpSpPr>
+            <p:cNvPr id="15708" name="Group 15707">
+              <a:extLst>
+                <a:ext uri="{FF2B5EF4-FFF2-40B4-BE49-F238E27FC236}">
+                  <a16:creationId xmlns:a16="http://schemas.microsoft.com/office/drawing/2014/main" id="{F3365FFA-9BF5-9EF3-928F-677A1E435CFE}"/>
+                </a:ext>
+              </a:extLst>
+            </p:cNvPr>
+            <p:cNvGrpSpPr/>
+            <p:nvPr/>
+          </p:nvGrpSpPr>
+          <p:grpSpPr>
+            <a:xfrm>
+              <a:off x="30968309" y="8084700"/>
+              <a:ext cx="4158601" cy="4300330"/>
+              <a:chOff x="30952728" y="4266720"/>
+              <a:chExt cx="6212381" cy="7160350"/>
+            </a:xfrm>
+          </p:grpSpPr>
+          <p:pic>
+            <p:nvPicPr>
+              <p:cNvPr id="15670" name="Picture 15669" descr="A brain with a red spot&#10;&#10;Description automatically generated">
+                <a:extLst>
+                  <a:ext uri="{FF2B5EF4-FFF2-40B4-BE49-F238E27FC236}">
+                    <a16:creationId xmlns:a16="http://schemas.microsoft.com/office/drawing/2014/main" id="{BA2FE39D-46B1-0722-481F-CB4E6283E65E}"/>
+                  </a:ext>
+                </a:extLst>
+              </p:cNvPr>
+              <p:cNvPicPr>
+                <a:picLocks noChangeAspect="1"/>
+              </p:cNvPicPr>
+              <p:nvPr/>
+            </p:nvPicPr>
+            <p:blipFill>
+              <a:blip r:embed="rId15">
+                <a:extLst>
+                  <a:ext uri="{28A0092B-C50C-407E-A947-70E740481C1C}">
+                    <a14:useLocalDpi xmlns:a14="http://schemas.microsoft.com/office/drawing/2010/main" val="0"/>
+                  </a:ext>
+                </a:extLst>
+              </a:blip>
+              <a:stretch>
+                <a:fillRect/>
+              </a:stretch>
+            </p:blipFill>
+            <p:spPr>
+              <a:xfrm>
+                <a:off x="31172216" y="5328136"/>
+                <a:ext cx="5683649" cy="4771937"/>
+              </a:xfrm>
+              <a:prstGeom prst="rect">
+                <a:avLst/>
+              </a:prstGeom>
+            </p:spPr>
+          </p:pic>
+          <p:sp>
+            <p:nvSpPr>
+              <p:cNvPr id="15674" name="TextBox 15673">
+                <a:extLst>
+                  <a:ext uri="{FF2B5EF4-FFF2-40B4-BE49-F238E27FC236}">
+                    <a16:creationId xmlns:a16="http://schemas.microsoft.com/office/drawing/2014/main" id="{6D1FEF78-5231-7339-DB44-5A31EBAD6F9E}"/>
+                  </a:ext>
+                </a:extLst>
+              </p:cNvPr>
+              <p:cNvSpPr txBox="1"/>
+              <p:nvPr/>
+            </p:nvSpPr>
+            <p:spPr>
+              <a:xfrm>
+                <a:off x="30952728" y="4266720"/>
+                <a:ext cx="1539203" cy="707886"/>
+              </a:xfrm>
+              <a:prstGeom prst="rect">
+                <a:avLst/>
+              </a:prstGeom>
+              <a:noFill/>
+            </p:spPr>
+            <p:txBody>
+              <a:bodyPr wrap="none" rtlCol="0">
+                <a:spAutoFit/>
+              </a:bodyPr>
+              <a:lstStyle/>
+              <a:p>
+                <a:r>
+                  <a:rPr lang="en-US" sz="4000" dirty="0"/>
+                  <a:t>X= 52</a:t>
+                </a:r>
+              </a:p>
+            </p:txBody>
+          </p:sp>
+          <p:sp>
+            <p:nvSpPr>
+              <p:cNvPr id="15680" name="TextBox 15679">
+                <a:extLst>
+                  <a:ext uri="{FF2B5EF4-FFF2-40B4-BE49-F238E27FC236}">
+                    <a16:creationId xmlns:a16="http://schemas.microsoft.com/office/drawing/2014/main" id="{0FE2F447-254E-923E-162C-DC99AACAFC55}"/>
+                  </a:ext>
+                </a:extLst>
+              </p:cNvPr>
+              <p:cNvSpPr txBox="1"/>
+              <p:nvPr/>
+            </p:nvSpPr>
+            <p:spPr>
+              <a:xfrm>
+                <a:off x="31154497" y="10453379"/>
+                <a:ext cx="6010612" cy="973691"/>
+              </a:xfrm>
+              <a:prstGeom prst="rect">
+                <a:avLst/>
+              </a:prstGeom>
+              <a:noFill/>
+            </p:spPr>
+            <p:txBody>
+              <a:bodyPr wrap="square">
+                <a:spAutoFit/>
+              </a:bodyPr>
+              <a:lstStyle/>
+              <a:p>
+                <a:r>
+                  <a:rPr lang="en-US" sz="3200" b="1" dirty="0" err="1">
+                    <a:latin typeface="Helvetica"/>
+                  </a:rPr>
+                  <a:t>dlPFC</a:t>
+                </a:r>
+                <a:endParaRPr lang="en-US" sz="3200" b="1" dirty="0">
+                  <a:latin typeface="Helvetica"/>
+                </a:endParaRPr>
+              </a:p>
+            </p:txBody>
+          </p:sp>
+        </p:grpSp>
         <p:sp>
           <p:nvSpPr>
-            <p:cNvPr id="15711" name="TextBox 15710">
+            <p:cNvPr id="15707" name="TextBox 15706">
               <a:extLst>
                 <a:ext uri="{FF2B5EF4-FFF2-40B4-BE49-F238E27FC236}">
-                  <a16:creationId xmlns:a16="http://schemas.microsoft.com/office/drawing/2014/main" id="{3F0968C1-C452-1885-6B38-F154CD473A3F}"/>
+                  <a16:creationId xmlns:a16="http://schemas.microsoft.com/office/drawing/2014/main" id="{0830B512-1237-C170-3104-978D2CC18E8D}"/>
                 </a:ext>
               </a:extLst>
             </p:cNvPr>
@@ -17926,8 +17842,8 @@
           </p:nvSpPr>
           <p:spPr>
             <a:xfrm>
-              <a:off x="37622248" y="7069792"/>
-              <a:ext cx="601117" cy="425002"/>
+              <a:off x="31126040" y="6528071"/>
+              <a:ext cx="4272148" cy="1077218"/>
             </a:xfrm>
             <a:prstGeom prst="rect">
               <a:avLst/>
@@ -17935,194 +17851,263 @@
             <a:noFill/>
           </p:spPr>
           <p:txBody>
-            <a:bodyPr wrap="none" rtlCol="0">
+            <a:bodyPr wrap="square" rtlCol="0">
               <a:spAutoFit/>
             </a:bodyPr>
             <a:lstStyle/>
             <a:p>
               <a:r>
-                <a:rPr lang="en-US" sz="2800" dirty="0"/>
-                <a:t>200</a:t>
+                <a:rPr lang="en-US" sz="3200" b="0" i="0" dirty="0">
+                  <a:effectLst/>
+                  <a:latin typeface="Helvetica" pitchFamily="2" charset="0"/>
+                </a:rPr>
+                <a:t>Friend Defecting &gt;</a:t>
               </a:r>
+              <a:r>
+                <a:rPr lang="en-US" sz="3200" dirty="0">
+                  <a:latin typeface="Helvetica" pitchFamily="2" charset="0"/>
+                </a:rPr>
+                <a:t> Computer Defecting</a:t>
+              </a:r>
+              <a:endParaRPr lang="en-US" sz="3200" i="0" dirty="0">
+                <a:effectLst/>
+                <a:latin typeface="Helvetica" pitchFamily="2" charset="0"/>
+              </a:endParaRPr>
             </a:p>
           </p:txBody>
         </p:sp>
-        <p:sp>
-          <p:nvSpPr>
-            <p:cNvPr id="15713" name="TextBox 15712">
+        <p:grpSp>
+          <p:nvGrpSpPr>
+            <p:cNvPr id="4" name="Group 3">
               <a:extLst>
                 <a:ext uri="{FF2B5EF4-FFF2-40B4-BE49-F238E27FC236}">
-                  <a16:creationId xmlns:a16="http://schemas.microsoft.com/office/drawing/2014/main" id="{0538FBF6-7909-445F-ACD2-9599FE92C967}"/>
+                  <a16:creationId xmlns:a16="http://schemas.microsoft.com/office/drawing/2014/main" id="{1655AFED-3947-A740-B235-4AE33711962C}"/>
                 </a:ext>
               </a:extLst>
             </p:cNvPr>
-            <p:cNvSpPr txBox="1"/>
+            <p:cNvGrpSpPr/>
             <p:nvPr/>
-          </p:nvSpPr>
-          <p:spPr>
+          </p:nvGrpSpPr>
+          <p:grpSpPr>
             <a:xfrm>
-              <a:off x="37564868" y="11337187"/>
-              <a:ext cx="693086" cy="425002"/>
+              <a:off x="35398172" y="6482142"/>
+              <a:ext cx="7128218" cy="6349248"/>
+              <a:chOff x="37564868" y="7069792"/>
+              <a:chExt cx="5452955" cy="5157377"/>
             </a:xfrm>
-            <a:prstGeom prst="rect">
-              <a:avLst/>
-            </a:prstGeom>
-            <a:noFill/>
-          </p:spPr>
-          <p:txBody>
-            <a:bodyPr wrap="none" rtlCol="0">
-              <a:spAutoFit/>
-            </a:bodyPr>
-            <a:lstStyle/>
-            <a:p>
-              <a:r>
-                <a:rPr lang="en-US" sz="2800" dirty="0"/>
-                <a:t>-300</a:t>
-              </a:r>
-            </a:p>
-          </p:txBody>
-        </p:sp>
-        <p:sp>
-          <p:nvSpPr>
-            <p:cNvPr id="15716" name="TextBox 15715">
-              <a:extLst>
-                <a:ext uri="{FF2B5EF4-FFF2-40B4-BE49-F238E27FC236}">
-                  <a16:creationId xmlns:a16="http://schemas.microsoft.com/office/drawing/2014/main" id="{A7B791E9-2592-EA60-AB27-F2DBE3421768}"/>
-                </a:ext>
-              </a:extLst>
-            </p:cNvPr>
-            <p:cNvSpPr txBox="1"/>
-            <p:nvPr/>
-          </p:nvSpPr>
-          <p:spPr>
-            <a:xfrm>
-              <a:off x="38211199" y="11728946"/>
-              <a:ext cx="447833" cy="425002"/>
-            </a:xfrm>
-            <a:prstGeom prst="rect">
-              <a:avLst/>
-            </a:prstGeom>
-            <a:noFill/>
-          </p:spPr>
-          <p:txBody>
-            <a:bodyPr wrap="none" rtlCol="0">
-              <a:spAutoFit/>
-            </a:bodyPr>
-            <a:lstStyle/>
-            <a:p>
-              <a:r>
-                <a:rPr lang="en-US" sz="2800" dirty="0"/>
-                <a:t>20</a:t>
-              </a:r>
-            </a:p>
-          </p:txBody>
-        </p:sp>
-        <p:sp>
-          <p:nvSpPr>
-            <p:cNvPr id="15717" name="TextBox 15716">
-              <a:extLst>
-                <a:ext uri="{FF2B5EF4-FFF2-40B4-BE49-F238E27FC236}">
-                  <a16:creationId xmlns:a16="http://schemas.microsoft.com/office/drawing/2014/main" id="{4288430D-B235-E5D2-0E3C-C928486D0544}"/>
-                </a:ext>
-              </a:extLst>
-            </p:cNvPr>
-            <p:cNvSpPr txBox="1"/>
-            <p:nvPr/>
-          </p:nvSpPr>
-          <p:spPr>
-            <a:xfrm>
-              <a:off x="42569990" y="11706123"/>
-              <a:ext cx="447833" cy="425002"/>
-            </a:xfrm>
-            <a:prstGeom prst="rect">
-              <a:avLst/>
-            </a:prstGeom>
-            <a:noFill/>
-          </p:spPr>
-          <p:txBody>
-            <a:bodyPr wrap="none" rtlCol="0">
-              <a:spAutoFit/>
-            </a:bodyPr>
-            <a:lstStyle/>
-            <a:p>
-              <a:r>
-                <a:rPr lang="en-US" sz="2800" dirty="0"/>
-                <a:t>70</a:t>
-              </a:r>
-            </a:p>
-          </p:txBody>
-        </p:sp>
-        <p:sp>
-          <p:nvSpPr>
-            <p:cNvPr id="15718" name="TextBox 15717">
-              <a:extLst>
-                <a:ext uri="{FF2B5EF4-FFF2-40B4-BE49-F238E27FC236}">
-                  <a16:creationId xmlns:a16="http://schemas.microsoft.com/office/drawing/2014/main" id="{C5EDCAEC-F972-A2CD-DE27-9E216B9AC130}"/>
-                </a:ext>
-              </a:extLst>
-            </p:cNvPr>
-            <p:cNvSpPr txBox="1"/>
-            <p:nvPr/>
-          </p:nvSpPr>
-          <p:spPr>
-            <a:xfrm>
-              <a:off x="39886352" y="11652166"/>
-              <a:ext cx="141316" cy="575003"/>
-            </a:xfrm>
-            <a:prstGeom prst="rect">
-              <a:avLst/>
-            </a:prstGeom>
-            <a:noFill/>
-          </p:spPr>
-          <p:txBody>
-            <a:bodyPr wrap="none" rtlCol="0">
-              <a:spAutoFit/>
-            </a:bodyPr>
-            <a:lstStyle/>
-            <a:p>
-              <a:endParaRPr lang="en-US" sz="4000" dirty="0"/>
-            </a:p>
-          </p:txBody>
-        </p:sp>
-        <p:sp>
-          <p:nvSpPr>
-            <p:cNvPr id="15715" name="TextBox 15714">
-              <a:extLst>
-                <a:ext uri="{FF2B5EF4-FFF2-40B4-BE49-F238E27FC236}">
-                  <a16:creationId xmlns:a16="http://schemas.microsoft.com/office/drawing/2014/main" id="{6A186BD7-7E16-8AE4-2E56-FAD05BEC16F6}"/>
-                </a:ext>
-              </a:extLst>
-            </p:cNvPr>
-            <p:cNvSpPr txBox="1"/>
-            <p:nvPr/>
-          </p:nvSpPr>
-          <p:spPr>
-            <a:xfrm rot="16200000">
-              <a:off x="36657648" y="8884400"/>
-              <a:ext cx="2422148" cy="423798"/>
-            </a:xfrm>
-            <a:prstGeom prst="rect">
-              <a:avLst/>
-            </a:prstGeom>
-            <a:noFill/>
-          </p:spPr>
-          <p:txBody>
-            <a:bodyPr wrap="none" rtlCol="0">
-              <a:spAutoFit/>
-            </a:bodyPr>
-            <a:lstStyle/>
-            <a:p>
-              <a:r>
-                <a:rPr lang="en-US" sz="3000" dirty="0" err="1"/>
-                <a:t>dlPFC</a:t>
-              </a:r>
-              <a:r>
-                <a:rPr lang="en-US" sz="3000" dirty="0"/>
-                <a:t> activation</a:t>
-              </a:r>
-            </a:p>
-          </p:txBody>
-        </p:sp>
+          </p:grpSpPr>
+          <p:sp>
+            <p:nvSpPr>
+              <p:cNvPr id="15711" name="TextBox 15710">
+                <a:extLst>
+                  <a:ext uri="{FF2B5EF4-FFF2-40B4-BE49-F238E27FC236}">
+                    <a16:creationId xmlns:a16="http://schemas.microsoft.com/office/drawing/2014/main" id="{3F0968C1-C452-1885-6B38-F154CD473A3F}"/>
+                  </a:ext>
+                </a:extLst>
+              </p:cNvPr>
+              <p:cNvSpPr txBox="1"/>
+              <p:nvPr/>
+            </p:nvSpPr>
+            <p:spPr>
+              <a:xfrm>
+                <a:off x="37622248" y="7069792"/>
+                <a:ext cx="601117" cy="425002"/>
+              </a:xfrm>
+              <a:prstGeom prst="rect">
+                <a:avLst/>
+              </a:prstGeom>
+              <a:noFill/>
+            </p:spPr>
+            <p:txBody>
+              <a:bodyPr wrap="none" rtlCol="0">
+                <a:spAutoFit/>
+              </a:bodyPr>
+              <a:lstStyle/>
+              <a:p>
+                <a:r>
+                  <a:rPr lang="en-US" sz="2800" dirty="0"/>
+                  <a:t>200</a:t>
+                </a:r>
+              </a:p>
+            </p:txBody>
+          </p:sp>
+          <p:sp>
+            <p:nvSpPr>
+              <p:cNvPr id="15713" name="TextBox 15712">
+                <a:extLst>
+                  <a:ext uri="{FF2B5EF4-FFF2-40B4-BE49-F238E27FC236}">
+                    <a16:creationId xmlns:a16="http://schemas.microsoft.com/office/drawing/2014/main" id="{0538FBF6-7909-445F-ACD2-9599FE92C967}"/>
+                  </a:ext>
+                </a:extLst>
+              </p:cNvPr>
+              <p:cNvSpPr txBox="1"/>
+              <p:nvPr/>
+            </p:nvSpPr>
+            <p:spPr>
+              <a:xfrm>
+                <a:off x="37564868" y="11337187"/>
+                <a:ext cx="693086" cy="425002"/>
+              </a:xfrm>
+              <a:prstGeom prst="rect">
+                <a:avLst/>
+              </a:prstGeom>
+              <a:noFill/>
+            </p:spPr>
+            <p:txBody>
+              <a:bodyPr wrap="none" rtlCol="0">
+                <a:spAutoFit/>
+              </a:bodyPr>
+              <a:lstStyle/>
+              <a:p>
+                <a:r>
+                  <a:rPr lang="en-US" sz="2800" dirty="0"/>
+                  <a:t>-300</a:t>
+                </a:r>
+              </a:p>
+            </p:txBody>
+          </p:sp>
+          <p:sp>
+            <p:nvSpPr>
+              <p:cNvPr id="15716" name="TextBox 15715">
+                <a:extLst>
+                  <a:ext uri="{FF2B5EF4-FFF2-40B4-BE49-F238E27FC236}">
+                    <a16:creationId xmlns:a16="http://schemas.microsoft.com/office/drawing/2014/main" id="{A7B791E9-2592-EA60-AB27-F2DBE3421768}"/>
+                  </a:ext>
+                </a:extLst>
+              </p:cNvPr>
+              <p:cNvSpPr txBox="1"/>
+              <p:nvPr/>
+            </p:nvSpPr>
+            <p:spPr>
+              <a:xfrm>
+                <a:off x="38211199" y="11728946"/>
+                <a:ext cx="447833" cy="425002"/>
+              </a:xfrm>
+              <a:prstGeom prst="rect">
+                <a:avLst/>
+              </a:prstGeom>
+              <a:noFill/>
+            </p:spPr>
+            <p:txBody>
+              <a:bodyPr wrap="none" rtlCol="0">
+                <a:spAutoFit/>
+              </a:bodyPr>
+              <a:lstStyle/>
+              <a:p>
+                <a:r>
+                  <a:rPr lang="en-US" sz="2800" dirty="0"/>
+                  <a:t>20</a:t>
+                </a:r>
+              </a:p>
+            </p:txBody>
+          </p:sp>
+          <p:sp>
+            <p:nvSpPr>
+              <p:cNvPr id="15717" name="TextBox 15716">
+                <a:extLst>
+                  <a:ext uri="{FF2B5EF4-FFF2-40B4-BE49-F238E27FC236}">
+                    <a16:creationId xmlns:a16="http://schemas.microsoft.com/office/drawing/2014/main" id="{4288430D-B235-E5D2-0E3C-C928486D0544}"/>
+                  </a:ext>
+                </a:extLst>
+              </p:cNvPr>
+              <p:cNvSpPr txBox="1"/>
+              <p:nvPr/>
+            </p:nvSpPr>
+            <p:spPr>
+              <a:xfrm>
+                <a:off x="42569990" y="11706123"/>
+                <a:ext cx="447833" cy="425002"/>
+              </a:xfrm>
+              <a:prstGeom prst="rect">
+                <a:avLst/>
+              </a:prstGeom>
+              <a:noFill/>
+            </p:spPr>
+            <p:txBody>
+              <a:bodyPr wrap="none" rtlCol="0">
+                <a:spAutoFit/>
+              </a:bodyPr>
+              <a:lstStyle/>
+              <a:p>
+                <a:r>
+                  <a:rPr lang="en-US" sz="2800" dirty="0"/>
+                  <a:t>70</a:t>
+                </a:r>
+              </a:p>
+            </p:txBody>
+          </p:sp>
+          <p:sp>
+            <p:nvSpPr>
+              <p:cNvPr id="15718" name="TextBox 15717">
+                <a:extLst>
+                  <a:ext uri="{FF2B5EF4-FFF2-40B4-BE49-F238E27FC236}">
+                    <a16:creationId xmlns:a16="http://schemas.microsoft.com/office/drawing/2014/main" id="{C5EDCAEC-F972-A2CD-DE27-9E216B9AC130}"/>
+                  </a:ext>
+                </a:extLst>
+              </p:cNvPr>
+              <p:cNvSpPr txBox="1"/>
+              <p:nvPr/>
+            </p:nvSpPr>
+            <p:spPr>
+              <a:xfrm>
+                <a:off x="39886352" y="11652166"/>
+                <a:ext cx="141316" cy="575003"/>
+              </a:xfrm>
+              <a:prstGeom prst="rect">
+                <a:avLst/>
+              </a:prstGeom>
+              <a:noFill/>
+            </p:spPr>
+            <p:txBody>
+              <a:bodyPr wrap="none" rtlCol="0">
+                <a:spAutoFit/>
+              </a:bodyPr>
+              <a:lstStyle/>
+              <a:p>
+                <a:endParaRPr lang="en-US" sz="4000" dirty="0"/>
+              </a:p>
+            </p:txBody>
+          </p:sp>
+          <p:sp>
+            <p:nvSpPr>
+              <p:cNvPr id="15715" name="TextBox 15714">
+                <a:extLst>
+                  <a:ext uri="{FF2B5EF4-FFF2-40B4-BE49-F238E27FC236}">
+                    <a16:creationId xmlns:a16="http://schemas.microsoft.com/office/drawing/2014/main" id="{6A186BD7-7E16-8AE4-2E56-FAD05BEC16F6}"/>
+                  </a:ext>
+                </a:extLst>
+              </p:cNvPr>
+              <p:cNvSpPr txBox="1"/>
+              <p:nvPr/>
+            </p:nvSpPr>
+            <p:spPr>
+              <a:xfrm rot="16200000">
+                <a:off x="36657648" y="8884400"/>
+                <a:ext cx="2422148" cy="423798"/>
+              </a:xfrm>
+              <a:prstGeom prst="rect">
+                <a:avLst/>
+              </a:prstGeom>
+              <a:noFill/>
+            </p:spPr>
+            <p:txBody>
+              <a:bodyPr wrap="none" rtlCol="0">
+                <a:spAutoFit/>
+              </a:bodyPr>
+              <a:lstStyle/>
+              <a:p>
+                <a:r>
+                  <a:rPr lang="en-US" sz="3000" dirty="0" err="1"/>
+                  <a:t>dlPFC</a:t>
+                </a:r>
+                <a:r>
+                  <a:rPr lang="en-US" sz="3000" dirty="0"/>
+                  <a:t> activation</a:t>
+                </a:r>
+              </a:p>
+            </p:txBody>
+          </p:sp>
+        </p:grpSp>
       </p:grpSp>
       <p:pic>
         <p:nvPicPr>
@@ -18279,8 +18264,8 @@
         </p:nvSpPr>
         <p:spPr>
           <a:xfrm>
-            <a:off x="30701558" y="20419705"/>
-            <a:ext cx="12914399" cy="3200876"/>
+            <a:off x="30683586" y="20292534"/>
+            <a:ext cx="12914399" cy="4185761"/>
           </a:xfrm>
           <a:prstGeom prst="rect">
             <a:avLst/>
@@ -18306,7 +18291,7 @@
                 <a:ea typeface="MS PGothic"/>
                 <a:cs typeface="Helvetica"/>
               </a:rPr>
-              <a:t>We found that friend defecting resulted in increased </a:t>
+              <a:t>We found that friend defecting resulted in increased dorsolateral prefrontal cortex (</a:t>
             </a:r>
             <a:r>
               <a:rPr lang="en-US" sz="3200" b="1" dirty="0" err="1">
@@ -18315,6 +18300,14 @@
                 <a:cs typeface="Helvetica"/>
               </a:rPr>
               <a:t>dlPFC</a:t>
+            </a:r>
+            <a:r>
+              <a:rPr lang="en-US" sz="3200" b="1" dirty="0">
+                <a:latin typeface="Helvetica"/>
+                <a:ea typeface="MS PGothic"/>
+                <a:cs typeface="Helvetica"/>
+              </a:rPr>
+              <a:t>)</a:t>
             </a:r>
             <a:r>
               <a:rPr lang="en-US" sz="3200" dirty="0">
@@ -18355,7 +18348,7 @@
                 <a:ea typeface="MS PGothic"/>
                 <a:cs typeface="Helvetica"/>
               </a:rPr>
-              <a:t>We also found that friend reciprocating resulted in reduced </a:t>
+              <a:t>We also found that friend reciprocating resulted in reduced medial prefrontal cortex (</a:t>
             </a:r>
             <a:r>
               <a:rPr lang="en-US" sz="3200" b="1" dirty="0" err="1">
@@ -18364,6 +18357,14 @@
                 <a:cs typeface="Helvetica"/>
               </a:rPr>
               <a:t>mPFC</a:t>
+            </a:r>
+            <a:r>
+              <a:rPr lang="en-US" sz="3200" b="1" dirty="0">
+                <a:latin typeface="Helvetica"/>
+                <a:ea typeface="MS PGothic"/>
+                <a:cs typeface="Helvetica"/>
+              </a:rPr>
+              <a:t>)</a:t>
             </a:r>
             <a:r>
               <a:rPr lang="en-US" sz="3200" dirty="0">
@@ -19385,7 +19386,7 @@
         </p:blipFill>
         <p:spPr>
           <a:xfrm>
-            <a:off x="36325224" y="5727924"/>
+            <a:off x="36346489" y="6514729"/>
             <a:ext cx="6554939" cy="5963480"/>
           </a:xfrm>
           <a:prstGeom prst="rect">
@@ -19407,7 +19408,7 @@
         </p:nvGrpSpPr>
         <p:grpSpPr>
           <a:xfrm>
-            <a:off x="31064767" y="13043782"/>
+            <a:off x="31064767" y="13596672"/>
             <a:ext cx="11815396" cy="6632263"/>
             <a:chOff x="30912367" y="13704182"/>
             <a:chExt cx="11623275" cy="6632263"/>
@@ -19427,10 +19428,10 @@
           </p:nvGrpSpPr>
           <p:grpSpPr>
             <a:xfrm>
-              <a:off x="30912367" y="15288687"/>
-              <a:ext cx="4003957" cy="4456527"/>
+              <a:off x="30912367" y="15288689"/>
+              <a:ext cx="4003957" cy="4057010"/>
               <a:chOff x="30175830" y="13427301"/>
-              <a:chExt cx="6887851" cy="8283820"/>
+              <a:chExt cx="6887851" cy="7541194"/>
             </a:xfrm>
           </p:grpSpPr>
           <p:pic>
@@ -19518,8 +19519,8 @@
             </p:nvSpPr>
             <p:spPr>
               <a:xfrm>
-                <a:off x="30483850" y="20109250"/>
-                <a:ext cx="5622817" cy="1601871"/>
+                <a:off x="30481077" y="19881512"/>
+                <a:ext cx="5622817" cy="1086983"/>
               </a:xfrm>
               <a:prstGeom prst="rect">
                 <a:avLst/>
@@ -19533,31 +19534,14 @@
               <a:lstStyle/>
               <a:p>
                 <a:r>
-                  <a:rPr lang="en-US" dirty="0">
-                    <a:latin typeface="Helvetica"/>
-                  </a:rPr>
-                  <a:t>Medial Prefrontal Cortex</a:t>
-                </a:r>
-              </a:p>
-              <a:p>
-                <a:r>
-                  <a:rPr lang="en-US" sz="3200" b="1" dirty="0">
-                    <a:latin typeface="Helvetica"/>
-                  </a:rPr>
-                  <a:t>(</a:t>
-                </a:r>
-                <a:r>
                   <a:rPr lang="en-US" sz="3200" b="1" dirty="0" err="1">
                     <a:latin typeface="Helvetica"/>
                   </a:rPr>
                   <a:t>mPFC</a:t>
                 </a:r>
-                <a:r>
-                  <a:rPr lang="en-US" sz="3200" b="1" dirty="0">
-                    <a:latin typeface="Helvetica"/>
-                  </a:rPr>
-                  <a:t>)</a:t>
-                </a:r>
+                <a:endParaRPr lang="en-US" sz="3200" b="1" dirty="0">
+                  <a:latin typeface="Helvetica"/>
+                </a:endParaRPr>
               </a:p>
             </p:txBody>
           </p:sp>
@@ -19963,8 +19947,8 @@
         </p:nvSpPr>
         <p:spPr>
           <a:xfrm>
-            <a:off x="17565515" y="19992104"/>
-            <a:ext cx="10624094" cy="1015663"/>
+            <a:off x="16952163" y="20057868"/>
+            <a:ext cx="12119276" cy="1077218"/>
           </a:xfrm>
           <a:prstGeom prst="rect">
             <a:avLst/>
@@ -19979,7 +19963,7 @@
           <a:p>
             <a:pPr algn="ctr"/>
             <a:r>
-              <a:rPr lang="en-US" sz="3000" dirty="0"/>
+              <a:rPr lang="en-US" sz="3200" dirty="0"/>
               <a:t>We found no age-related effects across financial exploitation measures or investment behavior</a:t>
             </a:r>
           </a:p>
@@ -20313,7 +20297,7 @@
         </p:nvSpPr>
         <p:spPr bwMode="auto">
           <a:xfrm>
-            <a:off x="18499855" y="3920818"/>
+            <a:off x="18223410" y="3920818"/>
             <a:ext cx="9336971" cy="748988"/>
           </a:xfrm>
           <a:prstGeom prst="rect">
@@ -20446,7 +20430,7 @@
                 </a:solidFill>
                 <a:latin typeface="Trebuchet MS" panose="020B0603020202020204" pitchFamily="34" charset="0"/>
               </a:rPr>
-              <a:t>3. Age Related Behavioral Effects</a:t>
+              <a:t>3. Age-Related Behavioral Effects</a:t>
             </a:r>
           </a:p>
         </p:txBody>
@@ -20468,7 +20452,7 @@
         <p:spPr bwMode="auto">
           <a:xfrm>
             <a:off x="30943648" y="3872154"/>
-            <a:ext cx="12337509" cy="746358"/>
+            <a:ext cx="12337509" cy="1400383"/>
           </a:xfrm>
           <a:prstGeom prst="rect">
             <a:avLst/>
@@ -20601,7 +20585,7 @@
                 <a:latin typeface="Trebuchet MS"/>
                 <a:ea typeface="MS PGothic"/>
               </a:rPr>
-              <a:t>5. Age Related Differences in Partner Response </a:t>
+              <a:t>5. Whole Brain Analyses of Neural Responses to Social Outcomes</a:t>
             </a:r>
             <a:endParaRPr lang="en-US" altLang="en-US" sz="4250" b="1" dirty="0">
               <a:solidFill>
@@ -20916,6 +20900,81 @@
                 <a:latin typeface="Trebuchet MS" panose="020B0603020202020204" pitchFamily="34" charset="0"/>
               </a:rPr>
               <a:t>6. Conclusions and Future Directions</a:t>
+            </a:r>
+          </a:p>
+        </p:txBody>
+      </p:sp>
+      <p:sp>
+        <p:nvSpPr>
+          <p:cNvPr id="142" name="TextBox 141">
+            <a:extLst>
+              <a:ext uri="{FF2B5EF4-FFF2-40B4-BE49-F238E27FC236}">
+                <a16:creationId xmlns:a16="http://schemas.microsoft.com/office/drawing/2014/main" id="{8DA2ABEA-DC63-DB4B-9E64-20A700C207F0}"/>
+              </a:ext>
+            </a:extLst>
+          </p:cNvPr>
+          <p:cNvSpPr txBox="1"/>
+          <p:nvPr/>
+        </p:nvSpPr>
+        <p:spPr>
+          <a:xfrm>
+            <a:off x="197691" y="13947099"/>
+            <a:ext cx="14650695" cy="2554545"/>
+          </a:xfrm>
+          <a:prstGeom prst="rect">
+            <a:avLst/>
+          </a:prstGeom>
+          <a:noFill/>
+        </p:spPr>
+        <p:txBody>
+          <a:bodyPr wrap="square" lIns="91440" tIns="45720" rIns="91440" bIns="45720" anchor="t">
+            <a:spAutoFit/>
+          </a:bodyPr>
+          <a:lstStyle/>
+          <a:p>
+            <a:pPr algn="ctr"/>
+            <a:r>
+              <a:rPr lang="en-US" altLang="en-US" sz="3200" dirty="0">
+                <a:latin typeface="Helvetica"/>
+                <a:ea typeface="MS PGothic"/>
+              </a:rPr>
+              <a:t>Participants (N = 62) completed a trust task with three partners: a computer, a stranger, and their chosen friend. They are given $8 each round and must share one of two pre-determined amounts. That amount is then tripled, and they are shown whether their partner reciprocated half of the total, or defected and kept it all to themselves.</a:t>
+            </a:r>
+          </a:p>
+        </p:txBody>
+      </p:sp>
+      <p:sp>
+        <p:nvSpPr>
+          <p:cNvPr id="11" name="TextBox 10">
+            <a:extLst>
+              <a:ext uri="{FF2B5EF4-FFF2-40B4-BE49-F238E27FC236}">
+                <a16:creationId xmlns:a16="http://schemas.microsoft.com/office/drawing/2014/main" id="{95DE763B-F4EB-754D-A139-C1319AD540CE}"/>
+              </a:ext>
+            </a:extLst>
+          </p:cNvPr>
+          <p:cNvSpPr txBox="1"/>
+          <p:nvPr/>
+        </p:nvSpPr>
+        <p:spPr>
+          <a:xfrm>
+            <a:off x="30903167" y="5316911"/>
+            <a:ext cx="12036015" cy="1077218"/>
+          </a:xfrm>
+          <a:prstGeom prst="rect">
+            <a:avLst/>
+          </a:prstGeom>
+          <a:noFill/>
+        </p:spPr>
+        <p:txBody>
+          <a:bodyPr wrap="square" rtlCol="0">
+            <a:spAutoFit/>
+          </a:bodyPr>
+          <a:lstStyle/>
+          <a:p>
+            <a:pPr algn="ctr"/>
+            <a:r>
+              <a:rPr lang="en-US" sz="3200" dirty="0"/>
+              <a:t>To investigate if age-related effects were present elsewhere, we conducted a set of whole brain analyses.</a:t>
             </a:r>
           </a:p>
         </p:txBody>

</xml_diff>

<commit_message>
Added effect sizes for a few plots
</commit_message>
<xml_diff>
--- a/SFN/2023_SFN_trust.pptx
+++ b/SFN/2023_SFN_trust.pptx
@@ -20979,6 +20979,146 @@
           </a:p>
         </p:txBody>
       </p:sp>
+      <p:sp>
+        <p:nvSpPr>
+          <p:cNvPr id="48" name="TextBox 47">
+            <a:extLst>
+              <a:ext uri="{FF2B5EF4-FFF2-40B4-BE49-F238E27FC236}">
+                <a16:creationId xmlns:a16="http://schemas.microsoft.com/office/drawing/2014/main" id="{5AD48B72-79AA-2C4A-8106-FEE9B29510DB}"/>
+              </a:ext>
+            </a:extLst>
+          </p:cNvPr>
+          <p:cNvSpPr txBox="1"/>
+          <p:nvPr/>
+        </p:nvSpPr>
+        <p:spPr>
+          <a:xfrm>
+            <a:off x="20959218" y="13113800"/>
+            <a:ext cx="1932677" cy="523220"/>
+          </a:xfrm>
+          <a:prstGeom prst="rect">
+            <a:avLst/>
+          </a:prstGeom>
+          <a:noFill/>
+        </p:spPr>
+        <p:txBody>
+          <a:bodyPr wrap="square" rtlCol="0">
+            <a:spAutoFit/>
+          </a:bodyPr>
+          <a:lstStyle/>
+          <a:p>
+            <a:r>
+              <a:rPr lang="en-US" sz="2800" i="1" dirty="0"/>
+              <a:t>R = -.21</a:t>
+            </a:r>
+          </a:p>
+        </p:txBody>
+      </p:sp>
+      <p:sp>
+        <p:nvSpPr>
+          <p:cNvPr id="153" name="TextBox 152">
+            <a:extLst>
+              <a:ext uri="{FF2B5EF4-FFF2-40B4-BE49-F238E27FC236}">
+                <a16:creationId xmlns:a16="http://schemas.microsoft.com/office/drawing/2014/main" id="{2A617A1E-C1F1-794A-A807-BBC21A37CDED}"/>
+              </a:ext>
+            </a:extLst>
+          </p:cNvPr>
+          <p:cNvSpPr txBox="1"/>
+          <p:nvPr/>
+        </p:nvSpPr>
+        <p:spPr>
+          <a:xfrm>
+            <a:off x="28609845" y="5241364"/>
+            <a:ext cx="1932677" cy="523220"/>
+          </a:xfrm>
+          <a:prstGeom prst="rect">
+            <a:avLst/>
+          </a:prstGeom>
+          <a:noFill/>
+        </p:spPr>
+        <p:txBody>
+          <a:bodyPr wrap="square" rtlCol="0">
+            <a:spAutoFit/>
+          </a:bodyPr>
+          <a:lstStyle/>
+          <a:p>
+            <a:r>
+              <a:rPr lang="en-US" sz="2800" i="1" dirty="0"/>
+              <a:t>R = -.03</a:t>
+            </a:r>
+          </a:p>
+        </p:txBody>
+      </p:sp>
+      <p:sp>
+        <p:nvSpPr>
+          <p:cNvPr id="154" name="TextBox 153">
+            <a:extLst>
+              <a:ext uri="{FF2B5EF4-FFF2-40B4-BE49-F238E27FC236}">
+                <a16:creationId xmlns:a16="http://schemas.microsoft.com/office/drawing/2014/main" id="{199A54FF-CFDA-AA4D-9B63-2C0BC38C1F8A}"/>
+              </a:ext>
+            </a:extLst>
+          </p:cNvPr>
+          <p:cNvSpPr txBox="1"/>
+          <p:nvPr/>
+        </p:nvSpPr>
+        <p:spPr>
+          <a:xfrm>
+            <a:off x="28527431" y="13109233"/>
+            <a:ext cx="1932677" cy="523220"/>
+          </a:xfrm>
+          <a:prstGeom prst="rect">
+            <a:avLst/>
+          </a:prstGeom>
+          <a:noFill/>
+        </p:spPr>
+        <p:txBody>
+          <a:bodyPr wrap="square" rtlCol="0">
+            <a:spAutoFit/>
+          </a:bodyPr>
+          <a:lstStyle/>
+          <a:p>
+            <a:r>
+              <a:rPr lang="en-US" sz="2800" i="1" dirty="0"/>
+              <a:t>R = -.</a:t>
+            </a:r>
+          </a:p>
+        </p:txBody>
+      </p:sp>
+      <p:sp>
+        <p:nvSpPr>
+          <p:cNvPr id="156" name="TextBox 155">
+            <a:extLst>
+              <a:ext uri="{FF2B5EF4-FFF2-40B4-BE49-F238E27FC236}">
+                <a16:creationId xmlns:a16="http://schemas.microsoft.com/office/drawing/2014/main" id="{8129937F-2145-7F4C-8C15-2C0DF8142096}"/>
+              </a:ext>
+            </a:extLst>
+          </p:cNvPr>
+          <p:cNvSpPr txBox="1"/>
+          <p:nvPr/>
+        </p:nvSpPr>
+        <p:spPr>
+          <a:xfrm>
+            <a:off x="38860917" y="12421214"/>
+            <a:ext cx="1464950" cy="899443"/>
+          </a:xfrm>
+          <a:prstGeom prst="rect">
+            <a:avLst/>
+          </a:prstGeom>
+          <a:noFill/>
+        </p:spPr>
+        <p:txBody>
+          <a:bodyPr wrap="none" rtlCol="0">
+            <a:spAutoFit/>
+          </a:bodyPr>
+          <a:lstStyle/>
+          <a:p>
+            <a:r>
+              <a:rPr lang="en-US" sz="4000" dirty="0"/>
+              <a:t>Age</a:t>
+            </a:r>
+          </a:p>
+        </p:txBody>
+      </p:sp>
     </p:spTree>
     <p:extLst>
       <p:ext uri="{BB962C8B-B14F-4D97-AF65-F5344CB8AC3E}">

</xml_diff>

<commit_message>
Shifted graph in box 4
</commit_message>
<xml_diff>
--- a/SFN/2023_SFN_trust.pptx
+++ b/SFN/2023_SFN_trust.pptx
@@ -13896,7 +13896,7 @@
         </p:nvGrpSpPr>
         <p:grpSpPr>
           <a:xfrm>
-            <a:off x="16012194" y="23993601"/>
+            <a:off x="15576764" y="23993601"/>
             <a:ext cx="5429343" cy="4910419"/>
             <a:chOff x="14636639" y="15406812"/>
             <a:chExt cx="7151031" cy="6468880"/>
@@ -17438,7 +17438,7 @@
         </p:nvGrpSpPr>
         <p:grpSpPr>
           <a:xfrm>
-            <a:off x="22103183" y="23179902"/>
+            <a:off x="21667753" y="23179902"/>
             <a:ext cx="7277183" cy="6638191"/>
             <a:chOff x="23516336" y="15981033"/>
             <a:chExt cx="5574747" cy="4915819"/>
@@ -19206,7 +19206,7 @@
         </p:blipFill>
         <p:spPr>
           <a:xfrm>
-            <a:off x="23186588" y="23295687"/>
+            <a:off x="22751158" y="23295687"/>
             <a:ext cx="6466501" cy="5861542"/>
           </a:xfrm>
           <a:prstGeom prst="rect">

</xml_diff>

<commit_message>
Update box 3 and logo alignment
</commit_message>
<xml_diff>
--- a/SFN/2023_SFN_trust.pptx
+++ b/SFN/2023_SFN_trust.pptx
@@ -18138,7 +18138,7 @@
         </p:blipFill>
         <p:spPr bwMode="auto">
           <a:xfrm>
-            <a:off x="251151" y="294825"/>
+            <a:off x="76979" y="120653"/>
             <a:ext cx="3390900" cy="3390900"/>
           </a:xfrm>
           <a:prstGeom prst="rect">
@@ -20380,7 +20380,7 @@
                 </a:solidFill>
                 <a:latin typeface="Trebuchet MS" panose="020B0603020202020204" pitchFamily="34" charset="0"/>
               </a:rPr>
-              <a:t>3. Age-Related Behavioral Effects</a:t>
+              <a:t>3. Age-Related Behavioral Effects?</a:t>
             </a:r>
           </a:p>
         </p:txBody>

</xml_diff>

<commit_message>
final final final draft part 2 finished version (for real)
</commit_message>
<xml_diff>
--- a/SFN/2023_SFN_trust.pptx
+++ b/SFN/2023_SFN_trust.pptx
@@ -5,16 +5,17 @@
     <p:sldMasterId id="2147483648" r:id="rId3"/>
   </p:sldMasterIdLst>
   <p:notesMasterIdLst>
-    <p:notesMasterId r:id="rId8"/>
+    <p:notesMasterId r:id="rId9"/>
   </p:notesMasterIdLst>
   <p:handoutMasterIdLst>
-    <p:handoutMasterId r:id="rId9"/>
+    <p:handoutMasterId r:id="rId10"/>
   </p:handoutMasterIdLst>
   <p:sldIdLst>
     <p:sldId id="263" r:id="rId4"/>
     <p:sldId id="262" r:id="rId5"/>
-    <p:sldId id="260" r:id="rId6"/>
-    <p:sldId id="261" r:id="rId7"/>
+    <p:sldId id="264" r:id="rId6"/>
+    <p:sldId id="260" r:id="rId7"/>
+    <p:sldId id="261" r:id="rId8"/>
   </p:sldIdLst>
   <p:sldSz cx="43891200" cy="32918400"/>
   <p:notesSz cx="7023100" cy="9309100"/>
@@ -7231,242 +7232,6 @@
       </p:sp>
       <p:grpSp>
         <p:nvGrpSpPr>
-          <p:cNvPr id="15666" name="Group 15665">
-            <a:extLst>
-              <a:ext uri="{FF2B5EF4-FFF2-40B4-BE49-F238E27FC236}">
-                <a16:creationId xmlns:a16="http://schemas.microsoft.com/office/drawing/2014/main" id="{F4499BAD-2B87-B075-89D7-E684EC5B1F7C}"/>
-              </a:ext>
-            </a:extLst>
-          </p:cNvPr>
-          <p:cNvGrpSpPr/>
-          <p:nvPr/>
-        </p:nvGrpSpPr>
-        <p:grpSpPr>
-          <a:xfrm>
-            <a:off x="16034879" y="4731272"/>
-            <a:ext cx="6499677" cy="7043851"/>
-            <a:chOff x="16270767" y="4773172"/>
-            <a:chExt cx="4112536" cy="4273122"/>
-          </a:xfrm>
-        </p:grpSpPr>
-        <p:pic>
-          <p:nvPicPr>
-            <p:cNvPr id="15659" name="Graphic 15658">
-              <a:extLst>
-                <a:ext uri="{FF2B5EF4-FFF2-40B4-BE49-F238E27FC236}">
-                  <a16:creationId xmlns:a16="http://schemas.microsoft.com/office/drawing/2014/main" id="{6D9E2B1C-10CC-F9D6-3D33-17375F7BFB84}"/>
-                </a:ext>
-              </a:extLst>
-            </p:cNvPr>
-            <p:cNvPicPr>
-              <a:picLocks noChangeAspect="1"/>
-            </p:cNvPicPr>
-            <p:nvPr/>
-          </p:nvPicPr>
-          <p:blipFill rotWithShape="1">
-            <a:blip r:embed="rId5">
-              <a:extLst>
-                <a:ext uri="{28A0092B-C50C-407E-A947-70E740481C1C}">
-                  <a14:useLocalDpi xmlns:a14="http://schemas.microsoft.com/office/drawing/2010/main" val="0"/>
-                </a:ext>
-                <a:ext uri="{96DAC541-7B7A-43D3-8B79-37D633B846F1}">
-                  <asvg:svgBlip xmlns:asvg="http://schemas.microsoft.com/office/drawing/2016/SVG/main" r:embed="rId6"/>
-                </a:ext>
-              </a:extLst>
-            </a:blip>
-            <a:srcRect l="8667"/>
-            <a:stretch/>
-          </p:blipFill>
-          <p:spPr>
-            <a:xfrm>
-              <a:off x="16619952" y="4773172"/>
-              <a:ext cx="3763351" cy="4273122"/>
-            </a:xfrm>
-            <a:prstGeom prst="rect">
-              <a:avLst/>
-            </a:prstGeom>
-          </p:spPr>
-        </p:pic>
-        <p:sp>
-          <p:nvSpPr>
-            <p:cNvPr id="15660" name="TextBox 15659">
-              <a:extLst>
-                <a:ext uri="{FF2B5EF4-FFF2-40B4-BE49-F238E27FC236}">
-                  <a16:creationId xmlns:a16="http://schemas.microsoft.com/office/drawing/2014/main" id="{0766629E-BCF3-6556-AF99-A6859175E636}"/>
-                </a:ext>
-              </a:extLst>
-            </p:cNvPr>
-            <p:cNvSpPr txBox="1"/>
-            <p:nvPr/>
-          </p:nvSpPr>
-          <p:spPr>
-            <a:xfrm>
-              <a:off x="16270767" y="8330236"/>
-              <a:ext cx="243627" cy="317409"/>
-            </a:xfrm>
-            <a:prstGeom prst="rect">
-              <a:avLst/>
-            </a:prstGeom>
-            <a:noFill/>
-          </p:spPr>
-          <p:txBody>
-            <a:bodyPr wrap="none" rtlCol="0">
-              <a:spAutoFit/>
-            </a:bodyPr>
-            <a:lstStyle/>
-            <a:p>
-              <a:r>
-                <a:rPr lang="en-US" sz="2800" dirty="0"/>
-                <a:t>0</a:t>
-              </a:r>
-            </a:p>
-          </p:txBody>
-        </p:sp>
-        <p:sp>
-          <p:nvSpPr>
-            <p:cNvPr id="15662" name="TextBox 15661">
-              <a:extLst>
-                <a:ext uri="{FF2B5EF4-FFF2-40B4-BE49-F238E27FC236}">
-                  <a16:creationId xmlns:a16="http://schemas.microsoft.com/office/drawing/2014/main" id="{4DC189FA-5EF4-8645-EFD2-F4AA0CF414D9}"/>
-                </a:ext>
-              </a:extLst>
-            </p:cNvPr>
-            <p:cNvSpPr txBox="1"/>
-            <p:nvPr/>
-          </p:nvSpPr>
-          <p:spPr>
-            <a:xfrm>
-              <a:off x="16286106" y="5815933"/>
-              <a:ext cx="243627" cy="317409"/>
-            </a:xfrm>
-            <a:prstGeom prst="rect">
-              <a:avLst/>
-            </a:prstGeom>
-            <a:noFill/>
-          </p:spPr>
-          <p:txBody>
-            <a:bodyPr wrap="none" rtlCol="0">
-              <a:spAutoFit/>
-            </a:bodyPr>
-            <a:lstStyle/>
-            <a:p>
-              <a:r>
-                <a:rPr lang="en-US" sz="2800" dirty="0"/>
-                <a:t>4</a:t>
-              </a:r>
-            </a:p>
-          </p:txBody>
-        </p:sp>
-        <p:sp>
-          <p:nvSpPr>
-            <p:cNvPr id="15663" name="TextBox 15662">
-              <a:extLst>
-                <a:ext uri="{FF2B5EF4-FFF2-40B4-BE49-F238E27FC236}">
-                  <a16:creationId xmlns:a16="http://schemas.microsoft.com/office/drawing/2014/main" id="{FEBA7C19-438A-8BB9-F286-7161582091EA}"/>
-                </a:ext>
-              </a:extLst>
-            </p:cNvPr>
-            <p:cNvSpPr txBox="1"/>
-            <p:nvPr/>
-          </p:nvSpPr>
-          <p:spPr>
-            <a:xfrm>
-              <a:off x="16897735" y="8562924"/>
-              <a:ext cx="805531" cy="336081"/>
-            </a:xfrm>
-            <a:prstGeom prst="rect">
-              <a:avLst/>
-            </a:prstGeom>
-            <a:noFill/>
-          </p:spPr>
-          <p:txBody>
-            <a:bodyPr wrap="none" rtlCol="0">
-              <a:spAutoFit/>
-            </a:bodyPr>
-            <a:lstStyle/>
-            <a:p>
-              <a:pPr algn="ctr"/>
-              <a:r>
-                <a:rPr lang="en-US" sz="3000" dirty="0"/>
-                <a:t>Friend</a:t>
-              </a:r>
-            </a:p>
-          </p:txBody>
-        </p:sp>
-        <p:sp>
-          <p:nvSpPr>
-            <p:cNvPr id="15664" name="TextBox 15663">
-              <a:extLst>
-                <a:ext uri="{FF2B5EF4-FFF2-40B4-BE49-F238E27FC236}">
-                  <a16:creationId xmlns:a16="http://schemas.microsoft.com/office/drawing/2014/main" id="{D1FDC6B6-A877-379F-C9B2-8D6C71CA3AC6}"/>
-                </a:ext>
-              </a:extLst>
-            </p:cNvPr>
-            <p:cNvSpPr txBox="1"/>
-            <p:nvPr/>
-          </p:nvSpPr>
-          <p:spPr>
-            <a:xfrm>
-              <a:off x="17943587" y="8561101"/>
-              <a:ext cx="1048955" cy="336081"/>
-            </a:xfrm>
-            <a:prstGeom prst="rect">
-              <a:avLst/>
-            </a:prstGeom>
-            <a:noFill/>
-          </p:spPr>
-          <p:txBody>
-            <a:bodyPr wrap="none" rtlCol="0">
-              <a:spAutoFit/>
-            </a:bodyPr>
-            <a:lstStyle/>
-            <a:p>
-              <a:r>
-                <a:rPr lang="en-US" sz="3000" dirty="0"/>
-                <a:t>Stranger</a:t>
-              </a:r>
-            </a:p>
-          </p:txBody>
-        </p:sp>
-        <p:sp>
-          <p:nvSpPr>
-            <p:cNvPr id="15665" name="TextBox 15664">
-              <a:extLst>
-                <a:ext uri="{FF2B5EF4-FFF2-40B4-BE49-F238E27FC236}">
-                  <a16:creationId xmlns:a16="http://schemas.microsoft.com/office/drawing/2014/main" id="{0D79EDF9-8FFC-03A5-0959-5F4339B2A174}"/>
-                </a:ext>
-              </a:extLst>
-            </p:cNvPr>
-            <p:cNvSpPr txBox="1"/>
-            <p:nvPr/>
-          </p:nvSpPr>
-          <p:spPr>
-            <a:xfrm>
-              <a:off x="19099843" y="8562985"/>
-              <a:ext cx="1183852" cy="336081"/>
-            </a:xfrm>
-            <a:prstGeom prst="rect">
-              <a:avLst/>
-            </a:prstGeom>
-            <a:noFill/>
-          </p:spPr>
-          <p:txBody>
-            <a:bodyPr wrap="none" rtlCol="0">
-              <a:spAutoFit/>
-            </a:bodyPr>
-            <a:lstStyle/>
-            <a:p>
-              <a:pPr algn="ctr"/>
-              <a:r>
-                <a:rPr lang="en-US" sz="3000" dirty="0"/>
-                <a:t>Computer</a:t>
-              </a:r>
-            </a:p>
-          </p:txBody>
-        </p:sp>
-      </p:grpSp>
-      <p:grpSp>
-        <p:nvGrpSpPr>
           <p:cNvPr id="6" name="Group 5">
             <a:extLst>
               <a:ext uri="{FF2B5EF4-FFF2-40B4-BE49-F238E27FC236}">
@@ -7560,7 +7325,7 @@
                   <p:nvPr/>
                 </p:nvPicPr>
                 <p:blipFill rotWithShape="1">
-                  <a:blip r:embed="rId7"/>
+                  <a:blip r:embed="rId5"/>
                   <a:srcRect l="14791" t="15087" r="12450" b="22936"/>
                   <a:stretch/>
                 </p:blipFill>
@@ -7619,7 +7384,7 @@
                   <p:nvPr/>
                 </p:nvPicPr>
                 <p:blipFill rotWithShape="1">
-                  <a:blip r:embed="rId8"/>
+                  <a:blip r:embed="rId6"/>
                   <a:srcRect l="17658" t="18357" r="18046" b="25816"/>
                   <a:stretch/>
                 </p:blipFill>
@@ -7678,7 +7443,7 @@
                   <p:nvPr/>
                 </p:nvPicPr>
                 <p:blipFill rotWithShape="1">
-                  <a:blip r:embed="rId9"/>
+                  <a:blip r:embed="rId7"/>
                   <a:srcRect l="2620" t="7420" r="2620" b="4981"/>
                   <a:stretch/>
                 </p:blipFill>
@@ -7737,7 +7502,7 @@
                   <p:nvPr/>
                 </p:nvPicPr>
                 <p:blipFill>
-                  <a:blip r:embed="rId10"/>
+                  <a:blip r:embed="rId8"/>
                   <a:stretch>
                     <a:fillRect/>
                   </a:stretch>
@@ -7797,7 +7562,7 @@
                   <p:nvPr/>
                 </p:nvPicPr>
                 <p:blipFill rotWithShape="1">
-                  <a:blip r:embed="rId11"/>
+                  <a:blip r:embed="rId9"/>
                   <a:srcRect l="2378" t="5420" r="2378" b="9853"/>
                   <a:stretch/>
                 </p:blipFill>
@@ -7876,7 +7641,7 @@
                     <p:nvPr/>
                   </p:nvPicPr>
                   <p:blipFill>
-                    <a:blip r:embed="rId12"/>
+                    <a:blip r:embed="rId10"/>
                     <a:stretch>
                       <a:fillRect/>
                     </a:stretch>
@@ -7936,7 +7701,7 @@
                     <p:nvPr/>
                   </p:nvPicPr>
                   <p:blipFill>
-                    <a:blip r:embed="rId13"/>
+                    <a:blip r:embed="rId11"/>
                     <a:stretch>
                       <a:fillRect/>
                     </a:stretch>
@@ -7996,7 +7761,7 @@
                     <p:nvPr/>
                   </p:nvPicPr>
                   <p:blipFill>
-                    <a:blip r:embed="rId14"/>
+                    <a:blip r:embed="rId12"/>
                     <a:stretch>
                       <a:fillRect/>
                     </a:stretch>
@@ -9292,7 +9057,7 @@
               <p:nvPr/>
             </p:nvPicPr>
             <p:blipFill>
-              <a:blip r:embed="rId15">
+              <a:blip r:embed="rId13">
                 <a:extLst>
                   <a:ext uri="{28A0092B-C50C-407E-A947-70E740481C1C}">
                     <a14:useLocalDpi xmlns:a14="http://schemas.microsoft.com/office/drawing/2010/main" val="0"/>
@@ -9685,7 +9450,7 @@
           <p:nvPr/>
         </p:nvPicPr>
         <p:blipFill>
-          <a:blip r:embed="rId16">
+          <a:blip r:embed="rId14">
             <a:extLst>
               <a:ext uri="{28A0092B-C50C-407E-A947-70E740481C1C}">
                 <a14:useLocalDpi xmlns:a14="http://schemas.microsoft.com/office/drawing/2010/main" val="0"/>
@@ -9732,7 +9497,7 @@
           <p:nvPr/>
         </p:nvPicPr>
         <p:blipFill>
-          <a:blip r:embed="rId17">
+          <a:blip r:embed="rId15">
             <a:extLst>
               <a:ext uri="{28A0092B-C50C-407E-A947-70E740481C1C}">
                 <a14:useLocalDpi xmlns:a14="http://schemas.microsoft.com/office/drawing/2010/main" val="0"/>
@@ -9779,7 +9544,7 @@
           <p:nvPr/>
         </p:nvPicPr>
         <p:blipFill>
-          <a:blip r:embed="rId18">
+          <a:blip r:embed="rId16">
             <a:extLst>
               <a:ext uri="{28A0092B-C50C-407E-A947-70E740481C1C}">
                 <a14:useLocalDpi xmlns:a14="http://schemas.microsoft.com/office/drawing/2010/main" val="0"/>
@@ -10077,13 +9842,13 @@
             <p:nvPr/>
           </p:nvPicPr>
           <p:blipFill rotWithShape="1">
-            <a:blip r:embed="rId19">
+            <a:blip r:embed="rId17">
               <a:extLst>
                 <a:ext uri="{28A0092B-C50C-407E-A947-70E740481C1C}">
                   <a14:useLocalDpi xmlns:a14="http://schemas.microsoft.com/office/drawing/2010/main" val="0"/>
                 </a:ext>
                 <a:ext uri="{96DAC541-7B7A-43D3-8B79-37D633B846F1}">
-                  <asvg:svgBlip xmlns:asvg="http://schemas.microsoft.com/office/drawing/2016/SVG/main" r:embed="rId20"/>
+                  <asvg:svgBlip xmlns:asvg="http://schemas.microsoft.com/office/drawing/2016/SVG/main" r:embed="rId18"/>
                 </a:ext>
               </a:extLst>
             </a:blip>
@@ -10367,13 +10132,13 @@
             <p:nvPr/>
           </p:nvPicPr>
           <p:blipFill rotWithShape="1">
-            <a:blip r:embed="rId21">
+            <a:blip r:embed="rId19">
               <a:extLst>
                 <a:ext uri="{28A0092B-C50C-407E-A947-70E740481C1C}">
                   <a14:useLocalDpi xmlns:a14="http://schemas.microsoft.com/office/drawing/2010/main" val="0"/>
                 </a:ext>
                 <a:ext uri="{96DAC541-7B7A-43D3-8B79-37D633B846F1}">
-                  <asvg:svgBlip xmlns:asvg="http://schemas.microsoft.com/office/drawing/2016/SVG/main" r:embed="rId22"/>
+                  <asvg:svgBlip xmlns:asvg="http://schemas.microsoft.com/office/drawing/2016/SVG/main" r:embed="rId20"/>
                 </a:ext>
               </a:extLst>
             </a:blip>
@@ -10405,10 +10170,10 @@
         </p:nvGrpSpPr>
         <p:grpSpPr>
           <a:xfrm>
-            <a:off x="22990136" y="13938199"/>
-            <a:ext cx="6912332" cy="6118831"/>
-            <a:chOff x="22987347" y="13324694"/>
-            <a:chExt cx="7202664" cy="6246177"/>
+            <a:off x="22955854" y="13938199"/>
+            <a:ext cx="6946614" cy="6118831"/>
+            <a:chOff x="22951625" y="13324694"/>
+            <a:chExt cx="7238386" cy="6246177"/>
           </a:xfrm>
         </p:grpSpPr>
         <p:grpSp>
@@ -10425,10 +10190,10 @@
           </p:nvGrpSpPr>
           <p:grpSpPr>
             <a:xfrm>
-              <a:off x="22987347" y="13324694"/>
-              <a:ext cx="6975844" cy="6246177"/>
-              <a:chOff x="22987347" y="13324694"/>
-              <a:chExt cx="6975844" cy="6246177"/>
+              <a:off x="22951625" y="13324694"/>
+              <a:ext cx="7011566" cy="6246177"/>
+              <a:chOff x="22951625" y="13324694"/>
+              <a:chExt cx="7011566" cy="6246177"/>
             </a:xfrm>
           </p:grpSpPr>
           <p:grpSp>
@@ -10445,10 +10210,10 @@
             </p:nvGrpSpPr>
             <p:grpSpPr>
               <a:xfrm>
-                <a:off x="22987347" y="13324694"/>
-                <a:ext cx="1390631" cy="6163871"/>
-                <a:chOff x="23198455" y="5142184"/>
-                <a:chExt cx="1086711" cy="5298947"/>
+                <a:off x="22951625" y="13324694"/>
+                <a:ext cx="1426361" cy="6163871"/>
+                <a:chOff x="23170534" y="5142184"/>
+                <a:chExt cx="1114632" cy="5298947"/>
               </a:xfrm>
             </p:grpSpPr>
             <p:sp>
@@ -10465,7 +10230,7 @@
               </p:nvSpPr>
               <p:spPr>
                 <a:xfrm rot="16200000">
-                  <a:off x="20765443" y="7575196"/>
+                  <a:off x="20737522" y="7575196"/>
                   <a:ext cx="5298947" cy="432923"/>
                 </a:xfrm>
                 <a:prstGeom prst="rect">
@@ -10713,13 +10478,13 @@
             <p:nvPr/>
           </p:nvPicPr>
           <p:blipFill rotWithShape="1">
-            <a:blip r:embed="rId23">
+            <a:blip r:embed="rId21">
               <a:extLst>
                 <a:ext uri="{28A0092B-C50C-407E-A947-70E740481C1C}">
                   <a14:useLocalDpi xmlns:a14="http://schemas.microsoft.com/office/drawing/2010/main" val="0"/>
                 </a:ext>
                 <a:ext uri="{96DAC541-7B7A-43D3-8B79-37D633B846F1}">
-                  <asvg:svgBlip xmlns:asvg="http://schemas.microsoft.com/office/drawing/2016/SVG/main" r:embed="rId24"/>
+                  <asvg:svgBlip xmlns:asvg="http://schemas.microsoft.com/office/drawing/2016/SVG/main" r:embed="rId22"/>
                 </a:ext>
               </a:extLst>
             </a:blip>
@@ -10752,13 +10517,13 @@
           <p:nvPr/>
         </p:nvPicPr>
         <p:blipFill rotWithShape="1">
-          <a:blip r:embed="rId25">
+          <a:blip r:embed="rId23">
             <a:extLst>
               <a:ext uri="{28A0092B-C50C-407E-A947-70E740481C1C}">
                 <a14:useLocalDpi xmlns:a14="http://schemas.microsoft.com/office/drawing/2010/main" val="0"/>
               </a:ext>
               <a:ext uri="{96DAC541-7B7A-43D3-8B79-37D633B846F1}">
-                <asvg:svgBlip xmlns:asvg="http://schemas.microsoft.com/office/drawing/2016/SVG/main" r:embed="rId26"/>
+                <asvg:svgBlip xmlns:asvg="http://schemas.microsoft.com/office/drawing/2016/SVG/main" r:embed="rId24"/>
               </a:ext>
             </a:extLst>
           </a:blip>
@@ -10790,13 +10555,13 @@
           <p:nvPr/>
         </p:nvPicPr>
         <p:blipFill rotWithShape="1">
-          <a:blip r:embed="rId27">
+          <a:blip r:embed="rId25">
             <a:extLst>
               <a:ext uri="{28A0092B-C50C-407E-A947-70E740481C1C}">
                 <a14:useLocalDpi xmlns:a14="http://schemas.microsoft.com/office/drawing/2010/main" val="0"/>
               </a:ext>
               <a:ext uri="{96DAC541-7B7A-43D3-8B79-37D633B846F1}">
-                <asvg:svgBlip xmlns:asvg="http://schemas.microsoft.com/office/drawing/2016/SVG/main" r:embed="rId28"/>
+                <asvg:svgBlip xmlns:asvg="http://schemas.microsoft.com/office/drawing/2016/SVG/main" r:embed="rId26"/>
               </a:ext>
             </a:extLst>
           </a:blip>
@@ -10960,7 +10725,7 @@
               <p:nvPr/>
             </p:nvPicPr>
             <p:blipFill>
-              <a:blip r:embed="rId29">
+              <a:blip r:embed="rId27">
                 <a:extLst>
                   <a:ext uri="{28A0092B-C50C-407E-A947-70E740481C1C}">
                     <a14:useLocalDpi xmlns:a14="http://schemas.microsoft.com/office/drawing/2010/main" val="0"/>
@@ -11349,13 +11114,13 @@
             <p:nvPr/>
           </p:nvPicPr>
           <p:blipFill rotWithShape="1">
-            <a:blip r:embed="rId30">
+            <a:blip r:embed="rId28">
               <a:extLst>
                 <a:ext uri="{28A0092B-C50C-407E-A947-70E740481C1C}">
                   <a14:useLocalDpi xmlns:a14="http://schemas.microsoft.com/office/drawing/2010/main" val="0"/>
                 </a:ext>
                 <a:ext uri="{96DAC541-7B7A-43D3-8B79-37D633B846F1}">
-                  <asvg:svgBlip xmlns:asvg="http://schemas.microsoft.com/office/drawing/2016/SVG/main" r:embed="rId31"/>
+                  <asvg:svgBlip xmlns:asvg="http://schemas.microsoft.com/office/drawing/2016/SVG/main" r:embed="rId29"/>
                 </a:ext>
               </a:extLst>
             </a:blip>
@@ -11373,41 +11138,6 @@
           </p:spPr>
         </p:pic>
       </p:grpSp>
-      <p:sp>
-        <p:nvSpPr>
-          <p:cNvPr id="44" name="TextBox 43">
-            <a:extLst>
-              <a:ext uri="{FF2B5EF4-FFF2-40B4-BE49-F238E27FC236}">
-                <a16:creationId xmlns:a16="http://schemas.microsoft.com/office/drawing/2014/main" id="{10C1E3FB-BD99-75D9-FE95-CD17FE3F9F8B}"/>
-              </a:ext>
-            </a:extLst>
-          </p:cNvPr>
-          <p:cNvSpPr txBox="1"/>
-          <p:nvPr/>
-        </p:nvSpPr>
-        <p:spPr>
-          <a:xfrm rot="16200000">
-            <a:off x="14901103" y="8163853"/>
-            <a:ext cx="1976823" cy="553998"/>
-          </a:xfrm>
-          <a:prstGeom prst="rect">
-            <a:avLst/>
-          </a:prstGeom>
-          <a:noFill/>
-        </p:spPr>
-        <p:txBody>
-          <a:bodyPr wrap="none" rtlCol="0">
-            <a:spAutoFit/>
-          </a:bodyPr>
-          <a:lstStyle/>
-          <a:p>
-            <a:r>
-              <a:rPr lang="en-US" sz="3000" dirty="0"/>
-              <a:t>Closeness</a:t>
-            </a:r>
-          </a:p>
-        </p:txBody>
-      </p:sp>
       <p:sp>
         <p:nvSpPr>
           <p:cNvPr id="46" name="TextBox 45">
@@ -12504,7 +12234,7 @@
         </p:nvSpPr>
         <p:spPr>
           <a:xfrm>
-            <a:off x="20959218" y="13549230"/>
+            <a:off x="20973506" y="13620670"/>
             <a:ext cx="1932677" cy="523220"/>
           </a:xfrm>
           <a:prstGeom prst="rect">
@@ -12539,7 +12269,7 @@
         </p:nvSpPr>
         <p:spPr>
           <a:xfrm>
-            <a:off x="28609845" y="5241364"/>
+            <a:off x="28598415" y="5241364"/>
             <a:ext cx="1932677" cy="523220"/>
           </a:xfrm>
           <a:prstGeom prst="rect">
@@ -12574,7 +12304,7 @@
         </p:nvSpPr>
         <p:spPr>
           <a:xfrm>
-            <a:off x="28570974" y="13544663"/>
+            <a:off x="28279896" y="13590309"/>
             <a:ext cx="1932677" cy="523220"/>
           </a:xfrm>
           <a:prstGeom prst="rect">
@@ -12590,7 +12320,7 @@
           <a:p>
             <a:r>
               <a:rPr lang="en-US" sz="2800" i="1" dirty="0"/>
-              <a:t>R = -.</a:t>
+              <a:t>R = -0.09</a:t>
             </a:r>
           </a:p>
         </p:txBody>
@@ -12689,6 +12419,1328 @@
           </a:p>
         </p:txBody>
       </p:sp>
+      <p:grpSp>
+        <p:nvGrpSpPr>
+          <p:cNvPr id="15705" name="Group 15704">
+            <a:extLst>
+              <a:ext uri="{FF2B5EF4-FFF2-40B4-BE49-F238E27FC236}">
+                <a16:creationId xmlns:a16="http://schemas.microsoft.com/office/drawing/2014/main" id="{B315F0CF-5757-721B-6FDA-3CDF8B65C4FC}"/>
+              </a:ext>
+            </a:extLst>
+          </p:cNvPr>
+          <p:cNvGrpSpPr/>
+          <p:nvPr/>
+        </p:nvGrpSpPr>
+        <p:grpSpPr>
+          <a:xfrm>
+            <a:off x="15693029" y="5633407"/>
+            <a:ext cx="6831019" cy="6045286"/>
+            <a:chOff x="15693029" y="5633407"/>
+            <a:chExt cx="6831019" cy="6045286"/>
+          </a:xfrm>
+        </p:grpSpPr>
+        <p:grpSp>
+          <p:nvGrpSpPr>
+            <p:cNvPr id="15694" name="Group 15693">
+              <a:extLst>
+                <a:ext uri="{FF2B5EF4-FFF2-40B4-BE49-F238E27FC236}">
+                  <a16:creationId xmlns:a16="http://schemas.microsoft.com/office/drawing/2014/main" id="{5055852D-9D38-8AD6-DEF6-61182430B0FF}"/>
+                </a:ext>
+              </a:extLst>
+            </p:cNvPr>
+            <p:cNvGrpSpPr/>
+            <p:nvPr/>
+          </p:nvGrpSpPr>
+          <p:grpSpPr>
+            <a:xfrm>
+              <a:off x="16753920" y="5633407"/>
+              <a:ext cx="5770128" cy="5560255"/>
+              <a:chOff x="1421938" y="14767343"/>
+              <a:chExt cx="5770128" cy="5560255"/>
+            </a:xfrm>
+          </p:grpSpPr>
+          <p:sp>
+            <p:nvSpPr>
+              <p:cNvPr id="15695" name="Rectangle 15694">
+                <a:extLst>
+                  <a:ext uri="{FF2B5EF4-FFF2-40B4-BE49-F238E27FC236}">
+                    <a16:creationId xmlns:a16="http://schemas.microsoft.com/office/drawing/2014/main" id="{59245EF6-EA65-4213-1DFF-5690FF2BCBB1}"/>
+                  </a:ext>
+                </a:extLst>
+              </p:cNvPr>
+              <p:cNvSpPr/>
+              <p:nvPr/>
+            </p:nvSpPr>
+            <p:spPr bwMode="auto">
+              <a:xfrm>
+                <a:off x="1421941" y="14767343"/>
+                <a:ext cx="5762869" cy="5560255"/>
+              </a:xfrm>
+              <a:prstGeom prst="rect">
+                <a:avLst/>
+              </a:prstGeom>
+              <a:solidFill>
+                <a:srgbClr val="EAEBEB"/>
+              </a:solidFill>
+              <a:ln w="9525" cap="flat" cmpd="sng" algn="ctr">
+                <a:noFill/>
+                <a:prstDash val="solid"/>
+                <a:round/>
+                <a:headEnd type="none" w="med" len="med"/>
+                <a:tailEnd type="none" w="med" len="med"/>
+              </a:ln>
+              <a:effectLst/>
+            </p:spPr>
+            <p:txBody>
+              <a:bodyPr vert="horz" wrap="square" lIns="91440" tIns="45720" rIns="91440" bIns="45720" numCol="1" rtlCol="0" anchor="t" anchorCtr="0" compatLnSpc="1">
+                <a:prstTxWarp prst="textNoShape">
+                  <a:avLst/>
+                </a:prstTxWarp>
+              </a:bodyPr>
+              <a:lstStyle/>
+              <a:p>
+                <a:pPr marL="0" marR="0" indent="0" algn="l" defTabSz="4389438" rtl="0" eaLnBrk="1" fontAlgn="base" latinLnBrk="0" hangingPunct="1">
+                  <a:lnSpc>
+                    <a:spcPct val="100000"/>
+                  </a:lnSpc>
+                  <a:spcBef>
+                    <a:spcPct val="0"/>
+                  </a:spcBef>
+                  <a:spcAft>
+                    <a:spcPct val="0"/>
+                  </a:spcAft>
+                  <a:buClrTx/>
+                  <a:buSzTx/>
+                  <a:buFontTx/>
+                  <a:buNone/>
+                  <a:tabLst/>
+                </a:pPr>
+                <a:endParaRPr kumimoji="0" lang="en-US" sz="1800" b="0" i="0" u="none" strike="noStrike" cap="none" normalizeH="0" baseline="0" dirty="0">
+                  <a:ln>
+                    <a:noFill/>
+                  </a:ln>
+                  <a:solidFill>
+                    <a:schemeClr val="tx1"/>
+                  </a:solidFill>
+                  <a:effectLst/>
+                  <a:latin typeface="Arial" charset="0"/>
+                  <a:cs typeface="Arial" charset="0"/>
+                </a:endParaRPr>
+              </a:p>
+            </p:txBody>
+          </p:sp>
+          <p:cxnSp>
+            <p:nvCxnSpPr>
+              <p:cNvPr id="15696" name="Straight Connector 15695">
+                <a:extLst>
+                  <a:ext uri="{FF2B5EF4-FFF2-40B4-BE49-F238E27FC236}">
+                    <a16:creationId xmlns:a16="http://schemas.microsoft.com/office/drawing/2014/main" id="{1F326A97-0889-F757-F9AC-A1939B026E6B}"/>
+                  </a:ext>
+                </a:extLst>
+              </p:cNvPr>
+              <p:cNvCxnSpPr/>
+              <p:nvPr/>
+            </p:nvCxnSpPr>
+            <p:spPr bwMode="auto">
+              <a:xfrm flipH="1">
+                <a:off x="4303375" y="14775666"/>
+                <a:ext cx="14515" cy="5551932"/>
+              </a:xfrm>
+              <a:prstGeom prst="line">
+                <a:avLst/>
+              </a:prstGeom>
+              <a:solidFill>
+                <a:schemeClr val="accent1"/>
+              </a:solidFill>
+              <a:ln w="25400" cap="flat" cmpd="sng" algn="ctr">
+                <a:solidFill>
+                  <a:schemeClr val="accent3"/>
+                </a:solidFill>
+                <a:prstDash val="solid"/>
+                <a:round/>
+                <a:headEnd type="none" w="med" len="med"/>
+                <a:tailEnd type="none" w="med" len="med"/>
+              </a:ln>
+              <a:effectLst/>
+            </p:spPr>
+          </p:cxnSp>
+          <p:cxnSp>
+            <p:nvCxnSpPr>
+              <p:cNvPr id="15697" name="Straight Connector 15696">
+                <a:extLst>
+                  <a:ext uri="{FF2B5EF4-FFF2-40B4-BE49-F238E27FC236}">
+                    <a16:creationId xmlns:a16="http://schemas.microsoft.com/office/drawing/2014/main" id="{318119A5-70BB-53DE-82A9-9A5AAEBA7808}"/>
+                  </a:ext>
+                </a:extLst>
+              </p:cNvPr>
+              <p:cNvCxnSpPr/>
+              <p:nvPr/>
+            </p:nvCxnSpPr>
+            <p:spPr bwMode="auto">
+              <a:xfrm flipH="1">
+                <a:off x="2840886" y="14771504"/>
+                <a:ext cx="14515" cy="5551932"/>
+              </a:xfrm>
+              <a:prstGeom prst="line">
+                <a:avLst/>
+              </a:prstGeom>
+              <a:solidFill>
+                <a:schemeClr val="accent1"/>
+              </a:solidFill>
+              <a:ln w="25400" cap="flat" cmpd="sng" algn="ctr">
+                <a:solidFill>
+                  <a:schemeClr val="accent3"/>
+                </a:solidFill>
+                <a:prstDash val="solid"/>
+                <a:round/>
+                <a:headEnd type="none" w="med" len="med"/>
+                <a:tailEnd type="none" w="med" len="med"/>
+              </a:ln>
+              <a:effectLst/>
+            </p:spPr>
+          </p:cxnSp>
+          <p:cxnSp>
+            <p:nvCxnSpPr>
+              <p:cNvPr id="15698" name="Straight Connector 15697">
+                <a:extLst>
+                  <a:ext uri="{FF2B5EF4-FFF2-40B4-BE49-F238E27FC236}">
+                    <a16:creationId xmlns:a16="http://schemas.microsoft.com/office/drawing/2014/main" id="{10C3C3A8-1BF5-3756-F475-F40BC5CEF4EC}"/>
+                  </a:ext>
+                </a:extLst>
+              </p:cNvPr>
+              <p:cNvCxnSpPr/>
+              <p:nvPr/>
+            </p:nvCxnSpPr>
+            <p:spPr bwMode="auto">
+              <a:xfrm flipH="1">
+                <a:off x="5722320" y="14767343"/>
+                <a:ext cx="14515" cy="5551932"/>
+              </a:xfrm>
+              <a:prstGeom prst="line">
+                <a:avLst/>
+              </a:prstGeom>
+              <a:solidFill>
+                <a:schemeClr val="accent1"/>
+              </a:solidFill>
+              <a:ln w="25400" cap="flat" cmpd="sng" algn="ctr">
+                <a:solidFill>
+                  <a:schemeClr val="accent3"/>
+                </a:solidFill>
+                <a:prstDash val="solid"/>
+                <a:round/>
+                <a:headEnd type="none" w="med" len="med"/>
+                <a:tailEnd type="none" w="med" len="med"/>
+              </a:ln>
+              <a:effectLst/>
+            </p:spPr>
+          </p:cxnSp>
+          <p:cxnSp>
+            <p:nvCxnSpPr>
+              <p:cNvPr id="15699" name="Straight Connector 15698">
+                <a:extLst>
+                  <a:ext uri="{FF2B5EF4-FFF2-40B4-BE49-F238E27FC236}">
+                    <a16:creationId xmlns:a16="http://schemas.microsoft.com/office/drawing/2014/main" id="{957E6B38-B9EE-99EE-54C6-E275A0014537}"/>
+                  </a:ext>
+                </a:extLst>
+              </p:cNvPr>
+              <p:cNvCxnSpPr>
+                <a:stCxn id="15695" idx="1"/>
+                <a:endCxn id="15695" idx="3"/>
+              </p:cNvCxnSpPr>
+              <p:nvPr/>
+            </p:nvCxnSpPr>
+            <p:spPr bwMode="auto">
+              <a:xfrm>
+                <a:off x="1421941" y="17547471"/>
+                <a:ext cx="5762869" cy="0"/>
+              </a:xfrm>
+              <a:prstGeom prst="line">
+                <a:avLst/>
+              </a:prstGeom>
+              <a:solidFill>
+                <a:schemeClr val="accent1"/>
+              </a:solidFill>
+              <a:ln w="25400" cap="flat" cmpd="sng" algn="ctr">
+                <a:solidFill>
+                  <a:schemeClr val="accent3"/>
+                </a:solidFill>
+                <a:prstDash val="solid"/>
+                <a:round/>
+                <a:headEnd type="none" w="med" len="med"/>
+                <a:tailEnd type="none" w="med" len="med"/>
+              </a:ln>
+              <a:effectLst/>
+            </p:spPr>
+          </p:cxnSp>
+          <p:cxnSp>
+            <p:nvCxnSpPr>
+              <p:cNvPr id="15700" name="Straight Connector 15699">
+                <a:extLst>
+                  <a:ext uri="{FF2B5EF4-FFF2-40B4-BE49-F238E27FC236}">
+                    <a16:creationId xmlns:a16="http://schemas.microsoft.com/office/drawing/2014/main" id="{1ADEF486-D1AE-3205-D856-B51DA49A5860}"/>
+                  </a:ext>
+                </a:extLst>
+              </p:cNvPr>
+              <p:cNvCxnSpPr/>
+              <p:nvPr/>
+            </p:nvCxnSpPr>
+            <p:spPr bwMode="auto">
+              <a:xfrm>
+                <a:off x="1421940" y="18803458"/>
+                <a:ext cx="5762869" cy="0"/>
+              </a:xfrm>
+              <a:prstGeom prst="line">
+                <a:avLst/>
+              </a:prstGeom>
+              <a:solidFill>
+                <a:schemeClr val="accent1"/>
+              </a:solidFill>
+              <a:ln w="25400" cap="flat" cmpd="sng" algn="ctr">
+                <a:solidFill>
+                  <a:schemeClr val="accent3"/>
+                </a:solidFill>
+                <a:prstDash val="solid"/>
+                <a:round/>
+                <a:headEnd type="none" w="med" len="med"/>
+                <a:tailEnd type="none" w="med" len="med"/>
+              </a:ln>
+              <a:effectLst/>
+            </p:spPr>
+          </p:cxnSp>
+          <p:cxnSp>
+            <p:nvCxnSpPr>
+              <p:cNvPr id="15701" name="Straight Connector 15700">
+                <a:extLst>
+                  <a:ext uri="{FF2B5EF4-FFF2-40B4-BE49-F238E27FC236}">
+                    <a16:creationId xmlns:a16="http://schemas.microsoft.com/office/drawing/2014/main" id="{2DF8FE5D-6599-B3FA-0149-297191C471D1}"/>
+                  </a:ext>
+                </a:extLst>
+              </p:cNvPr>
+              <p:cNvCxnSpPr/>
+              <p:nvPr/>
+            </p:nvCxnSpPr>
+            <p:spPr bwMode="auto">
+              <a:xfrm>
+                <a:off x="1429197" y="16328272"/>
+                <a:ext cx="5762869" cy="0"/>
+              </a:xfrm>
+              <a:prstGeom prst="line">
+                <a:avLst/>
+              </a:prstGeom>
+              <a:solidFill>
+                <a:schemeClr val="accent1"/>
+              </a:solidFill>
+              <a:ln w="25400" cap="flat" cmpd="sng" algn="ctr">
+                <a:solidFill>
+                  <a:schemeClr val="accent3"/>
+                </a:solidFill>
+                <a:prstDash val="solid"/>
+                <a:round/>
+                <a:headEnd type="none" w="med" len="med"/>
+                <a:tailEnd type="none" w="med" len="med"/>
+              </a:ln>
+              <a:effectLst/>
+            </p:spPr>
+          </p:cxnSp>
+          <p:cxnSp>
+            <p:nvCxnSpPr>
+              <p:cNvPr id="15702" name="Straight Connector 15701">
+                <a:extLst>
+                  <a:ext uri="{FF2B5EF4-FFF2-40B4-BE49-F238E27FC236}">
+                    <a16:creationId xmlns:a16="http://schemas.microsoft.com/office/drawing/2014/main" id="{EC14FBC0-C7F4-8654-EFD8-CCFF96ED3CCB}"/>
+                  </a:ext>
+                </a:extLst>
+              </p:cNvPr>
+              <p:cNvCxnSpPr/>
+              <p:nvPr/>
+            </p:nvCxnSpPr>
+            <p:spPr bwMode="auto">
+              <a:xfrm>
+                <a:off x="1421939" y="20048934"/>
+                <a:ext cx="5762869" cy="0"/>
+              </a:xfrm>
+              <a:prstGeom prst="line">
+                <a:avLst/>
+              </a:prstGeom>
+              <a:solidFill>
+                <a:schemeClr val="accent1"/>
+              </a:solidFill>
+              <a:ln w="25400" cap="flat" cmpd="sng" algn="ctr">
+                <a:solidFill>
+                  <a:schemeClr val="accent3"/>
+                </a:solidFill>
+                <a:prstDash val="solid"/>
+                <a:round/>
+                <a:headEnd type="none" w="med" len="med"/>
+                <a:tailEnd type="none" w="med" len="med"/>
+              </a:ln>
+              <a:effectLst/>
+            </p:spPr>
+          </p:cxnSp>
+          <p:cxnSp>
+            <p:nvCxnSpPr>
+              <p:cNvPr id="15703" name="Straight Connector 15702">
+                <a:extLst>
+                  <a:ext uri="{FF2B5EF4-FFF2-40B4-BE49-F238E27FC236}">
+                    <a16:creationId xmlns:a16="http://schemas.microsoft.com/office/drawing/2014/main" id="{594244E0-1BD5-0B30-441B-104DF3B61537}"/>
+                  </a:ext>
+                </a:extLst>
+              </p:cNvPr>
+              <p:cNvCxnSpPr/>
+              <p:nvPr/>
+            </p:nvCxnSpPr>
+            <p:spPr bwMode="auto">
+              <a:xfrm>
+                <a:off x="1421938" y="15088052"/>
+                <a:ext cx="5762869" cy="0"/>
+              </a:xfrm>
+              <a:prstGeom prst="line">
+                <a:avLst/>
+              </a:prstGeom>
+              <a:solidFill>
+                <a:schemeClr val="accent1"/>
+              </a:solidFill>
+              <a:ln w="25400" cap="flat" cmpd="sng" algn="ctr">
+                <a:solidFill>
+                  <a:schemeClr val="accent3"/>
+                </a:solidFill>
+                <a:prstDash val="solid"/>
+                <a:round/>
+                <a:headEnd type="none" w="med" len="med"/>
+                <a:tailEnd type="none" w="med" len="med"/>
+              </a:ln>
+              <a:effectLst/>
+            </p:spPr>
+          </p:cxnSp>
+        </p:grpSp>
+        <p:grpSp>
+          <p:nvGrpSpPr>
+            <p:cNvPr id="15686" name="Group 15685">
+              <a:extLst>
+                <a:ext uri="{FF2B5EF4-FFF2-40B4-BE49-F238E27FC236}">
+                  <a16:creationId xmlns:a16="http://schemas.microsoft.com/office/drawing/2014/main" id="{ED126016-F777-1072-6221-FC940E4C8421}"/>
+                </a:ext>
+              </a:extLst>
+            </p:cNvPr>
+            <p:cNvGrpSpPr/>
+            <p:nvPr/>
+          </p:nvGrpSpPr>
+          <p:grpSpPr>
+            <a:xfrm>
+              <a:off x="15693029" y="6238462"/>
+              <a:ext cx="6764612" cy="5440231"/>
+              <a:chOff x="15670877" y="5930781"/>
+              <a:chExt cx="6764612" cy="5440231"/>
+            </a:xfrm>
+          </p:grpSpPr>
+          <p:sp>
+            <p:nvSpPr>
+              <p:cNvPr id="44" name="TextBox 43">
+                <a:extLst>
+                  <a:ext uri="{FF2B5EF4-FFF2-40B4-BE49-F238E27FC236}">
+                    <a16:creationId xmlns:a16="http://schemas.microsoft.com/office/drawing/2014/main" id="{10C1E3FB-BD99-75D9-FE95-CD17FE3F9F8B}"/>
+                  </a:ext>
+                </a:extLst>
+              </p:cNvPr>
+              <p:cNvSpPr txBox="1"/>
+              <p:nvPr/>
+            </p:nvSpPr>
+            <p:spPr>
+              <a:xfrm rot="16200000">
+                <a:off x="14959464" y="8002434"/>
+                <a:ext cx="1976823" cy="553998"/>
+              </a:xfrm>
+              <a:prstGeom prst="rect">
+                <a:avLst/>
+              </a:prstGeom>
+              <a:noFill/>
+            </p:spPr>
+            <p:txBody>
+              <a:bodyPr wrap="none" rtlCol="0">
+                <a:spAutoFit/>
+              </a:bodyPr>
+              <a:lstStyle/>
+              <a:p>
+                <a:r>
+                  <a:rPr lang="en-US" sz="3000" dirty="0"/>
+                  <a:t>Closeness</a:t>
+                </a:r>
+              </a:p>
+            </p:txBody>
+          </p:sp>
+          <p:grpSp>
+            <p:nvGrpSpPr>
+              <p:cNvPr id="15685" name="Group 15684">
+                <a:extLst>
+                  <a:ext uri="{FF2B5EF4-FFF2-40B4-BE49-F238E27FC236}">
+                    <a16:creationId xmlns:a16="http://schemas.microsoft.com/office/drawing/2014/main" id="{F69E9B06-6DD1-AE5C-F052-C96A7F7CB40F}"/>
+                  </a:ext>
+                </a:extLst>
+              </p:cNvPr>
+              <p:cNvGrpSpPr/>
+              <p:nvPr/>
+            </p:nvGrpSpPr>
+            <p:grpSpPr>
+              <a:xfrm>
+                <a:off x="16093240" y="5930781"/>
+                <a:ext cx="6342249" cy="5440231"/>
+                <a:chOff x="16093240" y="5930781"/>
+                <a:chExt cx="6342249" cy="5440231"/>
+              </a:xfrm>
+            </p:grpSpPr>
+            <p:grpSp>
+              <p:nvGrpSpPr>
+                <p:cNvPr id="15666" name="Group 15665">
+                  <a:extLst>
+                    <a:ext uri="{FF2B5EF4-FFF2-40B4-BE49-F238E27FC236}">
+                      <a16:creationId xmlns:a16="http://schemas.microsoft.com/office/drawing/2014/main" id="{F4499BAD-2B87-B075-89D7-E684EC5B1F7C}"/>
+                    </a:ext>
+                  </a:extLst>
+                </p:cNvPr>
+                <p:cNvGrpSpPr/>
+                <p:nvPr/>
+              </p:nvGrpSpPr>
+              <p:grpSpPr>
+                <a:xfrm>
+                  <a:off x="16093240" y="6288749"/>
+                  <a:ext cx="6342249" cy="5082263"/>
+                  <a:chOff x="16307695" y="5718009"/>
+                  <a:chExt cx="4012927" cy="3083133"/>
+                </a:xfrm>
+              </p:grpSpPr>
+              <p:sp>
+                <p:nvSpPr>
+                  <p:cNvPr id="15660" name="TextBox 15659">
+                    <a:extLst>
+                      <a:ext uri="{FF2B5EF4-FFF2-40B4-BE49-F238E27FC236}">
+                        <a16:creationId xmlns:a16="http://schemas.microsoft.com/office/drawing/2014/main" id="{0766629E-BCF3-6556-AF99-A6859175E636}"/>
+                      </a:ext>
+                    </a:extLst>
+                  </p:cNvPr>
+                  <p:cNvSpPr txBox="1"/>
+                  <p:nvPr/>
+                </p:nvSpPr>
+                <p:spPr>
+                  <a:xfrm>
+                    <a:off x="16307695" y="8232313"/>
+                    <a:ext cx="243627" cy="317409"/>
+                  </a:xfrm>
+                  <a:prstGeom prst="rect">
+                    <a:avLst/>
+                  </a:prstGeom>
+                  <a:noFill/>
+                </p:spPr>
+                <p:txBody>
+                  <a:bodyPr wrap="none" rtlCol="0">
+                    <a:spAutoFit/>
+                  </a:bodyPr>
+                  <a:lstStyle/>
+                  <a:p>
+                    <a:r>
+                      <a:rPr lang="en-US" sz="2800" dirty="0"/>
+                      <a:t>0</a:t>
+                    </a:r>
+                  </a:p>
+                </p:txBody>
+              </p:sp>
+              <p:sp>
+                <p:nvSpPr>
+                  <p:cNvPr id="15662" name="TextBox 15661">
+                    <a:extLst>
+                      <a:ext uri="{FF2B5EF4-FFF2-40B4-BE49-F238E27FC236}">
+                        <a16:creationId xmlns:a16="http://schemas.microsoft.com/office/drawing/2014/main" id="{4DC189FA-5EF4-8645-EFD2-F4AA0CF414D9}"/>
+                      </a:ext>
+                    </a:extLst>
+                  </p:cNvPr>
+                  <p:cNvSpPr txBox="1"/>
+                  <p:nvPr/>
+                </p:nvSpPr>
+                <p:spPr>
+                  <a:xfrm>
+                    <a:off x="16323035" y="5718009"/>
+                    <a:ext cx="243627" cy="317409"/>
+                  </a:xfrm>
+                  <a:prstGeom prst="rect">
+                    <a:avLst/>
+                  </a:prstGeom>
+                  <a:noFill/>
+                </p:spPr>
+                <p:txBody>
+                  <a:bodyPr wrap="none" rtlCol="0">
+                    <a:spAutoFit/>
+                  </a:bodyPr>
+                  <a:lstStyle/>
+                  <a:p>
+                    <a:r>
+                      <a:rPr lang="en-US" sz="2800" dirty="0"/>
+                      <a:t>4</a:t>
+                    </a:r>
+                  </a:p>
+                </p:txBody>
+              </p:sp>
+              <p:sp>
+                <p:nvSpPr>
+                  <p:cNvPr id="15663" name="TextBox 15662">
+                    <a:extLst>
+                      <a:ext uri="{FF2B5EF4-FFF2-40B4-BE49-F238E27FC236}">
+                        <a16:creationId xmlns:a16="http://schemas.microsoft.com/office/drawing/2014/main" id="{FEBA7C19-438A-8BB9-F286-7161582091EA}"/>
+                      </a:ext>
+                    </a:extLst>
+                  </p:cNvPr>
+                  <p:cNvSpPr txBox="1"/>
+                  <p:nvPr/>
+                </p:nvSpPr>
+                <p:spPr>
+                  <a:xfrm>
+                    <a:off x="16934663" y="8465001"/>
+                    <a:ext cx="805531" cy="336081"/>
+                  </a:xfrm>
+                  <a:prstGeom prst="rect">
+                    <a:avLst/>
+                  </a:prstGeom>
+                  <a:noFill/>
+                </p:spPr>
+                <p:txBody>
+                  <a:bodyPr wrap="none" rtlCol="0">
+                    <a:spAutoFit/>
+                  </a:bodyPr>
+                  <a:lstStyle/>
+                  <a:p>
+                    <a:pPr algn="ctr"/>
+                    <a:r>
+                      <a:rPr lang="en-US" sz="3000" dirty="0"/>
+                      <a:t>Friend</a:t>
+                    </a:r>
+                  </a:p>
+                </p:txBody>
+              </p:sp>
+              <p:sp>
+                <p:nvSpPr>
+                  <p:cNvPr id="15664" name="TextBox 15663">
+                    <a:extLst>
+                      <a:ext uri="{FF2B5EF4-FFF2-40B4-BE49-F238E27FC236}">
+                        <a16:creationId xmlns:a16="http://schemas.microsoft.com/office/drawing/2014/main" id="{D1FDC6B6-A877-379F-C9B2-8D6C71CA3AC6}"/>
+                      </a:ext>
+                    </a:extLst>
+                  </p:cNvPr>
+                  <p:cNvSpPr txBox="1"/>
+                  <p:nvPr/>
+                </p:nvSpPr>
+                <p:spPr>
+                  <a:xfrm>
+                    <a:off x="18022351" y="8460397"/>
+                    <a:ext cx="1048955" cy="336081"/>
+                  </a:xfrm>
+                  <a:prstGeom prst="rect">
+                    <a:avLst/>
+                  </a:prstGeom>
+                  <a:noFill/>
+                </p:spPr>
+                <p:txBody>
+                  <a:bodyPr wrap="none" rtlCol="0">
+                    <a:spAutoFit/>
+                  </a:bodyPr>
+                  <a:lstStyle/>
+                  <a:p>
+                    <a:r>
+                      <a:rPr lang="en-US" sz="3000" dirty="0"/>
+                      <a:t>Stranger</a:t>
+                    </a:r>
+                  </a:p>
+                </p:txBody>
+              </p:sp>
+              <p:sp>
+                <p:nvSpPr>
+                  <p:cNvPr id="15665" name="TextBox 15664">
+                    <a:extLst>
+                      <a:ext uri="{FF2B5EF4-FFF2-40B4-BE49-F238E27FC236}">
+                        <a16:creationId xmlns:a16="http://schemas.microsoft.com/office/drawing/2014/main" id="{0D79EDF9-8FFC-03A5-0959-5F4339B2A174}"/>
+                      </a:ext>
+                    </a:extLst>
+                  </p:cNvPr>
+                  <p:cNvSpPr txBox="1"/>
+                  <p:nvPr/>
+                </p:nvSpPr>
+                <p:spPr>
+                  <a:xfrm>
+                    <a:off x="19136770" y="8465061"/>
+                    <a:ext cx="1183852" cy="336081"/>
+                  </a:xfrm>
+                  <a:prstGeom prst="rect">
+                    <a:avLst/>
+                  </a:prstGeom>
+                  <a:noFill/>
+                </p:spPr>
+                <p:txBody>
+                  <a:bodyPr wrap="none" rtlCol="0">
+                    <a:spAutoFit/>
+                  </a:bodyPr>
+                  <a:lstStyle/>
+                  <a:p>
+                    <a:pPr algn="ctr"/>
+                    <a:r>
+                      <a:rPr lang="en-US" sz="3000" dirty="0"/>
+                      <a:t>Computer</a:t>
+                    </a:r>
+                  </a:p>
+                </p:txBody>
+              </p:sp>
+            </p:grpSp>
+            <p:grpSp>
+              <p:nvGrpSpPr>
+                <p:cNvPr id="9" name="Group 8">
+                  <a:extLst>
+                    <a:ext uri="{FF2B5EF4-FFF2-40B4-BE49-F238E27FC236}">
+                      <a16:creationId xmlns:a16="http://schemas.microsoft.com/office/drawing/2014/main" id="{451527B6-A02F-7C50-BE7D-EF3CA2D82851}"/>
+                    </a:ext>
+                  </a:extLst>
+                </p:cNvPr>
+                <p:cNvGrpSpPr/>
+                <p:nvPr/>
+              </p:nvGrpSpPr>
+              <p:grpSpPr>
+                <a:xfrm>
+                  <a:off x="17478242" y="5930781"/>
+                  <a:ext cx="4174099" cy="4956803"/>
+                  <a:chOff x="35245965" y="10130725"/>
+                  <a:chExt cx="4594165" cy="5455637"/>
+                </a:xfrm>
+              </p:grpSpPr>
+              <p:sp>
+                <p:nvSpPr>
+                  <p:cNvPr id="49" name="Rectangle 48">
+                    <a:extLst>
+                      <a:ext uri="{FF2B5EF4-FFF2-40B4-BE49-F238E27FC236}">
+                        <a16:creationId xmlns:a16="http://schemas.microsoft.com/office/drawing/2014/main" id="{15A25FF5-81AC-06F1-BC36-DB83CAD59508}"/>
+                      </a:ext>
+                    </a:extLst>
+                  </p:cNvPr>
+                  <p:cNvSpPr/>
+                  <p:nvPr/>
+                </p:nvSpPr>
+                <p:spPr bwMode="auto">
+                  <a:xfrm>
+                    <a:off x="35245965" y="10341032"/>
+                    <a:ext cx="914400" cy="5245330"/>
+                  </a:xfrm>
+                  <a:prstGeom prst="rect">
+                    <a:avLst/>
+                  </a:prstGeom>
+                  <a:solidFill>
+                    <a:schemeClr val="accent1"/>
+                  </a:solidFill>
+                  <a:ln w="9525" cap="flat" cmpd="sng" algn="ctr">
+                    <a:noFill/>
+                    <a:prstDash val="solid"/>
+                    <a:round/>
+                    <a:headEnd type="none" w="med" len="med"/>
+                    <a:tailEnd type="none" w="med" len="med"/>
+                  </a:ln>
+                  <a:effectLst/>
+                </p:spPr>
+                <p:txBody>
+                  <a:bodyPr vert="horz" wrap="square" lIns="91440" tIns="45720" rIns="91440" bIns="45720" numCol="1" rtlCol="0" anchor="t" anchorCtr="0" compatLnSpc="1">
+                    <a:prstTxWarp prst="textNoShape">
+                      <a:avLst/>
+                    </a:prstTxWarp>
+                  </a:bodyPr>
+                  <a:lstStyle/>
+                  <a:p>
+                    <a:pPr marL="0" marR="0" indent="0" algn="l" defTabSz="4389438" rtl="0" eaLnBrk="1" fontAlgn="base" latinLnBrk="0" hangingPunct="1">
+                      <a:lnSpc>
+                        <a:spcPct val="100000"/>
+                      </a:lnSpc>
+                      <a:spcBef>
+                        <a:spcPct val="0"/>
+                      </a:spcBef>
+                      <a:spcAft>
+                        <a:spcPct val="0"/>
+                      </a:spcAft>
+                      <a:buClrTx/>
+                      <a:buSzTx/>
+                      <a:buFontTx/>
+                      <a:buNone/>
+                      <a:tabLst/>
+                    </a:pPr>
+                    <a:endParaRPr kumimoji="0" lang="en-US" sz="1800" b="0" i="0" u="none" strike="noStrike" cap="none" normalizeH="0" baseline="0">
+                      <a:ln>
+                        <a:noFill/>
+                      </a:ln>
+                      <a:solidFill>
+                        <a:schemeClr val="tx1"/>
+                      </a:solidFill>
+                      <a:effectLst/>
+                      <a:latin typeface="Arial" charset="0"/>
+                      <a:cs typeface="Arial" charset="0"/>
+                    </a:endParaRPr>
+                  </a:p>
+                </p:txBody>
+              </p:sp>
+              <p:sp>
+                <p:nvSpPr>
+                  <p:cNvPr id="50" name="Rectangle 49">
+                    <a:extLst>
+                      <a:ext uri="{FF2B5EF4-FFF2-40B4-BE49-F238E27FC236}">
+                        <a16:creationId xmlns:a16="http://schemas.microsoft.com/office/drawing/2014/main" id="{E562E75E-69FD-32B9-DA52-8CFDD4BA6E30}"/>
+                      </a:ext>
+                    </a:extLst>
+                  </p:cNvPr>
+                  <p:cNvSpPr/>
+                  <p:nvPr/>
+                </p:nvSpPr>
+                <p:spPr bwMode="auto">
+                  <a:xfrm>
+                    <a:off x="37085847" y="13716000"/>
+                    <a:ext cx="914400" cy="1859437"/>
+                  </a:xfrm>
+                  <a:prstGeom prst="rect">
+                    <a:avLst/>
+                  </a:prstGeom>
+                  <a:solidFill>
+                    <a:srgbClr val="72BFC6"/>
+                  </a:solidFill>
+                  <a:ln w="9525" cap="flat" cmpd="sng" algn="ctr">
+                    <a:noFill/>
+                    <a:prstDash val="solid"/>
+                    <a:round/>
+                    <a:headEnd type="none" w="med" len="med"/>
+                    <a:tailEnd type="none" w="med" len="med"/>
+                  </a:ln>
+                  <a:effectLst/>
+                </p:spPr>
+                <p:txBody>
+                  <a:bodyPr vert="horz" wrap="square" lIns="91440" tIns="45720" rIns="91440" bIns="45720" numCol="1" rtlCol="0" anchor="t" anchorCtr="0" compatLnSpc="1">
+                    <a:prstTxWarp prst="textNoShape">
+                      <a:avLst/>
+                    </a:prstTxWarp>
+                  </a:bodyPr>
+                  <a:lstStyle/>
+                  <a:p>
+                    <a:pPr marL="0" marR="0" indent="0" algn="l" defTabSz="4389438" rtl="0" eaLnBrk="1" fontAlgn="base" latinLnBrk="0" hangingPunct="1">
+                      <a:lnSpc>
+                        <a:spcPct val="100000"/>
+                      </a:lnSpc>
+                      <a:spcBef>
+                        <a:spcPct val="0"/>
+                      </a:spcBef>
+                      <a:spcAft>
+                        <a:spcPct val="0"/>
+                      </a:spcAft>
+                      <a:buClrTx/>
+                      <a:buSzTx/>
+                      <a:buFontTx/>
+                      <a:buNone/>
+                      <a:tabLst/>
+                    </a:pPr>
+                    <a:endParaRPr kumimoji="0" lang="en-US" sz="1800" b="0" i="0" u="none" strike="noStrike" cap="none" normalizeH="0" baseline="0">
+                      <a:ln>
+                        <a:noFill/>
+                      </a:ln>
+                      <a:solidFill>
+                        <a:schemeClr val="tx1"/>
+                      </a:solidFill>
+                      <a:effectLst/>
+                      <a:latin typeface="Arial" charset="0"/>
+                      <a:cs typeface="Arial" charset="0"/>
+                    </a:endParaRPr>
+                  </a:p>
+                </p:txBody>
+              </p:sp>
+              <p:sp>
+                <p:nvSpPr>
+                  <p:cNvPr id="51" name="Rectangle 50">
+                    <a:extLst>
+                      <a:ext uri="{FF2B5EF4-FFF2-40B4-BE49-F238E27FC236}">
+                        <a16:creationId xmlns:a16="http://schemas.microsoft.com/office/drawing/2014/main" id="{4528B3B9-AEEA-D1A4-0F7D-9568094B7BBF}"/>
+                      </a:ext>
+                    </a:extLst>
+                  </p:cNvPr>
+                  <p:cNvSpPr/>
+                  <p:nvPr/>
+                </p:nvSpPr>
+                <p:spPr bwMode="auto">
+                  <a:xfrm>
+                    <a:off x="38925730" y="13716000"/>
+                    <a:ext cx="914400" cy="1859437"/>
+                  </a:xfrm>
+                  <a:prstGeom prst="rect">
+                    <a:avLst/>
+                  </a:prstGeom>
+                  <a:solidFill>
+                    <a:srgbClr val="3C8C94"/>
+                  </a:solidFill>
+                  <a:ln w="9525" cap="flat" cmpd="sng" algn="ctr">
+                    <a:noFill/>
+                    <a:prstDash val="solid"/>
+                    <a:round/>
+                    <a:headEnd type="none" w="med" len="med"/>
+                    <a:tailEnd type="none" w="med" len="med"/>
+                  </a:ln>
+                  <a:effectLst/>
+                </p:spPr>
+                <p:txBody>
+                  <a:bodyPr vert="horz" wrap="square" lIns="91440" tIns="45720" rIns="91440" bIns="45720" numCol="1" rtlCol="0" anchor="t" anchorCtr="0" compatLnSpc="1">
+                    <a:prstTxWarp prst="textNoShape">
+                      <a:avLst/>
+                    </a:prstTxWarp>
+                  </a:bodyPr>
+                  <a:lstStyle/>
+                  <a:p>
+                    <a:pPr marL="0" marR="0" indent="0" algn="l" defTabSz="4389438" rtl="0" eaLnBrk="1" fontAlgn="base" latinLnBrk="0" hangingPunct="1">
+                      <a:lnSpc>
+                        <a:spcPct val="100000"/>
+                      </a:lnSpc>
+                      <a:spcBef>
+                        <a:spcPct val="0"/>
+                      </a:spcBef>
+                      <a:spcAft>
+                        <a:spcPct val="0"/>
+                      </a:spcAft>
+                      <a:buClrTx/>
+                      <a:buSzTx/>
+                      <a:buFontTx/>
+                      <a:buNone/>
+                      <a:tabLst/>
+                    </a:pPr>
+                    <a:endParaRPr kumimoji="0" lang="en-US" sz="1800" b="0" i="0" u="none" strike="noStrike" cap="none" normalizeH="0" baseline="0">
+                      <a:ln>
+                        <a:noFill/>
+                      </a:ln>
+                      <a:solidFill>
+                        <a:schemeClr val="tx1"/>
+                      </a:solidFill>
+                      <a:effectLst/>
+                      <a:latin typeface="Arial" charset="0"/>
+                      <a:cs typeface="Arial" charset="0"/>
+                    </a:endParaRPr>
+                  </a:p>
+                </p:txBody>
+              </p:sp>
+              <p:grpSp>
+                <p:nvGrpSpPr>
+                  <p:cNvPr id="53" name="Group 52">
+                    <a:extLst>
+                      <a:ext uri="{FF2B5EF4-FFF2-40B4-BE49-F238E27FC236}">
+                        <a16:creationId xmlns:a16="http://schemas.microsoft.com/office/drawing/2014/main" id="{E70E275C-F7FC-6193-D2BC-A588C1C4AA37}"/>
+                      </a:ext>
+                    </a:extLst>
+                  </p:cNvPr>
+                  <p:cNvGrpSpPr/>
+                  <p:nvPr/>
+                </p:nvGrpSpPr>
+                <p:grpSpPr>
+                  <a:xfrm>
+                    <a:off x="35522114" y="10130725"/>
+                    <a:ext cx="351296" cy="423621"/>
+                    <a:chOff x="35522114" y="10130725"/>
+                    <a:chExt cx="351296" cy="423621"/>
+                  </a:xfrm>
+                </p:grpSpPr>
+                <p:cxnSp>
+                  <p:nvCxnSpPr>
+                    <p:cNvPr id="63" name="Straight Connector 62">
+                      <a:extLst>
+                        <a:ext uri="{FF2B5EF4-FFF2-40B4-BE49-F238E27FC236}">
+                          <a16:creationId xmlns:a16="http://schemas.microsoft.com/office/drawing/2014/main" id="{9CF5B435-CE5C-BA28-F65C-12061DC5B489}"/>
+                        </a:ext>
+                      </a:extLst>
+                    </p:cNvPr>
+                    <p:cNvCxnSpPr>
+                      <a:cxnSpLocks/>
+                    </p:cNvCxnSpPr>
+                    <p:nvPr/>
+                  </p:nvCxnSpPr>
+                  <p:spPr bwMode="auto">
+                    <a:xfrm>
+                      <a:off x="35697998" y="10130725"/>
+                      <a:ext cx="0" cy="423621"/>
+                    </a:xfrm>
+                    <a:prstGeom prst="line">
+                      <a:avLst/>
+                    </a:prstGeom>
+                    <a:solidFill>
+                      <a:schemeClr val="accent1"/>
+                    </a:solidFill>
+                    <a:ln w="19050" cap="flat" cmpd="sng" algn="ctr">
+                      <a:solidFill>
+                        <a:schemeClr val="tx1"/>
+                      </a:solidFill>
+                      <a:prstDash val="solid"/>
+                      <a:round/>
+                      <a:headEnd type="none" w="med" len="med"/>
+                      <a:tailEnd type="none" w="med" len="med"/>
+                    </a:ln>
+                    <a:effectLst/>
+                  </p:spPr>
+                </p:cxnSp>
+                <p:cxnSp>
+                  <p:nvCxnSpPr>
+                    <p:cNvPr id="15681" name="Straight Connector 15680">
+                      <a:extLst>
+                        <a:ext uri="{FF2B5EF4-FFF2-40B4-BE49-F238E27FC236}">
+                          <a16:creationId xmlns:a16="http://schemas.microsoft.com/office/drawing/2014/main" id="{BEA6FFBB-9D35-354B-3AC6-E8A8F85B63E1}"/>
+                        </a:ext>
+                      </a:extLst>
+                    </p:cNvPr>
+                    <p:cNvCxnSpPr/>
+                    <p:nvPr/>
+                  </p:nvCxnSpPr>
+                  <p:spPr bwMode="auto">
+                    <a:xfrm>
+                      <a:off x="35522115" y="10130725"/>
+                      <a:ext cx="351295" cy="0"/>
+                    </a:xfrm>
+                    <a:prstGeom prst="line">
+                      <a:avLst/>
+                    </a:prstGeom>
+                    <a:solidFill>
+                      <a:schemeClr val="accent1"/>
+                    </a:solidFill>
+                    <a:ln w="19050" cap="flat" cmpd="sng" algn="ctr">
+                      <a:solidFill>
+                        <a:schemeClr val="tx1"/>
+                      </a:solidFill>
+                      <a:prstDash val="solid"/>
+                      <a:round/>
+                      <a:headEnd type="none" w="med" len="med"/>
+                      <a:tailEnd type="none" w="med" len="med"/>
+                    </a:ln>
+                    <a:effectLst/>
+                  </p:spPr>
+                </p:cxnSp>
+                <p:cxnSp>
+                  <p:nvCxnSpPr>
+                    <p:cNvPr id="15682" name="Straight Connector 15681">
+                      <a:extLst>
+                        <a:ext uri="{FF2B5EF4-FFF2-40B4-BE49-F238E27FC236}">
+                          <a16:creationId xmlns:a16="http://schemas.microsoft.com/office/drawing/2014/main" id="{5C2B39A8-E98F-C573-D650-2D9B21FAC8D9}"/>
+                        </a:ext>
+                      </a:extLst>
+                    </p:cNvPr>
+                    <p:cNvCxnSpPr/>
+                    <p:nvPr/>
+                  </p:nvCxnSpPr>
+                  <p:spPr bwMode="auto">
+                    <a:xfrm>
+                      <a:off x="35522114" y="10554346"/>
+                      <a:ext cx="351295" cy="0"/>
+                    </a:xfrm>
+                    <a:prstGeom prst="line">
+                      <a:avLst/>
+                    </a:prstGeom>
+                    <a:solidFill>
+                      <a:schemeClr val="accent1"/>
+                    </a:solidFill>
+                    <a:ln w="19050" cap="flat" cmpd="sng" algn="ctr">
+                      <a:solidFill>
+                        <a:schemeClr val="tx1"/>
+                      </a:solidFill>
+                      <a:prstDash val="solid"/>
+                      <a:round/>
+                      <a:headEnd type="none" w="med" len="med"/>
+                      <a:tailEnd type="none" w="med" len="med"/>
+                    </a:ln>
+                    <a:effectLst/>
+                  </p:spPr>
+                </p:cxnSp>
+              </p:grpSp>
+              <p:grpSp>
+                <p:nvGrpSpPr>
+                  <p:cNvPr id="54" name="Group 53">
+                    <a:extLst>
+                      <a:ext uri="{FF2B5EF4-FFF2-40B4-BE49-F238E27FC236}">
+                        <a16:creationId xmlns:a16="http://schemas.microsoft.com/office/drawing/2014/main" id="{968BAFCC-52D9-BFB9-CC07-A3696B041520}"/>
+                      </a:ext>
+                    </a:extLst>
+                  </p:cNvPr>
+                  <p:cNvGrpSpPr/>
+                  <p:nvPr/>
+                </p:nvGrpSpPr>
+                <p:grpSpPr>
+                  <a:xfrm>
+                    <a:off x="37367399" y="13504189"/>
+                    <a:ext cx="351296" cy="423621"/>
+                    <a:chOff x="35522114" y="10130725"/>
+                    <a:chExt cx="351296" cy="423621"/>
+                  </a:xfrm>
+                </p:grpSpPr>
+                <p:cxnSp>
+                  <p:nvCxnSpPr>
+                    <p:cNvPr id="60" name="Straight Connector 59">
+                      <a:extLst>
+                        <a:ext uri="{FF2B5EF4-FFF2-40B4-BE49-F238E27FC236}">
+                          <a16:creationId xmlns:a16="http://schemas.microsoft.com/office/drawing/2014/main" id="{749B3F97-30F0-6794-696B-E661B4B3BA94}"/>
+                        </a:ext>
+                      </a:extLst>
+                    </p:cNvPr>
+                    <p:cNvCxnSpPr>
+                      <a:cxnSpLocks/>
+                    </p:cNvCxnSpPr>
+                    <p:nvPr/>
+                  </p:nvCxnSpPr>
+                  <p:spPr bwMode="auto">
+                    <a:xfrm>
+                      <a:off x="35697998" y="10130725"/>
+                      <a:ext cx="0" cy="423621"/>
+                    </a:xfrm>
+                    <a:prstGeom prst="line">
+                      <a:avLst/>
+                    </a:prstGeom>
+                    <a:solidFill>
+                      <a:schemeClr val="accent1"/>
+                    </a:solidFill>
+                    <a:ln w="19050" cap="flat" cmpd="sng" algn="ctr">
+                      <a:solidFill>
+                        <a:schemeClr val="tx1"/>
+                      </a:solidFill>
+                      <a:prstDash val="solid"/>
+                      <a:round/>
+                      <a:headEnd type="none" w="med" len="med"/>
+                      <a:tailEnd type="none" w="med" len="med"/>
+                    </a:ln>
+                    <a:effectLst/>
+                  </p:spPr>
+                </p:cxnSp>
+                <p:cxnSp>
+                  <p:nvCxnSpPr>
+                    <p:cNvPr id="61" name="Straight Connector 60">
+                      <a:extLst>
+                        <a:ext uri="{FF2B5EF4-FFF2-40B4-BE49-F238E27FC236}">
+                          <a16:creationId xmlns:a16="http://schemas.microsoft.com/office/drawing/2014/main" id="{0340D7E1-5C88-15E7-0532-E190399621A6}"/>
+                        </a:ext>
+                      </a:extLst>
+                    </p:cNvPr>
+                    <p:cNvCxnSpPr/>
+                    <p:nvPr/>
+                  </p:nvCxnSpPr>
+                  <p:spPr bwMode="auto">
+                    <a:xfrm>
+                      <a:off x="35522115" y="10130725"/>
+                      <a:ext cx="351295" cy="0"/>
+                    </a:xfrm>
+                    <a:prstGeom prst="line">
+                      <a:avLst/>
+                    </a:prstGeom>
+                    <a:solidFill>
+                      <a:schemeClr val="accent1"/>
+                    </a:solidFill>
+                    <a:ln w="19050" cap="flat" cmpd="sng" algn="ctr">
+                      <a:solidFill>
+                        <a:schemeClr val="tx1"/>
+                      </a:solidFill>
+                      <a:prstDash val="solid"/>
+                      <a:round/>
+                      <a:headEnd type="none" w="med" len="med"/>
+                      <a:tailEnd type="none" w="med" len="med"/>
+                    </a:ln>
+                    <a:effectLst/>
+                  </p:spPr>
+                </p:cxnSp>
+                <p:cxnSp>
+                  <p:nvCxnSpPr>
+                    <p:cNvPr id="62" name="Straight Connector 61">
+                      <a:extLst>
+                        <a:ext uri="{FF2B5EF4-FFF2-40B4-BE49-F238E27FC236}">
+                          <a16:creationId xmlns:a16="http://schemas.microsoft.com/office/drawing/2014/main" id="{7F959E90-D232-A788-EBD7-D8540E0E969F}"/>
+                        </a:ext>
+                      </a:extLst>
+                    </p:cNvPr>
+                    <p:cNvCxnSpPr/>
+                    <p:nvPr/>
+                  </p:nvCxnSpPr>
+                  <p:spPr bwMode="auto">
+                    <a:xfrm>
+                      <a:off x="35522114" y="10554346"/>
+                      <a:ext cx="351295" cy="0"/>
+                    </a:xfrm>
+                    <a:prstGeom prst="line">
+                      <a:avLst/>
+                    </a:prstGeom>
+                    <a:solidFill>
+                      <a:schemeClr val="accent1"/>
+                    </a:solidFill>
+                    <a:ln w="19050" cap="flat" cmpd="sng" algn="ctr">
+                      <a:solidFill>
+                        <a:schemeClr val="tx1"/>
+                      </a:solidFill>
+                      <a:prstDash val="solid"/>
+                      <a:round/>
+                      <a:headEnd type="none" w="med" len="med"/>
+                      <a:tailEnd type="none" w="med" len="med"/>
+                    </a:ln>
+                    <a:effectLst/>
+                  </p:spPr>
+                </p:cxnSp>
+              </p:grpSp>
+              <p:grpSp>
+                <p:nvGrpSpPr>
+                  <p:cNvPr id="55" name="Group 54">
+                    <a:extLst>
+                      <a:ext uri="{FF2B5EF4-FFF2-40B4-BE49-F238E27FC236}">
+                        <a16:creationId xmlns:a16="http://schemas.microsoft.com/office/drawing/2014/main" id="{083FCD46-2613-2829-B84B-4421FD99A2AF}"/>
+                      </a:ext>
+                    </a:extLst>
+                  </p:cNvPr>
+                  <p:cNvGrpSpPr/>
+                  <p:nvPr/>
+                </p:nvGrpSpPr>
+                <p:grpSpPr>
+                  <a:xfrm>
+                    <a:off x="39207283" y="13504188"/>
+                    <a:ext cx="351296" cy="423621"/>
+                    <a:chOff x="35522114" y="10130725"/>
+                    <a:chExt cx="351296" cy="423621"/>
+                  </a:xfrm>
+                </p:grpSpPr>
+                <p:cxnSp>
+                  <p:nvCxnSpPr>
+                    <p:cNvPr id="57" name="Straight Connector 56">
+                      <a:extLst>
+                        <a:ext uri="{FF2B5EF4-FFF2-40B4-BE49-F238E27FC236}">
+                          <a16:creationId xmlns:a16="http://schemas.microsoft.com/office/drawing/2014/main" id="{DA16309C-2410-022D-0276-EB3CFD6D5CA8}"/>
+                        </a:ext>
+                      </a:extLst>
+                    </p:cNvPr>
+                    <p:cNvCxnSpPr>
+                      <a:cxnSpLocks/>
+                    </p:cNvCxnSpPr>
+                    <p:nvPr/>
+                  </p:nvCxnSpPr>
+                  <p:spPr bwMode="auto">
+                    <a:xfrm>
+                      <a:off x="35697998" y="10130725"/>
+                      <a:ext cx="0" cy="423621"/>
+                    </a:xfrm>
+                    <a:prstGeom prst="line">
+                      <a:avLst/>
+                    </a:prstGeom>
+                    <a:solidFill>
+                      <a:schemeClr val="accent1"/>
+                    </a:solidFill>
+                    <a:ln w="19050" cap="flat" cmpd="sng" algn="ctr">
+                      <a:solidFill>
+                        <a:schemeClr val="tx1"/>
+                      </a:solidFill>
+                      <a:prstDash val="solid"/>
+                      <a:round/>
+                      <a:headEnd type="none" w="med" len="med"/>
+                      <a:tailEnd type="none" w="med" len="med"/>
+                    </a:ln>
+                    <a:effectLst/>
+                  </p:spPr>
+                </p:cxnSp>
+                <p:cxnSp>
+                  <p:nvCxnSpPr>
+                    <p:cNvPr id="58" name="Straight Connector 57">
+                      <a:extLst>
+                        <a:ext uri="{FF2B5EF4-FFF2-40B4-BE49-F238E27FC236}">
+                          <a16:creationId xmlns:a16="http://schemas.microsoft.com/office/drawing/2014/main" id="{5B96560F-9416-EAF2-0E4F-4E8C90F317E8}"/>
+                        </a:ext>
+                      </a:extLst>
+                    </p:cNvPr>
+                    <p:cNvCxnSpPr/>
+                    <p:nvPr/>
+                  </p:nvCxnSpPr>
+                  <p:spPr bwMode="auto">
+                    <a:xfrm>
+                      <a:off x="35522115" y="10130725"/>
+                      <a:ext cx="351295" cy="0"/>
+                    </a:xfrm>
+                    <a:prstGeom prst="line">
+                      <a:avLst/>
+                    </a:prstGeom>
+                    <a:solidFill>
+                      <a:schemeClr val="accent1"/>
+                    </a:solidFill>
+                    <a:ln w="19050" cap="flat" cmpd="sng" algn="ctr">
+                      <a:solidFill>
+                        <a:schemeClr val="tx1"/>
+                      </a:solidFill>
+                      <a:prstDash val="solid"/>
+                      <a:round/>
+                      <a:headEnd type="none" w="med" len="med"/>
+                      <a:tailEnd type="none" w="med" len="med"/>
+                    </a:ln>
+                    <a:effectLst/>
+                  </p:spPr>
+                </p:cxnSp>
+                <p:cxnSp>
+                  <p:nvCxnSpPr>
+                    <p:cNvPr id="59" name="Straight Connector 58">
+                      <a:extLst>
+                        <a:ext uri="{FF2B5EF4-FFF2-40B4-BE49-F238E27FC236}">
+                          <a16:creationId xmlns:a16="http://schemas.microsoft.com/office/drawing/2014/main" id="{8DBCB99F-AF0E-1B7D-06FC-2CE1F0FBD87F}"/>
+                        </a:ext>
+                      </a:extLst>
+                    </p:cNvPr>
+                    <p:cNvCxnSpPr/>
+                    <p:nvPr/>
+                  </p:nvCxnSpPr>
+                  <p:spPr bwMode="auto">
+                    <a:xfrm>
+                      <a:off x="35522114" y="10554346"/>
+                      <a:ext cx="351295" cy="0"/>
+                    </a:xfrm>
+                    <a:prstGeom prst="line">
+                      <a:avLst/>
+                    </a:prstGeom>
+                    <a:solidFill>
+                      <a:schemeClr val="accent1"/>
+                    </a:solidFill>
+                    <a:ln w="19050" cap="flat" cmpd="sng" algn="ctr">
+                      <a:solidFill>
+                        <a:schemeClr val="tx1"/>
+                      </a:solidFill>
+                      <a:prstDash val="solid"/>
+                      <a:round/>
+                      <a:headEnd type="none" w="med" len="med"/>
+                      <a:tailEnd type="none" w="med" len="med"/>
+                    </a:ln>
+                    <a:effectLst/>
+                  </p:spPr>
+                </p:cxnSp>
+              </p:grpSp>
+            </p:grpSp>
+          </p:grpSp>
+        </p:grpSp>
+      </p:grpSp>
+      <p:cxnSp>
+        <p:nvCxnSpPr>
+          <p:cNvPr id="15712" name="Straight Connector 15711">
+            <a:extLst>
+              <a:ext uri="{FF2B5EF4-FFF2-40B4-BE49-F238E27FC236}">
+                <a16:creationId xmlns:a16="http://schemas.microsoft.com/office/drawing/2014/main" id="{4BBAB568-052E-34B5-544B-C63905197C01}"/>
+              </a:ext>
+            </a:extLst>
+          </p:cNvPr>
+          <p:cNvCxnSpPr>
+            <a:cxnSpLocks/>
+          </p:cNvCxnSpPr>
+          <p:nvPr/>
+        </p:nvCxnSpPr>
+        <p:spPr bwMode="auto">
+          <a:xfrm>
+            <a:off x="16761179" y="11181224"/>
+            <a:ext cx="5755610" cy="0"/>
+          </a:xfrm>
+          <a:prstGeom prst="line">
+            <a:avLst/>
+          </a:prstGeom>
+          <a:solidFill>
+            <a:schemeClr val="accent1"/>
+          </a:solidFill>
+          <a:ln w="9525" cap="flat" cmpd="sng" algn="ctr">
+            <a:solidFill>
+              <a:schemeClr val="tx1"/>
+            </a:solidFill>
+            <a:prstDash val="solid"/>
+            <a:round/>
+            <a:headEnd type="none" w="med" len="med"/>
+            <a:tailEnd type="none" w="med" len="med"/>
+          </a:ln>
+          <a:effectLst/>
+        </p:spPr>
+      </p:cxnSp>
     </p:spTree>
     <p:extLst>
       <p:ext uri="{BB962C8B-B14F-4D97-AF65-F5344CB8AC3E}">
@@ -14854,6 +15906,995 @@
           </p:pic>
         </p:grpSp>
       </p:grpSp>
+      <p:grpSp>
+        <p:nvGrpSpPr>
+          <p:cNvPr id="68" name="Group 67">
+            <a:extLst>
+              <a:ext uri="{FF2B5EF4-FFF2-40B4-BE49-F238E27FC236}">
+                <a16:creationId xmlns:a16="http://schemas.microsoft.com/office/drawing/2014/main" id="{528FCC7C-6755-8F55-4C3F-4AD8749A8074}"/>
+              </a:ext>
+            </a:extLst>
+          </p:cNvPr>
+          <p:cNvGrpSpPr/>
+          <p:nvPr/>
+        </p:nvGrpSpPr>
+        <p:grpSpPr>
+          <a:xfrm>
+            <a:off x="15013924" y="12119306"/>
+            <a:ext cx="4594166" cy="5455639"/>
+            <a:chOff x="35245964" y="10130725"/>
+            <a:chExt cx="4594166" cy="5455639"/>
+          </a:xfrm>
+        </p:grpSpPr>
+        <p:sp>
+          <p:nvSpPr>
+            <p:cNvPr id="6" name="Rectangle 5">
+              <a:extLst>
+                <a:ext uri="{FF2B5EF4-FFF2-40B4-BE49-F238E27FC236}">
+                  <a16:creationId xmlns:a16="http://schemas.microsoft.com/office/drawing/2014/main" id="{CECEAC77-0B26-1854-0835-68A245732429}"/>
+                </a:ext>
+              </a:extLst>
+            </p:cNvPr>
+            <p:cNvSpPr/>
+            <p:nvPr/>
+          </p:nvSpPr>
+          <p:spPr bwMode="auto">
+            <a:xfrm>
+              <a:off x="35245964" y="10341033"/>
+              <a:ext cx="914400" cy="5245331"/>
+            </a:xfrm>
+            <a:prstGeom prst="rect">
+              <a:avLst/>
+            </a:prstGeom>
+            <a:solidFill>
+              <a:srgbClr val="3C8C94"/>
+            </a:solidFill>
+            <a:ln w="9525" cap="flat" cmpd="sng" algn="ctr">
+              <a:noFill/>
+              <a:prstDash val="solid"/>
+              <a:round/>
+              <a:headEnd type="none" w="med" len="med"/>
+              <a:tailEnd type="none" w="med" len="med"/>
+            </a:ln>
+            <a:effectLst/>
+          </p:spPr>
+          <p:txBody>
+            <a:bodyPr vert="horz" wrap="square" lIns="91440" tIns="45720" rIns="91440" bIns="45720" numCol="1" rtlCol="0" anchor="t" anchorCtr="0" compatLnSpc="1">
+              <a:prstTxWarp prst="textNoShape">
+                <a:avLst/>
+              </a:prstTxWarp>
+            </a:bodyPr>
+            <a:lstStyle/>
+            <a:p>
+              <a:pPr marL="0" marR="0" indent="0" algn="l" defTabSz="4389438" rtl="0" eaLnBrk="1" fontAlgn="base" latinLnBrk="0" hangingPunct="1">
+                <a:lnSpc>
+                  <a:spcPct val="100000"/>
+                </a:lnSpc>
+                <a:spcBef>
+                  <a:spcPct val="0"/>
+                </a:spcBef>
+                <a:spcAft>
+                  <a:spcPct val="0"/>
+                </a:spcAft>
+                <a:buClrTx/>
+                <a:buSzTx/>
+                <a:buFontTx/>
+                <a:buNone/>
+                <a:tabLst/>
+              </a:pPr>
+              <a:endParaRPr kumimoji="0" lang="en-US" sz="1800" b="0" i="0" u="none" strike="noStrike" cap="none" normalizeH="0" baseline="0">
+                <a:ln>
+                  <a:noFill/>
+                </a:ln>
+                <a:solidFill>
+                  <a:schemeClr val="tx1"/>
+                </a:solidFill>
+                <a:effectLst/>
+                <a:latin typeface="Arial" charset="0"/>
+                <a:cs typeface="Arial" charset="0"/>
+              </a:endParaRPr>
+            </a:p>
+          </p:txBody>
+        </p:sp>
+        <p:sp>
+          <p:nvSpPr>
+            <p:cNvPr id="8" name="Rectangle 7">
+              <a:extLst>
+                <a:ext uri="{FF2B5EF4-FFF2-40B4-BE49-F238E27FC236}">
+                  <a16:creationId xmlns:a16="http://schemas.microsoft.com/office/drawing/2014/main" id="{1B2453FC-0F32-F09C-D33F-9CF35C97F575}"/>
+                </a:ext>
+              </a:extLst>
+            </p:cNvPr>
+            <p:cNvSpPr/>
+            <p:nvPr/>
+          </p:nvSpPr>
+          <p:spPr bwMode="auto">
+            <a:xfrm>
+              <a:off x="37085847" y="13716000"/>
+              <a:ext cx="914400" cy="1859437"/>
+            </a:xfrm>
+            <a:prstGeom prst="rect">
+              <a:avLst/>
+            </a:prstGeom>
+            <a:solidFill>
+              <a:srgbClr val="72BFC6"/>
+            </a:solidFill>
+            <a:ln w="9525" cap="flat" cmpd="sng" algn="ctr">
+              <a:noFill/>
+              <a:prstDash val="solid"/>
+              <a:round/>
+              <a:headEnd type="none" w="med" len="med"/>
+              <a:tailEnd type="none" w="med" len="med"/>
+            </a:ln>
+            <a:effectLst/>
+          </p:spPr>
+          <p:txBody>
+            <a:bodyPr vert="horz" wrap="square" lIns="91440" tIns="45720" rIns="91440" bIns="45720" numCol="1" rtlCol="0" anchor="t" anchorCtr="0" compatLnSpc="1">
+              <a:prstTxWarp prst="textNoShape">
+                <a:avLst/>
+              </a:prstTxWarp>
+            </a:bodyPr>
+            <a:lstStyle/>
+            <a:p>
+              <a:pPr marL="0" marR="0" indent="0" algn="l" defTabSz="4389438" rtl="0" eaLnBrk="1" fontAlgn="base" latinLnBrk="0" hangingPunct="1">
+                <a:lnSpc>
+                  <a:spcPct val="100000"/>
+                </a:lnSpc>
+                <a:spcBef>
+                  <a:spcPct val="0"/>
+                </a:spcBef>
+                <a:spcAft>
+                  <a:spcPct val="0"/>
+                </a:spcAft>
+                <a:buClrTx/>
+                <a:buSzTx/>
+                <a:buFontTx/>
+                <a:buNone/>
+                <a:tabLst/>
+              </a:pPr>
+              <a:endParaRPr kumimoji="0" lang="en-US" sz="1800" b="0" i="0" u="none" strike="noStrike" cap="none" normalizeH="0" baseline="0">
+                <a:ln>
+                  <a:noFill/>
+                </a:ln>
+                <a:solidFill>
+                  <a:schemeClr val="tx1"/>
+                </a:solidFill>
+                <a:effectLst/>
+                <a:latin typeface="Arial" charset="0"/>
+                <a:cs typeface="Arial" charset="0"/>
+              </a:endParaRPr>
+            </a:p>
+          </p:txBody>
+        </p:sp>
+        <p:sp>
+          <p:nvSpPr>
+            <p:cNvPr id="10" name="Rectangle 9">
+              <a:extLst>
+                <a:ext uri="{FF2B5EF4-FFF2-40B4-BE49-F238E27FC236}">
+                  <a16:creationId xmlns:a16="http://schemas.microsoft.com/office/drawing/2014/main" id="{AB05EE92-0D6D-24D5-3C18-F4E42B7DF8FA}"/>
+                </a:ext>
+              </a:extLst>
+            </p:cNvPr>
+            <p:cNvSpPr/>
+            <p:nvPr/>
+          </p:nvSpPr>
+          <p:spPr bwMode="auto">
+            <a:xfrm>
+              <a:off x="38925730" y="13716000"/>
+              <a:ext cx="914400" cy="1859437"/>
+            </a:xfrm>
+            <a:prstGeom prst="rect">
+              <a:avLst/>
+            </a:prstGeom>
+            <a:solidFill>
+              <a:schemeClr val="accent1"/>
+            </a:solidFill>
+            <a:ln w="9525" cap="flat" cmpd="sng" algn="ctr">
+              <a:noFill/>
+              <a:prstDash val="solid"/>
+              <a:round/>
+              <a:headEnd type="none" w="med" len="med"/>
+              <a:tailEnd type="none" w="med" len="med"/>
+            </a:ln>
+            <a:effectLst/>
+          </p:spPr>
+          <p:txBody>
+            <a:bodyPr vert="horz" wrap="square" lIns="91440" tIns="45720" rIns="91440" bIns="45720" numCol="1" rtlCol="0" anchor="t" anchorCtr="0" compatLnSpc="1">
+              <a:prstTxWarp prst="textNoShape">
+                <a:avLst/>
+              </a:prstTxWarp>
+            </a:bodyPr>
+            <a:lstStyle/>
+            <a:p>
+              <a:pPr marL="0" marR="0" indent="0" algn="l" defTabSz="4389438" rtl="0" eaLnBrk="1" fontAlgn="base" latinLnBrk="0" hangingPunct="1">
+                <a:lnSpc>
+                  <a:spcPct val="100000"/>
+                </a:lnSpc>
+                <a:spcBef>
+                  <a:spcPct val="0"/>
+                </a:spcBef>
+                <a:spcAft>
+                  <a:spcPct val="0"/>
+                </a:spcAft>
+                <a:buClrTx/>
+                <a:buSzTx/>
+                <a:buFontTx/>
+                <a:buNone/>
+                <a:tabLst/>
+              </a:pPr>
+              <a:endParaRPr kumimoji="0" lang="en-US" sz="1800" b="0" i="0" u="none" strike="noStrike" cap="none" normalizeH="0" baseline="0">
+                <a:ln>
+                  <a:noFill/>
+                </a:ln>
+                <a:solidFill>
+                  <a:schemeClr val="tx1"/>
+                </a:solidFill>
+                <a:effectLst/>
+                <a:latin typeface="Arial" charset="0"/>
+                <a:cs typeface="Arial" charset="0"/>
+              </a:endParaRPr>
+            </a:p>
+          </p:txBody>
+        </p:sp>
+        <p:grpSp>
+          <p:nvGrpSpPr>
+            <p:cNvPr id="59" name="Group 58">
+              <a:extLst>
+                <a:ext uri="{FF2B5EF4-FFF2-40B4-BE49-F238E27FC236}">
+                  <a16:creationId xmlns:a16="http://schemas.microsoft.com/office/drawing/2014/main" id="{12C94823-F8B7-BD70-9443-6E0864B4040E}"/>
+                </a:ext>
+              </a:extLst>
+            </p:cNvPr>
+            <p:cNvGrpSpPr/>
+            <p:nvPr/>
+          </p:nvGrpSpPr>
+          <p:grpSpPr>
+            <a:xfrm>
+              <a:off x="35522114" y="10130725"/>
+              <a:ext cx="351296" cy="423621"/>
+              <a:chOff x="35522114" y="10130725"/>
+              <a:chExt cx="351296" cy="423621"/>
+            </a:xfrm>
+          </p:grpSpPr>
+          <p:cxnSp>
+            <p:nvCxnSpPr>
+              <p:cNvPr id="16" name="Straight Connector 15">
+                <a:extLst>
+                  <a:ext uri="{FF2B5EF4-FFF2-40B4-BE49-F238E27FC236}">
+                    <a16:creationId xmlns:a16="http://schemas.microsoft.com/office/drawing/2014/main" id="{1D09282A-B515-4EE1-BDDF-AE42CA67AFBB}"/>
+                  </a:ext>
+                </a:extLst>
+              </p:cNvPr>
+              <p:cNvCxnSpPr>
+                <a:cxnSpLocks/>
+              </p:cNvCxnSpPr>
+              <p:nvPr/>
+            </p:nvCxnSpPr>
+            <p:spPr bwMode="auto">
+              <a:xfrm>
+                <a:off x="35697998" y="10130725"/>
+                <a:ext cx="0" cy="423621"/>
+              </a:xfrm>
+              <a:prstGeom prst="line">
+                <a:avLst/>
+              </a:prstGeom>
+              <a:solidFill>
+                <a:schemeClr val="accent1"/>
+              </a:solidFill>
+              <a:ln w="19050" cap="flat" cmpd="sng" algn="ctr">
+                <a:solidFill>
+                  <a:schemeClr val="tx1"/>
+                </a:solidFill>
+                <a:prstDash val="solid"/>
+                <a:round/>
+                <a:headEnd type="none" w="med" len="med"/>
+                <a:tailEnd type="none" w="med" len="med"/>
+              </a:ln>
+              <a:effectLst/>
+            </p:spPr>
+          </p:cxnSp>
+          <p:cxnSp>
+            <p:nvCxnSpPr>
+              <p:cNvPr id="57" name="Straight Connector 56">
+                <a:extLst>
+                  <a:ext uri="{FF2B5EF4-FFF2-40B4-BE49-F238E27FC236}">
+                    <a16:creationId xmlns:a16="http://schemas.microsoft.com/office/drawing/2014/main" id="{A156E826-50BD-B379-62AE-36A813651248}"/>
+                  </a:ext>
+                </a:extLst>
+              </p:cNvPr>
+              <p:cNvCxnSpPr/>
+              <p:nvPr/>
+            </p:nvCxnSpPr>
+            <p:spPr bwMode="auto">
+              <a:xfrm>
+                <a:off x="35522115" y="10130725"/>
+                <a:ext cx="351295" cy="0"/>
+              </a:xfrm>
+              <a:prstGeom prst="line">
+                <a:avLst/>
+              </a:prstGeom>
+              <a:solidFill>
+                <a:schemeClr val="accent1"/>
+              </a:solidFill>
+              <a:ln w="19050" cap="flat" cmpd="sng" algn="ctr">
+                <a:solidFill>
+                  <a:schemeClr val="tx1"/>
+                </a:solidFill>
+                <a:prstDash val="solid"/>
+                <a:round/>
+                <a:headEnd type="none" w="med" len="med"/>
+                <a:tailEnd type="none" w="med" len="med"/>
+              </a:ln>
+              <a:effectLst/>
+            </p:spPr>
+          </p:cxnSp>
+          <p:cxnSp>
+            <p:nvCxnSpPr>
+              <p:cNvPr id="58" name="Straight Connector 57">
+                <a:extLst>
+                  <a:ext uri="{FF2B5EF4-FFF2-40B4-BE49-F238E27FC236}">
+                    <a16:creationId xmlns:a16="http://schemas.microsoft.com/office/drawing/2014/main" id="{8B32D49D-083F-EDC8-35E2-12D77B21AD8D}"/>
+                  </a:ext>
+                </a:extLst>
+              </p:cNvPr>
+              <p:cNvCxnSpPr/>
+              <p:nvPr/>
+            </p:nvCxnSpPr>
+            <p:spPr bwMode="auto">
+              <a:xfrm>
+                <a:off x="35522114" y="10554346"/>
+                <a:ext cx="351295" cy="0"/>
+              </a:xfrm>
+              <a:prstGeom prst="line">
+                <a:avLst/>
+              </a:prstGeom>
+              <a:solidFill>
+                <a:schemeClr val="accent1"/>
+              </a:solidFill>
+              <a:ln w="19050" cap="flat" cmpd="sng" algn="ctr">
+                <a:solidFill>
+                  <a:schemeClr val="tx1"/>
+                </a:solidFill>
+                <a:prstDash val="solid"/>
+                <a:round/>
+                <a:headEnd type="none" w="med" len="med"/>
+                <a:tailEnd type="none" w="med" len="med"/>
+              </a:ln>
+              <a:effectLst/>
+            </p:spPr>
+          </p:cxnSp>
+        </p:grpSp>
+        <p:grpSp>
+          <p:nvGrpSpPr>
+            <p:cNvPr id="60" name="Group 59">
+              <a:extLst>
+                <a:ext uri="{FF2B5EF4-FFF2-40B4-BE49-F238E27FC236}">
+                  <a16:creationId xmlns:a16="http://schemas.microsoft.com/office/drawing/2014/main" id="{2545418C-55A1-D407-C68A-8D6C8579D69B}"/>
+                </a:ext>
+              </a:extLst>
+            </p:cNvPr>
+            <p:cNvGrpSpPr/>
+            <p:nvPr/>
+          </p:nvGrpSpPr>
+          <p:grpSpPr>
+            <a:xfrm>
+              <a:off x="37367399" y="13504189"/>
+              <a:ext cx="351296" cy="423621"/>
+              <a:chOff x="35522114" y="10130725"/>
+              <a:chExt cx="351296" cy="423621"/>
+            </a:xfrm>
+          </p:grpSpPr>
+          <p:cxnSp>
+            <p:nvCxnSpPr>
+              <p:cNvPr id="61" name="Straight Connector 60">
+                <a:extLst>
+                  <a:ext uri="{FF2B5EF4-FFF2-40B4-BE49-F238E27FC236}">
+                    <a16:creationId xmlns:a16="http://schemas.microsoft.com/office/drawing/2014/main" id="{5372E455-C99E-6522-5C21-053FE29FB28E}"/>
+                  </a:ext>
+                </a:extLst>
+              </p:cNvPr>
+              <p:cNvCxnSpPr>
+                <a:cxnSpLocks/>
+              </p:cNvCxnSpPr>
+              <p:nvPr/>
+            </p:nvCxnSpPr>
+            <p:spPr bwMode="auto">
+              <a:xfrm>
+                <a:off x="35697998" y="10130725"/>
+                <a:ext cx="0" cy="423621"/>
+              </a:xfrm>
+              <a:prstGeom prst="line">
+                <a:avLst/>
+              </a:prstGeom>
+              <a:solidFill>
+                <a:schemeClr val="accent1"/>
+              </a:solidFill>
+              <a:ln w="19050" cap="flat" cmpd="sng" algn="ctr">
+                <a:solidFill>
+                  <a:schemeClr val="tx1"/>
+                </a:solidFill>
+                <a:prstDash val="solid"/>
+                <a:round/>
+                <a:headEnd type="none" w="med" len="med"/>
+                <a:tailEnd type="none" w="med" len="med"/>
+              </a:ln>
+              <a:effectLst/>
+            </p:spPr>
+          </p:cxnSp>
+          <p:cxnSp>
+            <p:nvCxnSpPr>
+              <p:cNvPr id="62" name="Straight Connector 61">
+                <a:extLst>
+                  <a:ext uri="{FF2B5EF4-FFF2-40B4-BE49-F238E27FC236}">
+                    <a16:creationId xmlns:a16="http://schemas.microsoft.com/office/drawing/2014/main" id="{8BFC4EBF-0978-F826-349C-0E7972C254F4}"/>
+                  </a:ext>
+                </a:extLst>
+              </p:cNvPr>
+              <p:cNvCxnSpPr/>
+              <p:nvPr/>
+            </p:nvCxnSpPr>
+            <p:spPr bwMode="auto">
+              <a:xfrm>
+                <a:off x="35522115" y="10130725"/>
+                <a:ext cx="351295" cy="0"/>
+              </a:xfrm>
+              <a:prstGeom prst="line">
+                <a:avLst/>
+              </a:prstGeom>
+              <a:solidFill>
+                <a:schemeClr val="accent1"/>
+              </a:solidFill>
+              <a:ln w="19050" cap="flat" cmpd="sng" algn="ctr">
+                <a:solidFill>
+                  <a:schemeClr val="tx1"/>
+                </a:solidFill>
+                <a:prstDash val="solid"/>
+                <a:round/>
+                <a:headEnd type="none" w="med" len="med"/>
+                <a:tailEnd type="none" w="med" len="med"/>
+              </a:ln>
+              <a:effectLst/>
+            </p:spPr>
+          </p:cxnSp>
+          <p:cxnSp>
+            <p:nvCxnSpPr>
+              <p:cNvPr id="63" name="Straight Connector 62">
+                <a:extLst>
+                  <a:ext uri="{FF2B5EF4-FFF2-40B4-BE49-F238E27FC236}">
+                    <a16:creationId xmlns:a16="http://schemas.microsoft.com/office/drawing/2014/main" id="{5C748ACA-A449-130C-EC6B-9C598C3F9F8F}"/>
+                  </a:ext>
+                </a:extLst>
+              </p:cNvPr>
+              <p:cNvCxnSpPr/>
+              <p:nvPr/>
+            </p:nvCxnSpPr>
+            <p:spPr bwMode="auto">
+              <a:xfrm>
+                <a:off x="35522114" y="10554346"/>
+                <a:ext cx="351295" cy="0"/>
+              </a:xfrm>
+              <a:prstGeom prst="line">
+                <a:avLst/>
+              </a:prstGeom>
+              <a:solidFill>
+                <a:schemeClr val="accent1"/>
+              </a:solidFill>
+              <a:ln w="19050" cap="flat" cmpd="sng" algn="ctr">
+                <a:solidFill>
+                  <a:schemeClr val="tx1"/>
+                </a:solidFill>
+                <a:prstDash val="solid"/>
+                <a:round/>
+                <a:headEnd type="none" w="med" len="med"/>
+                <a:tailEnd type="none" w="med" len="med"/>
+              </a:ln>
+              <a:effectLst/>
+            </p:spPr>
+          </p:cxnSp>
+        </p:grpSp>
+        <p:grpSp>
+          <p:nvGrpSpPr>
+            <p:cNvPr id="64" name="Group 63">
+              <a:extLst>
+                <a:ext uri="{FF2B5EF4-FFF2-40B4-BE49-F238E27FC236}">
+                  <a16:creationId xmlns:a16="http://schemas.microsoft.com/office/drawing/2014/main" id="{ABD76B3B-0A73-E05E-DB39-CCFE628F01BD}"/>
+                </a:ext>
+              </a:extLst>
+            </p:cNvPr>
+            <p:cNvGrpSpPr/>
+            <p:nvPr/>
+          </p:nvGrpSpPr>
+          <p:grpSpPr>
+            <a:xfrm>
+              <a:off x="39207283" y="13504188"/>
+              <a:ext cx="351296" cy="423621"/>
+              <a:chOff x="35522114" y="10130725"/>
+              <a:chExt cx="351296" cy="423621"/>
+            </a:xfrm>
+          </p:grpSpPr>
+          <p:cxnSp>
+            <p:nvCxnSpPr>
+              <p:cNvPr id="65" name="Straight Connector 64">
+                <a:extLst>
+                  <a:ext uri="{FF2B5EF4-FFF2-40B4-BE49-F238E27FC236}">
+                    <a16:creationId xmlns:a16="http://schemas.microsoft.com/office/drawing/2014/main" id="{076CF0D3-AD0A-1AFF-143B-19B5E2288867}"/>
+                  </a:ext>
+                </a:extLst>
+              </p:cNvPr>
+              <p:cNvCxnSpPr>
+                <a:cxnSpLocks/>
+              </p:cNvCxnSpPr>
+              <p:nvPr/>
+            </p:nvCxnSpPr>
+            <p:spPr bwMode="auto">
+              <a:xfrm>
+                <a:off x="35697998" y="10130725"/>
+                <a:ext cx="0" cy="423621"/>
+              </a:xfrm>
+              <a:prstGeom prst="line">
+                <a:avLst/>
+              </a:prstGeom>
+              <a:solidFill>
+                <a:schemeClr val="accent1"/>
+              </a:solidFill>
+              <a:ln w="19050" cap="flat" cmpd="sng" algn="ctr">
+                <a:solidFill>
+                  <a:schemeClr val="tx1"/>
+                </a:solidFill>
+                <a:prstDash val="solid"/>
+                <a:round/>
+                <a:headEnd type="none" w="med" len="med"/>
+                <a:tailEnd type="none" w="med" len="med"/>
+              </a:ln>
+              <a:effectLst/>
+            </p:spPr>
+          </p:cxnSp>
+          <p:cxnSp>
+            <p:nvCxnSpPr>
+              <p:cNvPr id="66" name="Straight Connector 65">
+                <a:extLst>
+                  <a:ext uri="{FF2B5EF4-FFF2-40B4-BE49-F238E27FC236}">
+                    <a16:creationId xmlns:a16="http://schemas.microsoft.com/office/drawing/2014/main" id="{786827D3-1F61-686E-46B2-665C8E4C9D54}"/>
+                  </a:ext>
+                </a:extLst>
+              </p:cNvPr>
+              <p:cNvCxnSpPr/>
+              <p:nvPr/>
+            </p:nvCxnSpPr>
+            <p:spPr bwMode="auto">
+              <a:xfrm>
+                <a:off x="35522115" y="10130725"/>
+                <a:ext cx="351295" cy="0"/>
+              </a:xfrm>
+              <a:prstGeom prst="line">
+                <a:avLst/>
+              </a:prstGeom>
+              <a:solidFill>
+                <a:schemeClr val="accent1"/>
+              </a:solidFill>
+              <a:ln w="19050" cap="flat" cmpd="sng" algn="ctr">
+                <a:solidFill>
+                  <a:schemeClr val="tx1"/>
+                </a:solidFill>
+                <a:prstDash val="solid"/>
+                <a:round/>
+                <a:headEnd type="none" w="med" len="med"/>
+                <a:tailEnd type="none" w="med" len="med"/>
+              </a:ln>
+              <a:effectLst/>
+            </p:spPr>
+          </p:cxnSp>
+          <p:cxnSp>
+            <p:nvCxnSpPr>
+              <p:cNvPr id="67" name="Straight Connector 66">
+                <a:extLst>
+                  <a:ext uri="{FF2B5EF4-FFF2-40B4-BE49-F238E27FC236}">
+                    <a16:creationId xmlns:a16="http://schemas.microsoft.com/office/drawing/2014/main" id="{6D572BB6-024D-AAAB-4885-44452A80C9F5}"/>
+                  </a:ext>
+                </a:extLst>
+              </p:cNvPr>
+              <p:cNvCxnSpPr/>
+              <p:nvPr/>
+            </p:nvCxnSpPr>
+            <p:spPr bwMode="auto">
+              <a:xfrm>
+                <a:off x="35522114" y="10554346"/>
+                <a:ext cx="351295" cy="0"/>
+              </a:xfrm>
+              <a:prstGeom prst="line">
+                <a:avLst/>
+              </a:prstGeom>
+              <a:solidFill>
+                <a:schemeClr val="accent1"/>
+              </a:solidFill>
+              <a:ln w="19050" cap="flat" cmpd="sng" algn="ctr">
+                <a:solidFill>
+                  <a:schemeClr val="tx1"/>
+                </a:solidFill>
+                <a:prstDash val="solid"/>
+                <a:round/>
+                <a:headEnd type="none" w="med" len="med"/>
+                <a:tailEnd type="none" w="med" len="med"/>
+              </a:ln>
+              <a:effectLst/>
+            </p:spPr>
+          </p:cxnSp>
+        </p:grpSp>
+      </p:grpSp>
+      <p:grpSp>
+        <p:nvGrpSpPr>
+          <p:cNvPr id="71" name="Group 70">
+            <a:extLst>
+              <a:ext uri="{FF2B5EF4-FFF2-40B4-BE49-F238E27FC236}">
+                <a16:creationId xmlns:a16="http://schemas.microsoft.com/office/drawing/2014/main" id="{7134CAF9-8C55-C08E-0820-45E82172F285}"/>
+              </a:ext>
+            </a:extLst>
+          </p:cNvPr>
+          <p:cNvGrpSpPr/>
+          <p:nvPr/>
+        </p:nvGrpSpPr>
+        <p:grpSpPr>
+          <a:xfrm>
+            <a:off x="1421938" y="14767343"/>
+            <a:ext cx="5770128" cy="5560255"/>
+            <a:chOff x="1421938" y="14767343"/>
+            <a:chExt cx="5770128" cy="5560255"/>
+          </a:xfrm>
+        </p:grpSpPr>
+        <p:sp>
+          <p:nvSpPr>
+            <p:cNvPr id="72" name="Rectangle 71">
+              <a:extLst>
+                <a:ext uri="{FF2B5EF4-FFF2-40B4-BE49-F238E27FC236}">
+                  <a16:creationId xmlns:a16="http://schemas.microsoft.com/office/drawing/2014/main" id="{8692C001-552E-A0BF-EAF0-D9D03AC630FD}"/>
+                </a:ext>
+              </a:extLst>
+            </p:cNvPr>
+            <p:cNvSpPr/>
+            <p:nvPr/>
+          </p:nvSpPr>
+          <p:spPr bwMode="auto">
+            <a:xfrm>
+              <a:off x="1421941" y="14767343"/>
+              <a:ext cx="5762869" cy="5560255"/>
+            </a:xfrm>
+            <a:prstGeom prst="rect">
+              <a:avLst/>
+            </a:prstGeom>
+            <a:solidFill>
+              <a:srgbClr val="EBEBEB"/>
+            </a:solidFill>
+            <a:ln w="9525" cap="flat" cmpd="sng" algn="ctr">
+              <a:noFill/>
+              <a:prstDash val="solid"/>
+              <a:round/>
+              <a:headEnd type="none" w="med" len="med"/>
+              <a:tailEnd type="none" w="med" len="med"/>
+            </a:ln>
+            <a:effectLst/>
+          </p:spPr>
+          <p:txBody>
+            <a:bodyPr vert="horz" wrap="square" lIns="91440" tIns="45720" rIns="91440" bIns="45720" numCol="1" rtlCol="0" anchor="t" anchorCtr="0" compatLnSpc="1">
+              <a:prstTxWarp prst="textNoShape">
+                <a:avLst/>
+              </a:prstTxWarp>
+            </a:bodyPr>
+            <a:lstStyle/>
+            <a:p>
+              <a:pPr marL="0" marR="0" indent="0" algn="l" defTabSz="4389438" rtl="0" eaLnBrk="1" fontAlgn="base" latinLnBrk="0" hangingPunct="1">
+                <a:lnSpc>
+                  <a:spcPct val="100000"/>
+                </a:lnSpc>
+                <a:spcBef>
+                  <a:spcPct val="0"/>
+                </a:spcBef>
+                <a:spcAft>
+                  <a:spcPct val="0"/>
+                </a:spcAft>
+                <a:buClrTx/>
+                <a:buSzTx/>
+                <a:buFontTx/>
+                <a:buNone/>
+                <a:tabLst/>
+              </a:pPr>
+              <a:endParaRPr kumimoji="0" lang="en-US" sz="1800" b="0" i="0" u="none" strike="noStrike" cap="none" normalizeH="0" baseline="0" dirty="0">
+                <a:ln>
+                  <a:noFill/>
+                </a:ln>
+                <a:solidFill>
+                  <a:schemeClr val="tx1"/>
+                </a:solidFill>
+                <a:effectLst/>
+                <a:latin typeface="Arial" charset="0"/>
+                <a:cs typeface="Arial" charset="0"/>
+              </a:endParaRPr>
+            </a:p>
+          </p:txBody>
+        </p:sp>
+        <p:cxnSp>
+          <p:nvCxnSpPr>
+            <p:cNvPr id="73" name="Straight Connector 72">
+              <a:extLst>
+                <a:ext uri="{FF2B5EF4-FFF2-40B4-BE49-F238E27FC236}">
+                  <a16:creationId xmlns:a16="http://schemas.microsoft.com/office/drawing/2014/main" id="{892797BA-F206-B816-0D24-23740277F523}"/>
+                </a:ext>
+              </a:extLst>
+            </p:cNvPr>
+            <p:cNvCxnSpPr/>
+            <p:nvPr/>
+          </p:nvCxnSpPr>
+          <p:spPr bwMode="auto">
+            <a:xfrm flipH="1">
+              <a:off x="4303375" y="14775666"/>
+              <a:ext cx="14515" cy="5551932"/>
+            </a:xfrm>
+            <a:prstGeom prst="line">
+              <a:avLst/>
+            </a:prstGeom>
+            <a:solidFill>
+              <a:schemeClr val="accent1"/>
+            </a:solidFill>
+            <a:ln w="25400" cap="flat" cmpd="sng" algn="ctr">
+              <a:solidFill>
+                <a:schemeClr val="accent3"/>
+              </a:solidFill>
+              <a:prstDash val="solid"/>
+              <a:round/>
+              <a:headEnd type="none" w="med" len="med"/>
+              <a:tailEnd type="none" w="med" len="med"/>
+            </a:ln>
+            <a:effectLst/>
+          </p:spPr>
+        </p:cxnSp>
+        <p:cxnSp>
+          <p:nvCxnSpPr>
+            <p:cNvPr id="74" name="Straight Connector 73">
+              <a:extLst>
+                <a:ext uri="{FF2B5EF4-FFF2-40B4-BE49-F238E27FC236}">
+                  <a16:creationId xmlns:a16="http://schemas.microsoft.com/office/drawing/2014/main" id="{126CDECF-345E-D128-8967-4E340409A8D4}"/>
+                </a:ext>
+              </a:extLst>
+            </p:cNvPr>
+            <p:cNvCxnSpPr/>
+            <p:nvPr/>
+          </p:nvCxnSpPr>
+          <p:spPr bwMode="auto">
+            <a:xfrm flipH="1">
+              <a:off x="2840886" y="14771504"/>
+              <a:ext cx="14515" cy="5551932"/>
+            </a:xfrm>
+            <a:prstGeom prst="line">
+              <a:avLst/>
+            </a:prstGeom>
+            <a:solidFill>
+              <a:schemeClr val="accent1"/>
+            </a:solidFill>
+            <a:ln w="25400" cap="flat" cmpd="sng" algn="ctr">
+              <a:solidFill>
+                <a:schemeClr val="accent3"/>
+              </a:solidFill>
+              <a:prstDash val="solid"/>
+              <a:round/>
+              <a:headEnd type="none" w="med" len="med"/>
+              <a:tailEnd type="none" w="med" len="med"/>
+            </a:ln>
+            <a:effectLst/>
+          </p:spPr>
+        </p:cxnSp>
+        <p:cxnSp>
+          <p:nvCxnSpPr>
+            <p:cNvPr id="75" name="Straight Connector 74">
+              <a:extLst>
+                <a:ext uri="{FF2B5EF4-FFF2-40B4-BE49-F238E27FC236}">
+                  <a16:creationId xmlns:a16="http://schemas.microsoft.com/office/drawing/2014/main" id="{156F0576-3F33-7771-B61D-8B72E7C18AAE}"/>
+                </a:ext>
+              </a:extLst>
+            </p:cNvPr>
+            <p:cNvCxnSpPr/>
+            <p:nvPr/>
+          </p:nvCxnSpPr>
+          <p:spPr bwMode="auto">
+            <a:xfrm flipH="1">
+              <a:off x="5722320" y="14767343"/>
+              <a:ext cx="14515" cy="5551932"/>
+            </a:xfrm>
+            <a:prstGeom prst="line">
+              <a:avLst/>
+            </a:prstGeom>
+            <a:solidFill>
+              <a:schemeClr val="accent1"/>
+            </a:solidFill>
+            <a:ln w="25400" cap="flat" cmpd="sng" algn="ctr">
+              <a:solidFill>
+                <a:schemeClr val="accent3"/>
+              </a:solidFill>
+              <a:prstDash val="solid"/>
+              <a:round/>
+              <a:headEnd type="none" w="med" len="med"/>
+              <a:tailEnd type="none" w="med" len="med"/>
+            </a:ln>
+            <a:effectLst/>
+          </p:spPr>
+        </p:cxnSp>
+        <p:cxnSp>
+          <p:nvCxnSpPr>
+            <p:cNvPr id="76" name="Straight Connector 75">
+              <a:extLst>
+                <a:ext uri="{FF2B5EF4-FFF2-40B4-BE49-F238E27FC236}">
+                  <a16:creationId xmlns:a16="http://schemas.microsoft.com/office/drawing/2014/main" id="{B3535D1D-4108-CA34-F032-77C2E850B187}"/>
+                </a:ext>
+              </a:extLst>
+            </p:cNvPr>
+            <p:cNvCxnSpPr>
+              <a:stCxn id="72" idx="1"/>
+              <a:endCxn id="72" idx="3"/>
+            </p:cNvCxnSpPr>
+            <p:nvPr/>
+          </p:nvCxnSpPr>
+          <p:spPr bwMode="auto">
+            <a:xfrm>
+              <a:off x="1421941" y="17547471"/>
+              <a:ext cx="5762869" cy="0"/>
+            </a:xfrm>
+            <a:prstGeom prst="line">
+              <a:avLst/>
+            </a:prstGeom>
+            <a:solidFill>
+              <a:schemeClr val="accent1"/>
+            </a:solidFill>
+            <a:ln w="25400" cap="flat" cmpd="sng" algn="ctr">
+              <a:solidFill>
+                <a:schemeClr val="accent3"/>
+              </a:solidFill>
+              <a:prstDash val="solid"/>
+              <a:round/>
+              <a:headEnd type="none" w="med" len="med"/>
+              <a:tailEnd type="none" w="med" len="med"/>
+            </a:ln>
+            <a:effectLst/>
+          </p:spPr>
+        </p:cxnSp>
+        <p:cxnSp>
+          <p:nvCxnSpPr>
+            <p:cNvPr id="77" name="Straight Connector 76">
+              <a:extLst>
+                <a:ext uri="{FF2B5EF4-FFF2-40B4-BE49-F238E27FC236}">
+                  <a16:creationId xmlns:a16="http://schemas.microsoft.com/office/drawing/2014/main" id="{AF52D305-65CB-CEC1-9A60-BDDF5CF5B795}"/>
+                </a:ext>
+              </a:extLst>
+            </p:cNvPr>
+            <p:cNvCxnSpPr/>
+            <p:nvPr/>
+          </p:nvCxnSpPr>
+          <p:spPr bwMode="auto">
+            <a:xfrm>
+              <a:off x="1421940" y="18803458"/>
+              <a:ext cx="5762869" cy="0"/>
+            </a:xfrm>
+            <a:prstGeom prst="line">
+              <a:avLst/>
+            </a:prstGeom>
+            <a:solidFill>
+              <a:schemeClr val="accent1"/>
+            </a:solidFill>
+            <a:ln w="25400" cap="flat" cmpd="sng" algn="ctr">
+              <a:solidFill>
+                <a:schemeClr val="accent3"/>
+              </a:solidFill>
+              <a:prstDash val="solid"/>
+              <a:round/>
+              <a:headEnd type="none" w="med" len="med"/>
+              <a:tailEnd type="none" w="med" len="med"/>
+            </a:ln>
+            <a:effectLst/>
+          </p:spPr>
+        </p:cxnSp>
+        <p:cxnSp>
+          <p:nvCxnSpPr>
+            <p:cNvPr id="78" name="Straight Connector 77">
+              <a:extLst>
+                <a:ext uri="{FF2B5EF4-FFF2-40B4-BE49-F238E27FC236}">
+                  <a16:creationId xmlns:a16="http://schemas.microsoft.com/office/drawing/2014/main" id="{5D2F51D8-3D1A-6B2C-5FA6-27B779344ACC}"/>
+                </a:ext>
+              </a:extLst>
+            </p:cNvPr>
+            <p:cNvCxnSpPr/>
+            <p:nvPr/>
+          </p:nvCxnSpPr>
+          <p:spPr bwMode="auto">
+            <a:xfrm>
+              <a:off x="1429197" y="16328272"/>
+              <a:ext cx="5762869" cy="0"/>
+            </a:xfrm>
+            <a:prstGeom prst="line">
+              <a:avLst/>
+            </a:prstGeom>
+            <a:solidFill>
+              <a:schemeClr val="accent1"/>
+            </a:solidFill>
+            <a:ln w="25400" cap="flat" cmpd="sng" algn="ctr">
+              <a:solidFill>
+                <a:schemeClr val="accent3"/>
+              </a:solidFill>
+              <a:prstDash val="solid"/>
+              <a:round/>
+              <a:headEnd type="none" w="med" len="med"/>
+              <a:tailEnd type="none" w="med" len="med"/>
+            </a:ln>
+            <a:effectLst/>
+          </p:spPr>
+        </p:cxnSp>
+        <p:cxnSp>
+          <p:nvCxnSpPr>
+            <p:cNvPr id="79" name="Straight Connector 78">
+              <a:extLst>
+                <a:ext uri="{FF2B5EF4-FFF2-40B4-BE49-F238E27FC236}">
+                  <a16:creationId xmlns:a16="http://schemas.microsoft.com/office/drawing/2014/main" id="{88EF8ECA-4A75-8119-7C89-03A8BC4A6CEB}"/>
+                </a:ext>
+              </a:extLst>
+            </p:cNvPr>
+            <p:cNvCxnSpPr/>
+            <p:nvPr/>
+          </p:nvCxnSpPr>
+          <p:spPr bwMode="auto">
+            <a:xfrm>
+              <a:off x="1421939" y="20048934"/>
+              <a:ext cx="5762869" cy="0"/>
+            </a:xfrm>
+            <a:prstGeom prst="line">
+              <a:avLst/>
+            </a:prstGeom>
+            <a:solidFill>
+              <a:schemeClr val="accent1"/>
+            </a:solidFill>
+            <a:ln w="25400" cap="flat" cmpd="sng" algn="ctr">
+              <a:solidFill>
+                <a:schemeClr val="accent3"/>
+              </a:solidFill>
+              <a:prstDash val="solid"/>
+              <a:round/>
+              <a:headEnd type="none" w="med" len="med"/>
+              <a:tailEnd type="none" w="med" len="med"/>
+            </a:ln>
+            <a:effectLst/>
+          </p:spPr>
+        </p:cxnSp>
+        <p:cxnSp>
+          <p:nvCxnSpPr>
+            <p:cNvPr id="80" name="Straight Connector 79">
+              <a:extLst>
+                <a:ext uri="{FF2B5EF4-FFF2-40B4-BE49-F238E27FC236}">
+                  <a16:creationId xmlns:a16="http://schemas.microsoft.com/office/drawing/2014/main" id="{59BAF877-694B-9CFF-5728-FB72909E61AD}"/>
+                </a:ext>
+              </a:extLst>
+            </p:cNvPr>
+            <p:cNvCxnSpPr/>
+            <p:nvPr/>
+          </p:nvCxnSpPr>
+          <p:spPr bwMode="auto">
+            <a:xfrm>
+              <a:off x="1421938" y="15088052"/>
+              <a:ext cx="5762869" cy="0"/>
+            </a:xfrm>
+            <a:prstGeom prst="line">
+              <a:avLst/>
+            </a:prstGeom>
+            <a:solidFill>
+              <a:schemeClr val="accent1"/>
+            </a:solidFill>
+            <a:ln w="25400" cap="flat" cmpd="sng" algn="ctr">
+              <a:solidFill>
+                <a:schemeClr val="accent3"/>
+              </a:solidFill>
+              <a:prstDash val="solid"/>
+              <a:round/>
+              <a:headEnd type="none" w="med" len="med"/>
+              <a:tailEnd type="none" w="med" len="med"/>
+            </a:ln>
+            <a:effectLst/>
+          </p:spPr>
+        </p:cxnSp>
+      </p:grpSp>
     </p:spTree>
     <p:extLst>
       <p:ext uri="{BB962C8B-B14F-4D97-AF65-F5344CB8AC3E}">
@@ -14868,6 +16909,410 @@
 </file>
 
 <file path=ppt/slides/slide3.xml><?xml version="1.0" encoding="utf-8"?>
+<p:sld xmlns:a="http://schemas.openxmlformats.org/drawingml/2006/main" xmlns:r="http://schemas.openxmlformats.org/officeDocument/2006/relationships" xmlns:p="http://schemas.openxmlformats.org/presentationml/2006/main">
+  <p:cSld>
+    <p:spTree>
+      <p:nvGrpSpPr>
+        <p:cNvPr id="1" name=""/>
+        <p:cNvGrpSpPr/>
+        <p:nvPr/>
+      </p:nvGrpSpPr>
+      <p:grpSpPr>
+        <a:xfrm>
+          <a:off x="0" y="0"/>
+          <a:ext cx="0" cy="0"/>
+          <a:chOff x="0" y="0"/>
+          <a:chExt cx="0" cy="0"/>
+        </a:xfrm>
+      </p:grpSpPr>
+      <p:grpSp>
+        <p:nvGrpSpPr>
+          <p:cNvPr id="12" name="Group 11">
+            <a:extLst>
+              <a:ext uri="{FF2B5EF4-FFF2-40B4-BE49-F238E27FC236}">
+                <a16:creationId xmlns:a16="http://schemas.microsoft.com/office/drawing/2014/main" id="{87FEA0B6-0A74-0C0F-3FB1-0EAD7701882D}"/>
+              </a:ext>
+            </a:extLst>
+          </p:cNvPr>
+          <p:cNvGrpSpPr/>
+          <p:nvPr/>
+        </p:nvGrpSpPr>
+        <p:grpSpPr>
+          <a:xfrm>
+            <a:off x="1421938" y="14767343"/>
+            <a:ext cx="5770128" cy="5560255"/>
+            <a:chOff x="1421938" y="14767343"/>
+            <a:chExt cx="5770128" cy="5560255"/>
+          </a:xfrm>
+        </p:grpSpPr>
+        <p:sp>
+          <p:nvSpPr>
+            <p:cNvPr id="2" name="Rectangle 1">
+              <a:extLst>
+                <a:ext uri="{FF2B5EF4-FFF2-40B4-BE49-F238E27FC236}">
+                  <a16:creationId xmlns:a16="http://schemas.microsoft.com/office/drawing/2014/main" id="{D3C061F5-8F54-E2FF-255D-66D2D0F76517}"/>
+                </a:ext>
+              </a:extLst>
+            </p:cNvPr>
+            <p:cNvSpPr/>
+            <p:nvPr/>
+          </p:nvSpPr>
+          <p:spPr bwMode="auto">
+            <a:xfrm>
+              <a:off x="1421941" y="14767343"/>
+              <a:ext cx="5762869" cy="5560255"/>
+            </a:xfrm>
+            <a:prstGeom prst="rect">
+              <a:avLst/>
+            </a:prstGeom>
+            <a:solidFill>
+              <a:srgbClr val="EBEBEB"/>
+            </a:solidFill>
+            <a:ln w="9525" cap="flat" cmpd="sng" algn="ctr">
+              <a:noFill/>
+              <a:prstDash val="solid"/>
+              <a:round/>
+              <a:headEnd type="none" w="med" len="med"/>
+              <a:tailEnd type="none" w="med" len="med"/>
+            </a:ln>
+            <a:effectLst/>
+          </p:spPr>
+          <p:txBody>
+            <a:bodyPr vert="horz" wrap="square" lIns="91440" tIns="45720" rIns="91440" bIns="45720" numCol="1" rtlCol="0" anchor="t" anchorCtr="0" compatLnSpc="1">
+              <a:prstTxWarp prst="textNoShape">
+                <a:avLst/>
+              </a:prstTxWarp>
+            </a:bodyPr>
+            <a:lstStyle/>
+            <a:p>
+              <a:pPr marL="0" marR="0" indent="0" algn="l" defTabSz="4389438" rtl="0" eaLnBrk="1" fontAlgn="base" latinLnBrk="0" hangingPunct="1">
+                <a:lnSpc>
+                  <a:spcPct val="100000"/>
+                </a:lnSpc>
+                <a:spcBef>
+                  <a:spcPct val="0"/>
+                </a:spcBef>
+                <a:spcAft>
+                  <a:spcPct val="0"/>
+                </a:spcAft>
+                <a:buClrTx/>
+                <a:buSzTx/>
+                <a:buFontTx/>
+                <a:buNone/>
+                <a:tabLst/>
+              </a:pPr>
+              <a:endParaRPr kumimoji="0" lang="en-US" sz="1800" b="0" i="0" u="none" strike="noStrike" cap="none" normalizeH="0" baseline="0" dirty="0">
+                <a:ln>
+                  <a:noFill/>
+                </a:ln>
+                <a:solidFill>
+                  <a:schemeClr val="tx1"/>
+                </a:solidFill>
+                <a:effectLst/>
+                <a:latin typeface="Arial" charset="0"/>
+                <a:cs typeface="Arial" charset="0"/>
+              </a:endParaRPr>
+            </a:p>
+          </p:txBody>
+        </p:sp>
+        <p:cxnSp>
+          <p:nvCxnSpPr>
+            <p:cNvPr id="3" name="Straight Connector 2">
+              <a:extLst>
+                <a:ext uri="{FF2B5EF4-FFF2-40B4-BE49-F238E27FC236}">
+                  <a16:creationId xmlns:a16="http://schemas.microsoft.com/office/drawing/2014/main" id="{8D042BA7-5F5A-36F0-850A-C2577060B749}"/>
+                </a:ext>
+              </a:extLst>
+            </p:cNvPr>
+            <p:cNvCxnSpPr/>
+            <p:nvPr/>
+          </p:nvCxnSpPr>
+          <p:spPr bwMode="auto">
+            <a:xfrm flipH="1">
+              <a:off x="4303375" y="14775666"/>
+              <a:ext cx="14515" cy="5551932"/>
+            </a:xfrm>
+            <a:prstGeom prst="line">
+              <a:avLst/>
+            </a:prstGeom>
+            <a:solidFill>
+              <a:schemeClr val="accent1"/>
+            </a:solidFill>
+            <a:ln w="25400" cap="flat" cmpd="sng" algn="ctr">
+              <a:solidFill>
+                <a:schemeClr val="accent3"/>
+              </a:solidFill>
+              <a:prstDash val="solid"/>
+              <a:round/>
+              <a:headEnd type="none" w="med" len="med"/>
+              <a:tailEnd type="none" w="med" len="med"/>
+            </a:ln>
+            <a:effectLst/>
+          </p:spPr>
+        </p:cxnSp>
+        <p:cxnSp>
+          <p:nvCxnSpPr>
+            <p:cNvPr id="4" name="Straight Connector 3">
+              <a:extLst>
+                <a:ext uri="{FF2B5EF4-FFF2-40B4-BE49-F238E27FC236}">
+                  <a16:creationId xmlns:a16="http://schemas.microsoft.com/office/drawing/2014/main" id="{15FD1E44-CFDC-B758-7022-A454002AE588}"/>
+                </a:ext>
+              </a:extLst>
+            </p:cNvPr>
+            <p:cNvCxnSpPr/>
+            <p:nvPr/>
+          </p:nvCxnSpPr>
+          <p:spPr bwMode="auto">
+            <a:xfrm flipH="1">
+              <a:off x="2840886" y="14771504"/>
+              <a:ext cx="14515" cy="5551932"/>
+            </a:xfrm>
+            <a:prstGeom prst="line">
+              <a:avLst/>
+            </a:prstGeom>
+            <a:solidFill>
+              <a:schemeClr val="accent1"/>
+            </a:solidFill>
+            <a:ln w="25400" cap="flat" cmpd="sng" algn="ctr">
+              <a:solidFill>
+                <a:schemeClr val="accent3"/>
+              </a:solidFill>
+              <a:prstDash val="solid"/>
+              <a:round/>
+              <a:headEnd type="none" w="med" len="med"/>
+              <a:tailEnd type="none" w="med" len="med"/>
+            </a:ln>
+            <a:effectLst/>
+          </p:spPr>
+        </p:cxnSp>
+        <p:cxnSp>
+          <p:nvCxnSpPr>
+            <p:cNvPr id="5" name="Straight Connector 4">
+              <a:extLst>
+                <a:ext uri="{FF2B5EF4-FFF2-40B4-BE49-F238E27FC236}">
+                  <a16:creationId xmlns:a16="http://schemas.microsoft.com/office/drawing/2014/main" id="{2CADB742-0CDC-DC37-ED5C-2B377B62CEF5}"/>
+                </a:ext>
+              </a:extLst>
+            </p:cNvPr>
+            <p:cNvCxnSpPr/>
+            <p:nvPr/>
+          </p:nvCxnSpPr>
+          <p:spPr bwMode="auto">
+            <a:xfrm flipH="1">
+              <a:off x="5722320" y="14767343"/>
+              <a:ext cx="14515" cy="5551932"/>
+            </a:xfrm>
+            <a:prstGeom prst="line">
+              <a:avLst/>
+            </a:prstGeom>
+            <a:solidFill>
+              <a:schemeClr val="accent1"/>
+            </a:solidFill>
+            <a:ln w="25400" cap="flat" cmpd="sng" algn="ctr">
+              <a:solidFill>
+                <a:schemeClr val="accent3"/>
+              </a:solidFill>
+              <a:prstDash val="solid"/>
+              <a:round/>
+              <a:headEnd type="none" w="med" len="med"/>
+              <a:tailEnd type="none" w="med" len="med"/>
+            </a:ln>
+            <a:effectLst/>
+          </p:spPr>
+        </p:cxnSp>
+        <p:cxnSp>
+          <p:nvCxnSpPr>
+            <p:cNvPr id="7" name="Straight Connector 6">
+              <a:extLst>
+                <a:ext uri="{FF2B5EF4-FFF2-40B4-BE49-F238E27FC236}">
+                  <a16:creationId xmlns:a16="http://schemas.microsoft.com/office/drawing/2014/main" id="{D5418E4F-BB4E-52E4-446B-B4C3A71E88D0}"/>
+                </a:ext>
+              </a:extLst>
+            </p:cNvPr>
+            <p:cNvCxnSpPr>
+              <a:stCxn id="2" idx="1"/>
+              <a:endCxn id="2" idx="3"/>
+            </p:cNvCxnSpPr>
+            <p:nvPr/>
+          </p:nvCxnSpPr>
+          <p:spPr bwMode="auto">
+            <a:xfrm>
+              <a:off x="1421941" y="17547471"/>
+              <a:ext cx="5762869" cy="0"/>
+            </a:xfrm>
+            <a:prstGeom prst="line">
+              <a:avLst/>
+            </a:prstGeom>
+            <a:solidFill>
+              <a:schemeClr val="accent1"/>
+            </a:solidFill>
+            <a:ln w="25400" cap="flat" cmpd="sng" algn="ctr">
+              <a:solidFill>
+                <a:schemeClr val="accent3"/>
+              </a:solidFill>
+              <a:prstDash val="solid"/>
+              <a:round/>
+              <a:headEnd type="none" w="med" len="med"/>
+              <a:tailEnd type="none" w="med" len="med"/>
+            </a:ln>
+            <a:effectLst/>
+          </p:spPr>
+        </p:cxnSp>
+        <p:cxnSp>
+          <p:nvCxnSpPr>
+            <p:cNvPr id="8" name="Straight Connector 7">
+              <a:extLst>
+                <a:ext uri="{FF2B5EF4-FFF2-40B4-BE49-F238E27FC236}">
+                  <a16:creationId xmlns:a16="http://schemas.microsoft.com/office/drawing/2014/main" id="{C5D41D7D-E264-B1C2-07CB-937C70260BA2}"/>
+                </a:ext>
+              </a:extLst>
+            </p:cNvPr>
+            <p:cNvCxnSpPr/>
+            <p:nvPr/>
+          </p:nvCxnSpPr>
+          <p:spPr bwMode="auto">
+            <a:xfrm>
+              <a:off x="1421940" y="18803458"/>
+              <a:ext cx="5762869" cy="0"/>
+            </a:xfrm>
+            <a:prstGeom prst="line">
+              <a:avLst/>
+            </a:prstGeom>
+            <a:solidFill>
+              <a:schemeClr val="accent1"/>
+            </a:solidFill>
+            <a:ln w="25400" cap="flat" cmpd="sng" algn="ctr">
+              <a:solidFill>
+                <a:schemeClr val="accent3"/>
+              </a:solidFill>
+              <a:prstDash val="solid"/>
+              <a:round/>
+              <a:headEnd type="none" w="med" len="med"/>
+              <a:tailEnd type="none" w="med" len="med"/>
+            </a:ln>
+            <a:effectLst/>
+          </p:spPr>
+        </p:cxnSp>
+        <p:cxnSp>
+          <p:nvCxnSpPr>
+            <p:cNvPr id="9" name="Straight Connector 8">
+              <a:extLst>
+                <a:ext uri="{FF2B5EF4-FFF2-40B4-BE49-F238E27FC236}">
+                  <a16:creationId xmlns:a16="http://schemas.microsoft.com/office/drawing/2014/main" id="{E351987E-C902-D4BC-BEB6-8721F79F23DE}"/>
+                </a:ext>
+              </a:extLst>
+            </p:cNvPr>
+            <p:cNvCxnSpPr/>
+            <p:nvPr/>
+          </p:nvCxnSpPr>
+          <p:spPr bwMode="auto">
+            <a:xfrm>
+              <a:off x="1429197" y="16328272"/>
+              <a:ext cx="5762869" cy="0"/>
+            </a:xfrm>
+            <a:prstGeom prst="line">
+              <a:avLst/>
+            </a:prstGeom>
+            <a:solidFill>
+              <a:schemeClr val="accent1"/>
+            </a:solidFill>
+            <a:ln w="25400" cap="flat" cmpd="sng" algn="ctr">
+              <a:solidFill>
+                <a:schemeClr val="accent3"/>
+              </a:solidFill>
+              <a:prstDash val="solid"/>
+              <a:round/>
+              <a:headEnd type="none" w="med" len="med"/>
+              <a:tailEnd type="none" w="med" len="med"/>
+            </a:ln>
+            <a:effectLst/>
+          </p:spPr>
+        </p:cxnSp>
+        <p:cxnSp>
+          <p:nvCxnSpPr>
+            <p:cNvPr id="10" name="Straight Connector 9">
+              <a:extLst>
+                <a:ext uri="{FF2B5EF4-FFF2-40B4-BE49-F238E27FC236}">
+                  <a16:creationId xmlns:a16="http://schemas.microsoft.com/office/drawing/2014/main" id="{692C0EB5-3BE9-C9EB-E949-8240C7DC36CE}"/>
+                </a:ext>
+              </a:extLst>
+            </p:cNvPr>
+            <p:cNvCxnSpPr/>
+            <p:nvPr/>
+          </p:nvCxnSpPr>
+          <p:spPr bwMode="auto">
+            <a:xfrm>
+              <a:off x="1421939" y="20048934"/>
+              <a:ext cx="5762869" cy="0"/>
+            </a:xfrm>
+            <a:prstGeom prst="line">
+              <a:avLst/>
+            </a:prstGeom>
+            <a:solidFill>
+              <a:schemeClr val="accent1"/>
+            </a:solidFill>
+            <a:ln w="25400" cap="flat" cmpd="sng" algn="ctr">
+              <a:solidFill>
+                <a:schemeClr val="accent3"/>
+              </a:solidFill>
+              <a:prstDash val="solid"/>
+              <a:round/>
+              <a:headEnd type="none" w="med" len="med"/>
+              <a:tailEnd type="none" w="med" len="med"/>
+            </a:ln>
+            <a:effectLst/>
+          </p:spPr>
+        </p:cxnSp>
+        <p:cxnSp>
+          <p:nvCxnSpPr>
+            <p:cNvPr id="11" name="Straight Connector 10">
+              <a:extLst>
+                <a:ext uri="{FF2B5EF4-FFF2-40B4-BE49-F238E27FC236}">
+                  <a16:creationId xmlns:a16="http://schemas.microsoft.com/office/drawing/2014/main" id="{A71399DB-660C-6CE2-8B67-DA2660ACD78E}"/>
+                </a:ext>
+              </a:extLst>
+            </p:cNvPr>
+            <p:cNvCxnSpPr/>
+            <p:nvPr/>
+          </p:nvCxnSpPr>
+          <p:spPr bwMode="auto">
+            <a:xfrm>
+              <a:off x="1421938" y="15088052"/>
+              <a:ext cx="5762869" cy="0"/>
+            </a:xfrm>
+            <a:prstGeom prst="line">
+              <a:avLst/>
+            </a:prstGeom>
+            <a:solidFill>
+              <a:schemeClr val="accent1"/>
+            </a:solidFill>
+            <a:ln w="25400" cap="flat" cmpd="sng" algn="ctr">
+              <a:solidFill>
+                <a:schemeClr val="accent3"/>
+              </a:solidFill>
+              <a:prstDash val="solid"/>
+              <a:round/>
+              <a:headEnd type="none" w="med" len="med"/>
+              <a:tailEnd type="none" w="med" len="med"/>
+            </a:ln>
+            <a:effectLst/>
+          </p:spPr>
+        </p:cxnSp>
+      </p:grpSp>
+    </p:spTree>
+    <p:extLst>
+      <p:ext uri="{BB962C8B-B14F-4D97-AF65-F5344CB8AC3E}">
+        <p14:creationId xmlns:p14="http://schemas.microsoft.com/office/powerpoint/2010/main" val="2478095206"/>
+      </p:ext>
+    </p:extLst>
+  </p:cSld>
+  <p:clrMapOvr>
+    <a:masterClrMapping/>
+  </p:clrMapOvr>
+</p:sld>
+</file>
+
+<file path=ppt/slides/slide4.xml><?xml version="1.0" encoding="utf-8"?>
 <p:sld xmlns:a="http://schemas.openxmlformats.org/drawingml/2006/main" xmlns:r="http://schemas.openxmlformats.org/officeDocument/2006/relationships" xmlns:p="http://schemas.openxmlformats.org/presentationml/2006/main">
   <p:cSld>
     <p:spTree>
@@ -15755,7 +18200,7 @@
 </p:sld>
 </file>
 
-<file path=ppt/slides/slide4.xml><?xml version="1.0" encoding="utf-8"?>
+<file path=ppt/slides/slide5.xml><?xml version="1.0" encoding="utf-8"?>
 <p:sld xmlns:a="http://schemas.openxmlformats.org/drawingml/2006/main" xmlns:r="http://schemas.openxmlformats.org/officeDocument/2006/relationships" xmlns:p="http://schemas.openxmlformats.org/presentationml/2006/main">
   <p:cSld>
     <p:spTree>

</xml_diff>